<commit_message>
Add Mo Artifact Navigator + refresh PPTX to 11 slides (README update 82)
- mockups/mo_artifact_navigator.html: new table of contents for all 29 Mo
  working documents; 5 categories; sticky left nav; SVG mindmap; JS-rendered
  cards with title, file, audience, description, status
- mockups/mo_data_ops_kickoff.pptx: regenerated from script; now 11 slides
  (added Mo Trends & External Signal Integration slide)
- scripts/mo_data_ops_kickoff_pptx.py: Slide 9 inserted (Mo Trends), Slide 10
  updated to Automation Roadmap, Slide 11 = Next Steps

Co-Authored-By: Claude Sonnet 4.6 <noreply@anthropic.com>
</commit_message>
<xml_diff>
--- a/mockups/mo_data_ops_kickoff.pptx
+++ b/mockups/mo_data_ops_kickoff.pptx
@@ -15,6 +15,7 @@
     <p:sldId id="263" r:id="rId14"/>
     <p:sldId id="264" r:id="rId15"/>
     <p:sldId id="265" r:id="rId16"/>
+    <p:sldId id="266" r:id="rId17"/>
   </p:sldIdLst>
   <p:sldSz cx="12191695" cy="6858000" type="screen4x3"/>
   <p:notesSz cx="6858000" cy="9144000"/>
@@ -3790,6 +3791,1551 @@
             <a:avLst/>
           </a:prstGeom>
           <a:solidFill>
+            <a:srgbClr val="F0F4FA"/>
+          </a:solidFill>
+          <a:ln>
+            <a:noFill/>
+          </a:ln>
+        </p:spPr>
+        <p:style>
+          <a:lnRef idx="1">
+            <a:schemeClr val="accent1"/>
+          </a:lnRef>
+          <a:fillRef idx="3">
+            <a:schemeClr val="accent1"/>
+          </a:fillRef>
+          <a:effectRef idx="2">
+            <a:schemeClr val="accent1"/>
+          </a:effectRef>
+          <a:fontRef idx="minor">
+            <a:schemeClr val="lt1"/>
+          </a:fontRef>
+        </p:style>
+        <p:txBody>
+          <a:bodyPr rtlCol="0" anchor="ctr"/>
+          <a:lstStyle/>
+          <a:p>
+            <a:pPr algn="ctr"/>
+          </a:p>
+        </p:txBody>
+      </p:sp>
+      <p:sp>
+        <p:nvSpPr>
+          <p:cNvPr id="3" name="Rectangle 2"/>
+          <p:cNvSpPr/>
+          <p:nvPr/>
+        </p:nvSpPr>
+        <p:spPr>
+          <a:xfrm>
+            <a:off x="0" y="0"/>
+            <a:ext cx="12191695" cy="1005840"/>
+          </a:xfrm>
+          <a:prstGeom prst="rect">
+            <a:avLst/>
+          </a:prstGeom>
+          <a:solidFill>
+            <a:srgbClr val="1B3566"/>
+          </a:solidFill>
+          <a:ln>
+            <a:noFill/>
+          </a:ln>
+        </p:spPr>
+        <p:style>
+          <a:lnRef idx="1">
+            <a:schemeClr val="accent1"/>
+          </a:lnRef>
+          <a:fillRef idx="3">
+            <a:schemeClr val="accent1"/>
+          </a:fillRef>
+          <a:effectRef idx="2">
+            <a:schemeClr val="accent1"/>
+          </a:effectRef>
+          <a:fontRef idx="minor">
+            <a:schemeClr val="lt1"/>
+          </a:fontRef>
+        </p:style>
+        <p:txBody>
+          <a:bodyPr rtlCol="0" anchor="ctr"/>
+          <a:lstStyle/>
+          <a:p>
+            <a:pPr algn="ctr"/>
+          </a:p>
+        </p:txBody>
+      </p:sp>
+      <p:sp>
+        <p:nvSpPr>
+          <p:cNvPr id="4" name="Rectangle 3"/>
+          <p:cNvSpPr/>
+          <p:nvPr/>
+        </p:nvSpPr>
+        <p:spPr>
+          <a:xfrm>
+            <a:off x="0" y="0"/>
+            <a:ext cx="73152" cy="6858000"/>
+          </a:xfrm>
+          <a:prstGeom prst="rect">
+            <a:avLst/>
+          </a:prstGeom>
+          <a:solidFill>
+            <a:srgbClr val="4078D0"/>
+          </a:solidFill>
+          <a:ln>
+            <a:noFill/>
+          </a:ln>
+        </p:spPr>
+        <p:style>
+          <a:lnRef idx="1">
+            <a:schemeClr val="accent1"/>
+          </a:lnRef>
+          <a:fillRef idx="3">
+            <a:schemeClr val="accent1"/>
+          </a:fillRef>
+          <a:effectRef idx="2">
+            <a:schemeClr val="accent1"/>
+          </a:effectRef>
+          <a:fontRef idx="minor">
+            <a:schemeClr val="lt1"/>
+          </a:fontRef>
+        </p:style>
+        <p:txBody>
+          <a:bodyPr rtlCol="0" anchor="ctr"/>
+          <a:lstStyle/>
+          <a:p>
+            <a:pPr algn="ctr"/>
+          </a:p>
+        </p:txBody>
+      </p:sp>
+      <p:sp>
+        <p:nvSpPr>
+          <p:cNvPr id="5" name="TextBox 4"/>
+          <p:cNvSpPr txBox="1"/>
+          <p:nvPr/>
+        </p:nvSpPr>
+        <p:spPr>
+          <a:xfrm>
+            <a:off x="457200" y="201168"/>
+            <a:ext cx="9144000" cy="548640"/>
+          </a:xfrm>
+          <a:prstGeom prst="rect">
+            <a:avLst/>
+          </a:prstGeom>
+          <a:noFill/>
+        </p:spPr>
+        <p:txBody>
+          <a:bodyPr wrap="square">
+            <a:spAutoFit/>
+          </a:bodyPr>
+          <a:lstStyle/>
+          <a:p>
+            <a:pPr algn="l"/>
+            <a:r>
+              <a:rPr sz="2400" b="1" i="0">
+                <a:solidFill>
+                  <a:srgbClr val="FFFFFF"/>
+                </a:solidFill>
+                <a:latin typeface="Calibri"/>
+              </a:rPr>
+              <a:t>Automation Roadmap</a:t>
+            </a:r>
+          </a:p>
+        </p:txBody>
+      </p:sp>
+      <p:sp>
+        <p:nvSpPr>
+          <p:cNvPr id="6" name="TextBox 5"/>
+          <p:cNvSpPr txBox="1"/>
+          <p:nvPr/>
+        </p:nvSpPr>
+        <p:spPr>
+          <a:xfrm>
+            <a:off x="457200" y="658368"/>
+            <a:ext cx="10972800" cy="292608"/>
+          </a:xfrm>
+          <a:prstGeom prst="rect">
+            <a:avLst/>
+          </a:prstGeom>
+          <a:noFill/>
+        </p:spPr>
+        <p:txBody>
+          <a:bodyPr wrap="square">
+            <a:spAutoFit/>
+          </a:bodyPr>
+          <a:lstStyle/>
+          <a:p>
+            <a:pPr algn="l"/>
+            <a:r>
+              <a:rPr sz="1100" b="0" i="0">
+                <a:solidFill>
+                  <a:srgbClr val="A0C0F0"/>
+                </a:solidFill>
+                <a:latin typeface="Calibri"/>
+              </a:rPr>
+              <a:t>Five priorities to remove manual steps from the pipeline — ordered by impact-to-risk ratio. No changes implemented yet; design only.</a:t>
+            </a:r>
+          </a:p>
+        </p:txBody>
+      </p:sp>
+      <p:sp>
+        <p:nvSpPr>
+          <p:cNvPr id="7" name="Rectangle 6"/>
+          <p:cNvSpPr/>
+          <p:nvPr/>
+        </p:nvSpPr>
+        <p:spPr>
+          <a:xfrm>
+            <a:off x="347472" y="1170432"/>
+            <a:ext cx="2103120" cy="4297680"/>
+          </a:xfrm>
+          <a:prstGeom prst="rect">
+            <a:avLst/>
+          </a:prstGeom>
+          <a:solidFill>
+            <a:srgbClr val="FFFFFF"/>
+          </a:solidFill>
+          <a:ln w="9525">
+            <a:solidFill>
+              <a:srgbClr val="C0CCE4"/>
+            </a:solidFill>
+          </a:ln>
+        </p:spPr>
+        <p:style>
+          <a:lnRef idx="1">
+            <a:schemeClr val="accent1"/>
+          </a:lnRef>
+          <a:fillRef idx="3">
+            <a:schemeClr val="accent1"/>
+          </a:fillRef>
+          <a:effectRef idx="2">
+            <a:schemeClr val="accent1"/>
+          </a:effectRef>
+          <a:fontRef idx="minor">
+            <a:schemeClr val="lt1"/>
+          </a:fontRef>
+        </p:style>
+        <p:txBody>
+          <a:bodyPr rtlCol="0" anchor="ctr"/>
+          <a:lstStyle/>
+          <a:p>
+            <a:pPr algn="ctr"/>
+          </a:p>
+        </p:txBody>
+      </p:sp>
+      <p:sp>
+        <p:nvSpPr>
+          <p:cNvPr id="8" name="Rectangle 7"/>
+          <p:cNvSpPr/>
+          <p:nvPr/>
+        </p:nvSpPr>
+        <p:spPr>
+          <a:xfrm>
+            <a:off x="347472" y="1170432"/>
+            <a:ext cx="2103120" cy="457200"/>
+          </a:xfrm>
+          <a:prstGeom prst="rect">
+            <a:avLst/>
+          </a:prstGeom>
+          <a:solidFill>
+            <a:srgbClr val="0E5E38"/>
+          </a:solidFill>
+          <a:ln>
+            <a:noFill/>
+          </a:ln>
+        </p:spPr>
+        <p:style>
+          <a:lnRef idx="1">
+            <a:schemeClr val="accent1"/>
+          </a:lnRef>
+          <a:fillRef idx="3">
+            <a:schemeClr val="accent1"/>
+          </a:fillRef>
+          <a:effectRef idx="2">
+            <a:schemeClr val="accent1"/>
+          </a:effectRef>
+          <a:fontRef idx="minor">
+            <a:schemeClr val="lt1"/>
+          </a:fontRef>
+        </p:style>
+        <p:txBody>
+          <a:bodyPr rtlCol="0" anchor="ctr"/>
+          <a:lstStyle/>
+          <a:p>
+            <a:pPr algn="ctr"/>
+          </a:p>
+        </p:txBody>
+      </p:sp>
+      <p:sp>
+        <p:nvSpPr>
+          <p:cNvPr id="9" name="TextBox 8"/>
+          <p:cNvSpPr txBox="1"/>
+          <p:nvPr/>
+        </p:nvSpPr>
+        <p:spPr>
+          <a:xfrm>
+            <a:off x="438912" y="1261872"/>
+            <a:ext cx="1920239" cy="292608"/>
+          </a:xfrm>
+          <a:prstGeom prst="rect">
+            <a:avLst/>
+          </a:prstGeom>
+          <a:noFill/>
+        </p:spPr>
+        <p:txBody>
+          <a:bodyPr wrap="square">
+            <a:spAutoFit/>
+          </a:bodyPr>
+          <a:lstStyle/>
+          <a:p>
+            <a:pPr algn="l"/>
+            <a:r>
+              <a:rPr sz="800" b="1" i="0">
+                <a:solidFill>
+                  <a:srgbClr val="FFFFFF"/>
+                </a:solidFill>
+                <a:latin typeface="Calibri"/>
+              </a:rPr>
+              <a:t>P1  ·  Low risk · High impact</a:t>
+            </a:r>
+          </a:p>
+        </p:txBody>
+      </p:sp>
+      <p:sp>
+        <p:nvSpPr>
+          <p:cNvPr id="10" name="Rectangle 9"/>
+          <p:cNvSpPr/>
+          <p:nvPr/>
+        </p:nvSpPr>
+        <p:spPr>
+          <a:xfrm>
+            <a:off x="457200" y="1719072"/>
+            <a:ext cx="1883663" cy="54864"/>
+          </a:xfrm>
+          <a:prstGeom prst="rect">
+            <a:avLst/>
+          </a:prstGeom>
+          <a:solidFill>
+            <a:srgbClr val="0E5E38"/>
+          </a:solidFill>
+          <a:ln>
+            <a:noFill/>
+          </a:ln>
+        </p:spPr>
+        <p:style>
+          <a:lnRef idx="1">
+            <a:schemeClr val="accent1"/>
+          </a:lnRef>
+          <a:fillRef idx="3">
+            <a:schemeClr val="accent1"/>
+          </a:fillRef>
+          <a:effectRef idx="2">
+            <a:schemeClr val="accent1"/>
+          </a:effectRef>
+          <a:fontRef idx="minor">
+            <a:schemeClr val="lt1"/>
+          </a:fontRef>
+        </p:style>
+        <p:txBody>
+          <a:bodyPr rtlCol="0" anchor="ctr"/>
+          <a:lstStyle/>
+          <a:p>
+            <a:pPr algn="ctr"/>
+          </a:p>
+        </p:txBody>
+      </p:sp>
+      <p:sp>
+        <p:nvSpPr>
+          <p:cNvPr id="11" name="TextBox 10"/>
+          <p:cNvSpPr txBox="1"/>
+          <p:nvPr/>
+        </p:nvSpPr>
+        <p:spPr>
+          <a:xfrm>
+            <a:off x="457200" y="1847088"/>
+            <a:ext cx="1883663" cy="640080"/>
+          </a:xfrm>
+          <a:prstGeom prst="rect">
+            <a:avLst/>
+          </a:prstGeom>
+          <a:noFill/>
+        </p:spPr>
+        <p:txBody>
+          <a:bodyPr wrap="square">
+            <a:spAutoFit/>
+          </a:bodyPr>
+          <a:lstStyle/>
+          <a:p>
+            <a:pPr algn="l"/>
+            <a:r>
+              <a:rPr sz="1100" b="1" i="0">
+                <a:solidFill>
+                  <a:srgbClr val="111827"/>
+                </a:solidFill>
+                <a:latin typeface="Calibri"/>
+              </a:rPr>
+              <a:t>Incremental Ingest Watermark</a:t>
+            </a:r>
+          </a:p>
+        </p:txBody>
+      </p:sp>
+      <p:sp>
+        <p:nvSpPr>
+          <p:cNvPr id="12" name="TextBox 11"/>
+          <p:cNvSpPr txBox="1"/>
+          <p:nvPr/>
+        </p:nvSpPr>
+        <p:spPr>
+          <a:xfrm>
+            <a:off x="457200" y="2523744"/>
+            <a:ext cx="1883663" cy="2852928"/>
+          </a:xfrm>
+          <a:prstGeom prst="rect">
+            <a:avLst/>
+          </a:prstGeom>
+          <a:noFill/>
+        </p:spPr>
+        <p:txBody>
+          <a:bodyPr wrap="square">
+            <a:spAutoFit/>
+          </a:bodyPr>
+          <a:lstStyle/>
+          <a:p>
+            <a:pPr algn="l"/>
+            <a:r>
+              <a:rPr sz="850" b="0" i="0">
+                <a:solidFill>
+                  <a:srgbClr val="6B7FA0"/>
+                </a:solidFill>
+                <a:latin typeface="Calibri"/>
+              </a:rPr>
+              <a:t>Load only new weeks via OVERWRITE WHERE — never re-process full history. Requires a watermark metadata store and verification that all Q-series queries are window-safe.</a:t>
+            </a:r>
+          </a:p>
+        </p:txBody>
+      </p:sp>
+      <p:sp>
+        <p:nvSpPr>
+          <p:cNvPr id="13" name="Rectangle 12"/>
+          <p:cNvSpPr/>
+          <p:nvPr/>
+        </p:nvSpPr>
+        <p:spPr>
+          <a:xfrm>
+            <a:off x="2587751" y="1170432"/>
+            <a:ext cx="2103120" cy="4297680"/>
+          </a:xfrm>
+          <a:prstGeom prst="rect">
+            <a:avLst/>
+          </a:prstGeom>
+          <a:solidFill>
+            <a:srgbClr val="FFFFFF"/>
+          </a:solidFill>
+          <a:ln w="9525">
+            <a:solidFill>
+              <a:srgbClr val="C0CCE4"/>
+            </a:solidFill>
+          </a:ln>
+        </p:spPr>
+        <p:style>
+          <a:lnRef idx="1">
+            <a:schemeClr val="accent1"/>
+          </a:lnRef>
+          <a:fillRef idx="3">
+            <a:schemeClr val="accent1"/>
+          </a:fillRef>
+          <a:effectRef idx="2">
+            <a:schemeClr val="accent1"/>
+          </a:effectRef>
+          <a:fontRef idx="minor">
+            <a:schemeClr val="lt1"/>
+          </a:fontRef>
+        </p:style>
+        <p:txBody>
+          <a:bodyPr rtlCol="0" anchor="ctr"/>
+          <a:lstStyle/>
+          <a:p>
+            <a:pPr algn="ctr"/>
+          </a:p>
+        </p:txBody>
+      </p:sp>
+      <p:sp>
+        <p:nvSpPr>
+          <p:cNvPr id="14" name="Rectangle 13"/>
+          <p:cNvSpPr/>
+          <p:nvPr/>
+        </p:nvSpPr>
+        <p:spPr>
+          <a:xfrm>
+            <a:off x="2587751" y="1170432"/>
+            <a:ext cx="2103120" cy="457200"/>
+          </a:xfrm>
+          <a:prstGeom prst="rect">
+            <a:avLst/>
+          </a:prstGeom>
+          <a:solidFill>
+            <a:srgbClr val="4078D0"/>
+          </a:solidFill>
+          <a:ln>
+            <a:noFill/>
+          </a:ln>
+        </p:spPr>
+        <p:style>
+          <a:lnRef idx="1">
+            <a:schemeClr val="accent1"/>
+          </a:lnRef>
+          <a:fillRef idx="3">
+            <a:schemeClr val="accent1"/>
+          </a:fillRef>
+          <a:effectRef idx="2">
+            <a:schemeClr val="accent1"/>
+          </a:effectRef>
+          <a:fontRef idx="minor">
+            <a:schemeClr val="lt1"/>
+          </a:fontRef>
+        </p:style>
+        <p:txBody>
+          <a:bodyPr rtlCol="0" anchor="ctr"/>
+          <a:lstStyle/>
+          <a:p>
+            <a:pPr algn="ctr"/>
+          </a:p>
+        </p:txBody>
+      </p:sp>
+      <p:sp>
+        <p:nvSpPr>
+          <p:cNvPr id="15" name="TextBox 14"/>
+          <p:cNvSpPr txBox="1"/>
+          <p:nvPr/>
+        </p:nvSpPr>
+        <p:spPr>
+          <a:xfrm>
+            <a:off x="2679191" y="1261872"/>
+            <a:ext cx="1920239" cy="292608"/>
+          </a:xfrm>
+          <a:prstGeom prst="rect">
+            <a:avLst/>
+          </a:prstGeom>
+          <a:noFill/>
+        </p:spPr>
+        <p:txBody>
+          <a:bodyPr wrap="square">
+            <a:spAutoFit/>
+          </a:bodyPr>
+          <a:lstStyle/>
+          <a:p>
+            <a:pPr algn="l"/>
+            <a:r>
+              <a:rPr sz="800" b="1" i="0">
+                <a:solidFill>
+                  <a:srgbClr val="FFFFFF"/>
+                </a:solidFill>
+                <a:latin typeface="Calibri"/>
+              </a:rPr>
+              <a:t>P2  ·  Foundation for P3</a:t>
+            </a:r>
+          </a:p>
+        </p:txBody>
+      </p:sp>
+      <p:sp>
+        <p:nvSpPr>
+          <p:cNvPr id="16" name="Rectangle 15"/>
+          <p:cNvSpPr/>
+          <p:nvPr/>
+        </p:nvSpPr>
+        <p:spPr>
+          <a:xfrm>
+            <a:off x="2697479" y="1719072"/>
+            <a:ext cx="1883663" cy="54864"/>
+          </a:xfrm>
+          <a:prstGeom prst="rect">
+            <a:avLst/>
+          </a:prstGeom>
+          <a:solidFill>
+            <a:srgbClr val="4078D0"/>
+          </a:solidFill>
+          <a:ln>
+            <a:noFill/>
+          </a:ln>
+        </p:spPr>
+        <p:style>
+          <a:lnRef idx="1">
+            <a:schemeClr val="accent1"/>
+          </a:lnRef>
+          <a:fillRef idx="3">
+            <a:schemeClr val="accent1"/>
+          </a:fillRef>
+          <a:effectRef idx="2">
+            <a:schemeClr val="accent1"/>
+          </a:effectRef>
+          <a:fontRef idx="minor">
+            <a:schemeClr val="lt1"/>
+          </a:fontRef>
+        </p:style>
+        <p:txBody>
+          <a:bodyPr rtlCol="0" anchor="ctr"/>
+          <a:lstStyle/>
+          <a:p>
+            <a:pPr algn="ctr"/>
+          </a:p>
+        </p:txBody>
+      </p:sp>
+      <p:sp>
+        <p:nvSpPr>
+          <p:cNvPr id="17" name="TextBox 16"/>
+          <p:cNvSpPr txBox="1"/>
+          <p:nvPr/>
+        </p:nvSpPr>
+        <p:spPr>
+          <a:xfrm>
+            <a:off x="2697479" y="1847088"/>
+            <a:ext cx="1883663" cy="640080"/>
+          </a:xfrm>
+          <a:prstGeom prst="rect">
+            <a:avLst/>
+          </a:prstGeom>
+          <a:noFill/>
+        </p:spPr>
+        <p:txBody>
+          <a:bodyPr wrap="square">
+            <a:spAutoFit/>
+          </a:bodyPr>
+          <a:lstStyle/>
+          <a:p>
+            <a:pPr algn="l"/>
+            <a:r>
+              <a:rPr sz="1100" b="1" i="0">
+                <a:solidFill>
+                  <a:srgbClr val="111827"/>
+                </a:solidFill>
+                <a:latin typeface="Calibri"/>
+              </a:rPr>
+              <a:t>Shell Orchestration — run_data_ops.sh</a:t>
+            </a:r>
+          </a:p>
+        </p:txBody>
+      </p:sp>
+      <p:sp>
+        <p:nvSpPr>
+          <p:cNvPr id="18" name="TextBox 17"/>
+          <p:cNvSpPr txBox="1"/>
+          <p:nvPr/>
+        </p:nvSpPr>
+        <p:spPr>
+          <a:xfrm>
+            <a:off x="2697479" y="2523744"/>
+            <a:ext cx="1883663" cy="2852928"/>
+          </a:xfrm>
+          <a:prstGeom prst="rect">
+            <a:avLst/>
+          </a:prstGeom>
+          <a:noFill/>
+        </p:spPr>
+        <p:txBody>
+          <a:bodyPr wrap="square">
+            <a:spAutoFit/>
+          </a:bodyPr>
+          <a:lstStyle/>
+          <a:p>
+            <a:pPr algn="l"/>
+            <a:r>
+              <a:rPr sz="850" b="0" i="0">
+                <a:solidFill>
+                  <a:srgbClr val="6B7FA0"/>
+                </a:solidFill>
+                <a:latin typeface="Calibri"/>
+              </a:rPr>
+              <a:t>Chain Q-series and P-series scripts with per-stage gate assertions and halt-on-failure logic. Same pattern as run_fpa_report.sh. Manual execution first; trigger integration added in P3.</a:t>
+            </a:r>
+          </a:p>
+        </p:txBody>
+      </p:sp>
+      <p:sp>
+        <p:nvSpPr>
+          <p:cNvPr id="19" name="Rectangle 18"/>
+          <p:cNvSpPr/>
+          <p:nvPr/>
+        </p:nvSpPr>
+        <p:spPr>
+          <a:xfrm>
+            <a:off x="4828031" y="1170432"/>
+            <a:ext cx="2103120" cy="4297680"/>
+          </a:xfrm>
+          <a:prstGeom prst="rect">
+            <a:avLst/>
+          </a:prstGeom>
+          <a:solidFill>
+            <a:srgbClr val="FFFFFF"/>
+          </a:solidFill>
+          <a:ln w="9525">
+            <a:solidFill>
+              <a:srgbClr val="C0CCE4"/>
+            </a:solidFill>
+          </a:ln>
+        </p:spPr>
+        <p:style>
+          <a:lnRef idx="1">
+            <a:schemeClr val="accent1"/>
+          </a:lnRef>
+          <a:fillRef idx="3">
+            <a:schemeClr val="accent1"/>
+          </a:fillRef>
+          <a:effectRef idx="2">
+            <a:schemeClr val="accent1"/>
+          </a:effectRef>
+          <a:fontRef idx="minor">
+            <a:schemeClr val="lt1"/>
+          </a:fontRef>
+        </p:style>
+        <p:txBody>
+          <a:bodyPr rtlCol="0" anchor="ctr"/>
+          <a:lstStyle/>
+          <a:p>
+            <a:pPr algn="ctr"/>
+          </a:p>
+        </p:txBody>
+      </p:sp>
+      <p:sp>
+        <p:nvSpPr>
+          <p:cNvPr id="20" name="Rectangle 19"/>
+          <p:cNvSpPr/>
+          <p:nvPr/>
+        </p:nvSpPr>
+        <p:spPr>
+          <a:xfrm>
+            <a:off x="4828031" y="1170432"/>
+            <a:ext cx="2103120" cy="457200"/>
+          </a:xfrm>
+          <a:prstGeom prst="rect">
+            <a:avLst/>
+          </a:prstGeom>
+          <a:solidFill>
+            <a:srgbClr val="4078D0"/>
+          </a:solidFill>
+          <a:ln>
+            <a:noFill/>
+          </a:ln>
+        </p:spPr>
+        <p:style>
+          <a:lnRef idx="1">
+            <a:schemeClr val="accent1"/>
+          </a:lnRef>
+          <a:fillRef idx="3">
+            <a:schemeClr val="accent1"/>
+          </a:fillRef>
+          <a:effectRef idx="2">
+            <a:schemeClr val="accent1"/>
+          </a:effectRef>
+          <a:fontRef idx="minor">
+            <a:schemeClr val="lt1"/>
+          </a:fontRef>
+        </p:style>
+        <p:txBody>
+          <a:bodyPr rtlCol="0" anchor="ctr"/>
+          <a:lstStyle/>
+          <a:p>
+            <a:pPr algn="ctr"/>
+          </a:p>
+        </p:txBody>
+      </p:sp>
+      <p:sp>
+        <p:nvSpPr>
+          <p:cNvPr id="21" name="TextBox 20"/>
+          <p:cNvSpPr txBox="1"/>
+          <p:nvPr/>
+        </p:nvSpPr>
+        <p:spPr>
+          <a:xfrm>
+            <a:off x="4919471" y="1261872"/>
+            <a:ext cx="1920239" cy="292608"/>
+          </a:xfrm>
+          <a:prstGeom prst="rect">
+            <a:avLst/>
+          </a:prstGeom>
+          <a:noFill/>
+        </p:spPr>
+        <p:txBody>
+          <a:bodyPr wrap="square">
+            <a:spAutoFit/>
+          </a:bodyPr>
+          <a:lstStyle/>
+          <a:p>
+            <a:pPr algn="l"/>
+            <a:r>
+              <a:rPr sz="800" b="1" i="0">
+                <a:solidFill>
+                  <a:srgbClr val="FFFFFF"/>
+                </a:solidFill>
+                <a:latin typeface="Calibri"/>
+              </a:rPr>
+              <a:t>P3  ·  Requires P2</a:t>
+            </a:r>
+          </a:p>
+        </p:txBody>
+      </p:sp>
+      <p:sp>
+        <p:nvSpPr>
+          <p:cNvPr id="22" name="Rectangle 21"/>
+          <p:cNvSpPr/>
+          <p:nvPr/>
+        </p:nvSpPr>
+        <p:spPr>
+          <a:xfrm>
+            <a:off x="4937759" y="1719072"/>
+            <a:ext cx="1883663" cy="54864"/>
+          </a:xfrm>
+          <a:prstGeom prst="rect">
+            <a:avLst/>
+          </a:prstGeom>
+          <a:solidFill>
+            <a:srgbClr val="4078D0"/>
+          </a:solidFill>
+          <a:ln>
+            <a:noFill/>
+          </a:ln>
+        </p:spPr>
+        <p:style>
+          <a:lnRef idx="1">
+            <a:schemeClr val="accent1"/>
+          </a:lnRef>
+          <a:fillRef idx="3">
+            <a:schemeClr val="accent1"/>
+          </a:fillRef>
+          <a:effectRef idx="2">
+            <a:schemeClr val="accent1"/>
+          </a:effectRef>
+          <a:fontRef idx="minor">
+            <a:schemeClr val="lt1"/>
+          </a:fontRef>
+        </p:style>
+        <p:txBody>
+          <a:bodyPr rtlCol="0" anchor="ctr"/>
+          <a:lstStyle/>
+          <a:p>
+            <a:pPr algn="ctr"/>
+          </a:p>
+        </p:txBody>
+      </p:sp>
+      <p:sp>
+        <p:nvSpPr>
+          <p:cNvPr id="23" name="TextBox 22"/>
+          <p:cNvSpPr txBox="1"/>
+          <p:nvPr/>
+        </p:nvSpPr>
+        <p:spPr>
+          <a:xfrm>
+            <a:off x="4937759" y="1847088"/>
+            <a:ext cx="1883663" cy="640080"/>
+          </a:xfrm>
+          <a:prstGeom prst="rect">
+            <a:avLst/>
+          </a:prstGeom>
+          <a:noFill/>
+        </p:spPr>
+        <p:txBody>
+          <a:bodyPr wrap="square">
+            <a:spAutoFit/>
+          </a:bodyPr>
+          <a:lstStyle/>
+          <a:p>
+            <a:pPr algn="l"/>
+            <a:r>
+              <a:rPr sz="1100" b="1" i="0">
+                <a:solidFill>
+                  <a:srgbClr val="111827"/>
+                </a:solidFill>
+                <a:latin typeface="Calibri"/>
+              </a:rPr>
+              <a:t>File-Watch Trigger — MinIO bucket event</a:t>
+            </a:r>
+          </a:p>
+        </p:txBody>
+      </p:sp>
+      <p:sp>
+        <p:nvSpPr>
+          <p:cNvPr id="24" name="TextBox 23"/>
+          <p:cNvSpPr txBox="1"/>
+          <p:nvPr/>
+        </p:nvSpPr>
+        <p:spPr>
+          <a:xfrm>
+            <a:off x="4937759" y="2523744"/>
+            <a:ext cx="1883663" cy="2852928"/>
+          </a:xfrm>
+          <a:prstGeom prst="rect">
+            <a:avLst/>
+          </a:prstGeom>
+          <a:noFill/>
+        </p:spPr>
+        <p:txBody>
+          <a:bodyPr wrap="square">
+            <a:spAutoFit/>
+          </a:bodyPr>
+          <a:lstStyle/>
+          <a:p>
+            <a:pPr algn="l"/>
+            <a:r>
+              <a:rPr sz="850" b="0" i="0">
+                <a:solidFill>
+                  <a:srgbClr val="6B7FA0"/>
+                </a:solidFill>
+                <a:latin typeface="Calibri"/>
+              </a:rPr>
+              <a:t>Wire MinIO bucket notification to fire run_data_ops.sh when a new SPINS export lands. Aevah owns the entire run from deposit to scored output — no manual step required.</a:t>
+            </a:r>
+          </a:p>
+        </p:txBody>
+      </p:sp>
+      <p:sp>
+        <p:nvSpPr>
+          <p:cNvPr id="25" name="Rectangle 24"/>
+          <p:cNvSpPr/>
+          <p:nvPr/>
+        </p:nvSpPr>
+        <p:spPr>
+          <a:xfrm>
+            <a:off x="7068312" y="1170432"/>
+            <a:ext cx="2103120" cy="4297680"/>
+          </a:xfrm>
+          <a:prstGeom prst="rect">
+            <a:avLst/>
+          </a:prstGeom>
+          <a:solidFill>
+            <a:srgbClr val="FFFFFF"/>
+          </a:solidFill>
+          <a:ln w="9525">
+            <a:solidFill>
+              <a:srgbClr val="C0CCE4"/>
+            </a:solidFill>
+          </a:ln>
+        </p:spPr>
+        <p:style>
+          <a:lnRef idx="1">
+            <a:schemeClr val="accent1"/>
+          </a:lnRef>
+          <a:fillRef idx="3">
+            <a:schemeClr val="accent1"/>
+          </a:fillRef>
+          <a:effectRef idx="2">
+            <a:schemeClr val="accent1"/>
+          </a:effectRef>
+          <a:fontRef idx="minor">
+            <a:schemeClr val="lt1"/>
+          </a:fontRef>
+        </p:style>
+        <p:txBody>
+          <a:bodyPr rtlCol="0" anchor="ctr"/>
+          <a:lstStyle/>
+          <a:p>
+            <a:pPr algn="ctr"/>
+          </a:p>
+        </p:txBody>
+      </p:sp>
+      <p:sp>
+        <p:nvSpPr>
+          <p:cNvPr id="26" name="Rectangle 25"/>
+          <p:cNvSpPr/>
+          <p:nvPr/>
+        </p:nvSpPr>
+        <p:spPr>
+          <a:xfrm>
+            <a:off x="7068312" y="1170432"/>
+            <a:ext cx="2103120" cy="457200"/>
+          </a:xfrm>
+          <a:prstGeom prst="rect">
+            <a:avLst/>
+          </a:prstGeom>
+          <a:solidFill>
+            <a:srgbClr val="4B2D8A"/>
+          </a:solidFill>
+          <a:ln>
+            <a:noFill/>
+          </a:ln>
+        </p:spPr>
+        <p:style>
+          <a:lnRef idx="1">
+            <a:schemeClr val="accent1"/>
+          </a:lnRef>
+          <a:fillRef idx="3">
+            <a:schemeClr val="accent1"/>
+          </a:fillRef>
+          <a:effectRef idx="2">
+            <a:schemeClr val="accent1"/>
+          </a:effectRef>
+          <a:fontRef idx="minor">
+            <a:schemeClr val="lt1"/>
+          </a:fontRef>
+        </p:style>
+        <p:txBody>
+          <a:bodyPr rtlCol="0" anchor="ctr"/>
+          <a:lstStyle/>
+          <a:p>
+            <a:pPr algn="ctr"/>
+          </a:p>
+        </p:txBody>
+      </p:sp>
+      <p:sp>
+        <p:nvSpPr>
+          <p:cNvPr id="27" name="TextBox 26"/>
+          <p:cNvSpPr txBox="1"/>
+          <p:nvPr/>
+        </p:nvSpPr>
+        <p:spPr>
+          <a:xfrm>
+            <a:off x="7159751" y="1261872"/>
+            <a:ext cx="1920239" cy="292608"/>
+          </a:xfrm>
+          <a:prstGeom prst="rect">
+            <a:avLst/>
+          </a:prstGeom>
+          <a:noFill/>
+        </p:spPr>
+        <p:txBody>
+          <a:bodyPr wrap="square">
+            <a:spAutoFit/>
+          </a:bodyPr>
+          <a:lstStyle/>
+          <a:p>
+            <a:pPr algn="l"/>
+            <a:r>
+              <a:rPr sz="800" b="1" i="0">
+                <a:solidFill>
+                  <a:srgbClr val="FFFFFF"/>
+                </a:solidFill>
+                <a:latin typeface="Calibri"/>
+              </a:rPr>
+              <a:t>P4  ·  Testing</a:t>
+            </a:r>
+          </a:p>
+        </p:txBody>
+      </p:sp>
+      <p:sp>
+        <p:nvSpPr>
+          <p:cNvPr id="28" name="Rectangle 27"/>
+          <p:cNvSpPr/>
+          <p:nvPr/>
+        </p:nvSpPr>
+        <p:spPr>
+          <a:xfrm>
+            <a:off x="7178040" y="1719072"/>
+            <a:ext cx="1883663" cy="54864"/>
+          </a:xfrm>
+          <a:prstGeom prst="rect">
+            <a:avLst/>
+          </a:prstGeom>
+          <a:solidFill>
+            <a:srgbClr val="4B2D8A"/>
+          </a:solidFill>
+          <a:ln>
+            <a:noFill/>
+          </a:ln>
+        </p:spPr>
+        <p:style>
+          <a:lnRef idx="1">
+            <a:schemeClr val="accent1"/>
+          </a:lnRef>
+          <a:fillRef idx="3">
+            <a:schemeClr val="accent1"/>
+          </a:fillRef>
+          <a:effectRef idx="2">
+            <a:schemeClr val="accent1"/>
+          </a:effectRef>
+          <a:fontRef idx="minor">
+            <a:schemeClr val="lt1"/>
+          </a:fontRef>
+        </p:style>
+        <p:txBody>
+          <a:bodyPr rtlCol="0" anchor="ctr"/>
+          <a:lstStyle/>
+          <a:p>
+            <a:pPr algn="ctr"/>
+          </a:p>
+        </p:txBody>
+      </p:sp>
+      <p:sp>
+        <p:nvSpPr>
+          <p:cNvPr id="29" name="TextBox 28"/>
+          <p:cNvSpPr txBox="1"/>
+          <p:nvPr/>
+        </p:nvSpPr>
+        <p:spPr>
+          <a:xfrm>
+            <a:off x="7178040" y="1847088"/>
+            <a:ext cx="1883663" cy="640080"/>
+          </a:xfrm>
+          <a:prstGeom prst="rect">
+            <a:avLst/>
+          </a:prstGeom>
+          <a:noFill/>
+        </p:spPr>
+        <p:txBody>
+          <a:bodyPr wrap="square">
+            <a:spAutoFit/>
+          </a:bodyPr>
+          <a:lstStyle/>
+          <a:p>
+            <a:pPr algn="l"/>
+            <a:r>
+              <a:rPr sz="1100" b="1" i="0">
+                <a:solidFill>
+                  <a:srgbClr val="111827"/>
+                </a:solidFill>
+                <a:latin typeface="Calibri"/>
+              </a:rPr>
+              <a:t>Smoke Test Suite — pinned test cases</a:t>
+            </a:r>
+          </a:p>
+        </p:txBody>
+      </p:sp>
+      <p:sp>
+        <p:nvSpPr>
+          <p:cNvPr id="30" name="TextBox 29"/>
+          <p:cNvSpPr txBox="1"/>
+          <p:nvPr/>
+        </p:nvSpPr>
+        <p:spPr>
+          <a:xfrm>
+            <a:off x="7178040" y="2523744"/>
+            <a:ext cx="1883663" cy="2852928"/>
+          </a:xfrm>
+          <a:prstGeom prst="rect">
+            <a:avLst/>
+          </a:prstGeom>
+          <a:noFill/>
+        </p:spPr>
+        <p:txBody>
+          <a:bodyPr wrap="square">
+            <a:spAutoFit/>
+          </a:bodyPr>
+          <a:lstStyle/>
+          <a:p>
+            <a:pPr algn="l"/>
+            <a:r>
+              <a:rPr sz="850" b="0" i="0">
+                <a:solidFill>
+                  <a:srgbClr val="6B7FA0"/>
+                </a:solidFill>
+                <a:latin typeface="Calibri"/>
+              </a:rPr>
+              <a:t>Define Stage 4 pinned test cases: known UPC × account pairs with expected direction and magnitude bands. Use FOOD-channel accounts only — never MULO. Assert direction, not exact values.  [GEO-04 / ANO-01]</a:t>
+            </a:r>
+          </a:p>
+        </p:txBody>
+      </p:sp>
+      <p:sp>
+        <p:nvSpPr>
+          <p:cNvPr id="31" name="Rectangle 30"/>
+          <p:cNvSpPr/>
+          <p:nvPr/>
+        </p:nvSpPr>
+        <p:spPr>
+          <a:xfrm>
+            <a:off x="9308592" y="1170432"/>
+            <a:ext cx="2103120" cy="4297680"/>
+          </a:xfrm>
+          <a:prstGeom prst="rect">
+            <a:avLst/>
+          </a:prstGeom>
+          <a:solidFill>
+            <a:srgbClr val="FFFFFF"/>
+          </a:solidFill>
+          <a:ln w="9525">
+            <a:solidFill>
+              <a:srgbClr val="C0CCE4"/>
+            </a:solidFill>
+          </a:ln>
+        </p:spPr>
+        <p:style>
+          <a:lnRef idx="1">
+            <a:schemeClr val="accent1"/>
+          </a:lnRef>
+          <a:fillRef idx="3">
+            <a:schemeClr val="accent1"/>
+          </a:fillRef>
+          <a:effectRef idx="2">
+            <a:schemeClr val="accent1"/>
+          </a:effectRef>
+          <a:fontRef idx="minor">
+            <a:schemeClr val="lt1"/>
+          </a:fontRef>
+        </p:style>
+        <p:txBody>
+          <a:bodyPr rtlCol="0" anchor="ctr"/>
+          <a:lstStyle/>
+          <a:p>
+            <a:pPr algn="ctr"/>
+          </a:p>
+        </p:txBody>
+      </p:sp>
+      <p:sp>
+        <p:nvSpPr>
+          <p:cNvPr id="32" name="Rectangle 31"/>
+          <p:cNvSpPr/>
+          <p:nvPr/>
+        </p:nvSpPr>
+        <p:spPr>
+          <a:xfrm>
+            <a:off x="9308592" y="1170432"/>
+            <a:ext cx="2103120" cy="457200"/>
+          </a:xfrm>
+          <a:prstGeom prst="rect">
+            <a:avLst/>
+          </a:prstGeom>
+          <a:solidFill>
+            <a:srgbClr val="8A4800"/>
+          </a:solidFill>
+          <a:ln>
+            <a:noFill/>
+          </a:ln>
+        </p:spPr>
+        <p:style>
+          <a:lnRef idx="1">
+            <a:schemeClr val="accent1"/>
+          </a:lnRef>
+          <a:fillRef idx="3">
+            <a:schemeClr val="accent1"/>
+          </a:fillRef>
+          <a:effectRef idx="2">
+            <a:schemeClr val="accent1"/>
+          </a:effectRef>
+          <a:fontRef idx="minor">
+            <a:schemeClr val="lt1"/>
+          </a:fontRef>
+        </p:style>
+        <p:txBody>
+          <a:bodyPr rtlCol="0" anchor="ctr"/>
+          <a:lstStyle/>
+          <a:p>
+            <a:pPr algn="ctr"/>
+          </a:p>
+        </p:txBody>
+      </p:sp>
+      <p:sp>
+        <p:nvSpPr>
+          <p:cNvPr id="33" name="TextBox 32"/>
+          <p:cNvSpPr txBox="1"/>
+          <p:nvPr/>
+        </p:nvSpPr>
+        <p:spPr>
+          <a:xfrm>
+            <a:off x="9400032" y="1261872"/>
+            <a:ext cx="1920239" cy="292608"/>
+          </a:xfrm>
+          <a:prstGeom prst="rect">
+            <a:avLst/>
+          </a:prstGeom>
+          <a:noFill/>
+        </p:spPr>
+        <p:txBody>
+          <a:bodyPr wrap="square">
+            <a:spAutoFit/>
+          </a:bodyPr>
+          <a:lstStyle/>
+          <a:p>
+            <a:pPr algn="l"/>
+            <a:r>
+              <a:rPr sz="800" b="1" i="0">
+                <a:solidFill>
+                  <a:srgbClr val="FFFFFF"/>
+                </a:solidFill>
+                <a:latin typeface="Calibri"/>
+              </a:rPr>
+              <a:t>P5  ·  Benchmark required first</a:t>
+            </a:r>
+          </a:p>
+        </p:txBody>
+      </p:sp>
+      <p:sp>
+        <p:nvSpPr>
+          <p:cNvPr id="34" name="Rectangle 33"/>
+          <p:cNvSpPr/>
+          <p:nvPr/>
+        </p:nvSpPr>
+        <p:spPr>
+          <a:xfrm>
+            <a:off x="9418319" y="1719072"/>
+            <a:ext cx="1883663" cy="54864"/>
+          </a:xfrm>
+          <a:prstGeom prst="rect">
+            <a:avLst/>
+          </a:prstGeom>
+          <a:solidFill>
+            <a:srgbClr val="8A4800"/>
+          </a:solidFill>
+          <a:ln>
+            <a:noFill/>
+          </a:ln>
+        </p:spPr>
+        <p:style>
+          <a:lnRef idx="1">
+            <a:schemeClr val="accent1"/>
+          </a:lnRef>
+          <a:fillRef idx="3">
+            <a:schemeClr val="accent1"/>
+          </a:fillRef>
+          <a:effectRef idx="2">
+            <a:schemeClr val="accent1"/>
+          </a:effectRef>
+          <a:fontRef idx="minor">
+            <a:schemeClr val="lt1"/>
+          </a:fontRef>
+        </p:style>
+        <p:txBody>
+          <a:bodyPr rtlCol="0" anchor="ctr"/>
+          <a:lstStyle/>
+          <a:p>
+            <a:pPr algn="ctr"/>
+          </a:p>
+        </p:txBody>
+      </p:sp>
+      <p:sp>
+        <p:nvSpPr>
+          <p:cNvPr id="35" name="TextBox 34"/>
+          <p:cNvSpPr txBox="1"/>
+          <p:nvPr/>
+        </p:nvSpPr>
+        <p:spPr>
+          <a:xfrm>
+            <a:off x="9418319" y="1847088"/>
+            <a:ext cx="1883663" cy="640080"/>
+          </a:xfrm>
+          <a:prstGeom prst="rect">
+            <a:avLst/>
+          </a:prstGeom>
+          <a:noFill/>
+        </p:spPr>
+        <p:txBody>
+          <a:bodyPr wrap="square">
+            <a:spAutoFit/>
+          </a:bodyPr>
+          <a:lstStyle/>
+          <a:p>
+            <a:pPr algn="l"/>
+            <a:r>
+              <a:rPr sz="1100" b="1" i="0">
+                <a:solidFill>
+                  <a:srgbClr val="111827"/>
+                </a:solidFill>
+                <a:latin typeface="Calibri"/>
+              </a:rPr>
+              <a:t>Druid Segment Tuning</a:t>
+            </a:r>
+          </a:p>
+        </p:txBody>
+      </p:sp>
+      <p:sp>
+        <p:nvSpPr>
+          <p:cNvPr id="36" name="TextBox 35"/>
+          <p:cNvSpPr txBox="1"/>
+          <p:nvPr/>
+        </p:nvSpPr>
+        <p:spPr>
+          <a:xfrm>
+            <a:off x="9418319" y="2523744"/>
+            <a:ext cx="1883663" cy="2852928"/>
+          </a:xfrm>
+          <a:prstGeom prst="rect">
+            <a:avLst/>
+          </a:prstGeom>
+          <a:noFill/>
+        </p:spPr>
+        <p:txBody>
+          <a:bodyPr wrap="square">
+            <a:spAutoFit/>
+          </a:bodyPr>
+          <a:lstStyle/>
+          <a:p>
+            <a:pPr algn="l"/>
+            <a:r>
+              <a:rPr sz="850" b="0" i="0">
+                <a:solidFill>
+                  <a:srgbClr val="6B7FA0"/>
+                </a:solidFill>
+                <a:latin typeface="Calibri"/>
+              </a:rPr>
+              <a:t>Baseline query-time benchmark on built_filtered_weekly and ml_training_features. Evaluate segment granularity and partition changes on a copy before touching live specs. MULO exclusion logic and OVERWRITE WHERE pattern must be preserved.  [GEO-01]</a:t>
+            </a:r>
+          </a:p>
+        </p:txBody>
+      </p:sp>
+      <p:sp>
+        <p:nvSpPr>
+          <p:cNvPr id="37" name="Rectangle 36"/>
+          <p:cNvSpPr/>
+          <p:nvPr/>
+        </p:nvSpPr>
+        <p:spPr>
+          <a:xfrm>
+            <a:off x="347472" y="5687568"/>
+            <a:ext cx="11475720" cy="713232"/>
+          </a:xfrm>
+          <a:prstGeom prst="rect">
+            <a:avLst/>
+          </a:prstGeom>
+          <a:solidFill>
+            <a:srgbClr val="D8E5FF"/>
+          </a:solidFill>
+          <a:ln>
+            <a:noFill/>
+          </a:ln>
+        </p:spPr>
+        <p:style>
+          <a:lnRef idx="1">
+            <a:schemeClr val="accent1"/>
+          </a:lnRef>
+          <a:fillRef idx="3">
+            <a:schemeClr val="accent1"/>
+          </a:fillRef>
+          <a:effectRef idx="2">
+            <a:schemeClr val="accent1"/>
+          </a:effectRef>
+          <a:fontRef idx="minor">
+            <a:schemeClr val="lt1"/>
+          </a:fontRef>
+        </p:style>
+        <p:txBody>
+          <a:bodyPr rtlCol="0" anchor="ctr"/>
+          <a:lstStyle/>
+          <a:p>
+            <a:pPr algn="ctr"/>
+          </a:p>
+        </p:txBody>
+      </p:sp>
+      <p:sp>
+        <p:nvSpPr>
+          <p:cNvPr id="38" name="TextBox 37"/>
+          <p:cNvSpPr txBox="1"/>
+          <p:nvPr/>
+        </p:nvSpPr>
+        <p:spPr>
+          <a:xfrm>
+            <a:off x="502920" y="5742432"/>
+            <a:ext cx="11155680" cy="256032"/>
+          </a:xfrm>
+          <a:prstGeom prst="rect">
+            <a:avLst/>
+          </a:prstGeom>
+          <a:noFill/>
+        </p:spPr>
+        <p:txBody>
+          <a:bodyPr wrap="square">
+            <a:spAutoFit/>
+          </a:bodyPr>
+          <a:lstStyle/>
+          <a:p>
+            <a:pPr algn="l"/>
+            <a:r>
+              <a:rPr sz="800" b="1" i="0">
+                <a:solidFill>
+                  <a:srgbClr val="4078D0"/>
+                </a:solidFill>
+                <a:latin typeface="Calibri"/>
+              </a:rPr>
+              <a:t>TESTING PRINCIPLE</a:t>
+            </a:r>
+          </a:p>
+        </p:txBody>
+      </p:sp>
+      <p:sp>
+        <p:nvSpPr>
+          <p:cNvPr id="39" name="TextBox 38"/>
+          <p:cNvSpPr txBox="1"/>
+          <p:nvPr/>
+        </p:nvSpPr>
+        <p:spPr>
+          <a:xfrm>
+            <a:off x="502920" y="5971032"/>
+            <a:ext cx="11155680" cy="384048"/>
+          </a:xfrm>
+          <a:prstGeom prst="rect">
+            <a:avLst/>
+          </a:prstGeom>
+          <a:noFill/>
+        </p:spPr>
+        <p:txBody>
+          <a:bodyPr wrap="square">
+            <a:spAutoFit/>
+          </a:bodyPr>
+          <a:lstStyle/>
+          <a:p>
+            <a:pPr algn="l"/>
+            <a:r>
+              <a:rPr sz="950" b="0" i="0">
+                <a:solidFill>
+                  <a:srgbClr val="111827"/>
+                </a:solidFill>
+                <a:latin typeface="Calibri"/>
+              </a:rPr>
+              <a:t>No spec or script changes go live without a before/after benchmark. New methods run in parallel against the existing method on a copy first. Any coverage drop &gt;10% from prior run halts and alerts — degenerate output detection runs on every automated run, not just at release.  See: mo_automation_design.html and mo_decisions_register.html for full gate logic.</a:t>
+            </a:r>
+          </a:p>
+        </p:txBody>
+      </p:sp>
+      <p:sp>
+        <p:nvSpPr>
+          <p:cNvPr id="40" name="TextBox 39"/>
+          <p:cNvSpPr txBox="1"/>
+          <p:nvPr/>
+        </p:nvSpPr>
+        <p:spPr>
+          <a:xfrm>
+            <a:off x="457200" y="6583680"/>
+            <a:ext cx="11430000" cy="228600"/>
+          </a:xfrm>
+          <a:prstGeom prst="rect">
+            <a:avLst/>
+          </a:prstGeom>
+          <a:noFill/>
+        </p:spPr>
+        <p:txBody>
+          <a:bodyPr wrap="square">
+            <a:spAutoFit/>
+          </a:bodyPr>
+          <a:lstStyle/>
+          <a:p>
+            <a:pPr algn="r"/>
+            <a:r>
+              <a:rPr sz="800" b="0" i="0">
+                <a:solidFill>
+                  <a:srgbClr val="6B7FA0"/>
+                </a:solidFill>
+                <a:latin typeface="Calibri"/>
+              </a:rPr>
+              <a:t>Mo by Aevah  ·  BUILT Kickoff  ·  August 2026  ·  Confidential</a:t>
+            </a:r>
+          </a:p>
+        </p:txBody>
+      </p:sp>
+    </p:spTree>
+  </p:cSld>
+  <p:clrMapOvr>
+    <a:masterClrMapping/>
+  </p:clrMapOvr>
+</p:sld>
+</file>
+
+<file path=ppt/slides/slide11.xml><?xml version="1.0" encoding="utf-8"?>
+<p:sld xmlns:a="http://schemas.openxmlformats.org/drawingml/2006/main" xmlns:p="http://schemas.openxmlformats.org/presentationml/2006/main" xmlns:r="http://schemas.openxmlformats.org/officeDocument/2006/relationships">
+  <p:cSld>
+    <p:spTree>
+      <p:nvGrpSpPr>
+        <p:cNvPr id="1" name=""/>
+        <p:cNvGrpSpPr/>
+        <p:nvPr/>
+      </p:nvGrpSpPr>
+      <p:grpSpPr/>
+      <p:sp>
+        <p:nvSpPr>
+          <p:cNvPr id="2" name="Rectangle 1"/>
+          <p:cNvSpPr/>
+          <p:nvPr/>
+        </p:nvSpPr>
+        <p:spPr>
+          <a:xfrm>
+            <a:off x="0" y="0"/>
+            <a:ext cx="12191695" cy="6858000"/>
+          </a:xfrm>
+          <a:prstGeom prst="rect">
+            <a:avLst/>
+          </a:prstGeom>
+          <a:solidFill>
             <a:srgbClr val="0C1A38"/>
           </a:solidFill>
           <a:ln>
@@ -8191,7 +9737,7 @@
                 </a:solidFill>
                 <a:latin typeface="Calibri"/>
               </a:rPr>
-              <a:t>48-entry living register: null handling, normalization rules, MULO exclusion, known data anomalies, model guardrails, key formulas, and open items. Updated every session.</a:t>
+              <a:t>56-entry living register: null handling, normalization rules, MULO exclusion, known anomalies, model guardrails, key formulas (LaTeX-typeset), external data API rules, and open items. Updated every session.</a:t>
             </a:r>
           </a:p>
         </p:txBody>
@@ -8401,7 +9947,7 @@
                 </a:solidFill>
                 <a:latin typeface="Calibri"/>
               </a:rPr>
-              <a:t>NUL/NRM/GEO/ANO/GRD/COV/FML/OPN</a:t>
+              <a:t>NUL/NRM/GEO/ANO/GRD/COV/FML/OPN/EXT</a:t>
             </a:r>
           </a:p>
         </p:txBody>
@@ -21235,7 +22781,7 @@
         </p:nvSpPr>
         <p:spPr>
           <a:xfrm>
-            <a:off x="457200" y="201168"/>
+            <a:off x="457200" y="164592"/>
             <a:ext cx="9144000" cy="548640"/>
           </a:xfrm>
           <a:prstGeom prst="rect">
@@ -21251,13 +22797,13 @@
           <a:p>
             <a:pPr algn="l"/>
             <a:r>
-              <a:rPr sz="2400" b="1" i="0">
+              <a:rPr sz="2200" b="1" i="0">
                 <a:solidFill>
                   <a:srgbClr val="FFFFFF"/>
                 </a:solidFill>
                 <a:latin typeface="Calibri"/>
               </a:rPr>
-              <a:t>Automation Roadmap</a:t>
+              <a:t>Mo Trends &amp; External Signal Integration</a:t>
             </a:r>
           </a:p>
         </p:txBody>
@@ -21286,13 +22832,13 @@
           <a:p>
             <a:pPr algn="l"/>
             <a:r>
-              <a:rPr sz="1100" b="0" i="0">
+              <a:rPr sz="1050" b="0" i="0">
                 <a:solidFill>
                   <a:srgbClr val="A0C0F0"/>
                 </a:solidFill>
                 <a:latin typeface="Calibri"/>
               </a:rPr>
-              <a:t>Five priorities to remove manual steps from the pipeline — ordered by impact-to-risk ratio. No changes implemented yet; design only.</a:t>
+              <a:t>Sections 06 + 07 of the customer overview — competitive dashboard tiles and external macro/market data feeds (FRED + roadmap).</a:t>
             </a:r>
           </a:p>
         </p:txBody>
@@ -21305,19 +22851,17 @@
         </p:nvSpPr>
         <p:spPr>
           <a:xfrm>
-            <a:off x="347472" y="1170432"/>
-            <a:ext cx="2103120" cy="4297680"/>
+            <a:off x="365760" y="1097280"/>
+            <a:ext cx="5394960" cy="292608"/>
           </a:xfrm>
           <a:prstGeom prst="rect">
             <a:avLst/>
           </a:prstGeom>
           <a:solidFill>
-            <a:srgbClr val="FFFFFF"/>
+            <a:srgbClr val="1B3566"/>
           </a:solidFill>
-          <a:ln w="9525">
-            <a:solidFill>
-              <a:srgbClr val="C0CCE4"/>
-            </a:solidFill>
+          <a:ln>
+            <a:noFill/>
           </a:ln>
         </p:spPr>
         <p:style>
@@ -21344,14 +22888,1082 @@
       </p:sp>
       <p:sp>
         <p:nvSpPr>
-          <p:cNvPr id="8" name="Rectangle 7"/>
+          <p:cNvPr id="8" name="TextBox 7"/>
+          <p:cNvSpPr txBox="1"/>
+          <p:nvPr/>
+        </p:nvSpPr>
+        <p:spPr>
+          <a:xfrm>
+            <a:off x="475488" y="1133856"/>
+            <a:ext cx="5175504" cy="219456"/>
+          </a:xfrm>
+          <a:prstGeom prst="rect">
+            <a:avLst/>
+          </a:prstGeom>
+          <a:noFill/>
+        </p:spPr>
+        <p:txBody>
+          <a:bodyPr wrap="square">
+            <a:spAutoFit/>
+          </a:bodyPr>
+          <a:lstStyle/>
+          <a:p>
+            <a:pPr algn="l"/>
+            <a:r>
+              <a:rPr sz="800" b="1" i="0">
+                <a:solidFill>
+                  <a:srgbClr val="A0C0F0"/>
+                </a:solidFill>
+                <a:latin typeface="Calibri"/>
+              </a:rPr>
+              <a:t>06  ·  MO TRENDS — all data queried live from Druid, no ML scoring table</a:t>
+            </a:r>
+          </a:p>
+        </p:txBody>
+      </p:sp>
+      <p:sp>
+        <p:nvSpPr>
+          <p:cNvPr id="9" name="Rectangle 8"/>
           <p:cNvSpPr/>
           <p:nvPr/>
         </p:nvSpPr>
         <p:spPr>
           <a:xfrm>
-            <a:off x="347472" y="1170432"/>
-            <a:ext cx="2103120" cy="457200"/>
+            <a:off x="365760" y="1389888"/>
+            <a:ext cx="5394960" cy="374904"/>
+          </a:xfrm>
+          <a:prstGeom prst="rect">
+            <a:avLst/>
+          </a:prstGeom>
+          <a:solidFill>
+            <a:srgbClr val="F8FAFD"/>
+          </a:solidFill>
+          <a:ln w="6350">
+            <a:solidFill>
+              <a:srgbClr val="CCD8EE"/>
+            </a:solidFill>
+          </a:ln>
+        </p:spPr>
+        <p:style>
+          <a:lnRef idx="1">
+            <a:schemeClr val="accent1"/>
+          </a:lnRef>
+          <a:fillRef idx="3">
+            <a:schemeClr val="accent1"/>
+          </a:fillRef>
+          <a:effectRef idx="2">
+            <a:schemeClr val="accent1"/>
+          </a:effectRef>
+          <a:fontRef idx="minor">
+            <a:schemeClr val="lt1"/>
+          </a:fontRef>
+        </p:style>
+        <p:txBody>
+          <a:bodyPr rtlCol="0" anchor="ctr"/>
+          <a:lstStyle/>
+          <a:p>
+            <a:pPr algn="ctr"/>
+          </a:p>
+        </p:txBody>
+      </p:sp>
+      <p:sp>
+        <p:nvSpPr>
+          <p:cNvPr id="10" name="TextBox 9"/>
+          <p:cNvSpPr txBox="1"/>
+          <p:nvPr/>
+        </p:nvSpPr>
+        <p:spPr>
+          <a:xfrm>
+            <a:off x="457200" y="1453896"/>
+            <a:ext cx="1965960" cy="283463"/>
+          </a:xfrm>
+          <a:prstGeom prst="rect">
+            <a:avLst/>
+          </a:prstGeom>
+          <a:noFill/>
+        </p:spPr>
+        <p:txBody>
+          <a:bodyPr wrap="square">
+            <a:spAutoFit/>
+          </a:bodyPr>
+          <a:lstStyle/>
+          <a:p>
+            <a:pPr algn="l"/>
+            <a:r>
+              <a:rPr sz="850" b="1" i="0">
+                <a:solidFill>
+                  <a:srgbClr val="111827"/>
+                </a:solidFill>
+                <a:latin typeface="Calibri"/>
+              </a:rPr>
+              <a:t>1 — Brand Velocity</a:t>
+            </a:r>
+          </a:p>
+        </p:txBody>
+      </p:sp>
+      <p:sp>
+        <p:nvSpPr>
+          <p:cNvPr id="11" name="TextBox 10"/>
+          <p:cNvSpPr txBox="1"/>
+          <p:nvPr/>
+        </p:nvSpPr>
+        <p:spPr>
+          <a:xfrm>
+            <a:off x="2468879" y="1453896"/>
+            <a:ext cx="3200400" cy="283463"/>
+          </a:xfrm>
+          <a:prstGeom prst="rect">
+            <a:avLst/>
+          </a:prstGeom>
+          <a:noFill/>
+        </p:spPr>
+        <p:txBody>
+          <a:bodyPr wrap="square">
+            <a:spAutoFit/>
+          </a:bodyPr>
+          <a:lstStyle/>
+          <a:p>
+            <a:pPr algn="l"/>
+            <a:r>
+              <a:rPr sz="800" b="0" i="0">
+                <a:solidFill>
+                  <a:srgbClr val="6B7FA0"/>
+                </a:solidFill>
+                <a:latin typeface="Calibri"/>
+              </a:rPr>
+              <a:t>Weekly units trend — 52-week history + 13-week rolling avg by product/retailer</a:t>
+            </a:r>
+          </a:p>
+        </p:txBody>
+      </p:sp>
+      <p:sp>
+        <p:nvSpPr>
+          <p:cNvPr id="12" name="Rectangle 11"/>
+          <p:cNvSpPr/>
+          <p:nvPr/>
+        </p:nvSpPr>
+        <p:spPr>
+          <a:xfrm>
+            <a:off x="365760" y="1764792"/>
+            <a:ext cx="5394960" cy="374904"/>
+          </a:xfrm>
+          <a:prstGeom prst="rect">
+            <a:avLst/>
+          </a:prstGeom>
+          <a:solidFill>
+            <a:srgbClr val="FFFFFF"/>
+          </a:solidFill>
+          <a:ln w="6350">
+            <a:solidFill>
+              <a:srgbClr val="CCD8EE"/>
+            </a:solidFill>
+          </a:ln>
+        </p:spPr>
+        <p:style>
+          <a:lnRef idx="1">
+            <a:schemeClr val="accent1"/>
+          </a:lnRef>
+          <a:fillRef idx="3">
+            <a:schemeClr val="accent1"/>
+          </a:fillRef>
+          <a:effectRef idx="2">
+            <a:schemeClr val="accent1"/>
+          </a:effectRef>
+          <a:fontRef idx="minor">
+            <a:schemeClr val="lt1"/>
+          </a:fontRef>
+        </p:style>
+        <p:txBody>
+          <a:bodyPr rtlCol="0" anchor="ctr"/>
+          <a:lstStyle/>
+          <a:p>
+            <a:pPr algn="ctr"/>
+          </a:p>
+        </p:txBody>
+      </p:sp>
+      <p:sp>
+        <p:nvSpPr>
+          <p:cNvPr id="13" name="TextBox 12"/>
+          <p:cNvSpPr txBox="1"/>
+          <p:nvPr/>
+        </p:nvSpPr>
+        <p:spPr>
+          <a:xfrm>
+            <a:off x="457200" y="1828800"/>
+            <a:ext cx="1965960" cy="283463"/>
+          </a:xfrm>
+          <a:prstGeom prst="rect">
+            <a:avLst/>
+          </a:prstGeom>
+          <a:noFill/>
+        </p:spPr>
+        <p:txBody>
+          <a:bodyPr wrap="square">
+            <a:spAutoFit/>
+          </a:bodyPr>
+          <a:lstStyle/>
+          <a:p>
+            <a:pPr algn="l"/>
+            <a:r>
+              <a:rPr sz="850" b="1" i="0">
+                <a:solidFill>
+                  <a:srgbClr val="111827"/>
+                </a:solidFill>
+                <a:latin typeface="Calibri"/>
+              </a:rPr>
+              <a:t>2 — Demand Forecast</a:t>
+            </a:r>
+          </a:p>
+        </p:txBody>
+      </p:sp>
+      <p:sp>
+        <p:nvSpPr>
+          <p:cNvPr id="14" name="TextBox 13"/>
+          <p:cNvSpPr txBox="1"/>
+          <p:nvPr/>
+        </p:nvSpPr>
+        <p:spPr>
+          <a:xfrm>
+            <a:off x="2468879" y="1828800"/>
+            <a:ext cx="3200400" cy="283463"/>
+          </a:xfrm>
+          <a:prstGeom prst="rect">
+            <a:avLst/>
+          </a:prstGeom>
+          <a:noFill/>
+        </p:spPr>
+        <p:txBody>
+          <a:bodyPr wrap="square">
+            <a:spAutoFit/>
+          </a:bodyPr>
+          <a:lstStyle/>
+          <a:p>
+            <a:pPr algn="l"/>
+            <a:r>
+              <a:rPr sz="800" b="0" i="0">
+                <a:solidFill>
+                  <a:srgbClr val="6B7FA0"/>
+                </a:solidFill>
+                <a:latin typeface="Calibri"/>
+              </a:rPr>
+              <a:t>13-week forward projection with confidence bands  [ML scoring table]</a:t>
+            </a:r>
+          </a:p>
+        </p:txBody>
+      </p:sp>
+      <p:sp>
+        <p:nvSpPr>
+          <p:cNvPr id="15" name="Rectangle 14"/>
+          <p:cNvSpPr/>
+          <p:nvPr/>
+        </p:nvSpPr>
+        <p:spPr>
+          <a:xfrm>
+            <a:off x="365760" y="2139696"/>
+            <a:ext cx="5394960" cy="374904"/>
+          </a:xfrm>
+          <a:prstGeom prst="rect">
+            <a:avLst/>
+          </a:prstGeom>
+          <a:solidFill>
+            <a:srgbClr val="F8FAFD"/>
+          </a:solidFill>
+          <a:ln w="6350">
+            <a:solidFill>
+              <a:srgbClr val="CCD8EE"/>
+            </a:solidFill>
+          </a:ln>
+        </p:spPr>
+        <p:style>
+          <a:lnRef idx="1">
+            <a:schemeClr val="accent1"/>
+          </a:lnRef>
+          <a:fillRef idx="3">
+            <a:schemeClr val="accent1"/>
+          </a:fillRef>
+          <a:effectRef idx="2">
+            <a:schemeClr val="accent1"/>
+          </a:effectRef>
+          <a:fontRef idx="minor">
+            <a:schemeClr val="lt1"/>
+          </a:fontRef>
+        </p:style>
+        <p:txBody>
+          <a:bodyPr rtlCol="0" anchor="ctr"/>
+          <a:lstStyle/>
+          <a:p>
+            <a:pPr algn="ctr"/>
+          </a:p>
+        </p:txBody>
+      </p:sp>
+      <p:sp>
+        <p:nvSpPr>
+          <p:cNvPr id="16" name="TextBox 15"/>
+          <p:cNvSpPr txBox="1"/>
+          <p:nvPr/>
+        </p:nvSpPr>
+        <p:spPr>
+          <a:xfrm>
+            <a:off x="457200" y="2203703"/>
+            <a:ext cx="1965960" cy="283463"/>
+          </a:xfrm>
+          <a:prstGeom prst="rect">
+            <a:avLst/>
+          </a:prstGeom>
+          <a:noFill/>
+        </p:spPr>
+        <p:txBody>
+          <a:bodyPr wrap="square">
+            <a:spAutoFit/>
+          </a:bodyPr>
+          <a:lstStyle/>
+          <a:p>
+            <a:pPr algn="l"/>
+            <a:r>
+              <a:rPr sz="850" b="1" i="0">
+                <a:solidFill>
+                  <a:srgbClr val="111827"/>
+                </a:solidFill>
+                <a:latin typeface="Calibri"/>
+              </a:rPr>
+              <a:t>3 — Pack Crossover</a:t>
+            </a:r>
+          </a:p>
+        </p:txBody>
+      </p:sp>
+      <p:sp>
+        <p:nvSpPr>
+          <p:cNvPr id="17" name="TextBox 16"/>
+          <p:cNvSpPr txBox="1"/>
+          <p:nvPr/>
+        </p:nvSpPr>
+        <p:spPr>
+          <a:xfrm>
+            <a:off x="2468879" y="2203703"/>
+            <a:ext cx="3200400" cy="283463"/>
+          </a:xfrm>
+          <a:prstGeom prst="rect">
+            <a:avLst/>
+          </a:prstGeom>
+          <a:noFill/>
+        </p:spPr>
+        <p:txBody>
+          <a:bodyPr wrap="square">
+            <a:spAutoFit/>
+          </a:bodyPr>
+          <a:lstStyle/>
+          <a:p>
+            <a:pPr algn="l"/>
+            <a:r>
+              <a:rPr sz="800" b="0" i="0">
+                <a:solidFill>
+                  <a:srgbClr val="6B7FA0"/>
+                </a:solidFill>
+                <a:latin typeface="Calibri"/>
+              </a:rPr>
+              <a:t>Single vs. multipack demand split across the BUILT product line</a:t>
+            </a:r>
+          </a:p>
+        </p:txBody>
+      </p:sp>
+      <p:sp>
+        <p:nvSpPr>
+          <p:cNvPr id="18" name="Rectangle 17"/>
+          <p:cNvSpPr/>
+          <p:nvPr/>
+        </p:nvSpPr>
+        <p:spPr>
+          <a:xfrm>
+            <a:off x="365760" y="2514600"/>
+            <a:ext cx="5394960" cy="374904"/>
+          </a:xfrm>
+          <a:prstGeom prst="rect">
+            <a:avLst/>
+          </a:prstGeom>
+          <a:solidFill>
+            <a:srgbClr val="FFFFFF"/>
+          </a:solidFill>
+          <a:ln w="6350">
+            <a:solidFill>
+              <a:srgbClr val="CCD8EE"/>
+            </a:solidFill>
+          </a:ln>
+        </p:spPr>
+        <p:style>
+          <a:lnRef idx="1">
+            <a:schemeClr val="accent1"/>
+          </a:lnRef>
+          <a:fillRef idx="3">
+            <a:schemeClr val="accent1"/>
+          </a:fillRef>
+          <a:effectRef idx="2">
+            <a:schemeClr val="accent1"/>
+          </a:effectRef>
+          <a:fontRef idx="minor">
+            <a:schemeClr val="lt1"/>
+          </a:fontRef>
+        </p:style>
+        <p:txBody>
+          <a:bodyPr rtlCol="0" anchor="ctr"/>
+          <a:lstStyle/>
+          <a:p>
+            <a:pPr algn="ctr"/>
+          </a:p>
+        </p:txBody>
+      </p:sp>
+      <p:sp>
+        <p:nvSpPr>
+          <p:cNvPr id="19" name="TextBox 18"/>
+          <p:cNvSpPr txBox="1"/>
+          <p:nvPr/>
+        </p:nvSpPr>
+        <p:spPr>
+          <a:xfrm>
+            <a:off x="457200" y="2578608"/>
+            <a:ext cx="1965960" cy="283463"/>
+          </a:xfrm>
+          <a:prstGeom prst="rect">
+            <a:avLst/>
+          </a:prstGeom>
+          <a:noFill/>
+        </p:spPr>
+        <p:txBody>
+          <a:bodyPr wrap="square">
+            <a:spAutoFit/>
+          </a:bodyPr>
+          <a:lstStyle/>
+          <a:p>
+            <a:pPr algn="l"/>
+            <a:r>
+              <a:rPr sz="850" b="1" i="0">
+                <a:solidFill>
+                  <a:srgbClr val="111827"/>
+                </a:solidFill>
+                <a:latin typeface="Calibri"/>
+              </a:rPr>
+              <a:t>4 — Price &amp; Promo</a:t>
+            </a:r>
+          </a:p>
+        </p:txBody>
+      </p:sp>
+      <p:sp>
+        <p:nvSpPr>
+          <p:cNvPr id="20" name="TextBox 19"/>
+          <p:cNvSpPr txBox="1"/>
+          <p:nvPr/>
+        </p:nvSpPr>
+        <p:spPr>
+          <a:xfrm>
+            <a:off x="2468879" y="2578608"/>
+            <a:ext cx="3200400" cy="283463"/>
+          </a:xfrm>
+          <a:prstGeom prst="rect">
+            <a:avLst/>
+          </a:prstGeom>
+          <a:noFill/>
+        </p:spPr>
+        <p:txBody>
+          <a:bodyPr wrap="square">
+            <a:spAutoFit/>
+          </a:bodyPr>
+          <a:lstStyle/>
+          <a:p>
+            <a:pPr algn="l"/>
+            <a:r>
+              <a:rPr sz="800" b="0" i="0">
+                <a:solidFill>
+                  <a:srgbClr val="6B7FA0"/>
+                </a:solidFill>
+                <a:latin typeface="Calibri"/>
+              </a:rPr>
+              <a:t>ARP trend with promo event overlays and discount depth markers</a:t>
+            </a:r>
+          </a:p>
+        </p:txBody>
+      </p:sp>
+      <p:sp>
+        <p:nvSpPr>
+          <p:cNvPr id="21" name="Rectangle 20"/>
+          <p:cNvSpPr/>
+          <p:nvPr/>
+        </p:nvSpPr>
+        <p:spPr>
+          <a:xfrm>
+            <a:off x="365760" y="2889504"/>
+            <a:ext cx="5394960" cy="374904"/>
+          </a:xfrm>
+          <a:prstGeom prst="rect">
+            <a:avLst/>
+          </a:prstGeom>
+          <a:solidFill>
+            <a:srgbClr val="F8FAFD"/>
+          </a:solidFill>
+          <a:ln w="6350">
+            <a:solidFill>
+              <a:srgbClr val="CCD8EE"/>
+            </a:solidFill>
+          </a:ln>
+        </p:spPr>
+        <p:style>
+          <a:lnRef idx="1">
+            <a:schemeClr val="accent1"/>
+          </a:lnRef>
+          <a:fillRef idx="3">
+            <a:schemeClr val="accent1"/>
+          </a:fillRef>
+          <a:effectRef idx="2">
+            <a:schemeClr val="accent1"/>
+          </a:effectRef>
+          <a:fontRef idx="minor">
+            <a:schemeClr val="lt1"/>
+          </a:fontRef>
+        </p:style>
+        <p:txBody>
+          <a:bodyPr rtlCol="0" anchor="ctr"/>
+          <a:lstStyle/>
+          <a:p>
+            <a:pPr algn="ctr"/>
+          </a:p>
+        </p:txBody>
+      </p:sp>
+      <p:sp>
+        <p:nvSpPr>
+          <p:cNvPr id="22" name="TextBox 21"/>
+          <p:cNvSpPr txBox="1"/>
+          <p:nvPr/>
+        </p:nvSpPr>
+        <p:spPr>
+          <a:xfrm>
+            <a:off x="457200" y="2953512"/>
+            <a:ext cx="1965960" cy="283463"/>
+          </a:xfrm>
+          <a:prstGeom prst="rect">
+            <a:avLst/>
+          </a:prstGeom>
+          <a:noFill/>
+        </p:spPr>
+        <p:txBody>
+          <a:bodyPr wrap="square">
+            <a:spAutoFit/>
+          </a:bodyPr>
+          <a:lstStyle/>
+          <a:p>
+            <a:pPr algn="l"/>
+            <a:r>
+              <a:rPr sz="850" b="1" i="0">
+                <a:solidFill>
+                  <a:srgbClr val="111827"/>
+                </a:solidFill>
+                <a:latin typeface="Calibri"/>
+              </a:rPr>
+              <a:t>5 — Distribution Arc</a:t>
+            </a:r>
+          </a:p>
+        </p:txBody>
+      </p:sp>
+      <p:sp>
+        <p:nvSpPr>
+          <p:cNvPr id="23" name="TextBox 22"/>
+          <p:cNvSpPr txBox="1"/>
+          <p:nvPr/>
+        </p:nvSpPr>
+        <p:spPr>
+          <a:xfrm>
+            <a:off x="2468879" y="2953512"/>
+            <a:ext cx="3200400" cy="283463"/>
+          </a:xfrm>
+          <a:prstGeom prst="rect">
+            <a:avLst/>
+          </a:prstGeom>
+          <a:noFill/>
+        </p:spPr>
+        <p:txBody>
+          <a:bodyPr wrap="square">
+            <a:spAutoFit/>
+          </a:bodyPr>
+          <a:lstStyle/>
+          <a:p>
+            <a:pPr algn="l"/>
+            <a:r>
+              <a:rPr sz="800" b="0" i="0">
+                <a:solidFill>
+                  <a:srgbClr val="6B7FA0"/>
+                </a:solidFill>
+                <a:latin typeface="Calibri"/>
+              </a:rPr>
+              <a:t>TDP build trajectory and ramp vs. category launch norms  [FML-05]</a:t>
+            </a:r>
+          </a:p>
+        </p:txBody>
+      </p:sp>
+      <p:sp>
+        <p:nvSpPr>
+          <p:cNvPr id="24" name="Rectangle 23"/>
+          <p:cNvSpPr/>
+          <p:nvPr/>
+        </p:nvSpPr>
+        <p:spPr>
+          <a:xfrm>
+            <a:off x="365760" y="3264408"/>
+            <a:ext cx="5394960" cy="374904"/>
+          </a:xfrm>
+          <a:prstGeom prst="rect">
+            <a:avLst/>
+          </a:prstGeom>
+          <a:solidFill>
+            <a:srgbClr val="FFFFFF"/>
+          </a:solidFill>
+          <a:ln w="6350">
+            <a:solidFill>
+              <a:srgbClr val="CCD8EE"/>
+            </a:solidFill>
+          </a:ln>
+        </p:spPr>
+        <p:style>
+          <a:lnRef idx="1">
+            <a:schemeClr val="accent1"/>
+          </a:lnRef>
+          <a:fillRef idx="3">
+            <a:schemeClr val="accent1"/>
+          </a:fillRef>
+          <a:effectRef idx="2">
+            <a:schemeClr val="accent1"/>
+          </a:effectRef>
+          <a:fontRef idx="minor">
+            <a:schemeClr val="lt1"/>
+          </a:fontRef>
+        </p:style>
+        <p:txBody>
+          <a:bodyPr rtlCol="0" anchor="ctr"/>
+          <a:lstStyle/>
+          <a:p>
+            <a:pPr algn="ctr"/>
+          </a:p>
+        </p:txBody>
+      </p:sp>
+      <p:sp>
+        <p:nvSpPr>
+          <p:cNvPr id="25" name="TextBox 24"/>
+          <p:cNvSpPr txBox="1"/>
+          <p:nvPr/>
+        </p:nvSpPr>
+        <p:spPr>
+          <a:xfrm>
+            <a:off x="457200" y="3328416"/>
+            <a:ext cx="1965960" cy="283463"/>
+          </a:xfrm>
+          <a:prstGeom prst="rect">
+            <a:avLst/>
+          </a:prstGeom>
+          <a:noFill/>
+        </p:spPr>
+        <p:txBody>
+          <a:bodyPr wrap="square">
+            <a:spAutoFit/>
+          </a:bodyPr>
+          <a:lstStyle/>
+          <a:p>
+            <a:pPr algn="l"/>
+            <a:r>
+              <a:rPr sz="850" b="1" i="0">
+                <a:solidFill>
+                  <a:srgbClr val="111827"/>
+                </a:solidFill>
+                <a:latin typeface="Calibri"/>
+              </a:rPr>
+              <a:t>6 — Flavor Demand</a:t>
+            </a:r>
+          </a:p>
+        </p:txBody>
+      </p:sp>
+      <p:sp>
+        <p:nvSpPr>
+          <p:cNvPr id="26" name="TextBox 25"/>
+          <p:cNvSpPr txBox="1"/>
+          <p:nvPr/>
+        </p:nvSpPr>
+        <p:spPr>
+          <a:xfrm>
+            <a:off x="2468879" y="3328416"/>
+            <a:ext cx="3200400" cy="283463"/>
+          </a:xfrm>
+          <a:prstGeom prst="rect">
+            <a:avLst/>
+          </a:prstGeom>
+          <a:noFill/>
+        </p:spPr>
+        <p:txBody>
+          <a:bodyPr wrap="square">
+            <a:spAutoFit/>
+          </a:bodyPr>
+          <a:lstStyle/>
+          <a:p>
+            <a:pPr algn="l"/>
+            <a:r>
+              <a:rPr sz="800" b="0" i="0">
+                <a:solidFill>
+                  <a:srgbClr val="6B7FA0"/>
+                </a:solidFill>
+                <a:latin typeface="Calibri"/>
+              </a:rPr>
+              <a:t>Flavor-level velocity comparison across full BUILT flavor range</a:t>
+            </a:r>
+          </a:p>
+        </p:txBody>
+      </p:sp>
+      <p:sp>
+        <p:nvSpPr>
+          <p:cNvPr id="27" name="Rectangle 26"/>
+          <p:cNvSpPr/>
+          <p:nvPr/>
+        </p:nvSpPr>
+        <p:spPr>
+          <a:xfrm>
+            <a:off x="365760" y="3639312"/>
+            <a:ext cx="5394960" cy="374904"/>
+          </a:xfrm>
+          <a:prstGeom prst="rect">
+            <a:avLst/>
+          </a:prstGeom>
+          <a:solidFill>
+            <a:srgbClr val="F8FAFD"/>
+          </a:solidFill>
+          <a:ln w="6350">
+            <a:solidFill>
+              <a:srgbClr val="CCD8EE"/>
+            </a:solidFill>
+          </a:ln>
+        </p:spPr>
+        <p:style>
+          <a:lnRef idx="1">
+            <a:schemeClr val="accent1"/>
+          </a:lnRef>
+          <a:fillRef idx="3">
+            <a:schemeClr val="accent1"/>
+          </a:fillRef>
+          <a:effectRef idx="2">
+            <a:schemeClr val="accent1"/>
+          </a:effectRef>
+          <a:fontRef idx="minor">
+            <a:schemeClr val="lt1"/>
+          </a:fontRef>
+        </p:style>
+        <p:txBody>
+          <a:bodyPr rtlCol="0" anchor="ctr"/>
+          <a:lstStyle/>
+          <a:p>
+            <a:pPr algn="ctr"/>
+          </a:p>
+        </p:txBody>
+      </p:sp>
+      <p:sp>
+        <p:nvSpPr>
+          <p:cNvPr id="28" name="TextBox 27"/>
+          <p:cNvSpPr txBox="1"/>
+          <p:nvPr/>
+        </p:nvSpPr>
+        <p:spPr>
+          <a:xfrm>
+            <a:off x="457200" y="3703320"/>
+            <a:ext cx="1965960" cy="283463"/>
+          </a:xfrm>
+          <a:prstGeom prst="rect">
+            <a:avLst/>
+          </a:prstGeom>
+          <a:noFill/>
+        </p:spPr>
+        <p:txBody>
+          <a:bodyPr wrap="square">
+            <a:spAutoFit/>
+          </a:bodyPr>
+          <a:lstStyle/>
+          <a:p>
+            <a:pPr algn="l"/>
+            <a:r>
+              <a:rPr sz="850" b="1" i="0">
+                <a:solidFill>
+                  <a:srgbClr val="111827"/>
+                </a:solidFill>
+                <a:latin typeface="Calibri"/>
+              </a:rPr>
+              <a:t>7 — Macro Context</a:t>
+            </a:r>
+          </a:p>
+        </p:txBody>
+      </p:sp>
+      <p:sp>
+        <p:nvSpPr>
+          <p:cNvPr id="29" name="TextBox 28"/>
+          <p:cNvSpPr txBox="1"/>
+          <p:nvPr/>
+        </p:nvSpPr>
+        <p:spPr>
+          <a:xfrm>
+            <a:off x="2468879" y="3703320"/>
+            <a:ext cx="3200400" cy="283463"/>
+          </a:xfrm>
+          <a:prstGeom prst="rect">
+            <a:avLst/>
+          </a:prstGeom>
+          <a:noFill/>
+        </p:spPr>
+        <p:txBody>
+          <a:bodyPr wrap="square">
+            <a:spAutoFit/>
+          </a:bodyPr>
+          <a:lstStyle/>
+          <a:p>
+            <a:pPr algn="l"/>
+            <a:r>
+              <a:rPr sz="800" b="0" i="0">
+                <a:solidFill>
+                  <a:srgbClr val="6B7FA0"/>
+                </a:solidFill>
+                <a:latin typeface="Calibri"/>
+              </a:rPr>
+              <a:t>FRED GASDESW + UMCSENT — gas prices + U of Michigan consumer confidence</a:t>
+            </a:r>
+          </a:p>
+        </p:txBody>
+      </p:sp>
+      <p:sp>
+        <p:nvSpPr>
+          <p:cNvPr id="30" name="Rectangle 29"/>
+          <p:cNvSpPr/>
+          <p:nvPr/>
+        </p:nvSpPr>
+        <p:spPr>
+          <a:xfrm>
+            <a:off x="365760" y="4014216"/>
+            <a:ext cx="5394960" cy="374904"/>
+          </a:xfrm>
+          <a:prstGeom prst="rect">
+            <a:avLst/>
+          </a:prstGeom>
+          <a:solidFill>
+            <a:srgbClr val="FFFFFF"/>
+          </a:solidFill>
+          <a:ln w="6350">
+            <a:solidFill>
+              <a:srgbClr val="CCD8EE"/>
+            </a:solidFill>
+          </a:ln>
+        </p:spPr>
+        <p:style>
+          <a:lnRef idx="1">
+            <a:schemeClr val="accent1"/>
+          </a:lnRef>
+          <a:fillRef idx="3">
+            <a:schemeClr val="accent1"/>
+          </a:fillRef>
+          <a:effectRef idx="2">
+            <a:schemeClr val="accent1"/>
+          </a:effectRef>
+          <a:fontRef idx="minor">
+            <a:schemeClr val="lt1"/>
+          </a:fontRef>
+        </p:style>
+        <p:txBody>
+          <a:bodyPr rtlCol="0" anchor="ctr"/>
+          <a:lstStyle/>
+          <a:p>
+            <a:pPr algn="ctr"/>
+          </a:p>
+        </p:txBody>
+      </p:sp>
+      <p:sp>
+        <p:nvSpPr>
+          <p:cNvPr id="31" name="TextBox 30"/>
+          <p:cNvSpPr txBox="1"/>
+          <p:nvPr/>
+        </p:nvSpPr>
+        <p:spPr>
+          <a:xfrm>
+            <a:off x="457200" y="4078224"/>
+            <a:ext cx="1965960" cy="283463"/>
+          </a:xfrm>
+          <a:prstGeom prst="rect">
+            <a:avLst/>
+          </a:prstGeom>
+          <a:noFill/>
+        </p:spPr>
+        <p:txBody>
+          <a:bodyPr wrap="square">
+            <a:spAutoFit/>
+          </a:bodyPr>
+          <a:lstStyle/>
+          <a:p>
+            <a:pPr algn="l"/>
+            <a:r>
+              <a:rPr sz="850" b="1" i="0">
+                <a:solidFill>
+                  <a:srgbClr val="111827"/>
+                </a:solidFill>
+                <a:latin typeface="Calibri"/>
+              </a:rPr>
+              <a:t>8 — Velocity + Macro</a:t>
+            </a:r>
+          </a:p>
+        </p:txBody>
+      </p:sp>
+      <p:sp>
+        <p:nvSpPr>
+          <p:cNvPr id="32" name="TextBox 31"/>
+          <p:cNvSpPr txBox="1"/>
+          <p:nvPr/>
+        </p:nvSpPr>
+        <p:spPr>
+          <a:xfrm>
+            <a:off x="2468879" y="4078224"/>
+            <a:ext cx="3200400" cy="283463"/>
+          </a:xfrm>
+          <a:prstGeom prst="rect">
+            <a:avLst/>
+          </a:prstGeom>
+          <a:noFill/>
+        </p:spPr>
+        <p:txBody>
+          <a:bodyPr wrap="square">
+            <a:spAutoFit/>
+          </a:bodyPr>
+          <a:lstStyle/>
+          <a:p>
+            <a:pPr algn="l"/>
+            <a:r>
+              <a:rPr sz="800" b="0" i="0">
+                <a:solidFill>
+                  <a:srgbClr val="6B7FA0"/>
+                </a:solidFill>
+                <a:latin typeface="Calibri"/>
+              </a:rPr>
+              <a:t>Stacked chart: brand velocity trend alongside macro signal overlay</a:t>
+            </a:r>
+          </a:p>
+        </p:txBody>
+      </p:sp>
+      <p:sp>
+        <p:nvSpPr>
+          <p:cNvPr id="33" name="Rectangle 32"/>
+          <p:cNvSpPr/>
+          <p:nvPr/>
+        </p:nvSpPr>
+        <p:spPr>
+          <a:xfrm>
+            <a:off x="365760" y="4462272"/>
+            <a:ext cx="5394960" cy="329184"/>
+          </a:xfrm>
+          <a:prstGeom prst="rect">
+            <a:avLst/>
+          </a:prstGeom>
+          <a:solidFill>
+            <a:srgbClr val="D8E5FF"/>
+          </a:solidFill>
+          <a:ln>
+            <a:noFill/>
+          </a:ln>
+        </p:spPr>
+        <p:style>
+          <a:lnRef idx="1">
+            <a:schemeClr val="accent1"/>
+          </a:lnRef>
+          <a:fillRef idx="3">
+            <a:schemeClr val="accent1"/>
+          </a:fillRef>
+          <a:effectRef idx="2">
+            <a:schemeClr val="accent1"/>
+          </a:effectRef>
+          <a:fontRef idx="minor">
+            <a:schemeClr val="lt1"/>
+          </a:fontRef>
+        </p:style>
+        <p:txBody>
+          <a:bodyPr rtlCol="0" anchor="ctr"/>
+          <a:lstStyle/>
+          <a:p>
+            <a:pPr algn="ctr"/>
+          </a:p>
+        </p:txBody>
+      </p:sp>
+      <p:sp>
+        <p:nvSpPr>
+          <p:cNvPr id="34" name="TextBox 33"/>
+          <p:cNvSpPr txBox="1"/>
+          <p:nvPr/>
+        </p:nvSpPr>
+        <p:spPr>
+          <a:xfrm>
+            <a:off x="475488" y="4517136"/>
+            <a:ext cx="5175504" cy="237744"/>
+          </a:xfrm>
+          <a:prstGeom prst="rect">
+            <a:avLst/>
+          </a:prstGeom>
+          <a:noFill/>
+        </p:spPr>
+        <p:txBody>
+          <a:bodyPr wrap="square">
+            <a:spAutoFit/>
+          </a:bodyPr>
+          <a:lstStyle/>
+          <a:p>
+            <a:pPr algn="l"/>
+            <a:r>
+              <a:rPr sz="850" b="0" i="0">
+                <a:solidFill>
+                  <a:srgbClr val="111827"/>
+                </a:solidFill>
+                <a:latin typeface="Calibri"/>
+              </a:rPr>
+              <a:t>Filter bar:  Product · Brand · Channel (FOOD / MASS / C-STORE) · Account · Units / $ toggle</a:t>
+            </a:r>
+          </a:p>
+        </p:txBody>
+      </p:sp>
+      <p:sp>
+        <p:nvSpPr>
+          <p:cNvPr id="35" name="TextBox 34"/>
+          <p:cNvSpPr txBox="1"/>
+          <p:nvPr/>
+        </p:nvSpPr>
+        <p:spPr>
+          <a:xfrm>
+            <a:off x="475488" y="4672584"/>
+            <a:ext cx="5175504" cy="146304"/>
+          </a:xfrm>
+          <a:prstGeom prst="rect">
+            <a:avLst/>
+          </a:prstGeom>
+          <a:noFill/>
+        </p:spPr>
+        <p:txBody>
+          <a:bodyPr wrap="square">
+            <a:spAutoFit/>
+          </a:bodyPr>
+          <a:lstStyle/>
+          <a:p>
+            <a:pPr algn="l"/>
+            <a:r>
+              <a:rPr sz="750" b="0" i="1">
+                <a:solidFill>
+                  <a:srgbClr val="6B7FA0"/>
+                </a:solidFill>
+                <a:latin typeface="Calibri"/>
+              </a:rPr>
+              <a:t>Demo defaults: BUILT Puff  +  KROGER  +  WALMART    |    MULO excluded from all Trends views  [GEO-01]</a:t>
+            </a:r>
+          </a:p>
+        </p:txBody>
+      </p:sp>
+      <p:sp>
+        <p:nvSpPr>
+          <p:cNvPr id="36" name="Rectangle 35"/>
+          <p:cNvSpPr/>
+          <p:nvPr/>
+        </p:nvSpPr>
+        <p:spPr>
+          <a:xfrm>
+            <a:off x="6126480" y="1097280"/>
+            <a:ext cx="5715000" cy="292608"/>
           </a:xfrm>
           <a:prstGeom prst="rect">
             <a:avLst/>
@@ -21387,14 +23999,14 @@
       </p:sp>
       <p:sp>
         <p:nvSpPr>
-          <p:cNvPr id="9" name="TextBox 8"/>
-          <p:cNvSpPr txBox="1"/>
-          <p:nvPr/>
-        </p:nvSpPr>
-        <p:spPr>
-          <a:xfrm>
-            <a:off x="438912" y="1261872"/>
-            <a:ext cx="1920239" cy="292608"/>
+          <p:cNvPr id="37" name="TextBox 36"/>
+          <p:cNvSpPr txBox="1"/>
+          <p:nvPr/>
+        </p:nvSpPr>
+        <p:spPr>
+          <a:xfrm>
+            <a:off x="6236208" y="1133856"/>
+            <a:ext cx="5495544" cy="219456"/>
           </a:xfrm>
           <a:prstGeom prst="rect">
             <a:avLst/>
@@ -21415,21 +24027,144 @@
                 </a:solidFill>
                 <a:latin typeface="Calibri"/>
               </a:rPr>
-              <a:t>P1  ·  Low risk · High impact</a:t>
-            </a:r>
-          </a:p>
-        </p:txBody>
-      </p:sp>
-      <p:sp>
-        <p:nvSpPr>
-          <p:cNvPr id="10" name="Rectangle 9"/>
+              <a:t>07  ·  EXTERNAL SIGNALS — commercial redistribution required for all  [EXT-02]</a:t>
+            </a:r>
+          </a:p>
+        </p:txBody>
+      </p:sp>
+      <p:sp>
+        <p:nvSpPr>
+          <p:cNvPr id="38" name="Rectangle 37"/>
           <p:cNvSpPr/>
           <p:nvPr/>
         </p:nvSpPr>
         <p:spPr>
           <a:xfrm>
-            <a:off x="457200" y="1719072"/>
-            <a:ext cx="1883663" cy="54864"/>
+            <a:off x="6126480" y="1389888"/>
+            <a:ext cx="5715000" cy="237744"/>
+          </a:xfrm>
+          <a:prstGeom prst="rect">
+            <a:avLst/>
+          </a:prstGeom>
+          <a:solidFill>
+            <a:srgbClr val="D4F0E4"/>
+          </a:solidFill>
+          <a:ln>
+            <a:noFill/>
+          </a:ln>
+        </p:spPr>
+        <p:style>
+          <a:lnRef idx="1">
+            <a:schemeClr val="accent1"/>
+          </a:lnRef>
+          <a:fillRef idx="3">
+            <a:schemeClr val="accent1"/>
+          </a:fillRef>
+          <a:effectRef idx="2">
+            <a:schemeClr val="accent1"/>
+          </a:effectRef>
+          <a:fontRef idx="minor">
+            <a:schemeClr val="lt1"/>
+          </a:fontRef>
+        </p:style>
+        <p:txBody>
+          <a:bodyPr rtlCol="0" anchor="ctr"/>
+          <a:lstStyle/>
+          <a:p>
+            <a:pPr algn="ctr"/>
+          </a:p>
+        </p:txBody>
+      </p:sp>
+      <p:sp>
+        <p:nvSpPr>
+          <p:cNvPr id="39" name="TextBox 38"/>
+          <p:cNvSpPr txBox="1"/>
+          <p:nvPr/>
+        </p:nvSpPr>
+        <p:spPr>
+          <a:xfrm>
+            <a:off x="6236208" y="1417320"/>
+            <a:ext cx="5495544" cy="182880"/>
+          </a:xfrm>
+          <a:prstGeom prst="rect">
+            <a:avLst/>
+          </a:prstGeom>
+          <a:noFill/>
+        </p:spPr>
+        <p:txBody>
+          <a:bodyPr wrap="square">
+            <a:spAutoFit/>
+          </a:bodyPr>
+          <a:lstStyle/>
+          <a:p>
+            <a:pPr algn="l"/>
+            <a:r>
+              <a:rPr sz="750" b="1" i="0">
+                <a:solidFill>
+                  <a:srgbClr val="0E5E38"/>
+                </a:solidFill>
+                <a:latin typeface="Calibri"/>
+              </a:rPr>
+              <a:t>LIVE IN PRODUCTION</a:t>
+            </a:r>
+          </a:p>
+        </p:txBody>
+      </p:sp>
+      <p:sp>
+        <p:nvSpPr>
+          <p:cNvPr id="40" name="Rectangle 39"/>
+          <p:cNvSpPr/>
+          <p:nvPr/>
+        </p:nvSpPr>
+        <p:spPr>
+          <a:xfrm>
+            <a:off x="6126480" y="1627632"/>
+            <a:ext cx="5715000" cy="329184"/>
+          </a:xfrm>
+          <a:prstGeom prst="rect">
+            <a:avLst/>
+          </a:prstGeom>
+          <a:solidFill>
+            <a:srgbClr val="FFFFFF"/>
+          </a:solidFill>
+          <a:ln w="6350">
+            <a:solidFill>
+              <a:srgbClr val="CCD8EE"/>
+            </a:solidFill>
+          </a:ln>
+        </p:spPr>
+        <p:style>
+          <a:lnRef idx="1">
+            <a:schemeClr val="accent1"/>
+          </a:lnRef>
+          <a:fillRef idx="3">
+            <a:schemeClr val="accent1"/>
+          </a:fillRef>
+          <a:effectRef idx="2">
+            <a:schemeClr val="accent1"/>
+          </a:effectRef>
+          <a:fontRef idx="minor">
+            <a:schemeClr val="lt1"/>
+          </a:fontRef>
+        </p:style>
+        <p:txBody>
+          <a:bodyPr rtlCol="0" anchor="ctr"/>
+          <a:lstStyle/>
+          <a:p>
+            <a:pPr algn="ctr"/>
+          </a:p>
+        </p:txBody>
+      </p:sp>
+      <p:sp>
+        <p:nvSpPr>
+          <p:cNvPr id="41" name="Rectangle 40"/>
+          <p:cNvSpPr/>
+          <p:nvPr/>
+        </p:nvSpPr>
+        <p:spPr>
+          <a:xfrm>
+            <a:off x="6126480" y="1627632"/>
+            <a:ext cx="64008" cy="329184"/>
           </a:xfrm>
           <a:prstGeom prst="rect">
             <a:avLst/>
@@ -21465,84 +24200,84 @@
       </p:sp>
       <p:sp>
         <p:nvSpPr>
-          <p:cNvPr id="11" name="TextBox 10"/>
-          <p:cNvSpPr txBox="1"/>
-          <p:nvPr/>
-        </p:nvSpPr>
-        <p:spPr>
-          <a:xfrm>
-            <a:off x="457200" y="1847088"/>
-            <a:ext cx="1883663" cy="640080"/>
-          </a:xfrm>
-          <a:prstGeom prst="rect">
-            <a:avLst/>
-          </a:prstGeom>
-          <a:noFill/>
-        </p:spPr>
-        <p:txBody>
-          <a:bodyPr wrap="square">
-            <a:spAutoFit/>
-          </a:bodyPr>
-          <a:lstStyle/>
-          <a:p>
-            <a:pPr algn="l"/>
-            <a:r>
-              <a:rPr sz="1100" b="1" i="0">
+          <p:cNvPr id="42" name="TextBox 41"/>
+          <p:cNvSpPr txBox="1"/>
+          <p:nvPr/>
+        </p:nvSpPr>
+        <p:spPr>
+          <a:xfrm>
+            <a:off x="6272784" y="1682496"/>
+            <a:ext cx="1920240" cy="237744"/>
+          </a:xfrm>
+          <a:prstGeom prst="rect">
+            <a:avLst/>
+          </a:prstGeom>
+          <a:noFill/>
+        </p:spPr>
+        <p:txBody>
+          <a:bodyPr wrap="square">
+            <a:spAutoFit/>
+          </a:bodyPr>
+          <a:lstStyle/>
+          <a:p>
+            <a:pPr algn="l"/>
+            <a:r>
+              <a:rPr sz="900" b="1" i="0">
                 <a:solidFill>
                   <a:srgbClr val="111827"/>
                 </a:solidFill>
                 <a:latin typeface="Calibri"/>
               </a:rPr>
-              <a:t>Incremental Ingest Watermark</a:t>
-            </a:r>
-          </a:p>
-        </p:txBody>
-      </p:sp>
-      <p:sp>
-        <p:nvSpPr>
-          <p:cNvPr id="12" name="TextBox 11"/>
-          <p:cNvSpPr txBox="1"/>
-          <p:nvPr/>
-        </p:nvSpPr>
-        <p:spPr>
-          <a:xfrm>
-            <a:off x="457200" y="2523744"/>
-            <a:ext cx="1883663" cy="2852928"/>
-          </a:xfrm>
-          <a:prstGeom prst="rect">
-            <a:avLst/>
-          </a:prstGeom>
-          <a:noFill/>
-        </p:spPr>
-        <p:txBody>
-          <a:bodyPr wrap="square">
-            <a:spAutoFit/>
-          </a:bodyPr>
-          <a:lstStyle/>
-          <a:p>
-            <a:pPr algn="l"/>
-            <a:r>
-              <a:rPr sz="850" b="0" i="0">
+              <a:t>FRED — GASDESW</a:t>
+            </a:r>
+          </a:p>
+        </p:txBody>
+      </p:sp>
+      <p:sp>
+        <p:nvSpPr>
+          <p:cNvPr id="43" name="TextBox 42"/>
+          <p:cNvSpPr txBox="1"/>
+          <p:nvPr/>
+        </p:nvSpPr>
+        <p:spPr>
+          <a:xfrm>
+            <a:off x="8275320" y="1682496"/>
+            <a:ext cx="3474720" cy="237744"/>
+          </a:xfrm>
+          <a:prstGeom prst="rect">
+            <a:avLst/>
+          </a:prstGeom>
+          <a:noFill/>
+        </p:spPr>
+        <p:txBody>
+          <a:bodyPr wrap="square">
+            <a:spAutoFit/>
+          </a:bodyPr>
+          <a:lstStyle/>
+          <a:p>
+            <a:pPr algn="l"/>
+            <a:r>
+              <a:rPr sz="800" b="0" i="0">
                 <a:solidFill>
                   <a:srgbClr val="6B7FA0"/>
                 </a:solidFill>
                 <a:latin typeface="Calibri"/>
               </a:rPr>
-              <a:t>Load only new weeks via OVERWRITE WHERE — never re-process full history. Requires a watermark metadata store and verification that all Q-series queries are window-safe.</a:t>
-            </a:r>
-          </a:p>
-        </p:txBody>
-      </p:sp>
-      <p:sp>
-        <p:nvSpPr>
-          <p:cNvPr id="13" name="Rectangle 12"/>
+              <a:t>Weekly U.S. gas price index (St. Louis Fed)  ·  EXT-01</a:t>
+            </a:r>
+          </a:p>
+        </p:txBody>
+      </p:sp>
+      <p:sp>
+        <p:nvSpPr>
+          <p:cNvPr id="44" name="Rectangle 43"/>
           <p:cNvSpPr/>
           <p:nvPr/>
         </p:nvSpPr>
         <p:spPr>
           <a:xfrm>
-            <a:off x="2587751" y="1170432"/>
-            <a:ext cx="2103120" cy="4297680"/>
+            <a:off x="6126480" y="1956816"/>
+            <a:ext cx="5715000" cy="329184"/>
           </a:xfrm>
           <a:prstGeom prst="rect">
             <a:avLst/>
@@ -21550,9 +24285,9 @@
           <a:solidFill>
             <a:srgbClr val="FFFFFF"/>
           </a:solidFill>
-          <a:ln w="9525">
+          <a:ln w="6350">
             <a:solidFill>
-              <a:srgbClr val="C0CCE4"/>
+              <a:srgbClr val="CCD8EE"/>
             </a:solidFill>
           </a:ln>
         </p:spPr>
@@ -21580,20 +24315,20 @@
       </p:sp>
       <p:sp>
         <p:nvSpPr>
-          <p:cNvPr id="14" name="Rectangle 13"/>
+          <p:cNvPr id="45" name="Rectangle 44"/>
           <p:cNvSpPr/>
           <p:nvPr/>
         </p:nvSpPr>
         <p:spPr>
           <a:xfrm>
-            <a:off x="2587751" y="1170432"/>
-            <a:ext cx="2103120" cy="457200"/>
+            <a:off x="6126480" y="1956816"/>
+            <a:ext cx="64008" cy="329184"/>
           </a:xfrm>
           <a:prstGeom prst="rect">
             <a:avLst/>
           </a:prstGeom>
           <a:solidFill>
-            <a:srgbClr val="4078D0"/>
+            <a:srgbClr val="0E5E38"/>
           </a:solidFill>
           <a:ln>
             <a:noFill/>
@@ -21623,55 +24358,90 @@
       </p:sp>
       <p:sp>
         <p:nvSpPr>
-          <p:cNvPr id="15" name="TextBox 14"/>
-          <p:cNvSpPr txBox="1"/>
-          <p:nvPr/>
-        </p:nvSpPr>
-        <p:spPr>
-          <a:xfrm>
-            <a:off x="2679191" y="1261872"/>
-            <a:ext cx="1920239" cy="292608"/>
-          </a:xfrm>
-          <a:prstGeom prst="rect">
-            <a:avLst/>
-          </a:prstGeom>
-          <a:noFill/>
-        </p:spPr>
-        <p:txBody>
-          <a:bodyPr wrap="square">
-            <a:spAutoFit/>
-          </a:bodyPr>
-          <a:lstStyle/>
-          <a:p>
-            <a:pPr algn="l"/>
-            <a:r>
-              <a:rPr sz="800" b="1" i="0">
-                <a:solidFill>
-                  <a:srgbClr val="FFFFFF"/>
-                </a:solidFill>
-                <a:latin typeface="Calibri"/>
-              </a:rPr>
-              <a:t>P2  ·  Foundation for P3</a:t>
-            </a:r>
-          </a:p>
-        </p:txBody>
-      </p:sp>
-      <p:sp>
-        <p:nvSpPr>
-          <p:cNvPr id="16" name="Rectangle 15"/>
+          <p:cNvPr id="46" name="TextBox 45"/>
+          <p:cNvSpPr txBox="1"/>
+          <p:nvPr/>
+        </p:nvSpPr>
+        <p:spPr>
+          <a:xfrm>
+            <a:off x="6272784" y="2011680"/>
+            <a:ext cx="1920240" cy="237744"/>
+          </a:xfrm>
+          <a:prstGeom prst="rect">
+            <a:avLst/>
+          </a:prstGeom>
+          <a:noFill/>
+        </p:spPr>
+        <p:txBody>
+          <a:bodyPr wrap="square">
+            <a:spAutoFit/>
+          </a:bodyPr>
+          <a:lstStyle/>
+          <a:p>
+            <a:pPr algn="l"/>
+            <a:r>
+              <a:rPr sz="900" b="1" i="0">
+                <a:solidFill>
+                  <a:srgbClr val="111827"/>
+                </a:solidFill>
+                <a:latin typeface="Calibri"/>
+              </a:rPr>
+              <a:t>FRED — UMCSENT</a:t>
+            </a:r>
+          </a:p>
+        </p:txBody>
+      </p:sp>
+      <p:sp>
+        <p:nvSpPr>
+          <p:cNvPr id="47" name="TextBox 46"/>
+          <p:cNvSpPr txBox="1"/>
+          <p:nvPr/>
+        </p:nvSpPr>
+        <p:spPr>
+          <a:xfrm>
+            <a:off x="8275320" y="2011680"/>
+            <a:ext cx="3474720" cy="237744"/>
+          </a:xfrm>
+          <a:prstGeom prst="rect">
+            <a:avLst/>
+          </a:prstGeom>
+          <a:noFill/>
+        </p:spPr>
+        <p:txBody>
+          <a:bodyPr wrap="square">
+            <a:spAutoFit/>
+          </a:bodyPr>
+          <a:lstStyle/>
+          <a:p>
+            <a:pPr algn="l"/>
+            <a:r>
+              <a:rPr sz="800" b="0" i="0">
+                <a:solidFill>
+                  <a:srgbClr val="6B7FA0"/>
+                </a:solidFill>
+                <a:latin typeface="Calibri"/>
+              </a:rPr>
+              <a:t>U. of Michigan consumer confidence index  ·  EXT-01</a:t>
+            </a:r>
+          </a:p>
+        </p:txBody>
+      </p:sp>
+      <p:sp>
+        <p:nvSpPr>
+          <p:cNvPr id="48" name="Rectangle 47"/>
           <p:cNvSpPr/>
           <p:nvPr/>
         </p:nvSpPr>
         <p:spPr>
           <a:xfrm>
-            <a:off x="2697479" y="1719072"/>
-            <a:ext cx="1883663" cy="54864"/>
+            <a:off x="6126480" y="2377440"/>
+            <a:ext cx="5715000" cy="237744"/>
           </a:xfrm>
           <a:prstGeom prst="rect">
             <a:avLst/>
           </a:prstGeom>
           <a:solidFill>
-            <a:srgbClr val="4078D0"/>
+            <a:srgbClr val="FFF3D6"/>
           </a:solidFill>
           <a:ln>
             <a:noFill/>
@@ -21701,84 +24471,49 @@
       </p:sp>
       <p:sp>
         <p:nvSpPr>
-          <p:cNvPr id="17" name="TextBox 16"/>
-          <p:cNvSpPr txBox="1"/>
-          <p:nvPr/>
-        </p:nvSpPr>
-        <p:spPr>
-          <a:xfrm>
-            <a:off x="2697479" y="1847088"/>
-            <a:ext cx="1883663" cy="640080"/>
-          </a:xfrm>
-          <a:prstGeom prst="rect">
-            <a:avLst/>
-          </a:prstGeom>
-          <a:noFill/>
-        </p:spPr>
-        <p:txBody>
-          <a:bodyPr wrap="square">
-            <a:spAutoFit/>
-          </a:bodyPr>
-          <a:lstStyle/>
-          <a:p>
-            <a:pPr algn="l"/>
-            <a:r>
-              <a:rPr sz="1100" b="1" i="0">
-                <a:solidFill>
-                  <a:srgbClr val="111827"/>
-                </a:solidFill>
-                <a:latin typeface="Calibri"/>
-              </a:rPr>
-              <a:t>Shell Orchestration — run_data_ops.sh</a:t>
-            </a:r>
-          </a:p>
-        </p:txBody>
-      </p:sp>
-      <p:sp>
-        <p:nvSpPr>
-          <p:cNvPr id="18" name="TextBox 17"/>
-          <p:cNvSpPr txBox="1"/>
-          <p:nvPr/>
-        </p:nvSpPr>
-        <p:spPr>
-          <a:xfrm>
-            <a:off x="2697479" y="2523744"/>
-            <a:ext cx="1883663" cy="2852928"/>
-          </a:xfrm>
-          <a:prstGeom prst="rect">
-            <a:avLst/>
-          </a:prstGeom>
-          <a:noFill/>
-        </p:spPr>
-        <p:txBody>
-          <a:bodyPr wrap="square">
-            <a:spAutoFit/>
-          </a:bodyPr>
-          <a:lstStyle/>
-          <a:p>
-            <a:pPr algn="l"/>
-            <a:r>
-              <a:rPr sz="850" b="0" i="0">
-                <a:solidFill>
-                  <a:srgbClr val="6B7FA0"/>
-                </a:solidFill>
-                <a:latin typeface="Calibri"/>
-              </a:rPr>
-              <a:t>Chain Q-series and P-series scripts with per-stage gate assertions and halt-on-failure logic. Same pattern as run_fpa_report.sh. Manual execution first; trigger integration added in P3.</a:t>
-            </a:r>
-          </a:p>
-        </p:txBody>
-      </p:sp>
-      <p:sp>
-        <p:nvSpPr>
-          <p:cNvPr id="19" name="Rectangle 18"/>
+          <p:cNvPr id="49" name="TextBox 48"/>
+          <p:cNvSpPr txBox="1"/>
+          <p:nvPr/>
+        </p:nvSpPr>
+        <p:spPr>
+          <a:xfrm>
+            <a:off x="6236208" y="2414016"/>
+            <a:ext cx="5495544" cy="182880"/>
+          </a:xfrm>
+          <a:prstGeom prst="rect">
+            <a:avLst/>
+          </a:prstGeom>
+          <a:noFill/>
+        </p:spPr>
+        <p:txBody>
+          <a:bodyPr wrap="square">
+            <a:spAutoFit/>
+          </a:bodyPr>
+          <a:lstStyle/>
+          <a:p>
+            <a:pPr algn="l"/>
+            <a:r>
+              <a:rPr sz="750" b="1" i="0">
+                <a:solidFill>
+                  <a:srgbClr val="8A4800"/>
+                </a:solidFill>
+                <a:latin typeface="Calibri"/>
+              </a:rPr>
+              <a:t>PLANNED — OPEN ITEMS  (EXT-04 through EXT-08)</a:t>
+            </a:r>
+          </a:p>
+        </p:txBody>
+      </p:sp>
+      <p:sp>
+        <p:nvSpPr>
+          <p:cNvPr id="50" name="Rectangle 49"/>
           <p:cNvSpPr/>
           <p:nvPr/>
         </p:nvSpPr>
         <p:spPr>
           <a:xfrm>
-            <a:off x="4828031" y="1170432"/>
-            <a:ext cx="2103120" cy="4297680"/>
+            <a:off x="6126480" y="2615184"/>
+            <a:ext cx="5715000" cy="329184"/>
           </a:xfrm>
           <a:prstGeom prst="rect">
             <a:avLst/>
@@ -21786,9 +24521,9 @@
           <a:solidFill>
             <a:srgbClr val="FFFFFF"/>
           </a:solidFill>
-          <a:ln w="9525">
+          <a:ln w="6350">
             <a:solidFill>
-              <a:srgbClr val="C0CCE4"/>
+              <a:srgbClr val="CCD8EE"/>
             </a:solidFill>
           </a:ln>
         </p:spPr>
@@ -21816,486 +24551,14 @@
       </p:sp>
       <p:sp>
         <p:nvSpPr>
-          <p:cNvPr id="20" name="Rectangle 19"/>
+          <p:cNvPr id="51" name="Rectangle 50"/>
           <p:cNvSpPr/>
           <p:nvPr/>
         </p:nvSpPr>
         <p:spPr>
           <a:xfrm>
-            <a:off x="4828031" y="1170432"/>
-            <a:ext cx="2103120" cy="457200"/>
-          </a:xfrm>
-          <a:prstGeom prst="rect">
-            <a:avLst/>
-          </a:prstGeom>
-          <a:solidFill>
-            <a:srgbClr val="4078D0"/>
-          </a:solidFill>
-          <a:ln>
-            <a:noFill/>
-          </a:ln>
-        </p:spPr>
-        <p:style>
-          <a:lnRef idx="1">
-            <a:schemeClr val="accent1"/>
-          </a:lnRef>
-          <a:fillRef idx="3">
-            <a:schemeClr val="accent1"/>
-          </a:fillRef>
-          <a:effectRef idx="2">
-            <a:schemeClr val="accent1"/>
-          </a:effectRef>
-          <a:fontRef idx="minor">
-            <a:schemeClr val="lt1"/>
-          </a:fontRef>
-        </p:style>
-        <p:txBody>
-          <a:bodyPr rtlCol="0" anchor="ctr"/>
-          <a:lstStyle/>
-          <a:p>
-            <a:pPr algn="ctr"/>
-          </a:p>
-        </p:txBody>
-      </p:sp>
-      <p:sp>
-        <p:nvSpPr>
-          <p:cNvPr id="21" name="TextBox 20"/>
-          <p:cNvSpPr txBox="1"/>
-          <p:nvPr/>
-        </p:nvSpPr>
-        <p:spPr>
-          <a:xfrm>
-            <a:off x="4919471" y="1261872"/>
-            <a:ext cx="1920239" cy="292608"/>
-          </a:xfrm>
-          <a:prstGeom prst="rect">
-            <a:avLst/>
-          </a:prstGeom>
-          <a:noFill/>
-        </p:spPr>
-        <p:txBody>
-          <a:bodyPr wrap="square">
-            <a:spAutoFit/>
-          </a:bodyPr>
-          <a:lstStyle/>
-          <a:p>
-            <a:pPr algn="l"/>
-            <a:r>
-              <a:rPr sz="800" b="1" i="0">
-                <a:solidFill>
-                  <a:srgbClr val="FFFFFF"/>
-                </a:solidFill>
-                <a:latin typeface="Calibri"/>
-              </a:rPr>
-              <a:t>P3  ·  Requires P2</a:t>
-            </a:r>
-          </a:p>
-        </p:txBody>
-      </p:sp>
-      <p:sp>
-        <p:nvSpPr>
-          <p:cNvPr id="22" name="Rectangle 21"/>
-          <p:cNvSpPr/>
-          <p:nvPr/>
-        </p:nvSpPr>
-        <p:spPr>
-          <a:xfrm>
-            <a:off x="4937759" y="1719072"/>
-            <a:ext cx="1883663" cy="54864"/>
-          </a:xfrm>
-          <a:prstGeom prst="rect">
-            <a:avLst/>
-          </a:prstGeom>
-          <a:solidFill>
-            <a:srgbClr val="4078D0"/>
-          </a:solidFill>
-          <a:ln>
-            <a:noFill/>
-          </a:ln>
-        </p:spPr>
-        <p:style>
-          <a:lnRef idx="1">
-            <a:schemeClr val="accent1"/>
-          </a:lnRef>
-          <a:fillRef idx="3">
-            <a:schemeClr val="accent1"/>
-          </a:fillRef>
-          <a:effectRef idx="2">
-            <a:schemeClr val="accent1"/>
-          </a:effectRef>
-          <a:fontRef idx="minor">
-            <a:schemeClr val="lt1"/>
-          </a:fontRef>
-        </p:style>
-        <p:txBody>
-          <a:bodyPr rtlCol="0" anchor="ctr"/>
-          <a:lstStyle/>
-          <a:p>
-            <a:pPr algn="ctr"/>
-          </a:p>
-        </p:txBody>
-      </p:sp>
-      <p:sp>
-        <p:nvSpPr>
-          <p:cNvPr id="23" name="TextBox 22"/>
-          <p:cNvSpPr txBox="1"/>
-          <p:nvPr/>
-        </p:nvSpPr>
-        <p:spPr>
-          <a:xfrm>
-            <a:off x="4937759" y="1847088"/>
-            <a:ext cx="1883663" cy="640080"/>
-          </a:xfrm>
-          <a:prstGeom prst="rect">
-            <a:avLst/>
-          </a:prstGeom>
-          <a:noFill/>
-        </p:spPr>
-        <p:txBody>
-          <a:bodyPr wrap="square">
-            <a:spAutoFit/>
-          </a:bodyPr>
-          <a:lstStyle/>
-          <a:p>
-            <a:pPr algn="l"/>
-            <a:r>
-              <a:rPr sz="1100" b="1" i="0">
-                <a:solidFill>
-                  <a:srgbClr val="111827"/>
-                </a:solidFill>
-                <a:latin typeface="Calibri"/>
-              </a:rPr>
-              <a:t>File-Watch Trigger — MinIO bucket event</a:t>
-            </a:r>
-          </a:p>
-        </p:txBody>
-      </p:sp>
-      <p:sp>
-        <p:nvSpPr>
-          <p:cNvPr id="24" name="TextBox 23"/>
-          <p:cNvSpPr txBox="1"/>
-          <p:nvPr/>
-        </p:nvSpPr>
-        <p:spPr>
-          <a:xfrm>
-            <a:off x="4937759" y="2523744"/>
-            <a:ext cx="1883663" cy="2852928"/>
-          </a:xfrm>
-          <a:prstGeom prst="rect">
-            <a:avLst/>
-          </a:prstGeom>
-          <a:noFill/>
-        </p:spPr>
-        <p:txBody>
-          <a:bodyPr wrap="square">
-            <a:spAutoFit/>
-          </a:bodyPr>
-          <a:lstStyle/>
-          <a:p>
-            <a:pPr algn="l"/>
-            <a:r>
-              <a:rPr sz="850" b="0" i="0">
-                <a:solidFill>
-                  <a:srgbClr val="6B7FA0"/>
-                </a:solidFill>
-                <a:latin typeface="Calibri"/>
-              </a:rPr>
-              <a:t>Wire MinIO bucket notification to fire run_data_ops.sh when a new SPINS export lands. Aevah owns the entire run from deposit to scored output — no manual step required.</a:t>
-            </a:r>
-          </a:p>
-        </p:txBody>
-      </p:sp>
-      <p:sp>
-        <p:nvSpPr>
-          <p:cNvPr id="25" name="Rectangle 24"/>
-          <p:cNvSpPr/>
-          <p:nvPr/>
-        </p:nvSpPr>
-        <p:spPr>
-          <a:xfrm>
-            <a:off x="7068312" y="1170432"/>
-            <a:ext cx="2103120" cy="4297680"/>
-          </a:xfrm>
-          <a:prstGeom prst="rect">
-            <a:avLst/>
-          </a:prstGeom>
-          <a:solidFill>
-            <a:srgbClr val="FFFFFF"/>
-          </a:solidFill>
-          <a:ln w="9525">
-            <a:solidFill>
-              <a:srgbClr val="C0CCE4"/>
-            </a:solidFill>
-          </a:ln>
-        </p:spPr>
-        <p:style>
-          <a:lnRef idx="1">
-            <a:schemeClr val="accent1"/>
-          </a:lnRef>
-          <a:fillRef idx="3">
-            <a:schemeClr val="accent1"/>
-          </a:fillRef>
-          <a:effectRef idx="2">
-            <a:schemeClr val="accent1"/>
-          </a:effectRef>
-          <a:fontRef idx="minor">
-            <a:schemeClr val="lt1"/>
-          </a:fontRef>
-        </p:style>
-        <p:txBody>
-          <a:bodyPr rtlCol="0" anchor="ctr"/>
-          <a:lstStyle/>
-          <a:p>
-            <a:pPr algn="ctr"/>
-          </a:p>
-        </p:txBody>
-      </p:sp>
-      <p:sp>
-        <p:nvSpPr>
-          <p:cNvPr id="26" name="Rectangle 25"/>
-          <p:cNvSpPr/>
-          <p:nvPr/>
-        </p:nvSpPr>
-        <p:spPr>
-          <a:xfrm>
-            <a:off x="7068312" y="1170432"/>
-            <a:ext cx="2103120" cy="457200"/>
-          </a:xfrm>
-          <a:prstGeom prst="rect">
-            <a:avLst/>
-          </a:prstGeom>
-          <a:solidFill>
-            <a:srgbClr val="4B2D8A"/>
-          </a:solidFill>
-          <a:ln>
-            <a:noFill/>
-          </a:ln>
-        </p:spPr>
-        <p:style>
-          <a:lnRef idx="1">
-            <a:schemeClr val="accent1"/>
-          </a:lnRef>
-          <a:fillRef idx="3">
-            <a:schemeClr val="accent1"/>
-          </a:fillRef>
-          <a:effectRef idx="2">
-            <a:schemeClr val="accent1"/>
-          </a:effectRef>
-          <a:fontRef idx="minor">
-            <a:schemeClr val="lt1"/>
-          </a:fontRef>
-        </p:style>
-        <p:txBody>
-          <a:bodyPr rtlCol="0" anchor="ctr"/>
-          <a:lstStyle/>
-          <a:p>
-            <a:pPr algn="ctr"/>
-          </a:p>
-        </p:txBody>
-      </p:sp>
-      <p:sp>
-        <p:nvSpPr>
-          <p:cNvPr id="27" name="TextBox 26"/>
-          <p:cNvSpPr txBox="1"/>
-          <p:nvPr/>
-        </p:nvSpPr>
-        <p:spPr>
-          <a:xfrm>
-            <a:off x="7159751" y="1261872"/>
-            <a:ext cx="1920239" cy="292608"/>
-          </a:xfrm>
-          <a:prstGeom prst="rect">
-            <a:avLst/>
-          </a:prstGeom>
-          <a:noFill/>
-        </p:spPr>
-        <p:txBody>
-          <a:bodyPr wrap="square">
-            <a:spAutoFit/>
-          </a:bodyPr>
-          <a:lstStyle/>
-          <a:p>
-            <a:pPr algn="l"/>
-            <a:r>
-              <a:rPr sz="800" b="1" i="0">
-                <a:solidFill>
-                  <a:srgbClr val="FFFFFF"/>
-                </a:solidFill>
-                <a:latin typeface="Calibri"/>
-              </a:rPr>
-              <a:t>P4  ·  Testing</a:t>
-            </a:r>
-          </a:p>
-        </p:txBody>
-      </p:sp>
-      <p:sp>
-        <p:nvSpPr>
-          <p:cNvPr id="28" name="Rectangle 27"/>
-          <p:cNvSpPr/>
-          <p:nvPr/>
-        </p:nvSpPr>
-        <p:spPr>
-          <a:xfrm>
-            <a:off x="7178040" y="1719072"/>
-            <a:ext cx="1883663" cy="54864"/>
-          </a:xfrm>
-          <a:prstGeom prst="rect">
-            <a:avLst/>
-          </a:prstGeom>
-          <a:solidFill>
-            <a:srgbClr val="4B2D8A"/>
-          </a:solidFill>
-          <a:ln>
-            <a:noFill/>
-          </a:ln>
-        </p:spPr>
-        <p:style>
-          <a:lnRef idx="1">
-            <a:schemeClr val="accent1"/>
-          </a:lnRef>
-          <a:fillRef idx="3">
-            <a:schemeClr val="accent1"/>
-          </a:fillRef>
-          <a:effectRef idx="2">
-            <a:schemeClr val="accent1"/>
-          </a:effectRef>
-          <a:fontRef idx="minor">
-            <a:schemeClr val="lt1"/>
-          </a:fontRef>
-        </p:style>
-        <p:txBody>
-          <a:bodyPr rtlCol="0" anchor="ctr"/>
-          <a:lstStyle/>
-          <a:p>
-            <a:pPr algn="ctr"/>
-          </a:p>
-        </p:txBody>
-      </p:sp>
-      <p:sp>
-        <p:nvSpPr>
-          <p:cNvPr id="29" name="TextBox 28"/>
-          <p:cNvSpPr txBox="1"/>
-          <p:nvPr/>
-        </p:nvSpPr>
-        <p:spPr>
-          <a:xfrm>
-            <a:off x="7178040" y="1847088"/>
-            <a:ext cx="1883663" cy="640080"/>
-          </a:xfrm>
-          <a:prstGeom prst="rect">
-            <a:avLst/>
-          </a:prstGeom>
-          <a:noFill/>
-        </p:spPr>
-        <p:txBody>
-          <a:bodyPr wrap="square">
-            <a:spAutoFit/>
-          </a:bodyPr>
-          <a:lstStyle/>
-          <a:p>
-            <a:pPr algn="l"/>
-            <a:r>
-              <a:rPr sz="1100" b="1" i="0">
-                <a:solidFill>
-                  <a:srgbClr val="111827"/>
-                </a:solidFill>
-                <a:latin typeface="Calibri"/>
-              </a:rPr>
-              <a:t>Smoke Test Suite — pinned test cases</a:t>
-            </a:r>
-          </a:p>
-        </p:txBody>
-      </p:sp>
-      <p:sp>
-        <p:nvSpPr>
-          <p:cNvPr id="30" name="TextBox 29"/>
-          <p:cNvSpPr txBox="1"/>
-          <p:nvPr/>
-        </p:nvSpPr>
-        <p:spPr>
-          <a:xfrm>
-            <a:off x="7178040" y="2523744"/>
-            <a:ext cx="1883663" cy="2852928"/>
-          </a:xfrm>
-          <a:prstGeom prst="rect">
-            <a:avLst/>
-          </a:prstGeom>
-          <a:noFill/>
-        </p:spPr>
-        <p:txBody>
-          <a:bodyPr wrap="square">
-            <a:spAutoFit/>
-          </a:bodyPr>
-          <a:lstStyle/>
-          <a:p>
-            <a:pPr algn="l"/>
-            <a:r>
-              <a:rPr sz="850" b="0" i="0">
-                <a:solidFill>
-                  <a:srgbClr val="6B7FA0"/>
-                </a:solidFill>
-                <a:latin typeface="Calibri"/>
-              </a:rPr>
-              <a:t>Define Stage 4 pinned test cases: known UPC × account pairs with expected direction and magnitude bands. Use FOOD-channel accounts only — never MULO. Assert direction, not exact values.  [GEO-04 / ANO-01]</a:t>
-            </a:r>
-          </a:p>
-        </p:txBody>
-      </p:sp>
-      <p:sp>
-        <p:nvSpPr>
-          <p:cNvPr id="31" name="Rectangle 30"/>
-          <p:cNvSpPr/>
-          <p:nvPr/>
-        </p:nvSpPr>
-        <p:spPr>
-          <a:xfrm>
-            <a:off x="9308592" y="1170432"/>
-            <a:ext cx="2103120" cy="4297680"/>
-          </a:xfrm>
-          <a:prstGeom prst="rect">
-            <a:avLst/>
-          </a:prstGeom>
-          <a:solidFill>
-            <a:srgbClr val="FFFFFF"/>
-          </a:solidFill>
-          <a:ln w="9525">
-            <a:solidFill>
-              <a:srgbClr val="C0CCE4"/>
-            </a:solidFill>
-          </a:ln>
-        </p:spPr>
-        <p:style>
-          <a:lnRef idx="1">
-            <a:schemeClr val="accent1"/>
-          </a:lnRef>
-          <a:fillRef idx="3">
-            <a:schemeClr val="accent1"/>
-          </a:fillRef>
-          <a:effectRef idx="2">
-            <a:schemeClr val="accent1"/>
-          </a:effectRef>
-          <a:fontRef idx="minor">
-            <a:schemeClr val="lt1"/>
-          </a:fontRef>
-        </p:style>
-        <p:txBody>
-          <a:bodyPr rtlCol="0" anchor="ctr"/>
-          <a:lstStyle/>
-          <a:p>
-            <a:pPr algn="ctr"/>
-          </a:p>
-        </p:txBody>
-      </p:sp>
-      <p:sp>
-        <p:nvSpPr>
-          <p:cNvPr id="32" name="Rectangle 31"/>
-          <p:cNvSpPr/>
-          <p:nvPr/>
-        </p:nvSpPr>
-        <p:spPr>
-          <a:xfrm>
-            <a:off x="9308592" y="1170432"/>
-            <a:ext cx="2103120" cy="457200"/>
+            <a:off x="6126480" y="2615184"/>
+            <a:ext cx="64008" cy="329184"/>
           </a:xfrm>
           <a:prstGeom prst="rect">
             <a:avLst/>
@@ -22331,49 +24594,129 @@
       </p:sp>
       <p:sp>
         <p:nvSpPr>
-          <p:cNvPr id="33" name="TextBox 32"/>
-          <p:cNvSpPr txBox="1"/>
-          <p:nvPr/>
-        </p:nvSpPr>
-        <p:spPr>
-          <a:xfrm>
-            <a:off x="9400032" y="1261872"/>
-            <a:ext cx="1920239" cy="292608"/>
-          </a:xfrm>
-          <a:prstGeom prst="rect">
-            <a:avLst/>
-          </a:prstGeom>
-          <a:noFill/>
-        </p:spPr>
-        <p:txBody>
-          <a:bodyPr wrap="square">
-            <a:spAutoFit/>
-          </a:bodyPr>
-          <a:lstStyle/>
-          <a:p>
-            <a:pPr algn="l"/>
-            <a:r>
-              <a:rPr sz="800" b="1" i="0">
-                <a:solidFill>
-                  <a:srgbClr val="FFFFFF"/>
-                </a:solidFill>
-                <a:latin typeface="Calibri"/>
-              </a:rPr>
-              <a:t>P5  ·  Benchmark required first</a:t>
-            </a:r>
-          </a:p>
-        </p:txBody>
-      </p:sp>
-      <p:sp>
-        <p:nvSpPr>
-          <p:cNvPr id="34" name="Rectangle 33"/>
+          <p:cNvPr id="52" name="TextBox 51"/>
+          <p:cNvSpPr txBox="1"/>
+          <p:nvPr/>
+        </p:nvSpPr>
+        <p:spPr>
+          <a:xfrm>
+            <a:off x="6272784" y="2670048"/>
+            <a:ext cx="1920240" cy="237744"/>
+          </a:xfrm>
+          <a:prstGeom prst="rect">
+            <a:avLst/>
+          </a:prstGeom>
+          <a:noFill/>
+        </p:spPr>
+        <p:txBody>
+          <a:bodyPr wrap="square">
+            <a:spAutoFit/>
+          </a:bodyPr>
+          <a:lstStyle/>
+          <a:p>
+            <a:pPr algn="l"/>
+            <a:r>
+              <a:rPr sz="900" b="1" i="0">
+                <a:solidFill>
+                  <a:srgbClr val="111827"/>
+                </a:solidFill>
+                <a:latin typeface="Calibri"/>
+              </a:rPr>
+              <a:t>Open-Meteo Weather</a:t>
+            </a:r>
+          </a:p>
+        </p:txBody>
+      </p:sp>
+      <p:sp>
+        <p:nvSpPr>
+          <p:cNvPr id="53" name="TextBox 52"/>
+          <p:cNvSpPr txBox="1"/>
+          <p:nvPr/>
+        </p:nvSpPr>
+        <p:spPr>
+          <a:xfrm>
+            <a:off x="8275320" y="2670048"/>
+            <a:ext cx="3474720" cy="237744"/>
+          </a:xfrm>
+          <a:prstGeom prst="rect">
+            <a:avLst/>
+          </a:prstGeom>
+          <a:noFill/>
+        </p:spPr>
+        <p:txBody>
+          <a:bodyPr wrap="square">
+            <a:spAutoFit/>
+          </a:bodyPr>
+          <a:lstStyle/>
+          <a:p>
+            <a:pPr algn="l"/>
+            <a:r>
+              <a:rPr sz="800" b="0" i="0">
+                <a:solidFill>
+                  <a:srgbClr val="6B7FA0"/>
+                </a:solidFill>
+                <a:latin typeface="Calibri"/>
+              </a:rPr>
+              <a:t>Regional precip + temperature for seasonal demand context  ·  EXT-04</a:t>
+            </a:r>
+          </a:p>
+        </p:txBody>
+      </p:sp>
+      <p:sp>
+        <p:nvSpPr>
+          <p:cNvPr id="54" name="Rectangle 53"/>
           <p:cNvSpPr/>
           <p:nvPr/>
         </p:nvSpPr>
         <p:spPr>
           <a:xfrm>
-            <a:off x="9418319" y="1719072"/>
-            <a:ext cx="1883663" cy="54864"/>
+            <a:off x="6126480" y="2944368"/>
+            <a:ext cx="5715000" cy="329184"/>
+          </a:xfrm>
+          <a:prstGeom prst="rect">
+            <a:avLst/>
+          </a:prstGeom>
+          <a:solidFill>
+            <a:srgbClr val="FFFFFF"/>
+          </a:solidFill>
+          <a:ln w="6350">
+            <a:solidFill>
+              <a:srgbClr val="CCD8EE"/>
+            </a:solidFill>
+          </a:ln>
+        </p:spPr>
+        <p:style>
+          <a:lnRef idx="1">
+            <a:schemeClr val="accent1"/>
+          </a:lnRef>
+          <a:fillRef idx="3">
+            <a:schemeClr val="accent1"/>
+          </a:fillRef>
+          <a:effectRef idx="2">
+            <a:schemeClr val="accent1"/>
+          </a:effectRef>
+          <a:fontRef idx="minor">
+            <a:schemeClr val="lt1"/>
+          </a:fontRef>
+        </p:style>
+        <p:txBody>
+          <a:bodyPr rtlCol="0" anchor="ctr"/>
+          <a:lstStyle/>
+          <a:p>
+            <a:pPr algn="ctr"/>
+          </a:p>
+        </p:txBody>
+      </p:sp>
+      <p:sp>
+        <p:nvSpPr>
+          <p:cNvPr id="55" name="Rectangle 54"/>
+          <p:cNvSpPr/>
+          <p:nvPr/>
+        </p:nvSpPr>
+        <p:spPr>
+          <a:xfrm>
+            <a:off x="6126480" y="2944368"/>
+            <a:ext cx="64008" cy="329184"/>
           </a:xfrm>
           <a:prstGeom prst="rect">
             <a:avLst/>
@@ -22409,93 +24752,95 @@
       </p:sp>
       <p:sp>
         <p:nvSpPr>
-          <p:cNvPr id="35" name="TextBox 34"/>
-          <p:cNvSpPr txBox="1"/>
-          <p:nvPr/>
-        </p:nvSpPr>
-        <p:spPr>
-          <a:xfrm>
-            <a:off x="9418319" y="1847088"/>
-            <a:ext cx="1883663" cy="640080"/>
-          </a:xfrm>
-          <a:prstGeom prst="rect">
-            <a:avLst/>
-          </a:prstGeom>
-          <a:noFill/>
-        </p:spPr>
-        <p:txBody>
-          <a:bodyPr wrap="square">
-            <a:spAutoFit/>
-          </a:bodyPr>
-          <a:lstStyle/>
-          <a:p>
-            <a:pPr algn="l"/>
-            <a:r>
-              <a:rPr sz="1100" b="1" i="0">
+          <p:cNvPr id="56" name="TextBox 55"/>
+          <p:cNvSpPr txBox="1"/>
+          <p:nvPr/>
+        </p:nvSpPr>
+        <p:spPr>
+          <a:xfrm>
+            <a:off x="6272784" y="2999232"/>
+            <a:ext cx="1920240" cy="237744"/>
+          </a:xfrm>
+          <a:prstGeom prst="rect">
+            <a:avLst/>
+          </a:prstGeom>
+          <a:noFill/>
+        </p:spPr>
+        <p:txBody>
+          <a:bodyPr wrap="square">
+            <a:spAutoFit/>
+          </a:bodyPr>
+          <a:lstStyle/>
+          <a:p>
+            <a:pPr algn="l"/>
+            <a:r>
+              <a:rPr sz="900" b="1" i="0">
                 <a:solidFill>
                   <a:srgbClr val="111827"/>
                 </a:solidFill>
                 <a:latin typeface="Calibri"/>
               </a:rPr>
-              <a:t>Druid Segment Tuning</a:t>
-            </a:r>
-          </a:p>
-        </p:txBody>
-      </p:sp>
-      <p:sp>
-        <p:nvSpPr>
-          <p:cNvPr id="36" name="TextBox 35"/>
-          <p:cNvSpPr txBox="1"/>
-          <p:nvPr/>
-        </p:nvSpPr>
-        <p:spPr>
-          <a:xfrm>
-            <a:off x="9418319" y="2523744"/>
-            <a:ext cx="1883663" cy="2852928"/>
-          </a:xfrm>
-          <a:prstGeom prst="rect">
-            <a:avLst/>
-          </a:prstGeom>
-          <a:noFill/>
-        </p:spPr>
-        <p:txBody>
-          <a:bodyPr wrap="square">
-            <a:spAutoFit/>
-          </a:bodyPr>
-          <a:lstStyle/>
-          <a:p>
-            <a:pPr algn="l"/>
-            <a:r>
-              <a:rPr sz="850" b="0" i="0">
+              <a:t>BLS CPI — Food</a:t>
+            </a:r>
+          </a:p>
+        </p:txBody>
+      </p:sp>
+      <p:sp>
+        <p:nvSpPr>
+          <p:cNvPr id="57" name="TextBox 56"/>
+          <p:cNvSpPr txBox="1"/>
+          <p:nvPr/>
+        </p:nvSpPr>
+        <p:spPr>
+          <a:xfrm>
+            <a:off x="8275320" y="2999232"/>
+            <a:ext cx="3474720" cy="237744"/>
+          </a:xfrm>
+          <a:prstGeom prst="rect">
+            <a:avLst/>
+          </a:prstGeom>
+          <a:noFill/>
+        </p:spPr>
+        <p:txBody>
+          <a:bodyPr wrap="square">
+            <a:spAutoFit/>
+          </a:bodyPr>
+          <a:lstStyle/>
+          <a:p>
+            <a:pPr algn="l"/>
+            <a:r>
+              <a:rPr sz="800" b="0" i="0">
                 <a:solidFill>
                   <a:srgbClr val="6B7FA0"/>
                 </a:solidFill>
                 <a:latin typeface="Calibri"/>
               </a:rPr>
-              <a:t>Baseline query-time benchmark on built_filtered_weekly and ml_training_features. Evaluate segment granularity and partition changes on a copy before touching live specs. MULO exclusion logic and OVERWRITE WHERE pattern must be preserved.  [GEO-01]</a:t>
-            </a:r>
-          </a:p>
-        </p:txBody>
-      </p:sp>
-      <p:sp>
-        <p:nvSpPr>
-          <p:cNvPr id="37" name="Rectangle 36"/>
+              <a:t>CPI food sub-indices for consumer price-pressure signal  ·  EXT-05</a:t>
+            </a:r>
+          </a:p>
+        </p:txBody>
+      </p:sp>
+      <p:sp>
+        <p:nvSpPr>
+          <p:cNvPr id="58" name="Rectangle 57"/>
           <p:cNvSpPr/>
           <p:nvPr/>
         </p:nvSpPr>
         <p:spPr>
           <a:xfrm>
-            <a:off x="347472" y="5687568"/>
-            <a:ext cx="11475720" cy="713232"/>
+            <a:off x="6126480" y="3273552"/>
+            <a:ext cx="5715000" cy="329184"/>
           </a:xfrm>
           <a:prstGeom prst="rect">
             <a:avLst/>
           </a:prstGeom>
           <a:solidFill>
-            <a:srgbClr val="D8E5FF"/>
+            <a:srgbClr val="FFFFFF"/>
           </a:solidFill>
-          <a:ln>
-            <a:noFill/>
+          <a:ln w="6350">
+            <a:solidFill>
+              <a:srgbClr val="CCD8EE"/>
+            </a:solidFill>
           </a:ln>
         </p:spPr>
         <p:style>
@@ -22522,77 +24867,517 @@
       </p:sp>
       <p:sp>
         <p:nvSpPr>
-          <p:cNvPr id="38" name="TextBox 37"/>
-          <p:cNvSpPr txBox="1"/>
-          <p:nvPr/>
-        </p:nvSpPr>
-        <p:spPr>
-          <a:xfrm>
-            <a:off x="502920" y="5742432"/>
-            <a:ext cx="11155680" cy="256032"/>
-          </a:xfrm>
-          <a:prstGeom prst="rect">
-            <a:avLst/>
-          </a:prstGeom>
-          <a:noFill/>
-        </p:spPr>
-        <p:txBody>
-          <a:bodyPr wrap="square">
-            <a:spAutoFit/>
-          </a:bodyPr>
-          <a:lstStyle/>
-          <a:p>
-            <a:pPr algn="l"/>
-            <a:r>
-              <a:rPr sz="800" b="1" i="0">
-                <a:solidFill>
-                  <a:srgbClr val="4078D0"/>
-                </a:solidFill>
-                <a:latin typeface="Calibri"/>
-              </a:rPr>
-              <a:t>TESTING PRINCIPLE</a:t>
-            </a:r>
-          </a:p>
-        </p:txBody>
-      </p:sp>
-      <p:sp>
-        <p:nvSpPr>
-          <p:cNvPr id="39" name="TextBox 38"/>
-          <p:cNvSpPr txBox="1"/>
-          <p:nvPr/>
-        </p:nvSpPr>
-        <p:spPr>
-          <a:xfrm>
-            <a:off x="502920" y="5971032"/>
-            <a:ext cx="11155680" cy="384048"/>
-          </a:xfrm>
-          <a:prstGeom prst="rect">
-            <a:avLst/>
-          </a:prstGeom>
-          <a:noFill/>
-        </p:spPr>
-        <p:txBody>
-          <a:bodyPr wrap="square">
-            <a:spAutoFit/>
-          </a:bodyPr>
-          <a:lstStyle/>
-          <a:p>
-            <a:pPr algn="l"/>
-            <a:r>
-              <a:rPr sz="950" b="0" i="0">
+          <p:cNvPr id="59" name="Rectangle 58"/>
+          <p:cNvSpPr/>
+          <p:nvPr/>
+        </p:nvSpPr>
+        <p:spPr>
+          <a:xfrm>
+            <a:off x="6126480" y="3273552"/>
+            <a:ext cx="64008" cy="329184"/>
+          </a:xfrm>
+          <a:prstGeom prst="rect">
+            <a:avLst/>
+          </a:prstGeom>
+          <a:solidFill>
+            <a:srgbClr val="8A4800"/>
+          </a:solidFill>
+          <a:ln>
+            <a:noFill/>
+          </a:ln>
+        </p:spPr>
+        <p:style>
+          <a:lnRef idx="1">
+            <a:schemeClr val="accent1"/>
+          </a:lnRef>
+          <a:fillRef idx="3">
+            <a:schemeClr val="accent1"/>
+          </a:fillRef>
+          <a:effectRef idx="2">
+            <a:schemeClr val="accent1"/>
+          </a:effectRef>
+          <a:fontRef idx="minor">
+            <a:schemeClr val="lt1"/>
+          </a:fontRef>
+        </p:style>
+        <p:txBody>
+          <a:bodyPr rtlCol="0" anchor="ctr"/>
+          <a:lstStyle/>
+          <a:p>
+            <a:pPr algn="ctr"/>
+          </a:p>
+        </p:txBody>
+      </p:sp>
+      <p:sp>
+        <p:nvSpPr>
+          <p:cNvPr id="60" name="TextBox 59"/>
+          <p:cNvSpPr txBox="1"/>
+          <p:nvPr/>
+        </p:nvSpPr>
+        <p:spPr>
+          <a:xfrm>
+            <a:off x="6272784" y="3328416"/>
+            <a:ext cx="1920240" cy="237744"/>
+          </a:xfrm>
+          <a:prstGeom prst="rect">
+            <a:avLst/>
+          </a:prstGeom>
+          <a:noFill/>
+        </p:spPr>
+        <p:txBody>
+          <a:bodyPr wrap="square">
+            <a:spAutoFit/>
+          </a:bodyPr>
+          <a:lstStyle/>
+          <a:p>
+            <a:pPr algn="l"/>
+            <a:r>
+              <a:rPr sz="900" b="1" i="0">
                 <a:solidFill>
                   <a:srgbClr val="111827"/>
                 </a:solidFill>
                 <a:latin typeface="Calibri"/>
               </a:rPr>
-              <a:t>No spec or script changes go live without a before/after benchmark. New methods run in parallel against the existing method on a copy first. Any coverage drop &gt;10% from prior run halts and alerts — degenerate output detection runs on every automated run, not just at release.  See: mo_automation_design.html and mo_decisions_register.html for full gate logic.</a:t>
-            </a:r>
-          </a:p>
-        </p:txBody>
-      </p:sp>
-      <p:sp>
-        <p:nvSpPr>
-          <p:cNvPr id="40" name="TextBox 39"/>
+              <a:t>Kalshi Markets</a:t>
+            </a:r>
+          </a:p>
+        </p:txBody>
+      </p:sp>
+      <p:sp>
+        <p:nvSpPr>
+          <p:cNvPr id="61" name="TextBox 60"/>
+          <p:cNvSpPr txBox="1"/>
+          <p:nvPr/>
+        </p:nvSpPr>
+        <p:spPr>
+          <a:xfrm>
+            <a:off x="8275320" y="3328416"/>
+            <a:ext cx="3474720" cy="237744"/>
+          </a:xfrm>
+          <a:prstGeom prst="rect">
+            <a:avLst/>
+          </a:prstGeom>
+          <a:noFill/>
+        </p:spPr>
+        <p:txBody>
+          <a:bodyPr wrap="square">
+            <a:spAutoFit/>
+          </a:bodyPr>
+          <a:lstStyle/>
+          <a:p>
+            <a:pPr algn="l"/>
+            <a:r>
+              <a:rPr sz="800" b="0" i="0">
+                <a:solidFill>
+                  <a:srgbClr val="6B7FA0"/>
+                </a:solidFill>
+                <a:latin typeface="Calibri"/>
+              </a:rPr>
+              <a:t>Prediction market odds for macro events (recession, rates)  ·  EXT-06</a:t>
+            </a:r>
+          </a:p>
+        </p:txBody>
+      </p:sp>
+      <p:sp>
+        <p:nvSpPr>
+          <p:cNvPr id="62" name="Rectangle 61"/>
+          <p:cNvSpPr/>
+          <p:nvPr/>
+        </p:nvSpPr>
+        <p:spPr>
+          <a:xfrm>
+            <a:off x="6126480" y="3602736"/>
+            <a:ext cx="5715000" cy="329184"/>
+          </a:xfrm>
+          <a:prstGeom prst="rect">
+            <a:avLst/>
+          </a:prstGeom>
+          <a:solidFill>
+            <a:srgbClr val="FFFFFF"/>
+          </a:solidFill>
+          <a:ln w="6350">
+            <a:solidFill>
+              <a:srgbClr val="CCD8EE"/>
+            </a:solidFill>
+          </a:ln>
+        </p:spPr>
+        <p:style>
+          <a:lnRef idx="1">
+            <a:schemeClr val="accent1"/>
+          </a:lnRef>
+          <a:fillRef idx="3">
+            <a:schemeClr val="accent1"/>
+          </a:fillRef>
+          <a:effectRef idx="2">
+            <a:schemeClr val="accent1"/>
+          </a:effectRef>
+          <a:fontRef idx="minor">
+            <a:schemeClr val="lt1"/>
+          </a:fontRef>
+        </p:style>
+        <p:txBody>
+          <a:bodyPr rtlCol="0" anchor="ctr"/>
+          <a:lstStyle/>
+          <a:p>
+            <a:pPr algn="ctr"/>
+          </a:p>
+        </p:txBody>
+      </p:sp>
+      <p:sp>
+        <p:nvSpPr>
+          <p:cNvPr id="63" name="Rectangle 62"/>
+          <p:cNvSpPr/>
+          <p:nvPr/>
+        </p:nvSpPr>
+        <p:spPr>
+          <a:xfrm>
+            <a:off x="6126480" y="3602736"/>
+            <a:ext cx="64008" cy="329184"/>
+          </a:xfrm>
+          <a:prstGeom prst="rect">
+            <a:avLst/>
+          </a:prstGeom>
+          <a:solidFill>
+            <a:srgbClr val="8A4800"/>
+          </a:solidFill>
+          <a:ln>
+            <a:noFill/>
+          </a:ln>
+        </p:spPr>
+        <p:style>
+          <a:lnRef idx="1">
+            <a:schemeClr val="accent1"/>
+          </a:lnRef>
+          <a:fillRef idx="3">
+            <a:schemeClr val="accent1"/>
+          </a:fillRef>
+          <a:effectRef idx="2">
+            <a:schemeClr val="accent1"/>
+          </a:effectRef>
+          <a:fontRef idx="minor">
+            <a:schemeClr val="lt1"/>
+          </a:fontRef>
+        </p:style>
+        <p:txBody>
+          <a:bodyPr rtlCol="0" anchor="ctr"/>
+          <a:lstStyle/>
+          <a:p>
+            <a:pPr algn="ctr"/>
+          </a:p>
+        </p:txBody>
+      </p:sp>
+      <p:sp>
+        <p:nvSpPr>
+          <p:cNvPr id="64" name="TextBox 63"/>
+          <p:cNvSpPr txBox="1"/>
+          <p:nvPr/>
+        </p:nvSpPr>
+        <p:spPr>
+          <a:xfrm>
+            <a:off x="6272784" y="3657600"/>
+            <a:ext cx="1920240" cy="237744"/>
+          </a:xfrm>
+          <a:prstGeom prst="rect">
+            <a:avLst/>
+          </a:prstGeom>
+          <a:noFill/>
+        </p:spPr>
+        <p:txBody>
+          <a:bodyPr wrap="square">
+            <a:spAutoFit/>
+          </a:bodyPr>
+          <a:lstStyle/>
+          <a:p>
+            <a:pPr algn="l"/>
+            <a:r>
+              <a:rPr sz="900" b="1" i="0">
+                <a:solidFill>
+                  <a:srgbClr val="111827"/>
+                </a:solidFill>
+                <a:latin typeface="Calibri"/>
+              </a:rPr>
+              <a:t>Amazon BSR / Helium 10</a:t>
+            </a:r>
+          </a:p>
+        </p:txBody>
+      </p:sp>
+      <p:sp>
+        <p:nvSpPr>
+          <p:cNvPr id="65" name="TextBox 64"/>
+          <p:cNvSpPr txBox="1"/>
+          <p:nvPr/>
+        </p:nvSpPr>
+        <p:spPr>
+          <a:xfrm>
+            <a:off x="8275320" y="3657600"/>
+            <a:ext cx="3474720" cy="237744"/>
+          </a:xfrm>
+          <a:prstGeom prst="rect">
+            <a:avLst/>
+          </a:prstGeom>
+          <a:noFill/>
+        </p:spPr>
+        <p:txBody>
+          <a:bodyPr wrap="square">
+            <a:spAutoFit/>
+          </a:bodyPr>
+          <a:lstStyle/>
+          <a:p>
+            <a:pPr algn="l"/>
+            <a:r>
+              <a:rPr sz="800" b="0" i="0">
+                <a:solidFill>
+                  <a:srgbClr val="6B7FA0"/>
+                </a:solidFill>
+                <a:latin typeface="Calibri"/>
+              </a:rPr>
+              <a:t>Digital shelf velocity proxy for e-commerce demand  ·  EXT-07</a:t>
+            </a:r>
+          </a:p>
+        </p:txBody>
+      </p:sp>
+      <p:sp>
+        <p:nvSpPr>
+          <p:cNvPr id="66" name="Rectangle 65"/>
+          <p:cNvSpPr/>
+          <p:nvPr/>
+        </p:nvSpPr>
+        <p:spPr>
+          <a:xfrm>
+            <a:off x="6126480" y="3931920"/>
+            <a:ext cx="5715000" cy="329184"/>
+          </a:xfrm>
+          <a:prstGeom prst="rect">
+            <a:avLst/>
+          </a:prstGeom>
+          <a:solidFill>
+            <a:srgbClr val="FFFFFF"/>
+          </a:solidFill>
+          <a:ln w="6350">
+            <a:solidFill>
+              <a:srgbClr val="CCD8EE"/>
+            </a:solidFill>
+          </a:ln>
+        </p:spPr>
+        <p:style>
+          <a:lnRef idx="1">
+            <a:schemeClr val="accent1"/>
+          </a:lnRef>
+          <a:fillRef idx="3">
+            <a:schemeClr val="accent1"/>
+          </a:fillRef>
+          <a:effectRef idx="2">
+            <a:schemeClr val="accent1"/>
+          </a:effectRef>
+          <a:fontRef idx="minor">
+            <a:schemeClr val="lt1"/>
+          </a:fontRef>
+        </p:style>
+        <p:txBody>
+          <a:bodyPr rtlCol="0" anchor="ctr"/>
+          <a:lstStyle/>
+          <a:p>
+            <a:pPr algn="ctr"/>
+          </a:p>
+        </p:txBody>
+      </p:sp>
+      <p:sp>
+        <p:nvSpPr>
+          <p:cNvPr id="67" name="Rectangle 66"/>
+          <p:cNvSpPr/>
+          <p:nvPr/>
+        </p:nvSpPr>
+        <p:spPr>
+          <a:xfrm>
+            <a:off x="6126480" y="3931920"/>
+            <a:ext cx="64008" cy="329184"/>
+          </a:xfrm>
+          <a:prstGeom prst="rect">
+            <a:avLst/>
+          </a:prstGeom>
+          <a:solidFill>
+            <a:srgbClr val="8A4800"/>
+          </a:solidFill>
+          <a:ln>
+            <a:noFill/>
+          </a:ln>
+        </p:spPr>
+        <p:style>
+          <a:lnRef idx="1">
+            <a:schemeClr val="accent1"/>
+          </a:lnRef>
+          <a:fillRef idx="3">
+            <a:schemeClr val="accent1"/>
+          </a:fillRef>
+          <a:effectRef idx="2">
+            <a:schemeClr val="accent1"/>
+          </a:effectRef>
+          <a:fontRef idx="minor">
+            <a:schemeClr val="lt1"/>
+          </a:fontRef>
+        </p:style>
+        <p:txBody>
+          <a:bodyPr rtlCol="0" anchor="ctr"/>
+          <a:lstStyle/>
+          <a:p>
+            <a:pPr algn="ctr"/>
+          </a:p>
+        </p:txBody>
+      </p:sp>
+      <p:sp>
+        <p:nvSpPr>
+          <p:cNvPr id="68" name="TextBox 67"/>
+          <p:cNvSpPr txBox="1"/>
+          <p:nvPr/>
+        </p:nvSpPr>
+        <p:spPr>
+          <a:xfrm>
+            <a:off x="6272784" y="3986783"/>
+            <a:ext cx="1920240" cy="237744"/>
+          </a:xfrm>
+          <a:prstGeom prst="rect">
+            <a:avLst/>
+          </a:prstGeom>
+          <a:noFill/>
+        </p:spPr>
+        <p:txBody>
+          <a:bodyPr wrap="square">
+            <a:spAutoFit/>
+          </a:bodyPr>
+          <a:lstStyle/>
+          <a:p>
+            <a:pPr algn="l"/>
+            <a:r>
+              <a:rPr sz="900" b="1" i="0">
+                <a:solidFill>
+                  <a:srgbClr val="111827"/>
+                </a:solidFill>
+                <a:latin typeface="Calibri"/>
+              </a:rPr>
+              <a:t>EIA / USDA Commodities</a:t>
+            </a:r>
+          </a:p>
+        </p:txBody>
+      </p:sp>
+      <p:sp>
+        <p:nvSpPr>
+          <p:cNvPr id="69" name="TextBox 68"/>
+          <p:cNvSpPr txBox="1"/>
+          <p:nvPr/>
+        </p:nvSpPr>
+        <p:spPr>
+          <a:xfrm>
+            <a:off x="8275320" y="3986783"/>
+            <a:ext cx="3474720" cy="237744"/>
+          </a:xfrm>
+          <a:prstGeom prst="rect">
+            <a:avLst/>
+          </a:prstGeom>
+          <a:noFill/>
+        </p:spPr>
+        <p:txBody>
+          <a:bodyPr wrap="square">
+            <a:spAutoFit/>
+          </a:bodyPr>
+          <a:lstStyle/>
+          <a:p>
+            <a:pPr algn="l"/>
+            <a:r>
+              <a:rPr sz="800" b="0" i="0">
+                <a:solidFill>
+                  <a:srgbClr val="6B7FA0"/>
+                </a:solidFill>
+                <a:latin typeface="Calibri"/>
+              </a:rPr>
+              <a:t>Cocoa, whey, oat prices — ingredient cost-pressure signal  ·  EXT-08</a:t>
+            </a:r>
+          </a:p>
+        </p:txBody>
+      </p:sp>
+      <p:sp>
+        <p:nvSpPr>
+          <p:cNvPr id="70" name="Rectangle 69"/>
+          <p:cNvSpPr/>
+          <p:nvPr/>
+        </p:nvSpPr>
+        <p:spPr>
+          <a:xfrm>
+            <a:off x="6126480" y="4315968"/>
+            <a:ext cx="5715000" cy="402336"/>
+          </a:xfrm>
+          <a:prstGeom prst="rect">
+            <a:avLst/>
+          </a:prstGeom>
+          <a:solidFill>
+            <a:srgbClr val="FEF0F0"/>
+          </a:solidFill>
+          <a:ln w="6350">
+            <a:solidFill>
+              <a:srgbClr val="DDAAAA"/>
+            </a:solidFill>
+          </a:ln>
+        </p:spPr>
+        <p:style>
+          <a:lnRef idx="1">
+            <a:schemeClr val="accent1"/>
+          </a:lnRef>
+          <a:fillRef idx="3">
+            <a:schemeClr val="accent1"/>
+          </a:fillRef>
+          <a:effectRef idx="2">
+            <a:schemeClr val="accent1"/>
+          </a:effectRef>
+          <a:fontRef idx="minor">
+            <a:schemeClr val="lt1"/>
+          </a:fontRef>
+        </p:style>
+        <p:txBody>
+          <a:bodyPr rtlCol="0" anchor="ctr"/>
+          <a:lstStyle/>
+          <a:p>
+            <a:pPr algn="ctr"/>
+          </a:p>
+        </p:txBody>
+      </p:sp>
+      <p:sp>
+        <p:nvSpPr>
+          <p:cNvPr id="71" name="TextBox 70"/>
+          <p:cNvSpPr txBox="1"/>
+          <p:nvPr/>
+        </p:nvSpPr>
+        <p:spPr>
+          <a:xfrm>
+            <a:off x="6236208" y="4370831"/>
+            <a:ext cx="5495544" cy="310896"/>
+          </a:xfrm>
+          <a:prstGeom prst="rect">
+            <a:avLst/>
+          </a:prstGeom>
+          <a:noFill/>
+        </p:spPr>
+        <p:txBody>
+          <a:bodyPr wrap="square">
+            <a:spAutoFit/>
+          </a:bodyPr>
+          <a:lstStyle/>
+          <a:p>
+            <a:pPr algn="l"/>
+            <a:r>
+              <a:rPr sz="800" b="0" i="0">
+                <a:solidFill>
+                  <a:srgbClr val="8B1A1A"/>
+                </a:solidFill>
+                <a:latin typeface="Calibri"/>
+              </a:rPr>
+              <a:t>Licensing rule: all signals must permit commercial redistribution before integration  [EXT-02]
+Google Trends / pytrends: internal analysis only — never redistribute  [EXT-03]</a:t>
+            </a:r>
+          </a:p>
+        </p:txBody>
+      </p:sp>
+      <p:sp>
+        <p:nvSpPr>
+          <p:cNvPr id="72" name="TextBox 71"/>
           <p:cNvSpPr txBox="1"/>
           <p:nvPr/>
         </p:nvSpPr>

</xml_diff>

<commit_message>
PPTX visual fixes: phase bands on title slide, badge → eyebrow on modules, short purpose strings
Three issues flagged from screenshots:
- Title slide: replace tiny side-by-side module badges with two proper section bands
  (PHASE 1 header band above P1 boxes, PHASE 2 header band above P2 boxes; 11pt labels)
- Module slides: remove phase_badge() which was covering the italic question text;
  phase now shown as right-aligned eyebrow text on the same line as "MODULE 01"
- Purpose column: shortened all 30 purpose strings to ≤20 chars so they fit one line at 7pt

Co-Authored-By: Claude Sonnet 4.6 <noreply@anthropic.com>
</commit_message>
<xml_diff>
--- a/mockups/mo_data_ops_kickoff.pptx
+++ b/mockups/mo_data_ops_kickoff.pptx
@@ -3298,14 +3298,14 @@
         </p:nvSpPr>
         <p:spPr>
           <a:xfrm>
-            <a:off x="457200" y="4343400"/>
-            <a:ext cx="5486400" cy="27432"/>
+            <a:off x="457200" y="3931920"/>
+            <a:ext cx="11338560" cy="310896"/>
           </a:xfrm>
           <a:prstGeom prst="rect">
             <a:avLst/>
           </a:prstGeom>
           <a:solidFill>
-            <a:srgbClr val="4078D0"/>
+            <a:srgbClr val="1A3462"/>
           </a:solidFill>
           <a:ln>
             <a:noFill/>
@@ -3341,25 +3341,25 @@
         </p:nvSpPr>
         <p:spPr>
           <a:xfrm>
-            <a:off x="457200" y="4480560"/>
-            <a:ext cx="4297680" cy="201168"/>
-          </a:xfrm>
-          <a:prstGeom prst="rect">
-            <a:avLst/>
-          </a:prstGeom>
-          <a:noFill/>
-        </p:spPr>
-        <p:txBody>
-          <a:bodyPr wrap="square">
-            <a:spAutoFit/>
-          </a:bodyPr>
-          <a:lstStyle/>
-          <a:p>
-            <a:pPr algn="l"/>
-            <a:r>
-              <a:rPr sz="750" b="1" i="0">
-                <a:solidFill>
-                  <a:srgbClr val="4078D0"/>
+            <a:off x="594360" y="3995928"/>
+            <a:ext cx="10515600" cy="201168"/>
+          </a:xfrm>
+          <a:prstGeom prst="rect">
+            <a:avLst/>
+          </a:prstGeom>
+          <a:noFill/>
+        </p:spPr>
+        <p:txBody>
+          <a:bodyPr wrap="square">
+            <a:spAutoFit/>
+          </a:bodyPr>
+          <a:lstStyle/>
+          <a:p>
+            <a:pPr algn="l"/>
+            <a:r>
+              <a:rPr sz="1100" b="1" i="0">
+                <a:solidFill>
+                  <a:srgbClr val="A0C0F0"/>
                 </a:solidFill>
                 <a:latin typeface="Calibri"/>
               </a:rPr>
@@ -3370,49 +3370,14 @@
       </p:sp>
       <p:sp>
         <p:nvSpPr>
-          <p:cNvPr id="9" name="TextBox 8"/>
-          <p:cNvSpPr txBox="1"/>
-          <p:nvPr/>
-        </p:nvSpPr>
-        <p:spPr>
-          <a:xfrm>
-            <a:off x="4800600" y="4480560"/>
-            <a:ext cx="6217920" cy="201168"/>
-          </a:xfrm>
-          <a:prstGeom prst="rect">
-            <a:avLst/>
-          </a:prstGeom>
-          <a:noFill/>
-        </p:spPr>
-        <p:txBody>
-          <a:bodyPr wrap="square">
-            <a:spAutoFit/>
-          </a:bodyPr>
-          <a:lstStyle/>
-          <a:p>
-            <a:pPr algn="l"/>
-            <a:r>
-              <a:rPr sz="750" b="1" i="0">
-                <a:solidFill>
-                  <a:srgbClr val="4A566A"/>
-                </a:solidFill>
-                <a:latin typeface="Calibri"/>
-              </a:rPr>
-              <a:t>PHASE 2  ·  PLANNED 2027</a:t>
-            </a:r>
-          </a:p>
-        </p:txBody>
-      </p:sp>
-      <p:sp>
-        <p:nvSpPr>
-          <p:cNvPr id="10" name="Rectangle 9"/>
+          <p:cNvPr id="9" name="Rectangle 8"/>
           <p:cNvSpPr/>
           <p:nvPr/>
         </p:nvSpPr>
         <p:spPr>
           <a:xfrm>
-            <a:off x="457200" y="4663440"/>
-            <a:ext cx="1993391" cy="457200"/>
+            <a:off x="457200" y="4242816"/>
+            <a:ext cx="5577840" cy="685800"/>
           </a:xfrm>
           <a:prstGeom prst="rect">
             <a:avLst/>
@@ -3448,14 +3413,14 @@
       </p:sp>
       <p:sp>
         <p:nvSpPr>
-          <p:cNvPr id="11" name="TextBox 10"/>
-          <p:cNvSpPr txBox="1"/>
-          <p:nvPr/>
-        </p:nvSpPr>
-        <p:spPr>
-          <a:xfrm>
-            <a:off x="548640" y="4709160"/>
-            <a:ext cx="1901951" cy="365760"/>
+          <p:cNvPr id="10" name="TextBox 9"/>
+          <p:cNvSpPr txBox="1"/>
+          <p:nvPr/>
+        </p:nvSpPr>
+        <p:spPr>
+          <a:xfrm>
+            <a:off x="594360" y="4453128"/>
+            <a:ext cx="5303520" cy="347472"/>
           </a:xfrm>
           <a:prstGeom prst="rect">
             <a:avLst/>
@@ -3470,9 +3435,9 @@
           <a:p>
             <a:pPr algn="ctr"/>
             <a:r>
-              <a:rPr sz="1000" b="1" i="0">
-                <a:solidFill>
-                  <a:srgbClr val="A0C0F0"/>
+              <a:rPr sz="1500" b="1" i="0">
+                <a:solidFill>
+                  <a:srgbClr val="FFFFFF"/>
                 </a:solidFill>
                 <a:latin typeface="Calibri"/>
               </a:rPr>
@@ -3483,14 +3448,14 @@
       </p:sp>
       <p:sp>
         <p:nvSpPr>
-          <p:cNvPr id="12" name="Rectangle 11"/>
+          <p:cNvPr id="11" name="Rectangle 10"/>
           <p:cNvSpPr/>
           <p:nvPr/>
         </p:nvSpPr>
         <p:spPr>
           <a:xfrm>
-            <a:off x="2560320" y="4663440"/>
-            <a:ext cx="1993391" cy="457200"/>
+            <a:off x="6217920" y="4242816"/>
+            <a:ext cx="5577840" cy="685800"/>
           </a:xfrm>
           <a:prstGeom prst="rect">
             <a:avLst/>
@@ -3526,14 +3491,14 @@
       </p:sp>
       <p:sp>
         <p:nvSpPr>
-          <p:cNvPr id="13" name="TextBox 12"/>
-          <p:cNvSpPr txBox="1"/>
-          <p:nvPr/>
-        </p:nvSpPr>
-        <p:spPr>
-          <a:xfrm>
-            <a:off x="2651760" y="4709160"/>
-            <a:ext cx="1901951" cy="365760"/>
+          <p:cNvPr id="12" name="TextBox 11"/>
+          <p:cNvSpPr txBox="1"/>
+          <p:nvPr/>
+        </p:nvSpPr>
+        <p:spPr>
+          <a:xfrm>
+            <a:off x="6355080" y="4453128"/>
+            <a:ext cx="5303520" cy="347472"/>
           </a:xfrm>
           <a:prstGeom prst="rect">
             <a:avLst/>
@@ -3548,9 +3513,9 @@
           <a:p>
             <a:pPr algn="ctr"/>
             <a:r>
-              <a:rPr sz="1000" b="1" i="0">
-                <a:solidFill>
-                  <a:srgbClr val="A0C0F0"/>
+              <a:rPr sz="1500" b="1" i="0">
+                <a:solidFill>
+                  <a:srgbClr val="FFFFFF"/>
                 </a:solidFill>
                 <a:latin typeface="Calibri"/>
               </a:rPr>
@@ -3561,14 +3526,92 @@
       </p:sp>
       <p:sp>
         <p:nvSpPr>
-          <p:cNvPr id="14" name="Rectangle 13"/>
+          <p:cNvPr id="13" name="Rectangle 12"/>
           <p:cNvSpPr/>
           <p:nvPr/>
         </p:nvSpPr>
         <p:spPr>
           <a:xfrm>
-            <a:off x="4663440" y="4663440"/>
-            <a:ext cx="1993391" cy="457200"/>
+            <a:off x="457200" y="5111496"/>
+            <a:ext cx="11338560" cy="310896"/>
+          </a:xfrm>
+          <a:prstGeom prst="rect">
+            <a:avLst/>
+          </a:prstGeom>
+          <a:solidFill>
+            <a:srgbClr val="283244"/>
+          </a:solidFill>
+          <a:ln>
+            <a:noFill/>
+          </a:ln>
+        </p:spPr>
+        <p:style>
+          <a:lnRef idx="1">
+            <a:schemeClr val="accent1"/>
+          </a:lnRef>
+          <a:fillRef idx="3">
+            <a:schemeClr val="accent1"/>
+          </a:fillRef>
+          <a:effectRef idx="2">
+            <a:schemeClr val="accent1"/>
+          </a:effectRef>
+          <a:fontRef idx="minor">
+            <a:schemeClr val="lt1"/>
+          </a:fontRef>
+        </p:style>
+        <p:txBody>
+          <a:bodyPr rtlCol="0" anchor="ctr"/>
+          <a:lstStyle/>
+          <a:p>
+            <a:pPr algn="ctr"/>
+          </a:p>
+        </p:txBody>
+      </p:sp>
+      <p:sp>
+        <p:nvSpPr>
+          <p:cNvPr id="14" name="TextBox 13"/>
+          <p:cNvSpPr txBox="1"/>
+          <p:nvPr/>
+        </p:nvSpPr>
+        <p:spPr>
+          <a:xfrm>
+            <a:off x="594360" y="5175504"/>
+            <a:ext cx="10515600" cy="201168"/>
+          </a:xfrm>
+          <a:prstGeom prst="rect">
+            <a:avLst/>
+          </a:prstGeom>
+          <a:noFill/>
+        </p:spPr>
+        <p:txBody>
+          <a:bodyPr wrap="square">
+            <a:spAutoFit/>
+          </a:bodyPr>
+          <a:lstStyle/>
+          <a:p>
+            <a:pPr algn="l"/>
+            <a:r>
+              <a:rPr sz="1100" b="1" i="0">
+                <a:solidFill>
+                  <a:srgbClr val="D4DAE6"/>
+                </a:solidFill>
+                <a:latin typeface="Calibri"/>
+              </a:rPr>
+              <a:t>PHASE 2  ·  PLANNED 2027</a:t>
+            </a:r>
+          </a:p>
+        </p:txBody>
+      </p:sp>
+      <p:sp>
+        <p:nvSpPr>
+          <p:cNvPr id="15" name="Rectangle 14"/>
+          <p:cNvSpPr/>
+          <p:nvPr/>
+        </p:nvSpPr>
+        <p:spPr>
+          <a:xfrm>
+            <a:off x="457200" y="5422392"/>
+            <a:ext cx="3657600" cy="594360"/>
           </a:xfrm>
           <a:prstGeom prst="rect">
             <a:avLst/>
@@ -3604,14 +3647,14 @@
       </p:sp>
       <p:sp>
         <p:nvSpPr>
-          <p:cNvPr id="15" name="TextBox 14"/>
-          <p:cNvSpPr txBox="1"/>
-          <p:nvPr/>
-        </p:nvSpPr>
-        <p:spPr>
-          <a:xfrm>
-            <a:off x="4754879" y="4709160"/>
-            <a:ext cx="1901951" cy="365760"/>
+          <p:cNvPr id="16" name="TextBox 15"/>
+          <p:cNvSpPr txBox="1"/>
+          <p:nvPr/>
+        </p:nvSpPr>
+        <p:spPr>
+          <a:xfrm>
+            <a:off x="548640" y="5586983"/>
+            <a:ext cx="3474720" cy="310896"/>
           </a:xfrm>
           <a:prstGeom prst="rect">
             <a:avLst/>
@@ -3626,7 +3669,7 @@
           <a:p>
             <a:pPr algn="ctr"/>
             <a:r>
-              <a:rPr sz="1000" b="1" i="0">
+              <a:rPr sz="1200" b="1" i="0">
                 <a:solidFill>
                   <a:srgbClr val="D4DAE6"/>
                 </a:solidFill>
@@ -3639,14 +3682,14 @@
       </p:sp>
       <p:sp>
         <p:nvSpPr>
-          <p:cNvPr id="16" name="Rectangle 15"/>
+          <p:cNvPr id="17" name="Rectangle 16"/>
           <p:cNvSpPr/>
           <p:nvPr/>
         </p:nvSpPr>
         <p:spPr>
           <a:xfrm>
-            <a:off x="6766559" y="4663440"/>
-            <a:ext cx="1993391" cy="457200"/>
+            <a:off x="4297680" y="5422392"/>
+            <a:ext cx="3657600" cy="594360"/>
           </a:xfrm>
           <a:prstGeom prst="rect">
             <a:avLst/>
@@ -3682,14 +3725,14 @@
       </p:sp>
       <p:sp>
         <p:nvSpPr>
-          <p:cNvPr id="17" name="TextBox 16"/>
-          <p:cNvSpPr txBox="1"/>
-          <p:nvPr/>
-        </p:nvSpPr>
-        <p:spPr>
-          <a:xfrm>
-            <a:off x="6857999" y="4709160"/>
-            <a:ext cx="1901951" cy="365760"/>
+          <p:cNvPr id="18" name="TextBox 17"/>
+          <p:cNvSpPr txBox="1"/>
+          <p:nvPr/>
+        </p:nvSpPr>
+        <p:spPr>
+          <a:xfrm>
+            <a:off x="4389120" y="5586983"/>
+            <a:ext cx="3474720" cy="310896"/>
           </a:xfrm>
           <a:prstGeom prst="rect">
             <a:avLst/>
@@ -3704,7 +3747,7 @@
           <a:p>
             <a:pPr algn="ctr"/>
             <a:r>
-              <a:rPr sz="1000" b="1" i="0">
+              <a:rPr sz="1200" b="1" i="0">
                 <a:solidFill>
                   <a:srgbClr val="D4DAE6"/>
                 </a:solidFill>
@@ -3717,14 +3760,14 @@
       </p:sp>
       <p:sp>
         <p:nvSpPr>
-          <p:cNvPr id="18" name="Rectangle 17"/>
+          <p:cNvPr id="19" name="Rectangle 18"/>
           <p:cNvSpPr/>
           <p:nvPr/>
         </p:nvSpPr>
         <p:spPr>
           <a:xfrm>
-            <a:off x="8869680" y="4663440"/>
-            <a:ext cx="1993391" cy="457200"/>
+            <a:off x="8138160" y="5422392"/>
+            <a:ext cx="3657600" cy="594360"/>
           </a:xfrm>
           <a:prstGeom prst="rect">
             <a:avLst/>
@@ -3760,14 +3803,14 @@
       </p:sp>
       <p:sp>
         <p:nvSpPr>
-          <p:cNvPr id="19" name="TextBox 18"/>
-          <p:cNvSpPr txBox="1"/>
-          <p:nvPr/>
-        </p:nvSpPr>
-        <p:spPr>
-          <a:xfrm>
-            <a:off x="8961119" y="4709160"/>
-            <a:ext cx="1901951" cy="365760"/>
+          <p:cNvPr id="20" name="TextBox 19"/>
+          <p:cNvSpPr txBox="1"/>
+          <p:nvPr/>
+        </p:nvSpPr>
+        <p:spPr>
+          <a:xfrm>
+            <a:off x="8229600" y="5586983"/>
+            <a:ext cx="3474720" cy="310896"/>
           </a:xfrm>
           <a:prstGeom prst="rect">
             <a:avLst/>
@@ -3782,7 +3825,7 @@
           <a:p>
             <a:pPr algn="ctr"/>
             <a:r>
-              <a:rPr sz="1000" b="1" i="0">
+              <a:rPr sz="1200" b="1" i="0">
                 <a:solidFill>
                   <a:srgbClr val="D4DAE6"/>
                 </a:solidFill>
@@ -3795,14 +3838,14 @@
       </p:sp>
       <p:sp>
         <p:nvSpPr>
-          <p:cNvPr id="20" name="TextBox 19"/>
-          <p:cNvSpPr txBox="1"/>
-          <p:nvPr/>
-        </p:nvSpPr>
-        <p:spPr>
-          <a:xfrm>
-            <a:off x="8229600" y="6217920"/>
-            <a:ext cx="3657600" cy="365760"/>
+          <p:cNvPr id="21" name="TextBox 20"/>
+          <p:cNvSpPr txBox="1"/>
+          <p:nvPr/>
+        </p:nvSpPr>
+        <p:spPr>
+          <a:xfrm>
+            <a:off x="8229600" y="6492240"/>
+            <a:ext cx="3657600" cy="274320"/>
           </a:xfrm>
           <a:prstGeom prst="rect">
             <a:avLst/>
@@ -12164,7 +12207,7 @@
         <p:spPr>
           <a:xfrm>
             <a:off x="457200" y="91440"/>
-            <a:ext cx="1828800" cy="274320"/>
+            <a:ext cx="3200400" cy="256032"/>
           </a:xfrm>
           <a:prstGeom prst="rect">
             <a:avLst/>
@@ -12193,6 +12236,41 @@
       <p:sp>
         <p:nvSpPr>
           <p:cNvPr id="6" name="TextBox 5"/>
+          <p:cNvSpPr txBox="1"/>
+          <p:nvPr/>
+        </p:nvSpPr>
+        <p:spPr>
+          <a:xfrm>
+            <a:off x="3657600" y="91440"/>
+            <a:ext cx="8229600" cy="256032"/>
+          </a:xfrm>
+          <a:prstGeom prst="rect">
+            <a:avLst/>
+          </a:prstGeom>
+          <a:noFill/>
+        </p:spPr>
+        <p:txBody>
+          <a:bodyPr wrap="square">
+            <a:spAutoFit/>
+          </a:bodyPr>
+          <a:lstStyle/>
+          <a:p>
+            <a:pPr algn="r"/>
+            <a:r>
+              <a:rPr sz="900" b="1" i="0">
+                <a:solidFill>
+                  <a:srgbClr val="4078D0"/>
+                </a:solidFill>
+                <a:latin typeface="Calibri"/>
+              </a:rPr>
+              <a:t>PHASE 1 — NOW THROUGH DEC 2026</a:t>
+            </a:r>
+          </a:p>
+        </p:txBody>
+      </p:sp>
+      <p:sp>
+        <p:nvSpPr>
+          <p:cNvPr id="7" name="TextBox 6"/>
           <p:cNvSpPr txBox="1"/>
           <p:nvPr/>
         </p:nvSpPr>
@@ -12227,7 +12305,7 @@
       </p:sp>
       <p:sp>
         <p:nvSpPr>
-          <p:cNvPr id="7" name="TextBox 6"/>
+          <p:cNvPr id="8" name="TextBox 7"/>
           <p:cNvSpPr txBox="1"/>
           <p:nvPr/>
         </p:nvSpPr>
@@ -12262,85 +12340,7 @@
       </p:sp>
       <p:sp>
         <p:nvSpPr>
-          <p:cNvPr id="8" name="Rectangle 7"/>
-          <p:cNvSpPr/>
-          <p:nvPr/>
-        </p:nvSpPr>
-        <p:spPr>
-          <a:xfrm>
-            <a:off x="8961120" y="201168"/>
-            <a:ext cx="3017520" cy="292608"/>
-          </a:xfrm>
-          <a:prstGeom prst="rect">
-            <a:avLst/>
-          </a:prstGeom>
-          <a:solidFill>
-            <a:srgbClr val="4078D0"/>
-          </a:solidFill>
-          <a:ln>
-            <a:noFill/>
-          </a:ln>
-        </p:spPr>
-        <p:style>
-          <a:lnRef idx="1">
-            <a:schemeClr val="accent1"/>
-          </a:lnRef>
-          <a:fillRef idx="3">
-            <a:schemeClr val="accent1"/>
-          </a:fillRef>
-          <a:effectRef idx="2">
-            <a:schemeClr val="accent1"/>
-          </a:effectRef>
-          <a:fontRef idx="minor">
-            <a:schemeClr val="lt1"/>
-          </a:fontRef>
-        </p:style>
-        <p:txBody>
-          <a:bodyPr rtlCol="0" anchor="ctr"/>
-          <a:lstStyle/>
-          <a:p>
-            <a:pPr algn="ctr"/>
-          </a:p>
-        </p:txBody>
-      </p:sp>
-      <p:sp>
-        <p:nvSpPr>
-          <p:cNvPr id="9" name="TextBox 8"/>
-          <p:cNvSpPr txBox="1"/>
-          <p:nvPr/>
-        </p:nvSpPr>
-        <p:spPr>
-          <a:xfrm>
-            <a:off x="9006840" y="237744"/>
-            <a:ext cx="2926080" cy="219456"/>
-          </a:xfrm>
-          <a:prstGeom prst="rect">
-            <a:avLst/>
-          </a:prstGeom>
-          <a:noFill/>
-        </p:spPr>
-        <p:txBody>
-          <a:bodyPr wrap="square">
-            <a:spAutoFit/>
-          </a:bodyPr>
-          <a:lstStyle/>
-          <a:p>
-            <a:pPr algn="ctr"/>
-            <a:r>
-              <a:rPr sz="850" b="1" i="0">
-                <a:solidFill>
-                  <a:srgbClr val="FFFFFF"/>
-                </a:solidFill>
-                <a:latin typeface="Calibri"/>
-              </a:rPr>
-              <a:t>PHASE 1  ·  Now – Dec 2026</a:t>
-            </a:r>
-          </a:p>
-        </p:txBody>
-      </p:sp>
-      <p:sp>
-        <p:nvSpPr>
-          <p:cNvPr id="10" name="Rectangle 9"/>
+          <p:cNvPr id="9" name="Rectangle 8"/>
           <p:cNvSpPr/>
           <p:nvPr/>
         </p:nvSpPr>
@@ -12383,7 +12383,7 @@
       </p:sp>
       <p:sp>
         <p:nvSpPr>
-          <p:cNvPr id="11" name="TextBox 10"/>
+          <p:cNvPr id="10" name="TextBox 9"/>
           <p:cNvSpPr txBox="1"/>
           <p:nvPr/>
         </p:nvSpPr>
@@ -12418,7 +12418,7 @@
       </p:sp>
       <p:sp>
         <p:nvSpPr>
-          <p:cNvPr id="12" name="Rectangle 11"/>
+          <p:cNvPr id="11" name="Rectangle 10"/>
           <p:cNvSpPr/>
           <p:nvPr/>
         </p:nvSpPr>
@@ -12461,7 +12461,7 @@
       </p:sp>
       <p:sp>
         <p:nvSpPr>
-          <p:cNvPr id="13" name="TextBox 12"/>
+          <p:cNvPr id="12" name="TextBox 11"/>
           <p:cNvSpPr txBox="1"/>
           <p:nvPr/>
         </p:nvSpPr>
@@ -12496,7 +12496,7 @@
       </p:sp>
       <p:sp>
         <p:nvSpPr>
-          <p:cNvPr id="14" name="TextBox 13"/>
+          <p:cNvPr id="13" name="TextBox 12"/>
           <p:cNvSpPr txBox="1"/>
           <p:nvPr/>
         </p:nvSpPr>
@@ -12531,7 +12531,7 @@
       </p:sp>
       <p:sp>
         <p:nvSpPr>
-          <p:cNvPr id="15" name="TextBox 14"/>
+          <p:cNvPr id="14" name="TextBox 13"/>
           <p:cNvSpPr txBox="1"/>
           <p:nvPr/>
         </p:nvSpPr>
@@ -12566,7 +12566,7 @@
       </p:sp>
       <p:sp>
         <p:nvSpPr>
-          <p:cNvPr id="16" name="Rectangle 15"/>
+          <p:cNvPr id="15" name="Rectangle 14"/>
           <p:cNvSpPr/>
           <p:nvPr/>
         </p:nvSpPr>
@@ -12611,7 +12611,7 @@
       </p:sp>
       <p:sp>
         <p:nvSpPr>
-          <p:cNvPr id="17" name="TextBox 16"/>
+          <p:cNvPr id="16" name="TextBox 15"/>
           <p:cNvSpPr txBox="1"/>
           <p:nvPr/>
         </p:nvSpPr>
@@ -12646,7 +12646,7 @@
       </p:sp>
       <p:sp>
         <p:nvSpPr>
-          <p:cNvPr id="18" name="TextBox 17"/>
+          <p:cNvPr id="17" name="TextBox 16"/>
           <p:cNvSpPr txBox="1"/>
           <p:nvPr/>
         </p:nvSpPr>
@@ -12681,7 +12681,7 @@
       </p:sp>
       <p:sp>
         <p:nvSpPr>
-          <p:cNvPr id="19" name="TextBox 18"/>
+          <p:cNvPr id="18" name="TextBox 17"/>
           <p:cNvSpPr txBox="1"/>
           <p:nvPr/>
         </p:nvSpPr>
@@ -12709,14 +12709,14 @@
                 </a:solidFill>
                 <a:latin typeface="Calibri"/>
               </a:rPr>
-              <a:t>Measure demand before/after launch</a:t>
-            </a:r>
-          </a:p>
-        </p:txBody>
-      </p:sp>
-      <p:sp>
-        <p:nvSpPr>
-          <p:cNvPr id="20" name="Rectangle 19"/>
+              <a:t>Before/after demand</a:t>
+            </a:r>
+          </a:p>
+        </p:txBody>
+      </p:sp>
+      <p:sp>
+        <p:nvSpPr>
+          <p:cNvPr id="19" name="Rectangle 18"/>
           <p:cNvSpPr/>
           <p:nvPr/>
         </p:nvSpPr>
@@ -12761,7 +12761,7 @@
       </p:sp>
       <p:sp>
         <p:nvSpPr>
-          <p:cNvPr id="21" name="TextBox 20"/>
+          <p:cNvPr id="20" name="TextBox 19"/>
           <p:cNvSpPr txBox="1"/>
           <p:nvPr/>
         </p:nvSpPr>
@@ -12796,7 +12796,7 @@
       </p:sp>
       <p:sp>
         <p:nvSpPr>
-          <p:cNvPr id="22" name="TextBox 21"/>
+          <p:cNvPr id="21" name="TextBox 20"/>
           <p:cNvSpPr txBox="1"/>
           <p:nvPr/>
         </p:nvSpPr>
@@ -12831,7 +12831,7 @@
       </p:sp>
       <p:sp>
         <p:nvSpPr>
-          <p:cNvPr id="23" name="TextBox 22"/>
+          <p:cNvPr id="22" name="TextBox 21"/>
           <p:cNvSpPr txBox="1"/>
           <p:nvPr/>
         </p:nvSpPr>
@@ -12859,14 +12859,14 @@
                 </a:solidFill>
                 <a:latin typeface="Calibri"/>
               </a:rPr>
-              <a:t>Separate promo from organic demand</a:t>
-            </a:r>
-          </a:p>
-        </p:txBody>
-      </p:sp>
-      <p:sp>
-        <p:nvSpPr>
-          <p:cNvPr id="24" name="Rectangle 23"/>
+              <a:t>Isolate organic demand</a:t>
+            </a:r>
+          </a:p>
+        </p:txBody>
+      </p:sp>
+      <p:sp>
+        <p:nvSpPr>
+          <p:cNvPr id="23" name="Rectangle 22"/>
           <p:cNvSpPr/>
           <p:nvPr/>
         </p:nvSpPr>
@@ -12911,7 +12911,7 @@
       </p:sp>
       <p:sp>
         <p:nvSpPr>
-          <p:cNvPr id="25" name="TextBox 24"/>
+          <p:cNvPr id="24" name="TextBox 23"/>
           <p:cNvSpPr txBox="1"/>
           <p:nvPr/>
         </p:nvSpPr>
@@ -12946,7 +12946,7 @@
       </p:sp>
       <p:sp>
         <p:nvSpPr>
-          <p:cNvPr id="26" name="TextBox 25"/>
+          <p:cNvPr id="25" name="TextBox 24"/>
           <p:cNvSpPr txBox="1"/>
           <p:nvPr/>
         </p:nvSpPr>
@@ -12981,7 +12981,7 @@
       </p:sp>
       <p:sp>
         <p:nvSpPr>
-          <p:cNvPr id="27" name="TextBox 26"/>
+          <p:cNvPr id="26" name="TextBox 25"/>
           <p:cNvSpPr txBox="1"/>
           <p:nvPr/>
         </p:nvSpPr>
@@ -13009,14 +13009,14 @@
                 </a:solidFill>
                 <a:latin typeface="Calibri"/>
               </a:rPr>
-              <a:t>Distinguish demand drop from distribution loss</a:t>
-            </a:r>
-          </a:p>
-        </p:txBody>
-      </p:sp>
-      <p:sp>
-        <p:nvSpPr>
-          <p:cNvPr id="28" name="Rectangle 27"/>
+              <a:t>Demand vs. distrib. loss</a:t>
+            </a:r>
+          </a:p>
+        </p:txBody>
+      </p:sp>
+      <p:sp>
+        <p:nvSpPr>
+          <p:cNvPr id="27" name="Rectangle 26"/>
           <p:cNvSpPr/>
           <p:nvPr/>
         </p:nvSpPr>
@@ -13061,7 +13061,7 @@
       </p:sp>
       <p:sp>
         <p:nvSpPr>
-          <p:cNvPr id="29" name="TextBox 28"/>
+          <p:cNvPr id="28" name="TextBox 27"/>
           <p:cNvSpPr txBox="1"/>
           <p:nvPr/>
         </p:nvSpPr>
@@ -13096,7 +13096,7 @@
       </p:sp>
       <p:sp>
         <p:nvSpPr>
-          <p:cNvPr id="30" name="TextBox 29"/>
+          <p:cNvPr id="29" name="TextBox 28"/>
           <p:cNvSpPr txBox="1"/>
           <p:nvPr/>
         </p:nvSpPr>
@@ -13131,7 +13131,7 @@
       </p:sp>
       <p:sp>
         <p:nvSpPr>
-          <p:cNvPr id="31" name="TextBox 30"/>
+          <p:cNvPr id="30" name="TextBox 29"/>
           <p:cNvSpPr txBox="1"/>
           <p:nvPr/>
         </p:nvSpPr>
@@ -13159,14 +13159,14 @@
                 </a:solidFill>
                 <a:latin typeface="Calibri"/>
               </a:rPr>
-              <a:t>Detect whether price changes explain the shift</a:t>
-            </a:r>
-          </a:p>
-        </p:txBody>
-      </p:sp>
-      <p:sp>
-        <p:nvSpPr>
-          <p:cNvPr id="32" name="Rectangle 31"/>
+              <a:t>Rule out price effect</a:t>
+            </a:r>
+          </a:p>
+        </p:txBody>
+      </p:sp>
+      <p:sp>
+        <p:nvSpPr>
+          <p:cNvPr id="31" name="Rectangle 30"/>
           <p:cNvSpPr/>
           <p:nvPr/>
         </p:nvSpPr>
@@ -13211,7 +13211,7 @@
       </p:sp>
       <p:sp>
         <p:nvSpPr>
-          <p:cNvPr id="33" name="TextBox 32"/>
+          <p:cNvPr id="32" name="TextBox 31"/>
           <p:cNvSpPr txBox="1"/>
           <p:nvPr/>
         </p:nvSpPr>
@@ -13246,7 +13246,7 @@
       </p:sp>
       <p:sp>
         <p:nvSpPr>
-          <p:cNvPr id="34" name="TextBox 33"/>
+          <p:cNvPr id="33" name="TextBox 32"/>
           <p:cNvSpPr txBox="1"/>
           <p:nvPr/>
         </p:nvSpPr>
@@ -13281,7 +13281,7 @@
       </p:sp>
       <p:sp>
         <p:nvSpPr>
-          <p:cNvPr id="35" name="TextBox 34"/>
+          <p:cNvPr id="34" name="TextBox 33"/>
           <p:cNvSpPr txBox="1"/>
           <p:nvPr/>
         </p:nvSpPr>
@@ -13309,14 +13309,14 @@
                 </a:solidFill>
                 <a:latin typeface="Calibri"/>
               </a:rPr>
-              <a:t>Anchor the before/after comparison window</a:t>
-            </a:r>
-          </a:p>
-        </p:txBody>
-      </p:sp>
-      <p:sp>
-        <p:nvSpPr>
-          <p:cNvPr id="36" name="Rectangle 35"/>
+              <a:t>Launch anchor date</a:t>
+            </a:r>
+          </a:p>
+        </p:txBody>
+      </p:sp>
+      <p:sp>
+        <p:nvSpPr>
+          <p:cNvPr id="35" name="Rectangle 34"/>
           <p:cNvSpPr/>
           <p:nvPr/>
         </p:nvSpPr>
@@ -13361,7 +13361,7 @@
       </p:sp>
       <p:sp>
         <p:nvSpPr>
-          <p:cNvPr id="37" name="TextBox 36"/>
+          <p:cNvPr id="36" name="TextBox 35"/>
           <p:cNvSpPr txBox="1"/>
           <p:nvPr/>
         </p:nvSpPr>
@@ -13396,7 +13396,7 @@
       </p:sp>
       <p:sp>
         <p:nvSpPr>
-          <p:cNvPr id="38" name="TextBox 37"/>
+          <p:cNvPr id="37" name="TextBox 36"/>
           <p:cNvSpPr txBox="1"/>
           <p:nvPr/>
         </p:nvSpPr>
@@ -13431,7 +13431,7 @@
       </p:sp>
       <p:sp>
         <p:nvSpPr>
-          <p:cNvPr id="39" name="TextBox 38"/>
+          <p:cNvPr id="38" name="TextBox 37"/>
           <p:cNvSpPr txBox="1"/>
           <p:nvPr/>
         </p:nvSpPr>
@@ -13459,14 +13459,14 @@
                 </a:solidFill>
                 <a:latin typeface="Calibri"/>
               </a:rPr>
-              <a:t>Identify likely substitute SKUs</a:t>
-            </a:r>
-          </a:p>
-        </p:txBody>
-      </p:sp>
-      <p:sp>
-        <p:nvSpPr>
-          <p:cNvPr id="40" name="Rectangle 39"/>
+              <a:t>Find substitute SKUs</a:t>
+            </a:r>
+          </a:p>
+        </p:txBody>
+      </p:sp>
+      <p:sp>
+        <p:nvSpPr>
+          <p:cNvPr id="39" name="Rectangle 38"/>
           <p:cNvSpPr/>
           <p:nvPr/>
         </p:nvSpPr>
@@ -13511,7 +13511,7 @@
       </p:sp>
       <p:sp>
         <p:nvSpPr>
-          <p:cNvPr id="41" name="TextBox 40"/>
+          <p:cNvPr id="40" name="TextBox 39"/>
           <p:cNvSpPr txBox="1"/>
           <p:nvPr/>
         </p:nvSpPr>
@@ -13546,7 +13546,7 @@
       </p:sp>
       <p:sp>
         <p:nvSpPr>
-          <p:cNvPr id="42" name="TextBox 41"/>
+          <p:cNvPr id="41" name="TextBox 40"/>
           <p:cNvSpPr txBox="1"/>
           <p:nvPr/>
         </p:nvSpPr>
@@ -13581,7 +13581,7 @@
       </p:sp>
       <p:sp>
         <p:nvSpPr>
-          <p:cNvPr id="43" name="TextBox 42"/>
+          <p:cNvPr id="42" name="TextBox 41"/>
           <p:cNvSpPr txBox="1"/>
           <p:nvPr/>
         </p:nvSpPr>
@@ -13609,14 +13609,14 @@
                 </a:solidFill>
                 <a:latin typeface="Calibri"/>
               </a:rPr>
-              <a:t>Flag confounding promotional periods</a:t>
-            </a:r>
-          </a:p>
-        </p:txBody>
-      </p:sp>
-      <p:sp>
-        <p:nvSpPr>
-          <p:cNvPr id="44" name="Rectangle 43"/>
+              <a:t>Flag promo periods</a:t>
+            </a:r>
+          </a:p>
+        </p:txBody>
+      </p:sp>
+      <p:sp>
+        <p:nvSpPr>
+          <p:cNvPr id="43" name="Rectangle 42"/>
           <p:cNvSpPr/>
           <p:nvPr/>
         </p:nvSpPr>
@@ -13659,7 +13659,7 @@
       </p:sp>
       <p:sp>
         <p:nvSpPr>
-          <p:cNvPr id="45" name="TextBox 44"/>
+          <p:cNvPr id="44" name="TextBox 43"/>
           <p:cNvSpPr txBox="1"/>
           <p:nvPr/>
         </p:nvSpPr>
@@ -13694,7 +13694,7 @@
       </p:sp>
       <p:sp>
         <p:nvSpPr>
-          <p:cNvPr id="46" name="Rectangle 45"/>
+          <p:cNvPr id="45" name="Rectangle 44"/>
           <p:cNvSpPr/>
           <p:nvPr/>
         </p:nvSpPr>
@@ -13737,7 +13737,7 @@
       </p:sp>
       <p:sp>
         <p:nvSpPr>
-          <p:cNvPr id="47" name="TextBox 46"/>
+          <p:cNvPr id="46" name="TextBox 45"/>
           <p:cNvSpPr txBox="1"/>
           <p:nvPr/>
         </p:nvSpPr>
@@ -13772,7 +13772,7 @@
       </p:sp>
       <p:sp>
         <p:nvSpPr>
-          <p:cNvPr id="48" name="Rectangle 47"/>
+          <p:cNvPr id="47" name="Rectangle 46"/>
           <p:cNvSpPr/>
           <p:nvPr/>
         </p:nvSpPr>
@@ -13815,7 +13815,7 @@
       </p:sp>
       <p:sp>
         <p:nvSpPr>
-          <p:cNvPr id="49" name="TextBox 48"/>
+          <p:cNvPr id="48" name="TextBox 47"/>
           <p:cNvSpPr txBox="1"/>
           <p:nvPr/>
         </p:nvSpPr>
@@ -13850,7 +13850,7 @@
       </p:sp>
       <p:sp>
         <p:nvSpPr>
-          <p:cNvPr id="50" name="Rectangle 49"/>
+          <p:cNvPr id="49" name="Rectangle 48"/>
           <p:cNvSpPr/>
           <p:nvPr/>
         </p:nvSpPr>
@@ -13893,7 +13893,7 @@
       </p:sp>
       <p:sp>
         <p:nvSpPr>
-          <p:cNvPr id="51" name="TextBox 50"/>
+          <p:cNvPr id="50" name="TextBox 49"/>
           <p:cNvSpPr txBox="1"/>
           <p:nvPr/>
         </p:nvSpPr>
@@ -13928,7 +13928,7 @@
       </p:sp>
       <p:sp>
         <p:nvSpPr>
-          <p:cNvPr id="52" name="Rectangle 51"/>
+          <p:cNvPr id="51" name="Rectangle 50"/>
           <p:cNvSpPr/>
           <p:nvPr/>
         </p:nvSpPr>
@@ -13971,7 +13971,7 @@
       </p:sp>
       <p:sp>
         <p:nvSpPr>
-          <p:cNvPr id="53" name="TextBox 52"/>
+          <p:cNvPr id="52" name="TextBox 51"/>
           <p:cNvSpPr txBox="1"/>
           <p:nvPr/>
         </p:nvSpPr>
@@ -14006,7 +14006,7 @@
       </p:sp>
       <p:sp>
         <p:nvSpPr>
-          <p:cNvPr id="54" name="Rectangle 53"/>
+          <p:cNvPr id="53" name="Rectangle 52"/>
           <p:cNvSpPr/>
           <p:nvPr/>
         </p:nvSpPr>
@@ -14049,7 +14049,7 @@
       </p:sp>
       <p:sp>
         <p:nvSpPr>
-          <p:cNvPr id="55" name="TextBox 54"/>
+          <p:cNvPr id="54" name="TextBox 53"/>
           <p:cNvSpPr txBox="1"/>
           <p:nvPr/>
         </p:nvSpPr>
@@ -14084,7 +14084,7 @@
       </p:sp>
       <p:sp>
         <p:nvSpPr>
-          <p:cNvPr id="56" name="Rectangle 55"/>
+          <p:cNvPr id="55" name="Rectangle 54"/>
           <p:cNvSpPr/>
           <p:nvPr/>
         </p:nvSpPr>
@@ -14127,7 +14127,7 @@
       </p:sp>
       <p:sp>
         <p:nvSpPr>
-          <p:cNvPr id="57" name="TextBox 56"/>
+          <p:cNvPr id="56" name="TextBox 55"/>
           <p:cNvSpPr txBox="1"/>
           <p:nvPr/>
         </p:nvSpPr>
@@ -14162,7 +14162,7 @@
       </p:sp>
       <p:sp>
         <p:nvSpPr>
-          <p:cNvPr id="58" name="Rectangle 57"/>
+          <p:cNvPr id="57" name="Rectangle 56"/>
           <p:cNvSpPr/>
           <p:nvPr/>
         </p:nvSpPr>
@@ -14205,7 +14205,7 @@
       </p:sp>
       <p:sp>
         <p:nvSpPr>
-          <p:cNvPr id="59" name="TextBox 58"/>
+          <p:cNvPr id="58" name="TextBox 57"/>
           <p:cNvSpPr txBox="1"/>
           <p:nvPr/>
         </p:nvSpPr>
@@ -14240,7 +14240,7 @@
       </p:sp>
       <p:sp>
         <p:nvSpPr>
-          <p:cNvPr id="60" name="Rectangle 59"/>
+          <p:cNvPr id="59" name="Rectangle 58"/>
           <p:cNvSpPr/>
           <p:nvPr/>
         </p:nvSpPr>
@@ -14285,7 +14285,7 @@
       </p:sp>
       <p:sp>
         <p:nvSpPr>
-          <p:cNvPr id="61" name="TextBox 60"/>
+          <p:cNvPr id="60" name="TextBox 59"/>
           <p:cNvSpPr txBox="1"/>
           <p:nvPr/>
         </p:nvSpPr>
@@ -14320,7 +14320,7 @@
       </p:sp>
       <p:sp>
         <p:nvSpPr>
-          <p:cNvPr id="62" name="TextBox 61"/>
+          <p:cNvPr id="61" name="TextBox 60"/>
           <p:cNvSpPr txBox="1"/>
           <p:nvPr/>
         </p:nvSpPr>
@@ -14355,7 +14355,7 @@
       </p:sp>
       <p:sp>
         <p:nvSpPr>
-          <p:cNvPr id="63" name="TextBox 62"/>
+          <p:cNvPr id="62" name="TextBox 61"/>
           <p:cNvSpPr txBox="1"/>
           <p:nvPr/>
         </p:nvSpPr>
@@ -14390,7 +14390,7 @@
       </p:sp>
       <p:sp>
         <p:nvSpPr>
-          <p:cNvPr id="64" name="TextBox 63"/>
+          <p:cNvPr id="63" name="TextBox 62"/>
           <p:cNvSpPr txBox="1"/>
           <p:nvPr/>
         </p:nvSpPr>
@@ -14425,7 +14425,7 @@
       </p:sp>
       <p:sp>
         <p:nvSpPr>
-          <p:cNvPr id="65" name="TextBox 64"/>
+          <p:cNvPr id="64" name="TextBox 63"/>
           <p:cNvSpPr txBox="1"/>
           <p:nvPr/>
         </p:nvSpPr>
@@ -14460,7 +14460,7 @@
       </p:sp>
       <p:sp>
         <p:nvSpPr>
-          <p:cNvPr id="66" name="Rectangle 65"/>
+          <p:cNvPr id="65" name="Rectangle 64"/>
           <p:cNvSpPr/>
           <p:nvPr/>
         </p:nvSpPr>
@@ -14503,7 +14503,7 @@
       </p:sp>
       <p:sp>
         <p:nvSpPr>
-          <p:cNvPr id="67" name="TextBox 66"/>
+          <p:cNvPr id="66" name="TextBox 65"/>
           <p:cNvSpPr txBox="1"/>
           <p:nvPr/>
         </p:nvSpPr>
@@ -14538,7 +14538,7 @@
       </p:sp>
       <p:sp>
         <p:nvSpPr>
-          <p:cNvPr id="68" name="Rectangle 67"/>
+          <p:cNvPr id="67" name="Rectangle 66"/>
           <p:cNvSpPr/>
           <p:nvPr/>
         </p:nvSpPr>
@@ -14583,7 +14583,7 @@
       </p:sp>
       <p:sp>
         <p:nvSpPr>
-          <p:cNvPr id="69" name="TextBox 68"/>
+          <p:cNvPr id="68" name="TextBox 67"/>
           <p:cNvSpPr txBox="1"/>
           <p:nvPr/>
         </p:nvSpPr>
@@ -14618,7 +14618,7 @@
       </p:sp>
       <p:sp>
         <p:nvSpPr>
-          <p:cNvPr id="70" name="TextBox 69"/>
+          <p:cNvPr id="69" name="TextBox 68"/>
           <p:cNvSpPr txBox="1"/>
           <p:nvPr/>
         </p:nvSpPr>
@@ -14653,7 +14653,7 @@
       </p:sp>
       <p:sp>
         <p:nvSpPr>
-          <p:cNvPr id="71" name="TextBox 70"/>
+          <p:cNvPr id="70" name="TextBox 69"/>
           <p:cNvSpPr txBox="1"/>
           <p:nvPr/>
         </p:nvSpPr>
@@ -14688,7 +14688,7 @@
       </p:sp>
       <p:sp>
         <p:nvSpPr>
-          <p:cNvPr id="72" name="TextBox 71"/>
+          <p:cNvPr id="71" name="TextBox 70"/>
           <p:cNvSpPr txBox="1"/>
           <p:nvPr/>
         </p:nvSpPr>
@@ -14723,7 +14723,7 @@
       </p:sp>
       <p:sp>
         <p:nvSpPr>
-          <p:cNvPr id="73" name="Rectangle 72"/>
+          <p:cNvPr id="72" name="Rectangle 71"/>
           <p:cNvSpPr/>
           <p:nvPr/>
         </p:nvSpPr>
@@ -14766,7 +14766,7 @@
       </p:sp>
       <p:sp>
         <p:nvSpPr>
-          <p:cNvPr id="74" name="TextBox 73"/>
+          <p:cNvPr id="73" name="TextBox 72"/>
           <p:cNvSpPr txBox="1"/>
           <p:nvPr/>
         </p:nvSpPr>
@@ -14801,7 +14801,7 @@
       </p:sp>
       <p:sp>
         <p:nvSpPr>
-          <p:cNvPr id="75" name="Rectangle 74"/>
+          <p:cNvPr id="74" name="Rectangle 73"/>
           <p:cNvSpPr/>
           <p:nvPr/>
         </p:nvSpPr>
@@ -14846,7 +14846,7 @@
       </p:sp>
       <p:sp>
         <p:nvSpPr>
-          <p:cNvPr id="76" name="TextBox 75"/>
+          <p:cNvPr id="75" name="TextBox 74"/>
           <p:cNvSpPr txBox="1"/>
           <p:nvPr/>
         </p:nvSpPr>
@@ -14881,7 +14881,7 @@
       </p:sp>
       <p:sp>
         <p:nvSpPr>
-          <p:cNvPr id="77" name="Rectangle 76"/>
+          <p:cNvPr id="76" name="Rectangle 75"/>
           <p:cNvSpPr/>
           <p:nvPr/>
         </p:nvSpPr>
@@ -14924,7 +14924,7 @@
       </p:sp>
       <p:sp>
         <p:nvSpPr>
-          <p:cNvPr id="78" name="TextBox 77"/>
+          <p:cNvPr id="77" name="TextBox 76"/>
           <p:cNvSpPr txBox="1"/>
           <p:nvPr/>
         </p:nvSpPr>
@@ -14959,7 +14959,7 @@
       </p:sp>
       <p:sp>
         <p:nvSpPr>
-          <p:cNvPr id="79" name="Rectangle 78"/>
+          <p:cNvPr id="78" name="Rectangle 77"/>
           <p:cNvSpPr/>
           <p:nvPr/>
         </p:nvSpPr>
@@ -15004,7 +15004,7 @@
       </p:sp>
       <p:sp>
         <p:nvSpPr>
-          <p:cNvPr id="80" name="TextBox 79"/>
+          <p:cNvPr id="79" name="TextBox 78"/>
           <p:cNvSpPr txBox="1"/>
           <p:nvPr/>
         </p:nvSpPr>
@@ -15039,7 +15039,7 @@
       </p:sp>
       <p:sp>
         <p:nvSpPr>
-          <p:cNvPr id="81" name="TextBox 80"/>
+          <p:cNvPr id="80" name="TextBox 79"/>
           <p:cNvSpPr txBox="1"/>
           <p:nvPr/>
         </p:nvSpPr>
@@ -15228,7 +15228,7 @@
         <p:spPr>
           <a:xfrm>
             <a:off x="457200" y="91440"/>
-            <a:ext cx="1828800" cy="274320"/>
+            <a:ext cx="3200400" cy="256032"/>
           </a:xfrm>
           <a:prstGeom prst="rect">
             <a:avLst/>
@@ -15257,6 +15257,41 @@
       <p:sp>
         <p:nvSpPr>
           <p:cNvPr id="6" name="TextBox 5"/>
+          <p:cNvSpPr txBox="1"/>
+          <p:nvPr/>
+        </p:nvSpPr>
+        <p:spPr>
+          <a:xfrm>
+            <a:off x="3657600" y="91440"/>
+            <a:ext cx="8229600" cy="256032"/>
+          </a:xfrm>
+          <a:prstGeom prst="rect">
+            <a:avLst/>
+          </a:prstGeom>
+          <a:noFill/>
+        </p:spPr>
+        <p:txBody>
+          <a:bodyPr wrap="square">
+            <a:spAutoFit/>
+          </a:bodyPr>
+          <a:lstStyle/>
+          <a:p>
+            <a:pPr algn="r"/>
+            <a:r>
+              <a:rPr sz="900" b="1" i="0">
+                <a:solidFill>
+                  <a:srgbClr val="4078D0"/>
+                </a:solidFill>
+                <a:latin typeface="Calibri"/>
+              </a:rPr>
+              <a:t>PHASE 1 — NOW THROUGH DEC 2026</a:t>
+            </a:r>
+          </a:p>
+        </p:txBody>
+      </p:sp>
+      <p:sp>
+        <p:nvSpPr>
+          <p:cNvPr id="7" name="TextBox 6"/>
           <p:cNvSpPr txBox="1"/>
           <p:nvPr/>
         </p:nvSpPr>
@@ -15291,7 +15326,7 @@
       </p:sp>
       <p:sp>
         <p:nvSpPr>
-          <p:cNvPr id="7" name="TextBox 6"/>
+          <p:cNvPr id="8" name="TextBox 7"/>
           <p:cNvSpPr txBox="1"/>
           <p:nvPr/>
         </p:nvSpPr>
@@ -15326,85 +15361,7 @@
       </p:sp>
       <p:sp>
         <p:nvSpPr>
-          <p:cNvPr id="8" name="Rectangle 7"/>
-          <p:cNvSpPr/>
-          <p:nvPr/>
-        </p:nvSpPr>
-        <p:spPr>
-          <a:xfrm>
-            <a:off x="8961120" y="201168"/>
-            <a:ext cx="3017520" cy="292608"/>
-          </a:xfrm>
-          <a:prstGeom prst="rect">
-            <a:avLst/>
-          </a:prstGeom>
-          <a:solidFill>
-            <a:srgbClr val="4078D0"/>
-          </a:solidFill>
-          <a:ln>
-            <a:noFill/>
-          </a:ln>
-        </p:spPr>
-        <p:style>
-          <a:lnRef idx="1">
-            <a:schemeClr val="accent1"/>
-          </a:lnRef>
-          <a:fillRef idx="3">
-            <a:schemeClr val="accent1"/>
-          </a:fillRef>
-          <a:effectRef idx="2">
-            <a:schemeClr val="accent1"/>
-          </a:effectRef>
-          <a:fontRef idx="minor">
-            <a:schemeClr val="lt1"/>
-          </a:fontRef>
-        </p:style>
-        <p:txBody>
-          <a:bodyPr rtlCol="0" anchor="ctr"/>
-          <a:lstStyle/>
-          <a:p>
-            <a:pPr algn="ctr"/>
-          </a:p>
-        </p:txBody>
-      </p:sp>
-      <p:sp>
-        <p:nvSpPr>
-          <p:cNvPr id="9" name="TextBox 8"/>
-          <p:cNvSpPr txBox="1"/>
-          <p:nvPr/>
-        </p:nvSpPr>
-        <p:spPr>
-          <a:xfrm>
-            <a:off x="9006840" y="237744"/>
-            <a:ext cx="2926080" cy="219456"/>
-          </a:xfrm>
-          <a:prstGeom prst="rect">
-            <a:avLst/>
-          </a:prstGeom>
-          <a:noFill/>
-        </p:spPr>
-        <p:txBody>
-          <a:bodyPr wrap="square">
-            <a:spAutoFit/>
-          </a:bodyPr>
-          <a:lstStyle/>
-          <a:p>
-            <a:pPr algn="ctr"/>
-            <a:r>
-              <a:rPr sz="850" b="1" i="0">
-                <a:solidFill>
-                  <a:srgbClr val="FFFFFF"/>
-                </a:solidFill>
-                <a:latin typeface="Calibri"/>
-              </a:rPr>
-              <a:t>PHASE 1  ·  Now – Dec 2026</a:t>
-            </a:r>
-          </a:p>
-        </p:txBody>
-      </p:sp>
-      <p:sp>
-        <p:nvSpPr>
-          <p:cNvPr id="10" name="Rectangle 9"/>
+          <p:cNvPr id="9" name="Rectangle 8"/>
           <p:cNvSpPr/>
           <p:nvPr/>
         </p:nvSpPr>
@@ -15447,7 +15404,7 @@
       </p:sp>
       <p:sp>
         <p:nvSpPr>
-          <p:cNvPr id="11" name="TextBox 10"/>
+          <p:cNvPr id="10" name="TextBox 9"/>
           <p:cNvSpPr txBox="1"/>
           <p:nvPr/>
         </p:nvSpPr>
@@ -15482,7 +15439,7 @@
       </p:sp>
       <p:sp>
         <p:nvSpPr>
-          <p:cNvPr id="12" name="Rectangle 11"/>
+          <p:cNvPr id="11" name="Rectangle 10"/>
           <p:cNvSpPr/>
           <p:nvPr/>
         </p:nvSpPr>
@@ -15525,7 +15482,7 @@
       </p:sp>
       <p:sp>
         <p:nvSpPr>
-          <p:cNvPr id="13" name="TextBox 12"/>
+          <p:cNvPr id="12" name="TextBox 11"/>
           <p:cNvSpPr txBox="1"/>
           <p:nvPr/>
         </p:nvSpPr>
@@ -15560,7 +15517,7 @@
       </p:sp>
       <p:sp>
         <p:nvSpPr>
-          <p:cNvPr id="14" name="TextBox 13"/>
+          <p:cNvPr id="13" name="TextBox 12"/>
           <p:cNvSpPr txBox="1"/>
           <p:nvPr/>
         </p:nvSpPr>
@@ -15595,7 +15552,7 @@
       </p:sp>
       <p:sp>
         <p:nvSpPr>
-          <p:cNvPr id="15" name="TextBox 14"/>
+          <p:cNvPr id="14" name="TextBox 13"/>
           <p:cNvSpPr txBox="1"/>
           <p:nvPr/>
         </p:nvSpPr>
@@ -15630,7 +15587,7 @@
       </p:sp>
       <p:sp>
         <p:nvSpPr>
-          <p:cNvPr id="16" name="Rectangle 15"/>
+          <p:cNvPr id="15" name="Rectangle 14"/>
           <p:cNvSpPr/>
           <p:nvPr/>
         </p:nvSpPr>
@@ -15675,7 +15632,7 @@
       </p:sp>
       <p:sp>
         <p:nvSpPr>
-          <p:cNvPr id="17" name="TextBox 16"/>
+          <p:cNvPr id="16" name="TextBox 15"/>
           <p:cNvSpPr txBox="1"/>
           <p:nvPr/>
         </p:nvSpPr>
@@ -15710,7 +15667,7 @@
       </p:sp>
       <p:sp>
         <p:nvSpPr>
-          <p:cNvPr id="18" name="TextBox 17"/>
+          <p:cNvPr id="17" name="TextBox 16"/>
           <p:cNvSpPr txBox="1"/>
           <p:nvPr/>
         </p:nvSpPr>
@@ -15745,7 +15702,7 @@
       </p:sp>
       <p:sp>
         <p:nvSpPr>
-          <p:cNvPr id="19" name="TextBox 18"/>
+          <p:cNvPr id="18" name="TextBox 17"/>
           <p:cNvSpPr txBox="1"/>
           <p:nvPr/>
         </p:nvSpPr>
@@ -15773,14 +15730,14 @@
                 </a:solidFill>
                 <a:latin typeface="Calibri"/>
               </a:rPr>
-              <a:t>Measure price level across accounts and weeks</a:t>
-            </a:r>
-          </a:p>
-        </p:txBody>
-      </p:sp>
-      <p:sp>
-        <p:nvSpPr>
-          <p:cNvPr id="20" name="Rectangle 19"/>
+              <a:t>Price level measure</a:t>
+            </a:r>
+          </a:p>
+        </p:txBody>
+      </p:sp>
+      <p:sp>
+        <p:nvSpPr>
+          <p:cNvPr id="19" name="Rectangle 18"/>
           <p:cNvSpPr/>
           <p:nvPr/>
         </p:nvSpPr>
@@ -15825,7 +15782,7 @@
       </p:sp>
       <p:sp>
         <p:nvSpPr>
-          <p:cNvPr id="21" name="TextBox 20"/>
+          <p:cNvPr id="20" name="TextBox 19"/>
           <p:cNvSpPr txBox="1"/>
           <p:nvPr/>
         </p:nvSpPr>
@@ -15860,7 +15817,7 @@
       </p:sp>
       <p:sp>
         <p:nvSpPr>
-          <p:cNvPr id="22" name="TextBox 21"/>
+          <p:cNvPr id="21" name="TextBox 20"/>
           <p:cNvSpPr txBox="1"/>
           <p:nvPr/>
         </p:nvSpPr>
@@ -15895,7 +15852,7 @@
       </p:sp>
       <p:sp>
         <p:nvSpPr>
-          <p:cNvPr id="23" name="TextBox 22"/>
+          <p:cNvPr id="22" name="TextBox 21"/>
           <p:cNvSpPr txBox="1"/>
           <p:nvPr/>
         </p:nvSpPr>
@@ -15923,14 +15880,14 @@
                 </a:solidFill>
                 <a:latin typeface="Calibri"/>
               </a:rPr>
-              <a:t>Measure demand response to price changes</a:t>
-            </a:r>
-          </a:p>
-        </p:txBody>
-      </p:sp>
-      <p:sp>
-        <p:nvSpPr>
-          <p:cNvPr id="24" name="Rectangle 23"/>
+              <a:t>Demand response</a:t>
+            </a:r>
+          </a:p>
+        </p:txBody>
+      </p:sp>
+      <p:sp>
+        <p:nvSpPr>
+          <p:cNvPr id="23" name="Rectangle 22"/>
           <p:cNvSpPr/>
           <p:nvPr/>
         </p:nvSpPr>
@@ -15975,7 +15932,7 @@
       </p:sp>
       <p:sp>
         <p:nvSpPr>
-          <p:cNvPr id="25" name="TextBox 24"/>
+          <p:cNvPr id="24" name="TextBox 23"/>
           <p:cNvSpPr txBox="1"/>
           <p:nvPr/>
         </p:nvSpPr>
@@ -16010,7 +15967,7 @@
       </p:sp>
       <p:sp>
         <p:nvSpPr>
-          <p:cNvPr id="26" name="TextBox 25"/>
+          <p:cNvPr id="25" name="TextBox 24"/>
           <p:cNvSpPr txBox="1"/>
           <p:nvPr/>
         </p:nvSpPr>
@@ -16045,7 +16002,7 @@
       </p:sp>
       <p:sp>
         <p:nvSpPr>
-          <p:cNvPr id="27" name="TextBox 26"/>
+          <p:cNvPr id="26" name="TextBox 25"/>
           <p:cNvSpPr txBox="1"/>
           <p:nvPr/>
         </p:nvSpPr>
@@ -16073,14 +16030,14 @@
                 </a:solidFill>
                 <a:latin typeface="Calibri"/>
               </a:rPr>
-              <a:t>Separate everyday price from promo price</a:t>
-            </a:r>
-          </a:p>
-        </p:txBody>
-      </p:sp>
-      <p:sp>
-        <p:nvSpPr>
-          <p:cNvPr id="28" name="Rectangle 27"/>
+              <a:t>Everyday vs. promo</a:t>
+            </a:r>
+          </a:p>
+        </p:txBody>
+      </p:sp>
+      <p:sp>
+        <p:nvSpPr>
+          <p:cNvPr id="27" name="Rectangle 26"/>
           <p:cNvSpPr/>
           <p:nvPr/>
         </p:nvSpPr>
@@ -16125,7 +16082,7 @@
       </p:sp>
       <p:sp>
         <p:nvSpPr>
-          <p:cNvPr id="29" name="TextBox 28"/>
+          <p:cNvPr id="28" name="TextBox 27"/>
           <p:cNvSpPr txBox="1"/>
           <p:nvPr/>
         </p:nvSpPr>
@@ -16160,7 +16117,7 @@
       </p:sp>
       <p:sp>
         <p:nvSpPr>
-          <p:cNvPr id="30" name="TextBox 29"/>
+          <p:cNvPr id="29" name="TextBox 28"/>
           <p:cNvSpPr txBox="1"/>
           <p:nvPr/>
         </p:nvSpPr>
@@ -16195,7 +16152,7 @@
       </p:sp>
       <p:sp>
         <p:nvSpPr>
-          <p:cNvPr id="31" name="TextBox 30"/>
+          <p:cNvPr id="30" name="TextBox 29"/>
           <p:cNvSpPr txBox="1"/>
           <p:nvPr/>
         </p:nvSpPr>
@@ -16223,14 +16180,14 @@
                 </a:solidFill>
                 <a:latin typeface="Calibri"/>
               </a:rPr>
-              <a:t>Quantify magnitude of promotional price drops</a:t>
-            </a:r>
-          </a:p>
-        </p:txBody>
-      </p:sp>
-      <p:sp>
-        <p:nvSpPr>
-          <p:cNvPr id="32" name="Rectangle 31"/>
+              <a:t>Quantify promo depth</a:t>
+            </a:r>
+          </a:p>
+        </p:txBody>
+      </p:sp>
+      <p:sp>
+        <p:nvSpPr>
+          <p:cNvPr id="31" name="Rectangle 30"/>
           <p:cNvSpPr/>
           <p:nvPr/>
         </p:nvSpPr>
@@ -16275,7 +16232,7 @@
       </p:sp>
       <p:sp>
         <p:nvSpPr>
-          <p:cNvPr id="33" name="TextBox 32"/>
+          <p:cNvPr id="32" name="TextBox 31"/>
           <p:cNvSpPr txBox="1"/>
           <p:nvPr/>
         </p:nvSpPr>
@@ -16310,7 +16267,7 @@
       </p:sp>
       <p:sp>
         <p:nvSpPr>
-          <p:cNvPr id="34" name="TextBox 33"/>
+          <p:cNvPr id="33" name="TextBox 32"/>
           <p:cNvSpPr txBox="1"/>
           <p:nvPr/>
         </p:nvSpPr>
@@ -16345,7 +16302,7 @@
       </p:sp>
       <p:sp>
         <p:nvSpPr>
-          <p:cNvPr id="35" name="TextBox 34"/>
+          <p:cNvPr id="34" name="TextBox 33"/>
           <p:cNvSpPr txBox="1"/>
           <p:nvPr/>
         </p:nvSpPr>
@@ -16373,14 +16330,14 @@
                 </a:solidFill>
                 <a:latin typeface="Calibri"/>
               </a:rPr>
-              <a:t>Isolate promoted demand from baseline</a:t>
-            </a:r>
-          </a:p>
-        </p:txBody>
-      </p:sp>
-      <p:sp>
-        <p:nvSpPr>
-          <p:cNvPr id="36" name="Rectangle 35"/>
+              <a:t>Isolate promo demand</a:t>
+            </a:r>
+          </a:p>
+        </p:txBody>
+      </p:sp>
+      <p:sp>
+        <p:nvSpPr>
+          <p:cNvPr id="35" name="Rectangle 34"/>
           <p:cNvSpPr/>
           <p:nvPr/>
         </p:nvSpPr>
@@ -16425,7 +16382,7 @@
       </p:sp>
       <p:sp>
         <p:nvSpPr>
-          <p:cNvPr id="37" name="TextBox 36"/>
+          <p:cNvPr id="36" name="TextBox 35"/>
           <p:cNvSpPr txBox="1"/>
           <p:nvPr/>
         </p:nvSpPr>
@@ -16460,7 +16417,7 @@
       </p:sp>
       <p:sp>
         <p:nvSpPr>
-          <p:cNvPr id="38" name="TextBox 37"/>
+          <p:cNvPr id="37" name="TextBox 36"/>
           <p:cNvSpPr txBox="1"/>
           <p:nvPr/>
         </p:nvSpPr>
@@ -16495,7 +16452,7 @@
       </p:sp>
       <p:sp>
         <p:nvSpPr>
-          <p:cNvPr id="39" name="TextBox 38"/>
+          <p:cNvPr id="38" name="TextBox 37"/>
           <p:cNvSpPr txBox="1"/>
           <p:nvPr/>
         </p:nvSpPr>
@@ -16523,14 +16480,14 @@
                 </a:solidFill>
                 <a:latin typeface="Calibri"/>
               </a:rPr>
-              <a:t>Control for distribution changes vs. price effects</a:t>
-            </a:r>
-          </a:p>
-        </p:txBody>
-      </p:sp>
-      <p:sp>
-        <p:nvSpPr>
-          <p:cNvPr id="40" name="Rectangle 39"/>
+              <a:t>Distribution control</a:t>
+            </a:r>
+          </a:p>
+        </p:txBody>
+      </p:sp>
+      <p:sp>
+        <p:nvSpPr>
+          <p:cNvPr id="39" name="Rectangle 38"/>
           <p:cNvSpPr/>
           <p:nvPr/>
         </p:nvSpPr>
@@ -16575,7 +16532,7 @@
       </p:sp>
       <p:sp>
         <p:nvSpPr>
-          <p:cNvPr id="41" name="TextBox 40"/>
+          <p:cNvPr id="40" name="TextBox 39"/>
           <p:cNvSpPr txBox="1"/>
           <p:nvPr/>
         </p:nvSpPr>
@@ -16610,7 +16567,7 @@
       </p:sp>
       <p:sp>
         <p:nvSpPr>
-          <p:cNvPr id="42" name="TextBox 41"/>
+          <p:cNvPr id="41" name="TextBox 40"/>
           <p:cNvSpPr txBox="1"/>
           <p:nvPr/>
         </p:nvSpPr>
@@ -16645,7 +16602,7 @@
       </p:sp>
       <p:sp>
         <p:nvSpPr>
-          <p:cNvPr id="43" name="TextBox 42"/>
+          <p:cNvPr id="42" name="TextBox 41"/>
           <p:cNvSpPr txBox="1"/>
           <p:nvPr/>
         </p:nvSpPr>
@@ -16673,14 +16630,14 @@
                 </a:solidFill>
                 <a:latin typeface="Calibri"/>
               </a:rPr>
-              <a:t>Separate own-price from competitive pressure</a:t>
-            </a:r>
-          </a:p>
-        </p:txBody>
-      </p:sp>
-      <p:sp>
-        <p:nvSpPr>
-          <p:cNvPr id="44" name="Rectangle 43"/>
+              <a:t>Own vs. competitor</a:t>
+            </a:r>
+          </a:p>
+        </p:txBody>
+      </p:sp>
+      <p:sp>
+        <p:nvSpPr>
+          <p:cNvPr id="43" name="Rectangle 42"/>
           <p:cNvSpPr/>
           <p:nvPr/>
         </p:nvSpPr>
@@ -16723,7 +16680,7 @@
       </p:sp>
       <p:sp>
         <p:nvSpPr>
-          <p:cNvPr id="45" name="TextBox 44"/>
+          <p:cNvPr id="44" name="TextBox 43"/>
           <p:cNvSpPr txBox="1"/>
           <p:nvPr/>
         </p:nvSpPr>
@@ -16758,7 +16715,7 @@
       </p:sp>
       <p:sp>
         <p:nvSpPr>
-          <p:cNvPr id="46" name="Rectangle 45"/>
+          <p:cNvPr id="45" name="Rectangle 44"/>
           <p:cNvSpPr/>
           <p:nvPr/>
         </p:nvSpPr>
@@ -16801,7 +16758,7 @@
       </p:sp>
       <p:sp>
         <p:nvSpPr>
-          <p:cNvPr id="47" name="TextBox 46"/>
+          <p:cNvPr id="46" name="TextBox 45"/>
           <p:cNvSpPr txBox="1"/>
           <p:nvPr/>
         </p:nvSpPr>
@@ -16836,7 +16793,7 @@
       </p:sp>
       <p:sp>
         <p:nvSpPr>
-          <p:cNvPr id="48" name="Rectangle 47"/>
+          <p:cNvPr id="47" name="Rectangle 46"/>
           <p:cNvSpPr/>
           <p:nvPr/>
         </p:nvSpPr>
@@ -16879,7 +16836,7 @@
       </p:sp>
       <p:sp>
         <p:nvSpPr>
-          <p:cNvPr id="49" name="TextBox 48"/>
+          <p:cNvPr id="48" name="TextBox 47"/>
           <p:cNvSpPr txBox="1"/>
           <p:nvPr/>
         </p:nvSpPr>
@@ -16914,7 +16871,7 @@
       </p:sp>
       <p:sp>
         <p:nvSpPr>
-          <p:cNvPr id="50" name="Rectangle 49"/>
+          <p:cNvPr id="49" name="Rectangle 48"/>
           <p:cNvSpPr/>
           <p:nvPr/>
         </p:nvSpPr>
@@ -16957,7 +16914,7 @@
       </p:sp>
       <p:sp>
         <p:nvSpPr>
-          <p:cNvPr id="51" name="TextBox 50"/>
+          <p:cNvPr id="50" name="TextBox 49"/>
           <p:cNvSpPr txBox="1"/>
           <p:nvPr/>
         </p:nvSpPr>
@@ -16992,7 +16949,7 @@
       </p:sp>
       <p:sp>
         <p:nvSpPr>
-          <p:cNvPr id="52" name="Rectangle 51"/>
+          <p:cNvPr id="51" name="Rectangle 50"/>
           <p:cNvSpPr/>
           <p:nvPr/>
         </p:nvSpPr>
@@ -17035,7 +16992,7 @@
       </p:sp>
       <p:sp>
         <p:nvSpPr>
-          <p:cNvPr id="53" name="TextBox 52"/>
+          <p:cNvPr id="52" name="TextBox 51"/>
           <p:cNvSpPr txBox="1"/>
           <p:nvPr/>
         </p:nvSpPr>
@@ -17070,7 +17027,7 @@
       </p:sp>
       <p:sp>
         <p:nvSpPr>
-          <p:cNvPr id="54" name="Rectangle 53"/>
+          <p:cNvPr id="53" name="Rectangle 52"/>
           <p:cNvSpPr/>
           <p:nvPr/>
         </p:nvSpPr>
@@ -17113,7 +17070,7 @@
       </p:sp>
       <p:sp>
         <p:nvSpPr>
-          <p:cNvPr id="55" name="TextBox 54"/>
+          <p:cNvPr id="54" name="TextBox 53"/>
           <p:cNvSpPr txBox="1"/>
           <p:nvPr/>
         </p:nvSpPr>
@@ -17148,7 +17105,7 @@
       </p:sp>
       <p:sp>
         <p:nvSpPr>
-          <p:cNvPr id="56" name="Rectangle 55"/>
+          <p:cNvPr id="55" name="Rectangle 54"/>
           <p:cNvSpPr/>
           <p:nvPr/>
         </p:nvSpPr>
@@ -17191,7 +17148,7 @@
       </p:sp>
       <p:sp>
         <p:nvSpPr>
-          <p:cNvPr id="57" name="TextBox 56"/>
+          <p:cNvPr id="56" name="TextBox 55"/>
           <p:cNvSpPr txBox="1"/>
           <p:nvPr/>
         </p:nvSpPr>
@@ -17226,7 +17183,7 @@
       </p:sp>
       <p:sp>
         <p:nvSpPr>
-          <p:cNvPr id="58" name="Rectangle 57"/>
+          <p:cNvPr id="57" name="Rectangle 56"/>
           <p:cNvSpPr/>
           <p:nvPr/>
         </p:nvSpPr>
@@ -17269,7 +17226,7 @@
       </p:sp>
       <p:sp>
         <p:nvSpPr>
-          <p:cNvPr id="59" name="TextBox 58"/>
+          <p:cNvPr id="58" name="TextBox 57"/>
           <p:cNvSpPr txBox="1"/>
           <p:nvPr/>
         </p:nvSpPr>
@@ -17304,7 +17261,7 @@
       </p:sp>
       <p:sp>
         <p:nvSpPr>
-          <p:cNvPr id="60" name="Rectangle 59"/>
+          <p:cNvPr id="59" name="Rectangle 58"/>
           <p:cNvSpPr/>
           <p:nvPr/>
         </p:nvSpPr>
@@ -17349,7 +17306,7 @@
       </p:sp>
       <p:sp>
         <p:nvSpPr>
-          <p:cNvPr id="61" name="TextBox 60"/>
+          <p:cNvPr id="60" name="TextBox 59"/>
           <p:cNvSpPr txBox="1"/>
           <p:nvPr/>
         </p:nvSpPr>
@@ -17384,7 +17341,7 @@
       </p:sp>
       <p:sp>
         <p:nvSpPr>
-          <p:cNvPr id="62" name="TextBox 61"/>
+          <p:cNvPr id="61" name="TextBox 60"/>
           <p:cNvSpPr txBox="1"/>
           <p:nvPr/>
         </p:nvSpPr>
@@ -17419,7 +17376,7 @@
       </p:sp>
       <p:sp>
         <p:nvSpPr>
-          <p:cNvPr id="63" name="TextBox 62"/>
+          <p:cNvPr id="62" name="TextBox 61"/>
           <p:cNvSpPr txBox="1"/>
           <p:nvPr/>
         </p:nvSpPr>
@@ -17454,7 +17411,7 @@
       </p:sp>
       <p:sp>
         <p:nvSpPr>
-          <p:cNvPr id="64" name="TextBox 63"/>
+          <p:cNvPr id="63" name="TextBox 62"/>
           <p:cNvSpPr txBox="1"/>
           <p:nvPr/>
         </p:nvSpPr>
@@ -17489,7 +17446,7 @@
       </p:sp>
       <p:sp>
         <p:nvSpPr>
-          <p:cNvPr id="65" name="TextBox 64"/>
+          <p:cNvPr id="64" name="TextBox 63"/>
           <p:cNvSpPr txBox="1"/>
           <p:nvPr/>
         </p:nvSpPr>
@@ -17524,7 +17481,7 @@
       </p:sp>
       <p:sp>
         <p:nvSpPr>
-          <p:cNvPr id="66" name="Rectangle 65"/>
+          <p:cNvPr id="65" name="Rectangle 64"/>
           <p:cNvSpPr/>
           <p:nvPr/>
         </p:nvSpPr>
@@ -17567,7 +17524,7 @@
       </p:sp>
       <p:sp>
         <p:nvSpPr>
-          <p:cNvPr id="67" name="TextBox 66"/>
+          <p:cNvPr id="66" name="TextBox 65"/>
           <p:cNvSpPr txBox="1"/>
           <p:nvPr/>
         </p:nvSpPr>
@@ -17602,7 +17559,7 @@
       </p:sp>
       <p:sp>
         <p:nvSpPr>
-          <p:cNvPr id="68" name="Rectangle 67"/>
+          <p:cNvPr id="67" name="Rectangle 66"/>
           <p:cNvSpPr/>
           <p:nvPr/>
         </p:nvSpPr>
@@ -17647,7 +17604,7 @@
       </p:sp>
       <p:sp>
         <p:nvSpPr>
-          <p:cNvPr id="69" name="TextBox 68"/>
+          <p:cNvPr id="68" name="TextBox 67"/>
           <p:cNvSpPr txBox="1"/>
           <p:nvPr/>
         </p:nvSpPr>
@@ -17682,7 +17639,7 @@
       </p:sp>
       <p:sp>
         <p:nvSpPr>
-          <p:cNvPr id="70" name="TextBox 69"/>
+          <p:cNvPr id="69" name="TextBox 68"/>
           <p:cNvSpPr txBox="1"/>
           <p:nvPr/>
         </p:nvSpPr>
@@ -17717,7 +17674,7 @@
       </p:sp>
       <p:sp>
         <p:nvSpPr>
-          <p:cNvPr id="71" name="TextBox 70"/>
+          <p:cNvPr id="70" name="TextBox 69"/>
           <p:cNvSpPr txBox="1"/>
           <p:nvPr/>
         </p:nvSpPr>
@@ -17752,7 +17709,7 @@
       </p:sp>
       <p:sp>
         <p:nvSpPr>
-          <p:cNvPr id="72" name="TextBox 71"/>
+          <p:cNvPr id="71" name="TextBox 70"/>
           <p:cNvSpPr txBox="1"/>
           <p:nvPr/>
         </p:nvSpPr>
@@ -17787,7 +17744,7 @@
       </p:sp>
       <p:sp>
         <p:nvSpPr>
-          <p:cNvPr id="73" name="Rectangle 72"/>
+          <p:cNvPr id="72" name="Rectangle 71"/>
           <p:cNvSpPr/>
           <p:nvPr/>
         </p:nvSpPr>
@@ -17830,7 +17787,7 @@
       </p:sp>
       <p:sp>
         <p:nvSpPr>
-          <p:cNvPr id="74" name="TextBox 73"/>
+          <p:cNvPr id="73" name="TextBox 72"/>
           <p:cNvSpPr txBox="1"/>
           <p:nvPr/>
         </p:nvSpPr>
@@ -17865,7 +17822,7 @@
       </p:sp>
       <p:sp>
         <p:nvSpPr>
-          <p:cNvPr id="75" name="Rectangle 74"/>
+          <p:cNvPr id="74" name="Rectangle 73"/>
           <p:cNvSpPr/>
           <p:nvPr/>
         </p:nvSpPr>
@@ -17910,7 +17867,7 @@
       </p:sp>
       <p:sp>
         <p:nvSpPr>
-          <p:cNvPr id="76" name="TextBox 75"/>
+          <p:cNvPr id="75" name="TextBox 74"/>
           <p:cNvSpPr txBox="1"/>
           <p:nvPr/>
         </p:nvSpPr>
@@ -17945,7 +17902,7 @@
       </p:sp>
       <p:sp>
         <p:nvSpPr>
-          <p:cNvPr id="77" name="Rectangle 76"/>
+          <p:cNvPr id="76" name="Rectangle 75"/>
           <p:cNvSpPr/>
           <p:nvPr/>
         </p:nvSpPr>
@@ -17988,7 +17945,7 @@
       </p:sp>
       <p:sp>
         <p:nvSpPr>
-          <p:cNvPr id="78" name="TextBox 77"/>
+          <p:cNvPr id="77" name="TextBox 76"/>
           <p:cNvSpPr txBox="1"/>
           <p:nvPr/>
         </p:nvSpPr>
@@ -18023,7 +17980,7 @@
       </p:sp>
       <p:sp>
         <p:nvSpPr>
-          <p:cNvPr id="79" name="Rectangle 78"/>
+          <p:cNvPr id="78" name="Rectangle 77"/>
           <p:cNvSpPr/>
           <p:nvPr/>
         </p:nvSpPr>
@@ -18068,7 +18025,7 @@
       </p:sp>
       <p:sp>
         <p:nvSpPr>
-          <p:cNvPr id="80" name="TextBox 79"/>
+          <p:cNvPr id="79" name="TextBox 78"/>
           <p:cNvSpPr txBox="1"/>
           <p:nvPr/>
         </p:nvSpPr>
@@ -18103,7 +18060,7 @@
       </p:sp>
       <p:sp>
         <p:nvSpPr>
-          <p:cNvPr id="81" name="TextBox 80"/>
+          <p:cNvPr id="80" name="TextBox 79"/>
           <p:cNvSpPr txBox="1"/>
           <p:nvPr/>
         </p:nvSpPr>
@@ -18335,7 +18292,7 @@
         <p:spPr>
           <a:xfrm>
             <a:off x="457200" y="91440"/>
-            <a:ext cx="1828800" cy="274320"/>
+            <a:ext cx="3200400" cy="256032"/>
           </a:xfrm>
           <a:prstGeom prst="rect">
             <a:avLst/>
@@ -18364,6 +18321,41 @@
       <p:sp>
         <p:nvSpPr>
           <p:cNvPr id="7" name="TextBox 6"/>
+          <p:cNvSpPr txBox="1"/>
+          <p:nvPr/>
+        </p:nvSpPr>
+        <p:spPr>
+          <a:xfrm>
+            <a:off x="3657600" y="91440"/>
+            <a:ext cx="8229600" cy="256032"/>
+          </a:xfrm>
+          <a:prstGeom prst="rect">
+            <a:avLst/>
+          </a:prstGeom>
+          <a:noFill/>
+        </p:spPr>
+        <p:txBody>
+          <a:bodyPr wrap="square">
+            <a:spAutoFit/>
+          </a:bodyPr>
+          <a:lstStyle/>
+          <a:p>
+            <a:pPr algn="r"/>
+            <a:r>
+              <a:rPr sz="900" b="1" i="0">
+                <a:solidFill>
+                  <a:srgbClr val="D4DAE6"/>
+                </a:solidFill>
+                <a:latin typeface="Calibri"/>
+              </a:rPr>
+              <a:t>PHASE 2 — PLANNED 2027</a:t>
+            </a:r>
+          </a:p>
+        </p:txBody>
+      </p:sp>
+      <p:sp>
+        <p:nvSpPr>
+          <p:cNvPr id="8" name="TextBox 7"/>
           <p:cNvSpPr txBox="1"/>
           <p:nvPr/>
         </p:nvSpPr>
@@ -18398,7 +18390,7 @@
       </p:sp>
       <p:sp>
         <p:nvSpPr>
-          <p:cNvPr id="8" name="TextBox 7"/>
+          <p:cNvPr id="9" name="TextBox 8"/>
           <p:cNvSpPr txBox="1"/>
           <p:nvPr/>
         </p:nvSpPr>
@@ -18433,85 +18425,7 @@
       </p:sp>
       <p:sp>
         <p:nvSpPr>
-          <p:cNvPr id="9" name="Rectangle 8"/>
-          <p:cNvSpPr/>
-          <p:nvPr/>
-        </p:nvSpPr>
-        <p:spPr>
-          <a:xfrm>
-            <a:off x="8961120" y="201168"/>
-            <a:ext cx="3017520" cy="292608"/>
-          </a:xfrm>
-          <a:prstGeom prst="rect">
-            <a:avLst/>
-          </a:prstGeom>
-          <a:solidFill>
-            <a:srgbClr val="4A566A"/>
-          </a:solidFill>
-          <a:ln>
-            <a:noFill/>
-          </a:ln>
-        </p:spPr>
-        <p:style>
-          <a:lnRef idx="1">
-            <a:schemeClr val="accent1"/>
-          </a:lnRef>
-          <a:fillRef idx="3">
-            <a:schemeClr val="accent1"/>
-          </a:fillRef>
-          <a:effectRef idx="2">
-            <a:schemeClr val="accent1"/>
-          </a:effectRef>
-          <a:fontRef idx="minor">
-            <a:schemeClr val="lt1"/>
-          </a:fontRef>
-        </p:style>
-        <p:txBody>
-          <a:bodyPr rtlCol="0" anchor="ctr"/>
-          <a:lstStyle/>
-          <a:p>
-            <a:pPr algn="ctr"/>
-          </a:p>
-        </p:txBody>
-      </p:sp>
-      <p:sp>
-        <p:nvSpPr>
-          <p:cNvPr id="10" name="TextBox 9"/>
-          <p:cNvSpPr txBox="1"/>
-          <p:nvPr/>
-        </p:nvSpPr>
-        <p:spPr>
-          <a:xfrm>
-            <a:off x="9006840" y="237744"/>
-            <a:ext cx="2926080" cy="219456"/>
-          </a:xfrm>
-          <a:prstGeom prst="rect">
-            <a:avLst/>
-          </a:prstGeom>
-          <a:noFill/>
-        </p:spPr>
-        <p:txBody>
-          <a:bodyPr wrap="square">
-            <a:spAutoFit/>
-          </a:bodyPr>
-          <a:lstStyle/>
-          <a:p>
-            <a:pPr algn="ctr"/>
-            <a:r>
-              <a:rPr sz="850" b="1" i="0">
-                <a:solidFill>
-                  <a:srgbClr val="FFFFFF"/>
-                </a:solidFill>
-                <a:latin typeface="Calibri"/>
-              </a:rPr>
-              <a:t>PHASE 2  ·  Planned 2027</a:t>
-            </a:r>
-          </a:p>
-        </p:txBody>
-      </p:sp>
-      <p:sp>
-        <p:nvSpPr>
-          <p:cNvPr id="11" name="Rectangle 10"/>
+          <p:cNvPr id="10" name="Rectangle 9"/>
           <p:cNvSpPr/>
           <p:nvPr/>
         </p:nvSpPr>
@@ -18554,7 +18468,7 @@
       </p:sp>
       <p:sp>
         <p:nvSpPr>
-          <p:cNvPr id="12" name="TextBox 11"/>
+          <p:cNvPr id="11" name="TextBox 10"/>
           <p:cNvSpPr txBox="1"/>
           <p:nvPr/>
         </p:nvSpPr>
@@ -18589,7 +18503,7 @@
       </p:sp>
       <p:sp>
         <p:nvSpPr>
-          <p:cNvPr id="13" name="Rectangle 12"/>
+          <p:cNvPr id="12" name="Rectangle 11"/>
           <p:cNvSpPr/>
           <p:nvPr/>
         </p:nvSpPr>
@@ -18632,7 +18546,7 @@
       </p:sp>
       <p:sp>
         <p:nvSpPr>
-          <p:cNvPr id="14" name="TextBox 13"/>
+          <p:cNvPr id="13" name="TextBox 12"/>
           <p:cNvSpPr txBox="1"/>
           <p:nvPr/>
         </p:nvSpPr>
@@ -18667,7 +18581,7 @@
       </p:sp>
       <p:sp>
         <p:nvSpPr>
-          <p:cNvPr id="15" name="TextBox 14"/>
+          <p:cNvPr id="14" name="TextBox 13"/>
           <p:cNvSpPr txBox="1"/>
           <p:nvPr/>
         </p:nvSpPr>
@@ -18702,7 +18616,7 @@
       </p:sp>
       <p:sp>
         <p:nvSpPr>
-          <p:cNvPr id="16" name="TextBox 15"/>
+          <p:cNvPr id="15" name="TextBox 14"/>
           <p:cNvSpPr txBox="1"/>
           <p:nvPr/>
         </p:nvSpPr>
@@ -18737,7 +18651,7 @@
       </p:sp>
       <p:sp>
         <p:nvSpPr>
-          <p:cNvPr id="17" name="Rectangle 16"/>
+          <p:cNvPr id="16" name="Rectangle 15"/>
           <p:cNvSpPr/>
           <p:nvPr/>
         </p:nvSpPr>
@@ -18782,7 +18696,7 @@
       </p:sp>
       <p:sp>
         <p:nvSpPr>
-          <p:cNvPr id="18" name="TextBox 17"/>
+          <p:cNvPr id="17" name="TextBox 16"/>
           <p:cNvSpPr txBox="1"/>
           <p:nvPr/>
         </p:nvSpPr>
@@ -18817,7 +18731,7 @@
       </p:sp>
       <p:sp>
         <p:nvSpPr>
-          <p:cNvPr id="19" name="TextBox 18"/>
+          <p:cNvPr id="18" name="TextBox 17"/>
           <p:cNvSpPr txBox="1"/>
           <p:nvPr/>
         </p:nvSpPr>
@@ -18852,7 +18766,7 @@
       </p:sp>
       <p:sp>
         <p:nvSpPr>
-          <p:cNvPr id="20" name="TextBox 19"/>
+          <p:cNvPr id="19" name="TextBox 18"/>
           <p:cNvSpPr txBox="1"/>
           <p:nvPr/>
         </p:nvSpPr>
@@ -18880,14 +18794,14 @@
                 </a:solidFill>
                 <a:latin typeface="Calibri"/>
               </a:rPr>
-              <a:t>SPINS-attributed demand above non-promo baseline</a:t>
-            </a:r>
-          </a:p>
-        </p:txBody>
-      </p:sp>
-      <p:sp>
-        <p:nvSpPr>
-          <p:cNvPr id="21" name="Rectangle 20"/>
+              <a:t>Above-baseline demand</a:t>
+            </a:r>
+          </a:p>
+        </p:txBody>
+      </p:sp>
+      <p:sp>
+        <p:nvSpPr>
+          <p:cNvPr id="20" name="Rectangle 19"/>
           <p:cNvSpPr/>
           <p:nvPr/>
         </p:nvSpPr>
@@ -18932,7 +18846,7 @@
       </p:sp>
       <p:sp>
         <p:nvSpPr>
-          <p:cNvPr id="22" name="TextBox 21"/>
+          <p:cNvPr id="21" name="TextBox 20"/>
           <p:cNvSpPr txBox="1"/>
           <p:nvPr/>
         </p:nvSpPr>
@@ -18967,7 +18881,7 @@
       </p:sp>
       <p:sp>
         <p:nvSpPr>
-          <p:cNvPr id="23" name="TextBox 22"/>
+          <p:cNvPr id="22" name="TextBox 21"/>
           <p:cNvSpPr txBox="1"/>
           <p:nvPr/>
         </p:nvSpPr>
@@ -19002,7 +18916,7 @@
       </p:sp>
       <p:sp>
         <p:nvSpPr>
-          <p:cNvPr id="24" name="TextBox 23"/>
+          <p:cNvPr id="23" name="TextBox 22"/>
           <p:cNvSpPr txBox="1"/>
           <p:nvPr/>
         </p:nvSpPr>
@@ -19030,14 +18944,14 @@
                 </a:solidFill>
                 <a:latin typeface="Calibri"/>
               </a:rPr>
-              <a:t>Denominator for promo lift ratio</a:t>
-            </a:r>
-          </a:p>
-        </p:txBody>
-      </p:sp>
-      <p:sp>
-        <p:nvSpPr>
-          <p:cNvPr id="25" name="Rectangle 24"/>
+              <a:t>Lift denominator</a:t>
+            </a:r>
+          </a:p>
+        </p:txBody>
+      </p:sp>
+      <p:sp>
+        <p:nvSpPr>
+          <p:cNvPr id="24" name="Rectangle 23"/>
           <p:cNvSpPr/>
           <p:nvPr/>
         </p:nvSpPr>
@@ -19082,7 +18996,7 @@
       </p:sp>
       <p:sp>
         <p:nvSpPr>
-          <p:cNvPr id="26" name="TextBox 25"/>
+          <p:cNvPr id="25" name="TextBox 24"/>
           <p:cNvSpPr txBox="1"/>
           <p:nvPr/>
         </p:nvSpPr>
@@ -19117,7 +19031,7 @@
       </p:sp>
       <p:sp>
         <p:nvSpPr>
-          <p:cNvPr id="27" name="TextBox 26"/>
+          <p:cNvPr id="26" name="TextBox 25"/>
           <p:cNvSpPr txBox="1"/>
           <p:nvPr/>
         </p:nvSpPr>
@@ -19152,7 +19066,7 @@
       </p:sp>
       <p:sp>
         <p:nvSpPr>
-          <p:cNvPr id="28" name="TextBox 27"/>
+          <p:cNvPr id="27" name="TextBox 26"/>
           <p:cNvSpPr txBox="1"/>
           <p:nvPr/>
         </p:nvSpPr>
@@ -19180,14 +19094,14 @@
                 </a:solidFill>
                 <a:latin typeface="Calibri"/>
               </a:rPr>
-              <a:t>Measure how promo-dependent a SKU is</a:t>
-            </a:r>
-          </a:p>
-        </p:txBody>
-      </p:sp>
-      <p:sp>
-        <p:nvSpPr>
-          <p:cNvPr id="29" name="Rectangle 28"/>
+              <a:t>Promo dependency</a:t>
+            </a:r>
+          </a:p>
+        </p:txBody>
+      </p:sp>
+      <p:sp>
+        <p:nvSpPr>
+          <p:cNvPr id="28" name="Rectangle 27"/>
           <p:cNvSpPr/>
           <p:nvPr/>
         </p:nvSpPr>
@@ -19232,7 +19146,7 @@
       </p:sp>
       <p:sp>
         <p:nvSpPr>
-          <p:cNvPr id="30" name="TextBox 29"/>
+          <p:cNvPr id="29" name="TextBox 28"/>
           <p:cNvSpPr txBox="1"/>
           <p:nvPr/>
         </p:nvSpPr>
@@ -19267,7 +19181,7 @@
       </p:sp>
       <p:sp>
         <p:nvSpPr>
-          <p:cNvPr id="31" name="TextBox 30"/>
+          <p:cNvPr id="30" name="TextBox 29"/>
           <p:cNvSpPr txBox="1"/>
           <p:nvPr/>
         </p:nvSpPr>
@@ -19302,7 +19216,7 @@
       </p:sp>
       <p:sp>
         <p:nvSpPr>
-          <p:cNvPr id="32" name="TextBox 31"/>
+          <p:cNvPr id="31" name="TextBox 30"/>
           <p:cNvSpPr txBox="1"/>
           <p:nvPr/>
         </p:nvSpPr>
@@ -19330,14 +19244,14 @@
                 </a:solidFill>
                 <a:latin typeface="Calibri"/>
               </a:rPr>
-              <a:t>Quantify the price concession driving lift</a:t>
-            </a:r>
-          </a:p>
-        </p:txBody>
-      </p:sp>
-      <p:sp>
-        <p:nvSpPr>
-          <p:cNvPr id="33" name="Rectangle 32"/>
+              <a:t>Quantify discount</a:t>
+            </a:r>
+          </a:p>
+        </p:txBody>
+      </p:sp>
+      <p:sp>
+        <p:nvSpPr>
+          <p:cNvPr id="32" name="Rectangle 31"/>
           <p:cNvSpPr/>
           <p:nvPr/>
         </p:nvSpPr>
@@ -19382,7 +19296,7 @@
       </p:sp>
       <p:sp>
         <p:nvSpPr>
-          <p:cNvPr id="34" name="TextBox 33"/>
+          <p:cNvPr id="33" name="TextBox 32"/>
           <p:cNvSpPr txBox="1"/>
           <p:nvPr/>
         </p:nvSpPr>
@@ -19417,7 +19331,7 @@
       </p:sp>
       <p:sp>
         <p:nvSpPr>
-          <p:cNvPr id="35" name="TextBox 34"/>
+          <p:cNvPr id="34" name="TextBox 33"/>
           <p:cNvSpPr txBox="1"/>
           <p:nvPr/>
         </p:nvSpPr>
@@ -19452,7 +19366,7 @@
       </p:sp>
       <p:sp>
         <p:nvSpPr>
-          <p:cNvPr id="36" name="TextBox 35"/>
+          <p:cNvPr id="35" name="TextBox 34"/>
           <p:cNvSpPr txBox="1"/>
           <p:nvPr/>
         </p:nvSpPr>
@@ -19480,14 +19394,14 @@
                 </a:solidFill>
                 <a:latin typeface="Calibri"/>
               </a:rPr>
-              <a:t>Response curves differ by channel</a:t>
-            </a:r>
-          </a:p>
-        </p:txBody>
-      </p:sp>
-      <p:sp>
-        <p:nvSpPr>
-          <p:cNvPr id="37" name="Rectangle 36"/>
+              <a:t>Channel response</a:t>
+            </a:r>
+          </a:p>
+        </p:txBody>
+      </p:sp>
+      <p:sp>
+        <p:nvSpPr>
+          <p:cNvPr id="36" name="Rectangle 35"/>
           <p:cNvSpPr/>
           <p:nvPr/>
         </p:nvSpPr>
@@ -19532,7 +19446,7 @@
       </p:sp>
       <p:sp>
         <p:nvSpPr>
-          <p:cNvPr id="38" name="TextBox 37"/>
+          <p:cNvPr id="37" name="TextBox 36"/>
           <p:cNvSpPr txBox="1"/>
           <p:nvPr/>
         </p:nvSpPr>
@@ -19567,7 +19481,7 @@
       </p:sp>
       <p:sp>
         <p:nvSpPr>
-          <p:cNvPr id="39" name="TextBox 38"/>
+          <p:cNvPr id="38" name="TextBox 37"/>
           <p:cNvSpPr txBox="1"/>
           <p:nvPr/>
         </p:nvSpPr>
@@ -19602,7 +19516,7 @@
       </p:sp>
       <p:sp>
         <p:nvSpPr>
-          <p:cNvPr id="40" name="TextBox 39"/>
+          <p:cNvPr id="39" name="TextBox 38"/>
           <p:cNvSpPr txBox="1"/>
           <p:nvPr/>
         </p:nvSpPr>
@@ -19630,14 +19544,14 @@
                 </a:solidFill>
                 <a:latin typeface="Calibri"/>
               </a:rPr>
-              <a:t>12-pack cliff behavior differs from single bar</a:t>
-            </a:r>
-          </a:p>
-        </p:txBody>
-      </p:sp>
-      <p:sp>
-        <p:nvSpPr>
-          <p:cNvPr id="41" name="Rectangle 40"/>
+              <a:t>Pack size behavior</a:t>
+            </a:r>
+          </a:p>
+        </p:txBody>
+      </p:sp>
+      <p:sp>
+        <p:nvSpPr>
+          <p:cNvPr id="40" name="Rectangle 39"/>
           <p:cNvSpPr/>
           <p:nvPr/>
         </p:nvSpPr>
@@ -19682,7 +19596,7 @@
       </p:sp>
       <p:sp>
         <p:nvSpPr>
-          <p:cNvPr id="42" name="TextBox 41"/>
+          <p:cNvPr id="41" name="TextBox 40"/>
           <p:cNvSpPr txBox="1"/>
           <p:nvPr/>
         </p:nvSpPr>
@@ -19717,7 +19631,7 @@
       </p:sp>
       <p:sp>
         <p:nvSpPr>
-          <p:cNvPr id="43" name="TextBox 42"/>
+          <p:cNvPr id="42" name="TextBox 41"/>
           <p:cNvSpPr txBox="1"/>
           <p:nvPr/>
         </p:nvSpPr>
@@ -19752,7 +19666,7 @@
       </p:sp>
       <p:sp>
         <p:nvSpPr>
-          <p:cNvPr id="44" name="TextBox 43"/>
+          <p:cNvPr id="43" name="TextBox 42"/>
           <p:cNvSpPr txBox="1"/>
           <p:nvPr/>
         </p:nvSpPr>
@@ -19780,14 +19694,14 @@
                 </a:solidFill>
                 <a:latin typeface="Calibri"/>
               </a:rPr>
-              <a:t>Separate display from price promo</a:t>
-            </a:r>
-          </a:p>
-        </p:txBody>
-      </p:sp>
-      <p:sp>
-        <p:nvSpPr>
-          <p:cNvPr id="45" name="Rectangle 44"/>
+              <a:t>Display vs. price</a:t>
+            </a:r>
+          </a:p>
+        </p:txBody>
+      </p:sp>
+      <p:sp>
+        <p:nvSpPr>
+          <p:cNvPr id="44" name="Rectangle 43"/>
           <p:cNvSpPr/>
           <p:nvPr/>
         </p:nvSpPr>
@@ -19830,7 +19744,7 @@
       </p:sp>
       <p:sp>
         <p:nvSpPr>
-          <p:cNvPr id="46" name="TextBox 45"/>
+          <p:cNvPr id="45" name="TextBox 44"/>
           <p:cNvSpPr txBox="1"/>
           <p:nvPr/>
         </p:nvSpPr>
@@ -19865,7 +19779,7 @@
       </p:sp>
       <p:sp>
         <p:nvSpPr>
-          <p:cNvPr id="47" name="Rectangle 46"/>
+          <p:cNvPr id="46" name="Rectangle 45"/>
           <p:cNvSpPr/>
           <p:nvPr/>
         </p:nvSpPr>
@@ -19908,7 +19822,7 @@
       </p:sp>
       <p:sp>
         <p:nvSpPr>
-          <p:cNvPr id="48" name="TextBox 47"/>
+          <p:cNvPr id="47" name="TextBox 46"/>
           <p:cNvSpPr txBox="1"/>
           <p:nvPr/>
         </p:nvSpPr>
@@ -19943,7 +19857,7 @@
       </p:sp>
       <p:sp>
         <p:nvSpPr>
-          <p:cNvPr id="49" name="Rectangle 48"/>
+          <p:cNvPr id="48" name="Rectangle 47"/>
           <p:cNvSpPr/>
           <p:nvPr/>
         </p:nvSpPr>
@@ -19986,7 +19900,7 @@
       </p:sp>
       <p:sp>
         <p:nvSpPr>
-          <p:cNvPr id="50" name="TextBox 49"/>
+          <p:cNvPr id="49" name="TextBox 48"/>
           <p:cNvSpPr txBox="1"/>
           <p:nvPr/>
         </p:nvSpPr>
@@ -20021,7 +19935,7 @@
       </p:sp>
       <p:sp>
         <p:nvSpPr>
-          <p:cNvPr id="51" name="Rectangle 50"/>
+          <p:cNvPr id="50" name="Rectangle 49"/>
           <p:cNvSpPr/>
           <p:nvPr/>
         </p:nvSpPr>
@@ -20064,7 +19978,7 @@
       </p:sp>
       <p:sp>
         <p:nvSpPr>
-          <p:cNvPr id="52" name="TextBox 51"/>
+          <p:cNvPr id="51" name="TextBox 50"/>
           <p:cNvSpPr txBox="1"/>
           <p:nvPr/>
         </p:nvSpPr>
@@ -20099,7 +20013,7 @@
       </p:sp>
       <p:sp>
         <p:nvSpPr>
-          <p:cNvPr id="53" name="Rectangle 52"/>
+          <p:cNvPr id="52" name="Rectangle 51"/>
           <p:cNvSpPr/>
           <p:nvPr/>
         </p:nvSpPr>
@@ -20142,7 +20056,7 @@
       </p:sp>
       <p:sp>
         <p:nvSpPr>
-          <p:cNvPr id="54" name="TextBox 53"/>
+          <p:cNvPr id="53" name="TextBox 52"/>
           <p:cNvSpPr txBox="1"/>
           <p:nvPr/>
         </p:nvSpPr>
@@ -20177,7 +20091,7 @@
       </p:sp>
       <p:sp>
         <p:nvSpPr>
-          <p:cNvPr id="55" name="Rectangle 54"/>
+          <p:cNvPr id="54" name="Rectangle 53"/>
           <p:cNvSpPr/>
           <p:nvPr/>
         </p:nvSpPr>
@@ -20220,7 +20134,7 @@
       </p:sp>
       <p:sp>
         <p:nvSpPr>
-          <p:cNvPr id="56" name="TextBox 55"/>
+          <p:cNvPr id="55" name="TextBox 54"/>
           <p:cNvSpPr txBox="1"/>
           <p:nvPr/>
         </p:nvSpPr>
@@ -20255,7 +20169,7 @@
       </p:sp>
       <p:sp>
         <p:nvSpPr>
-          <p:cNvPr id="57" name="Rectangle 56"/>
+          <p:cNvPr id="56" name="Rectangle 55"/>
           <p:cNvSpPr/>
           <p:nvPr/>
         </p:nvSpPr>
@@ -20298,7 +20212,7 @@
       </p:sp>
       <p:sp>
         <p:nvSpPr>
-          <p:cNvPr id="58" name="TextBox 57"/>
+          <p:cNvPr id="57" name="TextBox 56"/>
           <p:cNvSpPr txBox="1"/>
           <p:nvPr/>
         </p:nvSpPr>
@@ -20333,7 +20247,7 @@
       </p:sp>
       <p:sp>
         <p:nvSpPr>
-          <p:cNvPr id="59" name="Rectangle 58"/>
+          <p:cNvPr id="58" name="Rectangle 57"/>
           <p:cNvSpPr/>
           <p:nvPr/>
         </p:nvSpPr>
@@ -20378,7 +20292,7 @@
       </p:sp>
       <p:sp>
         <p:nvSpPr>
-          <p:cNvPr id="60" name="TextBox 59"/>
+          <p:cNvPr id="59" name="TextBox 58"/>
           <p:cNvSpPr txBox="1"/>
           <p:nvPr/>
         </p:nvSpPr>
@@ -20413,7 +20327,7 @@
       </p:sp>
       <p:sp>
         <p:nvSpPr>
-          <p:cNvPr id="61" name="TextBox 60"/>
+          <p:cNvPr id="60" name="TextBox 59"/>
           <p:cNvSpPr txBox="1"/>
           <p:nvPr/>
         </p:nvSpPr>
@@ -20448,7 +20362,7 @@
       </p:sp>
       <p:sp>
         <p:nvSpPr>
-          <p:cNvPr id="62" name="TextBox 61"/>
+          <p:cNvPr id="61" name="TextBox 60"/>
           <p:cNvSpPr txBox="1"/>
           <p:nvPr/>
         </p:nvSpPr>
@@ -20483,7 +20397,7 @@
       </p:sp>
       <p:sp>
         <p:nvSpPr>
-          <p:cNvPr id="63" name="Rectangle 62"/>
+          <p:cNvPr id="62" name="Rectangle 61"/>
           <p:cNvSpPr/>
           <p:nvPr/>
         </p:nvSpPr>
@@ -20526,7 +20440,7 @@
       </p:sp>
       <p:sp>
         <p:nvSpPr>
-          <p:cNvPr id="64" name="TextBox 63"/>
+          <p:cNvPr id="63" name="TextBox 62"/>
           <p:cNvSpPr txBox="1"/>
           <p:nvPr/>
         </p:nvSpPr>
@@ -20561,7 +20475,7 @@
       </p:sp>
       <p:sp>
         <p:nvSpPr>
-          <p:cNvPr id="65" name="Rectangle 64"/>
+          <p:cNvPr id="64" name="Rectangle 63"/>
           <p:cNvSpPr/>
           <p:nvPr/>
         </p:nvSpPr>
@@ -20606,7 +20520,7 @@
       </p:sp>
       <p:sp>
         <p:nvSpPr>
-          <p:cNvPr id="66" name="TextBox 65"/>
+          <p:cNvPr id="65" name="TextBox 64"/>
           <p:cNvSpPr txBox="1"/>
           <p:nvPr/>
         </p:nvSpPr>
@@ -20641,7 +20555,7 @@
       </p:sp>
       <p:sp>
         <p:nvSpPr>
-          <p:cNvPr id="67" name="TextBox 66"/>
+          <p:cNvPr id="66" name="TextBox 65"/>
           <p:cNvSpPr txBox="1"/>
           <p:nvPr/>
         </p:nvSpPr>
@@ -20676,7 +20590,7 @@
       </p:sp>
       <p:sp>
         <p:nvSpPr>
-          <p:cNvPr id="68" name="TextBox 67"/>
+          <p:cNvPr id="67" name="TextBox 66"/>
           <p:cNvSpPr txBox="1"/>
           <p:nvPr/>
         </p:nvSpPr>
@@ -20711,7 +20625,7 @@
       </p:sp>
       <p:sp>
         <p:nvSpPr>
-          <p:cNvPr id="69" name="TextBox 68"/>
+          <p:cNvPr id="68" name="TextBox 67"/>
           <p:cNvSpPr txBox="1"/>
           <p:nvPr/>
         </p:nvSpPr>
@@ -20746,7 +20660,7 @@
       </p:sp>
       <p:sp>
         <p:nvSpPr>
-          <p:cNvPr id="70" name="Rectangle 69"/>
+          <p:cNvPr id="69" name="Rectangle 68"/>
           <p:cNvSpPr/>
           <p:nvPr/>
         </p:nvSpPr>
@@ -20789,7 +20703,7 @@
       </p:sp>
       <p:sp>
         <p:nvSpPr>
-          <p:cNvPr id="71" name="TextBox 70"/>
+          <p:cNvPr id="70" name="TextBox 69"/>
           <p:cNvSpPr txBox="1"/>
           <p:nvPr/>
         </p:nvSpPr>
@@ -20824,7 +20738,7 @@
       </p:sp>
       <p:sp>
         <p:nvSpPr>
-          <p:cNvPr id="72" name="Rectangle 71"/>
+          <p:cNvPr id="71" name="Rectangle 70"/>
           <p:cNvSpPr/>
           <p:nvPr/>
         </p:nvSpPr>
@@ -20869,7 +20783,7 @@
       </p:sp>
       <p:sp>
         <p:nvSpPr>
-          <p:cNvPr id="73" name="TextBox 72"/>
+          <p:cNvPr id="72" name="TextBox 71"/>
           <p:cNvSpPr txBox="1"/>
           <p:nvPr/>
         </p:nvSpPr>
@@ -20904,7 +20818,7 @@
       </p:sp>
       <p:sp>
         <p:nvSpPr>
-          <p:cNvPr id="74" name="Rectangle 73"/>
+          <p:cNvPr id="73" name="Rectangle 72"/>
           <p:cNvSpPr/>
           <p:nvPr/>
         </p:nvSpPr>
@@ -20947,7 +20861,7 @@
       </p:sp>
       <p:sp>
         <p:nvSpPr>
-          <p:cNvPr id="75" name="TextBox 74"/>
+          <p:cNvPr id="74" name="TextBox 73"/>
           <p:cNvSpPr txBox="1"/>
           <p:nvPr/>
         </p:nvSpPr>
@@ -20982,7 +20896,7 @@
       </p:sp>
       <p:sp>
         <p:nvSpPr>
-          <p:cNvPr id="76" name="Rectangle 75"/>
+          <p:cNvPr id="75" name="Rectangle 74"/>
           <p:cNvSpPr/>
           <p:nvPr/>
         </p:nvSpPr>
@@ -21027,7 +20941,7 @@
       </p:sp>
       <p:sp>
         <p:nvSpPr>
-          <p:cNvPr id="77" name="TextBox 76"/>
+          <p:cNvPr id="76" name="TextBox 75"/>
           <p:cNvSpPr txBox="1"/>
           <p:nvPr/>
         </p:nvSpPr>
@@ -21062,7 +20976,7 @@
       </p:sp>
       <p:sp>
         <p:nvSpPr>
-          <p:cNvPr id="78" name="TextBox 77"/>
+          <p:cNvPr id="77" name="TextBox 76"/>
           <p:cNvSpPr txBox="1"/>
           <p:nvPr/>
         </p:nvSpPr>
@@ -21294,7 +21208,7 @@
         <p:spPr>
           <a:xfrm>
             <a:off x="457200" y="91440"/>
-            <a:ext cx="1828800" cy="274320"/>
+            <a:ext cx="3200400" cy="256032"/>
           </a:xfrm>
           <a:prstGeom prst="rect">
             <a:avLst/>
@@ -21323,6 +21237,41 @@
       <p:sp>
         <p:nvSpPr>
           <p:cNvPr id="7" name="TextBox 6"/>
+          <p:cNvSpPr txBox="1"/>
+          <p:nvPr/>
+        </p:nvSpPr>
+        <p:spPr>
+          <a:xfrm>
+            <a:off x="3657600" y="91440"/>
+            <a:ext cx="8229600" cy="256032"/>
+          </a:xfrm>
+          <a:prstGeom prst="rect">
+            <a:avLst/>
+          </a:prstGeom>
+          <a:noFill/>
+        </p:spPr>
+        <p:txBody>
+          <a:bodyPr wrap="square">
+            <a:spAutoFit/>
+          </a:bodyPr>
+          <a:lstStyle/>
+          <a:p>
+            <a:pPr algn="r"/>
+            <a:r>
+              <a:rPr sz="900" b="1" i="0">
+                <a:solidFill>
+                  <a:srgbClr val="D4DAE6"/>
+                </a:solidFill>
+                <a:latin typeface="Calibri"/>
+              </a:rPr>
+              <a:t>PHASE 2 — PLANNED 2027</a:t>
+            </a:r>
+          </a:p>
+        </p:txBody>
+      </p:sp>
+      <p:sp>
+        <p:nvSpPr>
+          <p:cNvPr id="8" name="TextBox 7"/>
           <p:cNvSpPr txBox="1"/>
           <p:nvPr/>
         </p:nvSpPr>
@@ -21357,7 +21306,7 @@
       </p:sp>
       <p:sp>
         <p:nvSpPr>
-          <p:cNvPr id="8" name="TextBox 7"/>
+          <p:cNvPr id="9" name="TextBox 8"/>
           <p:cNvSpPr txBox="1"/>
           <p:nvPr/>
         </p:nvSpPr>
@@ -21392,85 +21341,7 @@
       </p:sp>
       <p:sp>
         <p:nvSpPr>
-          <p:cNvPr id="9" name="Rectangle 8"/>
-          <p:cNvSpPr/>
-          <p:nvPr/>
-        </p:nvSpPr>
-        <p:spPr>
-          <a:xfrm>
-            <a:off x="8961120" y="201168"/>
-            <a:ext cx="3017520" cy="292608"/>
-          </a:xfrm>
-          <a:prstGeom prst="rect">
-            <a:avLst/>
-          </a:prstGeom>
-          <a:solidFill>
-            <a:srgbClr val="4A566A"/>
-          </a:solidFill>
-          <a:ln>
-            <a:noFill/>
-          </a:ln>
-        </p:spPr>
-        <p:style>
-          <a:lnRef idx="1">
-            <a:schemeClr val="accent1"/>
-          </a:lnRef>
-          <a:fillRef idx="3">
-            <a:schemeClr val="accent1"/>
-          </a:fillRef>
-          <a:effectRef idx="2">
-            <a:schemeClr val="accent1"/>
-          </a:effectRef>
-          <a:fontRef idx="minor">
-            <a:schemeClr val="lt1"/>
-          </a:fontRef>
-        </p:style>
-        <p:txBody>
-          <a:bodyPr rtlCol="0" anchor="ctr"/>
-          <a:lstStyle/>
-          <a:p>
-            <a:pPr algn="ctr"/>
-          </a:p>
-        </p:txBody>
-      </p:sp>
-      <p:sp>
-        <p:nvSpPr>
-          <p:cNvPr id="10" name="TextBox 9"/>
-          <p:cNvSpPr txBox="1"/>
-          <p:nvPr/>
-        </p:nvSpPr>
-        <p:spPr>
-          <a:xfrm>
-            <a:off x="9006840" y="237744"/>
-            <a:ext cx="2926080" cy="219456"/>
-          </a:xfrm>
-          <a:prstGeom prst="rect">
-            <a:avLst/>
-          </a:prstGeom>
-          <a:noFill/>
-        </p:spPr>
-        <p:txBody>
-          <a:bodyPr wrap="square">
-            <a:spAutoFit/>
-          </a:bodyPr>
-          <a:lstStyle/>
-          <a:p>
-            <a:pPr algn="ctr"/>
-            <a:r>
-              <a:rPr sz="850" b="1" i="0">
-                <a:solidFill>
-                  <a:srgbClr val="FFFFFF"/>
-                </a:solidFill>
-                <a:latin typeface="Calibri"/>
-              </a:rPr>
-              <a:t>PHASE 2  ·  Planned 2027</a:t>
-            </a:r>
-          </a:p>
-        </p:txBody>
-      </p:sp>
-      <p:sp>
-        <p:nvSpPr>
-          <p:cNvPr id="11" name="Rectangle 10"/>
+          <p:cNvPr id="10" name="Rectangle 9"/>
           <p:cNvSpPr/>
           <p:nvPr/>
         </p:nvSpPr>
@@ -21513,7 +21384,7 @@
       </p:sp>
       <p:sp>
         <p:nvSpPr>
-          <p:cNvPr id="12" name="TextBox 11"/>
+          <p:cNvPr id="11" name="TextBox 10"/>
           <p:cNvSpPr txBox="1"/>
           <p:nvPr/>
         </p:nvSpPr>
@@ -21548,7 +21419,7 @@
       </p:sp>
       <p:sp>
         <p:nvSpPr>
-          <p:cNvPr id="13" name="Rectangle 12"/>
+          <p:cNvPr id="12" name="Rectangle 11"/>
           <p:cNvSpPr/>
           <p:nvPr/>
         </p:nvSpPr>
@@ -21591,7 +21462,7 @@
       </p:sp>
       <p:sp>
         <p:nvSpPr>
-          <p:cNvPr id="14" name="TextBox 13"/>
+          <p:cNvPr id="13" name="TextBox 12"/>
           <p:cNvSpPr txBox="1"/>
           <p:nvPr/>
         </p:nvSpPr>
@@ -21626,7 +21497,7 @@
       </p:sp>
       <p:sp>
         <p:nvSpPr>
-          <p:cNvPr id="15" name="TextBox 14"/>
+          <p:cNvPr id="14" name="TextBox 13"/>
           <p:cNvSpPr txBox="1"/>
           <p:nvPr/>
         </p:nvSpPr>
@@ -21661,7 +21532,7 @@
       </p:sp>
       <p:sp>
         <p:nvSpPr>
-          <p:cNvPr id="16" name="TextBox 15"/>
+          <p:cNvPr id="15" name="TextBox 14"/>
           <p:cNvSpPr txBox="1"/>
           <p:nvPr/>
         </p:nvSpPr>
@@ -21696,7 +21567,7 @@
       </p:sp>
       <p:sp>
         <p:nvSpPr>
-          <p:cNvPr id="17" name="Rectangle 16"/>
+          <p:cNvPr id="16" name="Rectangle 15"/>
           <p:cNvSpPr/>
           <p:nvPr/>
         </p:nvSpPr>
@@ -21741,7 +21612,7 @@
       </p:sp>
       <p:sp>
         <p:nvSpPr>
-          <p:cNvPr id="18" name="TextBox 17"/>
+          <p:cNvPr id="17" name="TextBox 16"/>
           <p:cNvSpPr txBox="1"/>
           <p:nvPr/>
         </p:nvSpPr>
@@ -21776,7 +21647,7 @@
       </p:sp>
       <p:sp>
         <p:nvSpPr>
-          <p:cNvPr id="19" name="TextBox 18"/>
+          <p:cNvPr id="18" name="TextBox 17"/>
           <p:cNvSpPr txBox="1"/>
           <p:nvPr/>
         </p:nvSpPr>
@@ -21811,7 +21682,7 @@
       </p:sp>
       <p:sp>
         <p:nvSpPr>
-          <p:cNvPr id="20" name="TextBox 19"/>
+          <p:cNvPr id="19" name="TextBox 18"/>
           <p:cNvSpPr txBox="1"/>
           <p:nvPr/>
         </p:nvSpPr>
@@ -21839,14 +21710,14 @@
                 </a:solidFill>
                 <a:latin typeface="Calibri"/>
               </a:rPr>
-              <a:t>Training history for demand patterns</a:t>
-            </a:r>
-          </a:p>
-        </p:txBody>
-      </p:sp>
-      <p:sp>
-        <p:nvSpPr>
-          <p:cNvPr id="21" name="Rectangle 20"/>
+              <a:t>Demand history</a:t>
+            </a:r>
+          </a:p>
+        </p:txBody>
+      </p:sp>
+      <p:sp>
+        <p:nvSpPr>
+          <p:cNvPr id="20" name="Rectangle 19"/>
           <p:cNvSpPr/>
           <p:nvPr/>
         </p:nvSpPr>
@@ -21891,7 +21762,7 @@
       </p:sp>
       <p:sp>
         <p:nvSpPr>
-          <p:cNvPr id="22" name="TextBox 21"/>
+          <p:cNvPr id="21" name="TextBox 20"/>
           <p:cNvSpPr txBox="1"/>
           <p:nvPr/>
         </p:nvSpPr>
@@ -21926,7 +21797,7 @@
       </p:sp>
       <p:sp>
         <p:nvSpPr>
-          <p:cNvPr id="23" name="TextBox 22"/>
+          <p:cNvPr id="22" name="TextBox 21"/>
           <p:cNvSpPr txBox="1"/>
           <p:nvPr/>
         </p:nvSpPr>
@@ -21961,7 +21832,7 @@
       </p:sp>
       <p:sp>
         <p:nvSpPr>
-          <p:cNvPr id="24" name="TextBox 23"/>
+          <p:cNvPr id="23" name="TextBox 22"/>
           <p:cNvSpPr txBox="1"/>
           <p:nvPr/>
         </p:nvSpPr>
@@ -21989,14 +21860,14 @@
                 </a:solidFill>
                 <a:latin typeface="Calibri"/>
               </a:rPr>
-              <a:t>Normalize velocity to exclude distribution gaps</a:t>
-            </a:r>
-          </a:p>
-        </p:txBody>
-      </p:sp>
-      <p:sp>
-        <p:nvSpPr>
-          <p:cNvPr id="25" name="Rectangle 24"/>
+              <a:t>Distribution control</a:t>
+            </a:r>
+          </a:p>
+        </p:txBody>
+      </p:sp>
+      <p:sp>
+        <p:nvSpPr>
+          <p:cNvPr id="24" name="Rectangle 23"/>
           <p:cNvSpPr/>
           <p:nvPr/>
         </p:nvSpPr>
@@ -22041,7 +21912,7 @@
       </p:sp>
       <p:sp>
         <p:nvSpPr>
-          <p:cNvPr id="26" name="TextBox 25"/>
+          <p:cNvPr id="25" name="TextBox 24"/>
           <p:cNvSpPr txBox="1"/>
           <p:nvPr/>
         </p:nvSpPr>
@@ -22076,7 +21947,7 @@
       </p:sp>
       <p:sp>
         <p:nvSpPr>
-          <p:cNvPr id="27" name="TextBox 26"/>
+          <p:cNvPr id="26" name="TextBox 25"/>
           <p:cNvSpPr txBox="1"/>
           <p:nvPr/>
         </p:nvSpPr>
@@ -22111,7 +21982,7 @@
       </p:sp>
       <p:sp>
         <p:nvSpPr>
-          <p:cNvPr id="28" name="TextBox 27"/>
+          <p:cNvPr id="27" name="TextBox 26"/>
           <p:cNvSpPr txBox="1"/>
           <p:nvPr/>
         </p:nvSpPr>
@@ -22139,14 +22010,14 @@
                 </a:solidFill>
                 <a:latin typeface="Calibri"/>
               </a:rPr>
-              <a:t>Capture price-demand relationship in forecast</a:t>
-            </a:r>
-          </a:p>
-        </p:txBody>
-      </p:sp>
-      <p:sp>
-        <p:nvSpPr>
-          <p:cNvPr id="29" name="Rectangle 28"/>
+              <a:t>Price signal</a:t>
+            </a:r>
+          </a:p>
+        </p:txBody>
+      </p:sp>
+      <p:sp>
+        <p:nvSpPr>
+          <p:cNvPr id="28" name="Rectangle 27"/>
           <p:cNvSpPr/>
           <p:nvPr/>
         </p:nvSpPr>
@@ -22191,7 +22062,7 @@
       </p:sp>
       <p:sp>
         <p:nvSpPr>
-          <p:cNvPr id="30" name="TextBox 29"/>
+          <p:cNvPr id="29" name="TextBox 28"/>
           <p:cNvSpPr txBox="1"/>
           <p:nvPr/>
         </p:nvSpPr>
@@ -22226,7 +22097,7 @@
       </p:sp>
       <p:sp>
         <p:nvSpPr>
-          <p:cNvPr id="31" name="TextBox 30"/>
+          <p:cNvPr id="30" name="TextBox 29"/>
           <p:cNvSpPr txBox="1"/>
           <p:nvPr/>
         </p:nvSpPr>
@@ -22261,7 +22132,7 @@
       </p:sp>
       <p:sp>
         <p:nvSpPr>
-          <p:cNvPr id="32" name="TextBox 31"/>
+          <p:cNvPr id="31" name="TextBox 30"/>
           <p:cNvSpPr txBox="1"/>
           <p:nvPr/>
         </p:nvSpPr>
@@ -22289,14 +22160,14 @@
                 </a:solidFill>
                 <a:latin typeface="Calibri"/>
               </a:rPr>
-              <a:t>Separate promoted from non-promoted baseline</a:t>
-            </a:r>
-          </a:p>
-        </p:txBody>
-      </p:sp>
-      <p:sp>
-        <p:nvSpPr>
-          <p:cNvPr id="33" name="Rectangle 32"/>
+              <a:t>Promo flag</a:t>
+            </a:r>
+          </a:p>
+        </p:txBody>
+      </p:sp>
+      <p:sp>
+        <p:nvSpPr>
+          <p:cNvPr id="32" name="Rectangle 31"/>
           <p:cNvSpPr/>
           <p:nvPr/>
         </p:nvSpPr>
@@ -22341,7 +22212,7 @@
       </p:sp>
       <p:sp>
         <p:nvSpPr>
-          <p:cNvPr id="34" name="TextBox 33"/>
+          <p:cNvPr id="33" name="TextBox 32"/>
           <p:cNvSpPr txBox="1"/>
           <p:nvPr/>
         </p:nvSpPr>
@@ -22376,7 +22247,7 @@
       </p:sp>
       <p:sp>
         <p:nvSpPr>
-          <p:cNvPr id="35" name="TextBox 34"/>
+          <p:cNvPr id="34" name="TextBox 33"/>
           <p:cNvSpPr txBox="1"/>
           <p:nvPr/>
         </p:nvSpPr>
@@ -22411,7 +22282,7 @@
       </p:sp>
       <p:sp>
         <p:nvSpPr>
-          <p:cNvPr id="36" name="TextBox 35"/>
+          <p:cNvPr id="35" name="TextBox 34"/>
           <p:cNvSpPr txBox="1"/>
           <p:nvPr/>
         </p:nvSpPr>
@@ -22439,14 +22310,14 @@
                 </a:solidFill>
                 <a:latin typeface="Calibri"/>
               </a:rPr>
-              <a:t>Train a separate model per account</a:t>
-            </a:r>
-          </a:p>
-        </p:txBody>
-      </p:sp>
-      <p:sp>
-        <p:nvSpPr>
-          <p:cNvPr id="37" name="Rectangle 36"/>
+              <a:t>Per-account model</a:t>
+            </a:r>
+          </a:p>
+        </p:txBody>
+      </p:sp>
+      <p:sp>
+        <p:nvSpPr>
+          <p:cNvPr id="36" name="Rectangle 35"/>
           <p:cNvSpPr/>
           <p:nvPr/>
         </p:nvSpPr>
@@ -22491,7 +22362,7 @@
       </p:sp>
       <p:sp>
         <p:nvSpPr>
-          <p:cNvPr id="38" name="TextBox 37"/>
+          <p:cNvPr id="37" name="TextBox 36"/>
           <p:cNvSpPr txBox="1"/>
           <p:nvPr/>
         </p:nvSpPr>
@@ -22526,7 +22397,7 @@
       </p:sp>
       <p:sp>
         <p:nvSpPr>
-          <p:cNvPr id="39" name="TextBox 38"/>
+          <p:cNvPr id="38" name="TextBox 37"/>
           <p:cNvSpPr txBox="1"/>
           <p:nvPr/>
         </p:nvSpPr>
@@ -22561,7 +22432,7 @@
       </p:sp>
       <p:sp>
         <p:nvSpPr>
-          <p:cNvPr id="40" name="TextBox 39"/>
+          <p:cNvPr id="39" name="TextBox 38"/>
           <p:cNvSpPr txBox="1"/>
           <p:nvPr/>
         </p:nvSpPr>
@@ -22589,14 +22460,14 @@
                 </a:solidFill>
                 <a:latin typeface="Calibri"/>
               </a:rPr>
-              <a:t>Derive seasonality index and calendar features</a:t>
-            </a:r>
-          </a:p>
-        </p:txBody>
-      </p:sp>
-      <p:sp>
-        <p:nvSpPr>
-          <p:cNvPr id="41" name="Rectangle 40"/>
+              <a:t>Seasonality features</a:t>
+            </a:r>
+          </a:p>
+        </p:txBody>
+      </p:sp>
+      <p:sp>
+        <p:nvSpPr>
+          <p:cNvPr id="40" name="Rectangle 39"/>
           <p:cNvSpPr/>
           <p:nvPr/>
         </p:nvSpPr>
@@ -22639,7 +22510,7 @@
       </p:sp>
       <p:sp>
         <p:nvSpPr>
-          <p:cNvPr id="42" name="TextBox 41"/>
+          <p:cNvPr id="41" name="TextBox 40"/>
           <p:cNvSpPr txBox="1"/>
           <p:nvPr/>
         </p:nvSpPr>
@@ -22674,7 +22545,7 @@
       </p:sp>
       <p:sp>
         <p:nvSpPr>
-          <p:cNvPr id="43" name="Rectangle 42"/>
+          <p:cNvPr id="42" name="Rectangle 41"/>
           <p:cNvSpPr/>
           <p:nvPr/>
         </p:nvSpPr>
@@ -22717,7 +22588,7 @@
       </p:sp>
       <p:sp>
         <p:nvSpPr>
-          <p:cNvPr id="44" name="TextBox 43"/>
+          <p:cNvPr id="43" name="TextBox 42"/>
           <p:cNvSpPr txBox="1"/>
           <p:nvPr/>
         </p:nvSpPr>
@@ -22752,7 +22623,7 @@
       </p:sp>
       <p:sp>
         <p:nvSpPr>
-          <p:cNvPr id="45" name="Rectangle 44"/>
+          <p:cNvPr id="44" name="Rectangle 43"/>
           <p:cNvSpPr/>
           <p:nvPr/>
         </p:nvSpPr>
@@ -22795,7 +22666,7 @@
       </p:sp>
       <p:sp>
         <p:nvSpPr>
-          <p:cNvPr id="46" name="TextBox 45"/>
+          <p:cNvPr id="45" name="TextBox 44"/>
           <p:cNvSpPr txBox="1"/>
           <p:nvPr/>
         </p:nvSpPr>
@@ -22830,7 +22701,7 @@
       </p:sp>
       <p:sp>
         <p:nvSpPr>
-          <p:cNvPr id="47" name="Rectangle 46"/>
+          <p:cNvPr id="46" name="Rectangle 45"/>
           <p:cNvSpPr/>
           <p:nvPr/>
         </p:nvSpPr>
@@ -22873,7 +22744,7 @@
       </p:sp>
       <p:sp>
         <p:nvSpPr>
-          <p:cNvPr id="48" name="TextBox 47"/>
+          <p:cNvPr id="47" name="TextBox 46"/>
           <p:cNvSpPr txBox="1"/>
           <p:nvPr/>
         </p:nvSpPr>
@@ -22908,7 +22779,7 @@
       </p:sp>
       <p:sp>
         <p:nvSpPr>
-          <p:cNvPr id="49" name="Rectangle 48"/>
+          <p:cNvPr id="48" name="Rectangle 47"/>
           <p:cNvSpPr/>
           <p:nvPr/>
         </p:nvSpPr>
@@ -22951,7 +22822,7 @@
       </p:sp>
       <p:sp>
         <p:nvSpPr>
-          <p:cNvPr id="50" name="TextBox 49"/>
+          <p:cNvPr id="49" name="TextBox 48"/>
           <p:cNvSpPr txBox="1"/>
           <p:nvPr/>
         </p:nvSpPr>
@@ -22986,7 +22857,7 @@
       </p:sp>
       <p:sp>
         <p:nvSpPr>
-          <p:cNvPr id="51" name="Rectangle 50"/>
+          <p:cNvPr id="50" name="Rectangle 49"/>
           <p:cNvSpPr/>
           <p:nvPr/>
         </p:nvSpPr>
@@ -23029,7 +22900,7 @@
       </p:sp>
       <p:sp>
         <p:nvSpPr>
-          <p:cNvPr id="52" name="TextBox 51"/>
+          <p:cNvPr id="51" name="TextBox 50"/>
           <p:cNvSpPr txBox="1"/>
           <p:nvPr/>
         </p:nvSpPr>
@@ -23064,7 +22935,7 @@
       </p:sp>
       <p:sp>
         <p:nvSpPr>
-          <p:cNvPr id="53" name="Rectangle 52"/>
+          <p:cNvPr id="52" name="Rectangle 51"/>
           <p:cNvSpPr/>
           <p:nvPr/>
         </p:nvSpPr>
@@ -23107,7 +22978,7 @@
       </p:sp>
       <p:sp>
         <p:nvSpPr>
-          <p:cNvPr id="54" name="TextBox 53"/>
+          <p:cNvPr id="53" name="TextBox 52"/>
           <p:cNvSpPr txBox="1"/>
           <p:nvPr/>
         </p:nvSpPr>
@@ -23142,7 +23013,7 @@
       </p:sp>
       <p:sp>
         <p:nvSpPr>
-          <p:cNvPr id="55" name="Rectangle 54"/>
+          <p:cNvPr id="54" name="Rectangle 53"/>
           <p:cNvSpPr/>
           <p:nvPr/>
         </p:nvSpPr>
@@ -23185,7 +23056,7 @@
       </p:sp>
       <p:sp>
         <p:nvSpPr>
-          <p:cNvPr id="56" name="TextBox 55"/>
+          <p:cNvPr id="55" name="TextBox 54"/>
           <p:cNvSpPr txBox="1"/>
           <p:nvPr/>
         </p:nvSpPr>
@@ -23220,7 +23091,7 @@
       </p:sp>
       <p:sp>
         <p:nvSpPr>
-          <p:cNvPr id="57" name="Rectangle 56"/>
+          <p:cNvPr id="56" name="Rectangle 55"/>
           <p:cNvSpPr/>
           <p:nvPr/>
         </p:nvSpPr>
@@ -23265,7 +23136,7 @@
       </p:sp>
       <p:sp>
         <p:nvSpPr>
-          <p:cNvPr id="58" name="TextBox 57"/>
+          <p:cNvPr id="57" name="TextBox 56"/>
           <p:cNvSpPr txBox="1"/>
           <p:nvPr/>
         </p:nvSpPr>
@@ -23300,7 +23171,7 @@
       </p:sp>
       <p:sp>
         <p:nvSpPr>
-          <p:cNvPr id="59" name="TextBox 58"/>
+          <p:cNvPr id="58" name="TextBox 57"/>
           <p:cNvSpPr txBox="1"/>
           <p:nvPr/>
         </p:nvSpPr>
@@ -23335,7 +23206,7 @@
       </p:sp>
       <p:sp>
         <p:nvSpPr>
-          <p:cNvPr id="60" name="TextBox 59"/>
+          <p:cNvPr id="59" name="TextBox 58"/>
           <p:cNvSpPr txBox="1"/>
           <p:nvPr/>
         </p:nvSpPr>
@@ -23370,7 +23241,7 @@
       </p:sp>
       <p:sp>
         <p:nvSpPr>
-          <p:cNvPr id="61" name="TextBox 60"/>
+          <p:cNvPr id="60" name="TextBox 59"/>
           <p:cNvSpPr txBox="1"/>
           <p:nvPr/>
         </p:nvSpPr>
@@ -23405,7 +23276,7 @@
       </p:sp>
       <p:sp>
         <p:nvSpPr>
-          <p:cNvPr id="62" name="Rectangle 61"/>
+          <p:cNvPr id="61" name="Rectangle 60"/>
           <p:cNvSpPr/>
           <p:nvPr/>
         </p:nvSpPr>
@@ -23448,7 +23319,7 @@
       </p:sp>
       <p:sp>
         <p:nvSpPr>
-          <p:cNvPr id="63" name="TextBox 62"/>
+          <p:cNvPr id="62" name="TextBox 61"/>
           <p:cNvSpPr txBox="1"/>
           <p:nvPr/>
         </p:nvSpPr>
@@ -23483,7 +23354,7 @@
       </p:sp>
       <p:sp>
         <p:nvSpPr>
-          <p:cNvPr id="64" name="Rectangle 63"/>
+          <p:cNvPr id="63" name="Rectangle 62"/>
           <p:cNvSpPr/>
           <p:nvPr/>
         </p:nvSpPr>
@@ -23528,7 +23399,7 @@
       </p:sp>
       <p:sp>
         <p:nvSpPr>
-          <p:cNvPr id="65" name="TextBox 64"/>
+          <p:cNvPr id="64" name="TextBox 63"/>
           <p:cNvSpPr txBox="1"/>
           <p:nvPr/>
         </p:nvSpPr>
@@ -23563,7 +23434,7 @@
       </p:sp>
       <p:sp>
         <p:nvSpPr>
-          <p:cNvPr id="66" name="TextBox 65"/>
+          <p:cNvPr id="65" name="TextBox 64"/>
           <p:cNvSpPr txBox="1"/>
           <p:nvPr/>
         </p:nvSpPr>
@@ -23598,7 +23469,7 @@
       </p:sp>
       <p:sp>
         <p:nvSpPr>
-          <p:cNvPr id="67" name="TextBox 66"/>
+          <p:cNvPr id="66" name="TextBox 65"/>
           <p:cNvSpPr txBox="1"/>
           <p:nvPr/>
         </p:nvSpPr>
@@ -23633,7 +23504,7 @@
       </p:sp>
       <p:sp>
         <p:nvSpPr>
-          <p:cNvPr id="68" name="TextBox 67"/>
+          <p:cNvPr id="67" name="TextBox 66"/>
           <p:cNvSpPr txBox="1"/>
           <p:nvPr/>
         </p:nvSpPr>
@@ -23668,7 +23539,7 @@
       </p:sp>
       <p:sp>
         <p:nvSpPr>
-          <p:cNvPr id="69" name="Rectangle 68"/>
+          <p:cNvPr id="68" name="Rectangle 67"/>
           <p:cNvSpPr/>
           <p:nvPr/>
         </p:nvSpPr>
@@ -23711,7 +23582,7 @@
       </p:sp>
       <p:sp>
         <p:nvSpPr>
-          <p:cNvPr id="70" name="TextBox 69"/>
+          <p:cNvPr id="69" name="TextBox 68"/>
           <p:cNvSpPr txBox="1"/>
           <p:nvPr/>
         </p:nvSpPr>
@@ -23746,7 +23617,7 @@
       </p:sp>
       <p:sp>
         <p:nvSpPr>
-          <p:cNvPr id="71" name="Rectangle 70"/>
+          <p:cNvPr id="70" name="Rectangle 69"/>
           <p:cNvSpPr/>
           <p:nvPr/>
         </p:nvSpPr>
@@ -23791,7 +23662,7 @@
       </p:sp>
       <p:sp>
         <p:nvSpPr>
-          <p:cNvPr id="72" name="TextBox 71"/>
+          <p:cNvPr id="71" name="TextBox 70"/>
           <p:cNvSpPr txBox="1"/>
           <p:nvPr/>
         </p:nvSpPr>
@@ -23826,7 +23697,7 @@
       </p:sp>
       <p:sp>
         <p:nvSpPr>
-          <p:cNvPr id="73" name="Rectangle 72"/>
+          <p:cNvPr id="72" name="Rectangle 71"/>
           <p:cNvSpPr/>
           <p:nvPr/>
         </p:nvSpPr>
@@ -23869,7 +23740,7 @@
       </p:sp>
       <p:sp>
         <p:nvSpPr>
-          <p:cNvPr id="74" name="TextBox 73"/>
+          <p:cNvPr id="73" name="TextBox 72"/>
           <p:cNvSpPr txBox="1"/>
           <p:nvPr/>
         </p:nvSpPr>
@@ -23904,7 +23775,7 @@
       </p:sp>
       <p:sp>
         <p:nvSpPr>
-          <p:cNvPr id="75" name="Rectangle 74"/>
+          <p:cNvPr id="74" name="Rectangle 73"/>
           <p:cNvSpPr/>
           <p:nvPr/>
         </p:nvSpPr>
@@ -23949,7 +23820,7 @@
       </p:sp>
       <p:sp>
         <p:nvSpPr>
-          <p:cNvPr id="76" name="TextBox 75"/>
+          <p:cNvPr id="75" name="TextBox 74"/>
           <p:cNvSpPr txBox="1"/>
           <p:nvPr/>
         </p:nvSpPr>
@@ -23984,7 +23855,7 @@
       </p:sp>
       <p:sp>
         <p:nvSpPr>
-          <p:cNvPr id="77" name="TextBox 76"/>
+          <p:cNvPr id="76" name="TextBox 75"/>
           <p:cNvSpPr txBox="1"/>
           <p:nvPr/>
         </p:nvSpPr>
@@ -24216,7 +24087,7 @@
         <p:spPr>
           <a:xfrm>
             <a:off x="457200" y="91440"/>
-            <a:ext cx="1828800" cy="274320"/>
+            <a:ext cx="3200400" cy="256032"/>
           </a:xfrm>
           <a:prstGeom prst="rect">
             <a:avLst/>
@@ -24245,6 +24116,41 @@
       <p:sp>
         <p:nvSpPr>
           <p:cNvPr id="7" name="TextBox 6"/>
+          <p:cNvSpPr txBox="1"/>
+          <p:nvPr/>
+        </p:nvSpPr>
+        <p:spPr>
+          <a:xfrm>
+            <a:off x="3657600" y="91440"/>
+            <a:ext cx="8229600" cy="256032"/>
+          </a:xfrm>
+          <a:prstGeom prst="rect">
+            <a:avLst/>
+          </a:prstGeom>
+          <a:noFill/>
+        </p:spPr>
+        <p:txBody>
+          <a:bodyPr wrap="square">
+            <a:spAutoFit/>
+          </a:bodyPr>
+          <a:lstStyle/>
+          <a:p>
+            <a:pPr algn="r"/>
+            <a:r>
+              <a:rPr sz="900" b="1" i="0">
+                <a:solidFill>
+                  <a:srgbClr val="D4DAE6"/>
+                </a:solidFill>
+                <a:latin typeface="Calibri"/>
+              </a:rPr>
+              <a:t>PHASE 2 — PLANNED 2027</a:t>
+            </a:r>
+          </a:p>
+        </p:txBody>
+      </p:sp>
+      <p:sp>
+        <p:nvSpPr>
+          <p:cNvPr id="8" name="TextBox 7"/>
           <p:cNvSpPr txBox="1"/>
           <p:nvPr/>
         </p:nvSpPr>
@@ -24279,7 +24185,7 @@
       </p:sp>
       <p:sp>
         <p:nvSpPr>
-          <p:cNvPr id="8" name="TextBox 7"/>
+          <p:cNvPr id="9" name="TextBox 8"/>
           <p:cNvSpPr txBox="1"/>
           <p:nvPr/>
         </p:nvSpPr>
@@ -24314,85 +24220,7 @@
       </p:sp>
       <p:sp>
         <p:nvSpPr>
-          <p:cNvPr id="9" name="Rectangle 8"/>
-          <p:cNvSpPr/>
-          <p:nvPr/>
-        </p:nvSpPr>
-        <p:spPr>
-          <a:xfrm>
-            <a:off x="8961120" y="201168"/>
-            <a:ext cx="3017520" cy="292608"/>
-          </a:xfrm>
-          <a:prstGeom prst="rect">
-            <a:avLst/>
-          </a:prstGeom>
-          <a:solidFill>
-            <a:srgbClr val="4A566A"/>
-          </a:solidFill>
-          <a:ln>
-            <a:noFill/>
-          </a:ln>
-        </p:spPr>
-        <p:style>
-          <a:lnRef idx="1">
-            <a:schemeClr val="accent1"/>
-          </a:lnRef>
-          <a:fillRef idx="3">
-            <a:schemeClr val="accent1"/>
-          </a:fillRef>
-          <a:effectRef idx="2">
-            <a:schemeClr val="accent1"/>
-          </a:effectRef>
-          <a:fontRef idx="minor">
-            <a:schemeClr val="lt1"/>
-          </a:fontRef>
-        </p:style>
-        <p:txBody>
-          <a:bodyPr rtlCol="0" anchor="ctr"/>
-          <a:lstStyle/>
-          <a:p>
-            <a:pPr algn="ctr"/>
-          </a:p>
-        </p:txBody>
-      </p:sp>
-      <p:sp>
-        <p:nvSpPr>
-          <p:cNvPr id="10" name="TextBox 9"/>
-          <p:cNvSpPr txBox="1"/>
-          <p:nvPr/>
-        </p:nvSpPr>
-        <p:spPr>
-          <a:xfrm>
-            <a:off x="9006840" y="237744"/>
-            <a:ext cx="2926080" cy="219456"/>
-          </a:xfrm>
-          <a:prstGeom prst="rect">
-            <a:avLst/>
-          </a:prstGeom>
-          <a:noFill/>
-        </p:spPr>
-        <p:txBody>
-          <a:bodyPr wrap="square">
-            <a:spAutoFit/>
-          </a:bodyPr>
-          <a:lstStyle/>
-          <a:p>
-            <a:pPr algn="ctr"/>
-            <a:r>
-              <a:rPr sz="850" b="1" i="0">
-                <a:solidFill>
-                  <a:srgbClr val="FFFFFF"/>
-                </a:solidFill>
-                <a:latin typeface="Calibri"/>
-              </a:rPr>
-              <a:t>PHASE 2  ·  Planned 2027</a:t>
-            </a:r>
-          </a:p>
-        </p:txBody>
-      </p:sp>
-      <p:sp>
-        <p:nvSpPr>
-          <p:cNvPr id="11" name="Rectangle 10"/>
+          <p:cNvPr id="10" name="Rectangle 9"/>
           <p:cNvSpPr/>
           <p:nvPr/>
         </p:nvSpPr>
@@ -24435,7 +24263,7 @@
       </p:sp>
       <p:sp>
         <p:nvSpPr>
-          <p:cNvPr id="12" name="TextBox 11"/>
+          <p:cNvPr id="11" name="TextBox 10"/>
           <p:cNvSpPr txBox="1"/>
           <p:nvPr/>
         </p:nvSpPr>
@@ -24470,7 +24298,7 @@
       </p:sp>
       <p:sp>
         <p:nvSpPr>
-          <p:cNvPr id="13" name="Rectangle 12"/>
+          <p:cNvPr id="12" name="Rectangle 11"/>
           <p:cNvSpPr/>
           <p:nvPr/>
         </p:nvSpPr>
@@ -24513,7 +24341,7 @@
       </p:sp>
       <p:sp>
         <p:nvSpPr>
-          <p:cNvPr id="14" name="TextBox 13"/>
+          <p:cNvPr id="13" name="TextBox 12"/>
           <p:cNvSpPr txBox="1"/>
           <p:nvPr/>
         </p:nvSpPr>
@@ -24548,7 +24376,7 @@
       </p:sp>
       <p:sp>
         <p:nvSpPr>
-          <p:cNvPr id="15" name="TextBox 14"/>
+          <p:cNvPr id="14" name="TextBox 13"/>
           <p:cNvSpPr txBox="1"/>
           <p:nvPr/>
         </p:nvSpPr>
@@ -24583,7 +24411,7 @@
       </p:sp>
       <p:sp>
         <p:nvSpPr>
-          <p:cNvPr id="16" name="TextBox 15"/>
+          <p:cNvPr id="15" name="TextBox 14"/>
           <p:cNvSpPr txBox="1"/>
           <p:nvPr/>
         </p:nvSpPr>
@@ -24618,7 +24446,7 @@
       </p:sp>
       <p:sp>
         <p:nvSpPr>
-          <p:cNvPr id="17" name="Rectangle 16"/>
+          <p:cNvPr id="16" name="Rectangle 15"/>
           <p:cNvSpPr/>
           <p:nvPr/>
         </p:nvSpPr>
@@ -24663,7 +24491,7 @@
       </p:sp>
       <p:sp>
         <p:nvSpPr>
-          <p:cNvPr id="18" name="TextBox 17"/>
+          <p:cNvPr id="17" name="TextBox 16"/>
           <p:cNvSpPr txBox="1"/>
           <p:nvPr/>
         </p:nvSpPr>
@@ -24698,7 +24526,7 @@
       </p:sp>
       <p:sp>
         <p:nvSpPr>
-          <p:cNvPr id="19" name="TextBox 18"/>
+          <p:cNvPr id="18" name="TextBox 17"/>
           <p:cNvSpPr txBox="1"/>
           <p:nvPr/>
         </p:nvSpPr>
@@ -24733,7 +24561,7 @@
       </p:sp>
       <p:sp>
         <p:nvSpPr>
-          <p:cNvPr id="20" name="TextBox 19"/>
+          <p:cNvPr id="19" name="TextBox 18"/>
           <p:cNvSpPr txBox="1"/>
           <p:nvPr/>
         </p:nvSpPr>
@@ -24761,14 +24589,14 @@
                 </a:solidFill>
                 <a:latin typeface="Calibri"/>
               </a:rPr>
-              <a:t>Measure distribution build week over week</a:t>
-            </a:r>
-          </a:p>
-        </p:txBody>
-      </p:sp>
-      <p:sp>
-        <p:nvSpPr>
-          <p:cNvPr id="21" name="Rectangle 20"/>
+              <a:t>Distribution growth</a:t>
+            </a:r>
+          </a:p>
+        </p:txBody>
+      </p:sp>
+      <p:sp>
+        <p:nvSpPr>
+          <p:cNvPr id="20" name="Rectangle 19"/>
           <p:cNvSpPr/>
           <p:nvPr/>
         </p:nvSpPr>
@@ -24813,7 +24641,7 @@
       </p:sp>
       <p:sp>
         <p:nvSpPr>
-          <p:cNvPr id="22" name="TextBox 21"/>
+          <p:cNvPr id="21" name="TextBox 20"/>
           <p:cNvSpPr txBox="1"/>
           <p:nvPr/>
         </p:nvSpPr>
@@ -24848,7 +24676,7 @@
       </p:sp>
       <p:sp>
         <p:nvSpPr>
-          <p:cNvPr id="23" name="TextBox 22"/>
+          <p:cNvPr id="22" name="TextBox 21"/>
           <p:cNvSpPr txBox="1"/>
           <p:nvPr/>
         </p:nvSpPr>
@@ -24883,7 +24711,7 @@
       </p:sp>
       <p:sp>
         <p:nvSpPr>
-          <p:cNvPr id="24" name="TextBox 23"/>
+          <p:cNvPr id="23" name="TextBox 22"/>
           <p:cNvSpPr txBox="1"/>
           <p:nvPr/>
         </p:nvSpPr>
@@ -24911,14 +24739,14 @@
                 </a:solidFill>
                 <a:latin typeface="Calibri"/>
               </a:rPr>
-              <a:t>Primary ramp metric — store count × presence</a:t>
-            </a:r>
-          </a:p>
-        </p:txBody>
-      </p:sp>
-      <p:sp>
-        <p:nvSpPr>
-          <p:cNvPr id="25" name="Rectangle 24"/>
+              <a:t>Primary ramp metric</a:t>
+            </a:r>
+          </a:p>
+        </p:txBody>
+      </p:sp>
+      <p:sp>
+        <p:nvSpPr>
+          <p:cNvPr id="24" name="Rectangle 23"/>
           <p:cNvSpPr/>
           <p:nvPr/>
         </p:nvSpPr>
@@ -24963,7 +24791,7 @@
       </p:sp>
       <p:sp>
         <p:nvSpPr>
-          <p:cNvPr id="26" name="TextBox 25"/>
+          <p:cNvPr id="25" name="TextBox 24"/>
           <p:cNvSpPr txBox="1"/>
           <p:nvPr/>
         </p:nvSpPr>
@@ -24998,7 +24826,7 @@
       </p:sp>
       <p:sp>
         <p:nvSpPr>
-          <p:cNvPr id="27" name="TextBox 26"/>
+          <p:cNvPr id="26" name="TextBox 25"/>
           <p:cNvSpPr txBox="1"/>
           <p:nvPr/>
         </p:nvSpPr>
@@ -25033,7 +24861,7 @@
       </p:sp>
       <p:sp>
         <p:nvSpPr>
-          <p:cNvPr id="28" name="TextBox 27"/>
+          <p:cNvPr id="27" name="TextBox 26"/>
           <p:cNvSpPr txBox="1"/>
           <p:nvPr/>
         </p:nvSpPr>
@@ -25061,14 +24889,14 @@
                 </a:solidFill>
                 <a:latin typeface="Calibri"/>
               </a:rPr>
-              <a:t>Velocity independent of distribution level</a:t>
-            </a:r>
-          </a:p>
-        </p:txBody>
-      </p:sp>
-      <p:sp>
-        <p:nvSpPr>
-          <p:cNvPr id="29" name="Rectangle 28"/>
+              <a:t>Velocity per store</a:t>
+            </a:r>
+          </a:p>
+        </p:txBody>
+      </p:sp>
+      <p:sp>
+        <p:nvSpPr>
+          <p:cNvPr id="28" name="Rectangle 27"/>
           <p:cNvSpPr/>
           <p:nvPr/>
         </p:nvSpPr>
@@ -25113,7 +24941,7 @@
       </p:sp>
       <p:sp>
         <p:nvSpPr>
-          <p:cNvPr id="30" name="TextBox 29"/>
+          <p:cNvPr id="29" name="TextBox 28"/>
           <p:cNvSpPr txBox="1"/>
           <p:nvPr/>
         </p:nvSpPr>
@@ -25148,7 +24976,7 @@
       </p:sp>
       <p:sp>
         <p:nvSpPr>
-          <p:cNvPr id="31" name="TextBox 30"/>
+          <p:cNvPr id="30" name="TextBox 29"/>
           <p:cNvSpPr txBox="1"/>
           <p:nvPr/>
         </p:nvSpPr>
@@ -25183,7 +25011,7 @@
       </p:sp>
       <p:sp>
         <p:nvSpPr>
-          <p:cNvPr id="32" name="TextBox 31"/>
+          <p:cNvPr id="31" name="TextBox 30"/>
           <p:cNvSpPr txBox="1"/>
           <p:nvPr/>
         </p:nvSpPr>
@@ -25211,14 +25039,14 @@
                 </a:solidFill>
                 <a:latin typeface="Calibri"/>
               </a:rPr>
-              <a:t>Anchor the ramp monitoring window</a:t>
-            </a:r>
-          </a:p>
-        </p:txBody>
-      </p:sp>
-      <p:sp>
-        <p:nvSpPr>
-          <p:cNvPr id="33" name="Rectangle 32"/>
+              <a:t>Launch anchor date</a:t>
+            </a:r>
+          </a:p>
+        </p:txBody>
+      </p:sp>
+      <p:sp>
+        <p:nvSpPr>
+          <p:cNvPr id="32" name="Rectangle 31"/>
           <p:cNvSpPr/>
           <p:nvPr/>
         </p:nvSpPr>
@@ -25263,7 +25091,7 @@
       </p:sp>
       <p:sp>
         <p:nvSpPr>
-          <p:cNvPr id="34" name="TextBox 33"/>
+          <p:cNvPr id="33" name="TextBox 32"/>
           <p:cNvSpPr txBox="1"/>
           <p:nvPr/>
         </p:nvSpPr>
@@ -25298,7 +25126,7 @@
       </p:sp>
       <p:sp>
         <p:nvSpPr>
-          <p:cNvPr id="35" name="TextBox 34"/>
+          <p:cNvPr id="34" name="TextBox 33"/>
           <p:cNvSpPr txBox="1"/>
           <p:nvPr/>
         </p:nvSpPr>
@@ -25333,7 +25161,7 @@
       </p:sp>
       <p:sp>
         <p:nvSpPr>
-          <p:cNvPr id="36" name="TextBox 35"/>
+          <p:cNvPr id="35" name="TextBox 34"/>
           <p:cNvSpPr txBox="1"/>
           <p:nvPr/>
         </p:nvSpPr>
@@ -25361,14 +25189,14 @@
                 </a:solidFill>
                 <a:latin typeface="Calibri"/>
               </a:rPr>
-              <a:t>Track position in the launch lifecycle</a:t>
-            </a:r>
-          </a:p>
-        </p:txBody>
-      </p:sp>
-      <p:sp>
-        <p:nvSpPr>
-          <p:cNvPr id="37" name="Rectangle 36"/>
+              <a:t>Lifecycle position</a:t>
+            </a:r>
+          </a:p>
+        </p:txBody>
+      </p:sp>
+      <p:sp>
+        <p:nvSpPr>
+          <p:cNvPr id="36" name="Rectangle 35"/>
           <p:cNvSpPr/>
           <p:nvPr/>
         </p:nvSpPr>
@@ -25411,7 +25239,7 @@
       </p:sp>
       <p:sp>
         <p:nvSpPr>
-          <p:cNvPr id="38" name="TextBox 37"/>
+          <p:cNvPr id="37" name="TextBox 36"/>
           <p:cNvSpPr txBox="1"/>
           <p:nvPr/>
         </p:nvSpPr>
@@ -25446,7 +25274,7 @@
       </p:sp>
       <p:sp>
         <p:nvSpPr>
-          <p:cNvPr id="39" name="Rectangle 38"/>
+          <p:cNvPr id="38" name="Rectangle 37"/>
           <p:cNvSpPr/>
           <p:nvPr/>
         </p:nvSpPr>
@@ -25489,7 +25317,7 @@
       </p:sp>
       <p:sp>
         <p:nvSpPr>
-          <p:cNvPr id="40" name="TextBox 39"/>
+          <p:cNvPr id="39" name="TextBox 38"/>
           <p:cNvSpPr txBox="1"/>
           <p:nvPr/>
         </p:nvSpPr>
@@ -25524,7 +25352,7 @@
       </p:sp>
       <p:sp>
         <p:nvSpPr>
-          <p:cNvPr id="41" name="Rectangle 40"/>
+          <p:cNvPr id="40" name="Rectangle 39"/>
           <p:cNvSpPr/>
           <p:nvPr/>
         </p:nvSpPr>
@@ -25567,7 +25395,7 @@
       </p:sp>
       <p:sp>
         <p:nvSpPr>
-          <p:cNvPr id="42" name="TextBox 41"/>
+          <p:cNvPr id="41" name="TextBox 40"/>
           <p:cNvSpPr txBox="1"/>
           <p:nvPr/>
         </p:nvSpPr>
@@ -25602,7 +25430,7 @@
       </p:sp>
       <p:sp>
         <p:nvSpPr>
-          <p:cNvPr id="43" name="Rectangle 42"/>
+          <p:cNvPr id="42" name="Rectangle 41"/>
           <p:cNvSpPr/>
           <p:nvPr/>
         </p:nvSpPr>
@@ -25645,7 +25473,7 @@
       </p:sp>
       <p:sp>
         <p:nvSpPr>
-          <p:cNvPr id="44" name="TextBox 43"/>
+          <p:cNvPr id="43" name="TextBox 42"/>
           <p:cNvSpPr txBox="1"/>
           <p:nvPr/>
         </p:nvSpPr>
@@ -25680,7 +25508,7 @@
       </p:sp>
       <p:sp>
         <p:nvSpPr>
-          <p:cNvPr id="45" name="Rectangle 44"/>
+          <p:cNvPr id="44" name="Rectangle 43"/>
           <p:cNvSpPr/>
           <p:nvPr/>
         </p:nvSpPr>
@@ -25723,7 +25551,7 @@
       </p:sp>
       <p:sp>
         <p:nvSpPr>
-          <p:cNvPr id="46" name="TextBox 45"/>
+          <p:cNvPr id="45" name="TextBox 44"/>
           <p:cNvSpPr txBox="1"/>
           <p:nvPr/>
         </p:nvSpPr>
@@ -25758,7 +25586,7 @@
       </p:sp>
       <p:sp>
         <p:nvSpPr>
-          <p:cNvPr id="47" name="Rectangle 46"/>
+          <p:cNvPr id="46" name="Rectangle 45"/>
           <p:cNvSpPr/>
           <p:nvPr/>
         </p:nvSpPr>
@@ -25801,7 +25629,7 @@
       </p:sp>
       <p:sp>
         <p:nvSpPr>
-          <p:cNvPr id="48" name="TextBox 47"/>
+          <p:cNvPr id="47" name="TextBox 46"/>
           <p:cNvSpPr txBox="1"/>
           <p:nvPr/>
         </p:nvSpPr>
@@ -25836,7 +25664,7 @@
       </p:sp>
       <p:sp>
         <p:nvSpPr>
-          <p:cNvPr id="49" name="Rectangle 48"/>
+          <p:cNvPr id="48" name="Rectangle 47"/>
           <p:cNvSpPr/>
           <p:nvPr/>
         </p:nvSpPr>
@@ -25879,7 +25707,7 @@
       </p:sp>
       <p:sp>
         <p:nvSpPr>
-          <p:cNvPr id="50" name="TextBox 49"/>
+          <p:cNvPr id="49" name="TextBox 48"/>
           <p:cNvSpPr txBox="1"/>
           <p:nvPr/>
         </p:nvSpPr>
@@ -25914,7 +25742,7 @@
       </p:sp>
       <p:sp>
         <p:nvSpPr>
-          <p:cNvPr id="51" name="Rectangle 50"/>
+          <p:cNvPr id="50" name="Rectangle 49"/>
           <p:cNvSpPr/>
           <p:nvPr/>
         </p:nvSpPr>
@@ -25959,7 +25787,7 @@
       </p:sp>
       <p:sp>
         <p:nvSpPr>
-          <p:cNvPr id="52" name="TextBox 51"/>
+          <p:cNvPr id="51" name="TextBox 50"/>
           <p:cNvSpPr txBox="1"/>
           <p:nvPr/>
         </p:nvSpPr>
@@ -25994,7 +25822,7 @@
       </p:sp>
       <p:sp>
         <p:nvSpPr>
-          <p:cNvPr id="53" name="TextBox 52"/>
+          <p:cNvPr id="52" name="TextBox 51"/>
           <p:cNvSpPr txBox="1"/>
           <p:nvPr/>
         </p:nvSpPr>
@@ -26029,7 +25857,7 @@
       </p:sp>
       <p:sp>
         <p:nvSpPr>
-          <p:cNvPr id="54" name="TextBox 53"/>
+          <p:cNvPr id="53" name="TextBox 52"/>
           <p:cNvSpPr txBox="1"/>
           <p:nvPr/>
         </p:nvSpPr>
@@ -26064,7 +25892,7 @@
       </p:sp>
       <p:sp>
         <p:nvSpPr>
-          <p:cNvPr id="55" name="TextBox 54"/>
+          <p:cNvPr id="54" name="TextBox 53"/>
           <p:cNvSpPr txBox="1"/>
           <p:nvPr/>
         </p:nvSpPr>
@@ -26099,7 +25927,7 @@
       </p:sp>
       <p:sp>
         <p:nvSpPr>
-          <p:cNvPr id="56" name="Rectangle 55"/>
+          <p:cNvPr id="55" name="Rectangle 54"/>
           <p:cNvSpPr/>
           <p:nvPr/>
         </p:nvSpPr>
@@ -26142,7 +25970,7 @@
       </p:sp>
       <p:sp>
         <p:nvSpPr>
-          <p:cNvPr id="57" name="TextBox 56"/>
+          <p:cNvPr id="56" name="TextBox 55"/>
           <p:cNvSpPr txBox="1"/>
           <p:nvPr/>
         </p:nvSpPr>
@@ -26177,7 +26005,7 @@
       </p:sp>
       <p:sp>
         <p:nvSpPr>
-          <p:cNvPr id="58" name="Rectangle 57"/>
+          <p:cNvPr id="57" name="Rectangle 56"/>
           <p:cNvSpPr/>
           <p:nvPr/>
         </p:nvSpPr>
@@ -26222,7 +26050,7 @@
       </p:sp>
       <p:sp>
         <p:nvSpPr>
-          <p:cNvPr id="59" name="TextBox 58"/>
+          <p:cNvPr id="58" name="TextBox 57"/>
           <p:cNvSpPr txBox="1"/>
           <p:nvPr/>
         </p:nvSpPr>
@@ -26257,7 +26085,7 @@
       </p:sp>
       <p:sp>
         <p:nvSpPr>
-          <p:cNvPr id="60" name="TextBox 59"/>
+          <p:cNvPr id="59" name="TextBox 58"/>
           <p:cNvSpPr txBox="1"/>
           <p:nvPr/>
         </p:nvSpPr>
@@ -26292,7 +26120,7 @@
       </p:sp>
       <p:sp>
         <p:nvSpPr>
-          <p:cNvPr id="61" name="TextBox 60"/>
+          <p:cNvPr id="60" name="TextBox 59"/>
           <p:cNvSpPr txBox="1"/>
           <p:nvPr/>
         </p:nvSpPr>
@@ -26327,7 +26155,7 @@
       </p:sp>
       <p:sp>
         <p:nvSpPr>
-          <p:cNvPr id="62" name="TextBox 61"/>
+          <p:cNvPr id="61" name="TextBox 60"/>
           <p:cNvSpPr txBox="1"/>
           <p:nvPr/>
         </p:nvSpPr>
@@ -26362,7 +26190,7 @@
       </p:sp>
       <p:sp>
         <p:nvSpPr>
-          <p:cNvPr id="63" name="Rectangle 62"/>
+          <p:cNvPr id="62" name="Rectangle 61"/>
           <p:cNvSpPr/>
           <p:nvPr/>
         </p:nvSpPr>
@@ -26405,7 +26233,7 @@
       </p:sp>
       <p:sp>
         <p:nvSpPr>
-          <p:cNvPr id="64" name="TextBox 63"/>
+          <p:cNvPr id="63" name="TextBox 62"/>
           <p:cNvSpPr txBox="1"/>
           <p:nvPr/>
         </p:nvSpPr>
@@ -26440,7 +26268,7 @@
       </p:sp>
       <p:sp>
         <p:nvSpPr>
-          <p:cNvPr id="65" name="Rectangle 64"/>
+          <p:cNvPr id="64" name="Rectangle 63"/>
           <p:cNvSpPr/>
           <p:nvPr/>
         </p:nvSpPr>
@@ -26485,7 +26313,7 @@
       </p:sp>
       <p:sp>
         <p:nvSpPr>
-          <p:cNvPr id="66" name="TextBox 65"/>
+          <p:cNvPr id="65" name="TextBox 64"/>
           <p:cNvSpPr txBox="1"/>
           <p:nvPr/>
         </p:nvSpPr>
@@ -26520,7 +26348,7 @@
       </p:sp>
       <p:sp>
         <p:nvSpPr>
-          <p:cNvPr id="67" name="Rectangle 66"/>
+          <p:cNvPr id="66" name="Rectangle 65"/>
           <p:cNvSpPr/>
           <p:nvPr/>
         </p:nvSpPr>
@@ -26563,7 +26391,7 @@
       </p:sp>
       <p:sp>
         <p:nvSpPr>
-          <p:cNvPr id="68" name="TextBox 67"/>
+          <p:cNvPr id="67" name="TextBox 66"/>
           <p:cNvSpPr txBox="1"/>
           <p:nvPr/>
         </p:nvSpPr>
@@ -26598,7 +26426,7 @@
       </p:sp>
       <p:sp>
         <p:nvSpPr>
-          <p:cNvPr id="69" name="Rectangle 68"/>
+          <p:cNvPr id="68" name="Rectangle 67"/>
           <p:cNvSpPr/>
           <p:nvPr/>
         </p:nvSpPr>
@@ -26643,7 +26471,7 @@
       </p:sp>
       <p:sp>
         <p:nvSpPr>
-          <p:cNvPr id="70" name="TextBox 69"/>
+          <p:cNvPr id="69" name="TextBox 68"/>
           <p:cNvSpPr txBox="1"/>
           <p:nvPr/>
         </p:nvSpPr>
@@ -26678,7 +26506,7 @@
       </p:sp>
       <p:sp>
         <p:nvSpPr>
-          <p:cNvPr id="71" name="TextBox 70"/>
+          <p:cNvPr id="70" name="TextBox 69"/>
           <p:cNvSpPr txBox="1"/>
           <p:nvPr/>
         </p:nvSpPr>

</xml_diff>

<commit_message>
PPTX quality pass: fix filter bar overflow, ops/RACI overlap, legibility improvements
- Module slides: compact row height (0.31→0.29) and op spacing (0.30→0.27) so
  operations no longer overflow into the RACI strip on slides with 7 inputs + 6 ops
- Purpose column: bump font 7→7.5pt for improved readability
- Slide 9 filter bar: increase rect from 0.36→0.54" so both lines render cleanly
- Slide 9 external signals header: split into title (9pt) + subtitle (7.5pt light)
  instead of one long cramped line

Co-Authored-By: Claude Sonnet 4.6 <noreply@anthropic.com>
</commit_message>
<xml_diff>
--- a/mockups/mo_data_ops_kickoff.pptx
+++ b/mockups/mo_data_ops_kickoff.pptx
@@ -12573,7 +12573,7 @@
         <p:spPr>
           <a:xfrm>
             <a:off x="411480" y="1920240"/>
-            <a:ext cx="4572000" cy="283464"/>
+            <a:ext cx="4572000" cy="265176"/>
           </a:xfrm>
           <a:prstGeom prst="rect">
             <a:avLst/>
@@ -12617,8 +12617,8 @@
         </p:nvSpPr>
         <p:spPr>
           <a:xfrm>
-            <a:off x="484632" y="1975104"/>
-            <a:ext cx="2194560" cy="228600"/>
+            <a:off x="484632" y="1965960"/>
+            <a:ext cx="2194560" cy="219456"/>
           </a:xfrm>
           <a:prstGeom prst="rect">
             <a:avLst/>
@@ -12652,8 +12652,8 @@
         </p:nvSpPr>
         <p:spPr>
           <a:xfrm>
-            <a:off x="2770632" y="1975104"/>
-            <a:ext cx="914400" cy="228600"/>
+            <a:off x="2770632" y="1965960"/>
+            <a:ext cx="914400" cy="219456"/>
           </a:xfrm>
           <a:prstGeom prst="rect">
             <a:avLst/>
@@ -12687,23 +12687,23 @@
         </p:nvSpPr>
         <p:spPr>
           <a:xfrm>
-            <a:off x="3776472" y="1975104"/>
-            <a:ext cx="1115568" cy="228600"/>
-          </a:xfrm>
-          <a:prstGeom prst="rect">
-            <a:avLst/>
-          </a:prstGeom>
-          <a:noFill/>
-        </p:spPr>
-        <p:txBody>
-          <a:bodyPr wrap="square">
-            <a:spAutoFit/>
-          </a:bodyPr>
-          <a:lstStyle/>
-          <a:p>
-            <a:pPr algn="l"/>
-            <a:r>
-              <a:rPr sz="700" b="0" i="0">
+            <a:off x="3776472" y="1965960"/>
+            <a:ext cx="1115568" cy="219456"/>
+          </a:xfrm>
+          <a:prstGeom prst="rect">
+            <a:avLst/>
+          </a:prstGeom>
+          <a:noFill/>
+        </p:spPr>
+        <p:txBody>
+          <a:bodyPr wrap="square">
+            <a:spAutoFit/>
+          </a:bodyPr>
+          <a:lstStyle/>
+          <a:p>
+            <a:pPr algn="l"/>
+            <a:r>
+              <a:rPr sz="750" b="0" i="0">
                 <a:solidFill>
                   <a:srgbClr val="6B7FA0"/>
                 </a:solidFill>
@@ -12722,8 +12722,8 @@
         </p:nvSpPr>
         <p:spPr>
           <a:xfrm>
-            <a:off x="411480" y="2203704"/>
-            <a:ext cx="4572000" cy="283464"/>
+            <a:off x="411480" y="2185416"/>
+            <a:ext cx="4572000" cy="265176"/>
           </a:xfrm>
           <a:prstGeom prst="rect">
             <a:avLst/>
@@ -12767,8 +12767,8 @@
         </p:nvSpPr>
         <p:spPr>
           <a:xfrm>
-            <a:off x="484632" y="2258568"/>
-            <a:ext cx="2194560" cy="228600"/>
+            <a:off x="484632" y="2231136"/>
+            <a:ext cx="2194560" cy="219456"/>
           </a:xfrm>
           <a:prstGeom prst="rect">
             <a:avLst/>
@@ -12802,8 +12802,8 @@
         </p:nvSpPr>
         <p:spPr>
           <a:xfrm>
-            <a:off x="2770632" y="2258568"/>
-            <a:ext cx="914400" cy="228600"/>
+            <a:off x="2770632" y="2231136"/>
+            <a:ext cx="914400" cy="219456"/>
           </a:xfrm>
           <a:prstGeom prst="rect">
             <a:avLst/>
@@ -12837,23 +12837,23 @@
         </p:nvSpPr>
         <p:spPr>
           <a:xfrm>
-            <a:off x="3776472" y="2258568"/>
-            <a:ext cx="1115568" cy="228600"/>
-          </a:xfrm>
-          <a:prstGeom prst="rect">
-            <a:avLst/>
-          </a:prstGeom>
-          <a:noFill/>
-        </p:spPr>
-        <p:txBody>
-          <a:bodyPr wrap="square">
-            <a:spAutoFit/>
-          </a:bodyPr>
-          <a:lstStyle/>
-          <a:p>
-            <a:pPr algn="l"/>
-            <a:r>
-              <a:rPr sz="700" b="0" i="0">
+            <a:off x="3776472" y="2231136"/>
+            <a:ext cx="1115568" cy="219456"/>
+          </a:xfrm>
+          <a:prstGeom prst="rect">
+            <a:avLst/>
+          </a:prstGeom>
+          <a:noFill/>
+        </p:spPr>
+        <p:txBody>
+          <a:bodyPr wrap="square">
+            <a:spAutoFit/>
+          </a:bodyPr>
+          <a:lstStyle/>
+          <a:p>
+            <a:pPr algn="l"/>
+            <a:r>
+              <a:rPr sz="750" b="0" i="0">
                 <a:solidFill>
                   <a:srgbClr val="6B7FA0"/>
                 </a:solidFill>
@@ -12872,8 +12872,8 @@
         </p:nvSpPr>
         <p:spPr>
           <a:xfrm>
-            <a:off x="411480" y="2487168"/>
-            <a:ext cx="4572000" cy="283464"/>
+            <a:off x="411480" y="2450592"/>
+            <a:ext cx="4572000" cy="265176"/>
           </a:xfrm>
           <a:prstGeom prst="rect">
             <a:avLst/>
@@ -12917,8 +12917,8 @@
         </p:nvSpPr>
         <p:spPr>
           <a:xfrm>
-            <a:off x="484632" y="2542032"/>
-            <a:ext cx="2194560" cy="228600"/>
+            <a:off x="484632" y="2496312"/>
+            <a:ext cx="2194560" cy="219456"/>
           </a:xfrm>
           <a:prstGeom prst="rect">
             <a:avLst/>
@@ -12952,8 +12952,8 @@
         </p:nvSpPr>
         <p:spPr>
           <a:xfrm>
-            <a:off x="2770632" y="2542032"/>
-            <a:ext cx="914400" cy="228600"/>
+            <a:off x="2770632" y="2496312"/>
+            <a:ext cx="914400" cy="219456"/>
           </a:xfrm>
           <a:prstGeom prst="rect">
             <a:avLst/>
@@ -12987,23 +12987,23 @@
         </p:nvSpPr>
         <p:spPr>
           <a:xfrm>
-            <a:off x="3776472" y="2542032"/>
-            <a:ext cx="1115568" cy="228600"/>
-          </a:xfrm>
-          <a:prstGeom prst="rect">
-            <a:avLst/>
-          </a:prstGeom>
-          <a:noFill/>
-        </p:spPr>
-        <p:txBody>
-          <a:bodyPr wrap="square">
-            <a:spAutoFit/>
-          </a:bodyPr>
-          <a:lstStyle/>
-          <a:p>
-            <a:pPr algn="l"/>
-            <a:r>
-              <a:rPr sz="700" b="0" i="0">
+            <a:off x="3776472" y="2496312"/>
+            <a:ext cx="1115568" cy="219456"/>
+          </a:xfrm>
+          <a:prstGeom prst="rect">
+            <a:avLst/>
+          </a:prstGeom>
+          <a:noFill/>
+        </p:spPr>
+        <p:txBody>
+          <a:bodyPr wrap="square">
+            <a:spAutoFit/>
+          </a:bodyPr>
+          <a:lstStyle/>
+          <a:p>
+            <a:pPr algn="l"/>
+            <a:r>
+              <a:rPr sz="750" b="0" i="0">
                 <a:solidFill>
                   <a:srgbClr val="6B7FA0"/>
                 </a:solidFill>
@@ -13022,8 +13022,8 @@
         </p:nvSpPr>
         <p:spPr>
           <a:xfrm>
-            <a:off x="411480" y="2770632"/>
-            <a:ext cx="4572000" cy="283464"/>
+            <a:off x="411480" y="2715768"/>
+            <a:ext cx="4572000" cy="265176"/>
           </a:xfrm>
           <a:prstGeom prst="rect">
             <a:avLst/>
@@ -13067,8 +13067,8 @@
         </p:nvSpPr>
         <p:spPr>
           <a:xfrm>
-            <a:off x="484632" y="2825496"/>
-            <a:ext cx="2194560" cy="228600"/>
+            <a:off x="484632" y="2761488"/>
+            <a:ext cx="2194560" cy="219456"/>
           </a:xfrm>
           <a:prstGeom prst="rect">
             <a:avLst/>
@@ -13102,8 +13102,8 @@
         </p:nvSpPr>
         <p:spPr>
           <a:xfrm>
-            <a:off x="2770632" y="2825496"/>
-            <a:ext cx="914400" cy="228600"/>
+            <a:off x="2770632" y="2761488"/>
+            <a:ext cx="914400" cy="219456"/>
           </a:xfrm>
           <a:prstGeom prst="rect">
             <a:avLst/>
@@ -13137,23 +13137,23 @@
         </p:nvSpPr>
         <p:spPr>
           <a:xfrm>
-            <a:off x="3776472" y="2825496"/>
-            <a:ext cx="1115568" cy="228600"/>
-          </a:xfrm>
-          <a:prstGeom prst="rect">
-            <a:avLst/>
-          </a:prstGeom>
-          <a:noFill/>
-        </p:spPr>
-        <p:txBody>
-          <a:bodyPr wrap="square">
-            <a:spAutoFit/>
-          </a:bodyPr>
-          <a:lstStyle/>
-          <a:p>
-            <a:pPr algn="l"/>
-            <a:r>
-              <a:rPr sz="700" b="0" i="0">
+            <a:off x="3776472" y="2761488"/>
+            <a:ext cx="1115568" cy="219456"/>
+          </a:xfrm>
+          <a:prstGeom prst="rect">
+            <a:avLst/>
+          </a:prstGeom>
+          <a:noFill/>
+        </p:spPr>
+        <p:txBody>
+          <a:bodyPr wrap="square">
+            <a:spAutoFit/>
+          </a:bodyPr>
+          <a:lstStyle/>
+          <a:p>
+            <a:pPr algn="l"/>
+            <a:r>
+              <a:rPr sz="750" b="0" i="0">
                 <a:solidFill>
                   <a:srgbClr val="6B7FA0"/>
                 </a:solidFill>
@@ -13172,8 +13172,8 @@
         </p:nvSpPr>
         <p:spPr>
           <a:xfrm>
-            <a:off x="411480" y="3054096"/>
-            <a:ext cx="4572000" cy="283464"/>
+            <a:off x="411480" y="2980944"/>
+            <a:ext cx="4572000" cy="265176"/>
           </a:xfrm>
           <a:prstGeom prst="rect">
             <a:avLst/>
@@ -13217,8 +13217,8 @@
         </p:nvSpPr>
         <p:spPr>
           <a:xfrm>
-            <a:off x="484632" y="3108960"/>
-            <a:ext cx="2194560" cy="228600"/>
+            <a:off x="484632" y="3026664"/>
+            <a:ext cx="2194560" cy="219456"/>
           </a:xfrm>
           <a:prstGeom prst="rect">
             <a:avLst/>
@@ -13252,8 +13252,8 @@
         </p:nvSpPr>
         <p:spPr>
           <a:xfrm>
-            <a:off x="2770632" y="3108960"/>
-            <a:ext cx="914400" cy="228600"/>
+            <a:off x="2770632" y="3026664"/>
+            <a:ext cx="914400" cy="219456"/>
           </a:xfrm>
           <a:prstGeom prst="rect">
             <a:avLst/>
@@ -13287,23 +13287,23 @@
         </p:nvSpPr>
         <p:spPr>
           <a:xfrm>
-            <a:off x="3776472" y="3108960"/>
-            <a:ext cx="1115568" cy="228600"/>
-          </a:xfrm>
-          <a:prstGeom prst="rect">
-            <a:avLst/>
-          </a:prstGeom>
-          <a:noFill/>
-        </p:spPr>
-        <p:txBody>
-          <a:bodyPr wrap="square">
-            <a:spAutoFit/>
-          </a:bodyPr>
-          <a:lstStyle/>
-          <a:p>
-            <a:pPr algn="l"/>
-            <a:r>
-              <a:rPr sz="700" b="0" i="0">
+            <a:off x="3776472" y="3026664"/>
+            <a:ext cx="1115568" cy="219456"/>
+          </a:xfrm>
+          <a:prstGeom prst="rect">
+            <a:avLst/>
+          </a:prstGeom>
+          <a:noFill/>
+        </p:spPr>
+        <p:txBody>
+          <a:bodyPr wrap="square">
+            <a:spAutoFit/>
+          </a:bodyPr>
+          <a:lstStyle/>
+          <a:p>
+            <a:pPr algn="l"/>
+            <a:r>
+              <a:rPr sz="750" b="0" i="0">
                 <a:solidFill>
                   <a:srgbClr val="6B7FA0"/>
                 </a:solidFill>
@@ -13322,8 +13322,8 @@
         </p:nvSpPr>
         <p:spPr>
           <a:xfrm>
-            <a:off x="411480" y="3337560"/>
-            <a:ext cx="4572000" cy="283464"/>
+            <a:off x="411480" y="3246120"/>
+            <a:ext cx="4572000" cy="265176"/>
           </a:xfrm>
           <a:prstGeom prst="rect">
             <a:avLst/>
@@ -13367,8 +13367,8 @@
         </p:nvSpPr>
         <p:spPr>
           <a:xfrm>
-            <a:off x="484632" y="3392424"/>
-            <a:ext cx="2194560" cy="228600"/>
+            <a:off x="484632" y="3291840"/>
+            <a:ext cx="2194560" cy="219456"/>
           </a:xfrm>
           <a:prstGeom prst="rect">
             <a:avLst/>
@@ -13402,8 +13402,8 @@
         </p:nvSpPr>
         <p:spPr>
           <a:xfrm>
-            <a:off x="2770632" y="3392424"/>
-            <a:ext cx="914400" cy="228600"/>
+            <a:off x="2770632" y="3291840"/>
+            <a:ext cx="914400" cy="219456"/>
           </a:xfrm>
           <a:prstGeom prst="rect">
             <a:avLst/>
@@ -13437,23 +13437,23 @@
         </p:nvSpPr>
         <p:spPr>
           <a:xfrm>
-            <a:off x="3776472" y="3392424"/>
-            <a:ext cx="1115568" cy="228600"/>
-          </a:xfrm>
-          <a:prstGeom prst="rect">
-            <a:avLst/>
-          </a:prstGeom>
-          <a:noFill/>
-        </p:spPr>
-        <p:txBody>
-          <a:bodyPr wrap="square">
-            <a:spAutoFit/>
-          </a:bodyPr>
-          <a:lstStyle/>
-          <a:p>
-            <a:pPr algn="l"/>
-            <a:r>
-              <a:rPr sz="700" b="0" i="0">
+            <a:off x="3776472" y="3291840"/>
+            <a:ext cx="1115568" cy="219456"/>
+          </a:xfrm>
+          <a:prstGeom prst="rect">
+            <a:avLst/>
+          </a:prstGeom>
+          <a:noFill/>
+        </p:spPr>
+        <p:txBody>
+          <a:bodyPr wrap="square">
+            <a:spAutoFit/>
+          </a:bodyPr>
+          <a:lstStyle/>
+          <a:p>
+            <a:pPr algn="l"/>
+            <a:r>
+              <a:rPr sz="750" b="0" i="0">
                 <a:solidFill>
                   <a:srgbClr val="6B7FA0"/>
                 </a:solidFill>
@@ -13472,8 +13472,8 @@
         </p:nvSpPr>
         <p:spPr>
           <a:xfrm>
-            <a:off x="411480" y="3621024"/>
-            <a:ext cx="4572000" cy="283464"/>
+            <a:off x="411480" y="3511296"/>
+            <a:ext cx="4572000" cy="265176"/>
           </a:xfrm>
           <a:prstGeom prst="rect">
             <a:avLst/>
@@ -13517,8 +13517,8 @@
         </p:nvSpPr>
         <p:spPr>
           <a:xfrm>
-            <a:off x="484632" y="3675888"/>
-            <a:ext cx="2194560" cy="228600"/>
+            <a:off x="484632" y="3557016"/>
+            <a:ext cx="2194560" cy="219456"/>
           </a:xfrm>
           <a:prstGeom prst="rect">
             <a:avLst/>
@@ -13552,8 +13552,8 @@
         </p:nvSpPr>
         <p:spPr>
           <a:xfrm>
-            <a:off x="2770632" y="3675888"/>
-            <a:ext cx="914400" cy="228600"/>
+            <a:off x="2770632" y="3557016"/>
+            <a:ext cx="914400" cy="219456"/>
           </a:xfrm>
           <a:prstGeom prst="rect">
             <a:avLst/>
@@ -13587,23 +13587,23 @@
         </p:nvSpPr>
         <p:spPr>
           <a:xfrm>
-            <a:off x="3776472" y="3675888"/>
-            <a:ext cx="1115568" cy="228600"/>
-          </a:xfrm>
-          <a:prstGeom prst="rect">
-            <a:avLst/>
-          </a:prstGeom>
-          <a:noFill/>
-        </p:spPr>
-        <p:txBody>
-          <a:bodyPr wrap="square">
-            <a:spAutoFit/>
-          </a:bodyPr>
-          <a:lstStyle/>
-          <a:p>
-            <a:pPr algn="l"/>
-            <a:r>
-              <a:rPr sz="700" b="0" i="0">
+            <a:off x="3776472" y="3557016"/>
+            <a:ext cx="1115568" cy="219456"/>
+          </a:xfrm>
+          <a:prstGeom prst="rect">
+            <a:avLst/>
+          </a:prstGeom>
+          <a:noFill/>
+        </p:spPr>
+        <p:txBody>
+          <a:bodyPr wrap="square">
+            <a:spAutoFit/>
+          </a:bodyPr>
+          <a:lstStyle/>
+          <a:p>
+            <a:pPr algn="l"/>
+            <a:r>
+              <a:rPr sz="750" b="0" i="0">
                 <a:solidFill>
                   <a:srgbClr val="6B7FA0"/>
                 </a:solidFill>
@@ -13622,7 +13622,7 @@
         </p:nvSpPr>
         <p:spPr>
           <a:xfrm>
-            <a:off x="411480" y="4014216"/>
+            <a:off x="411480" y="3849624"/>
             <a:ext cx="4572000" cy="256032"/>
           </a:xfrm>
           <a:prstGeom prst="rect">
@@ -13665,7 +13665,7 @@
         </p:nvSpPr>
         <p:spPr>
           <a:xfrm>
-            <a:off x="502920" y="4050792"/>
+            <a:off x="502920" y="3886200"/>
             <a:ext cx="4389120" cy="201168"/>
           </a:xfrm>
           <a:prstGeom prst="rect">
@@ -13700,7 +13700,7 @@
         </p:nvSpPr>
         <p:spPr>
           <a:xfrm>
-            <a:off x="502920" y="4361688"/>
+            <a:off x="502920" y="4187952"/>
             <a:ext cx="73152" cy="73152"/>
           </a:xfrm>
           <a:prstGeom prst="rect">
@@ -13743,8 +13743,8 @@
         </p:nvSpPr>
         <p:spPr>
           <a:xfrm>
-            <a:off x="667512" y="4288536"/>
-            <a:ext cx="4224528" cy="274320"/>
+            <a:off x="667512" y="4123944"/>
+            <a:ext cx="4224528" cy="237744"/>
           </a:xfrm>
           <a:prstGeom prst="rect">
             <a:avLst/>
@@ -13778,7 +13778,7 @@
         </p:nvSpPr>
         <p:spPr>
           <a:xfrm>
-            <a:off x="502920" y="4636008"/>
+            <a:off x="502920" y="4434840"/>
             <a:ext cx="73152" cy="73152"/>
           </a:xfrm>
           <a:prstGeom prst="rect">
@@ -13821,8 +13821,8 @@
         </p:nvSpPr>
         <p:spPr>
           <a:xfrm>
-            <a:off x="667512" y="4562856"/>
-            <a:ext cx="4224528" cy="274320"/>
+            <a:off x="667512" y="4370831"/>
+            <a:ext cx="4224528" cy="237744"/>
           </a:xfrm>
           <a:prstGeom prst="rect">
             <a:avLst/>
@@ -13856,7 +13856,7 @@
         </p:nvSpPr>
         <p:spPr>
           <a:xfrm>
-            <a:off x="502920" y="4910328"/>
+            <a:off x="502920" y="4681727"/>
             <a:ext cx="73152" cy="73152"/>
           </a:xfrm>
           <a:prstGeom prst="rect">
@@ -13899,8 +13899,8 @@
         </p:nvSpPr>
         <p:spPr>
           <a:xfrm>
-            <a:off x="667512" y="4837176"/>
-            <a:ext cx="4224528" cy="274320"/>
+            <a:off x="667512" y="4617719"/>
+            <a:ext cx="4224528" cy="237744"/>
           </a:xfrm>
           <a:prstGeom prst="rect">
             <a:avLst/>
@@ -13934,7 +13934,7 @@
         </p:nvSpPr>
         <p:spPr>
           <a:xfrm>
-            <a:off x="502920" y="5184648"/>
+            <a:off x="502920" y="4928615"/>
             <a:ext cx="73152" cy="73152"/>
           </a:xfrm>
           <a:prstGeom prst="rect">
@@ -13977,8 +13977,8 @@
         </p:nvSpPr>
         <p:spPr>
           <a:xfrm>
-            <a:off x="667512" y="5111496"/>
-            <a:ext cx="4224528" cy="274320"/>
+            <a:off x="667512" y="4864607"/>
+            <a:ext cx="4224528" cy="237744"/>
           </a:xfrm>
           <a:prstGeom prst="rect">
             <a:avLst/>
@@ -14012,7 +14012,7 @@
         </p:nvSpPr>
         <p:spPr>
           <a:xfrm>
-            <a:off x="502920" y="5458968"/>
+            <a:off x="502920" y="5175503"/>
             <a:ext cx="73152" cy="73152"/>
           </a:xfrm>
           <a:prstGeom prst="rect">
@@ -14055,8 +14055,8 @@
         </p:nvSpPr>
         <p:spPr>
           <a:xfrm>
-            <a:off x="667512" y="5385816"/>
-            <a:ext cx="4224528" cy="274320"/>
+            <a:off x="667512" y="5111495"/>
+            <a:ext cx="4224528" cy="237744"/>
           </a:xfrm>
           <a:prstGeom prst="rect">
             <a:avLst/>
@@ -14090,7 +14090,7 @@
         </p:nvSpPr>
         <p:spPr>
           <a:xfrm>
-            <a:off x="502920" y="5733288"/>
+            <a:off x="502920" y="5422391"/>
             <a:ext cx="73152" cy="73152"/>
           </a:xfrm>
           <a:prstGeom prst="rect">
@@ -14133,8 +14133,8 @@
         </p:nvSpPr>
         <p:spPr>
           <a:xfrm>
-            <a:off x="667512" y="5660136"/>
-            <a:ext cx="4224528" cy="274320"/>
+            <a:off x="667512" y="5358383"/>
+            <a:ext cx="4224528" cy="237744"/>
           </a:xfrm>
           <a:prstGeom prst="rect">
             <a:avLst/>
@@ -15594,7 +15594,7 @@
         <p:spPr>
           <a:xfrm>
             <a:off x="411480" y="1920240"/>
-            <a:ext cx="4572000" cy="283464"/>
+            <a:ext cx="4572000" cy="265176"/>
           </a:xfrm>
           <a:prstGeom prst="rect">
             <a:avLst/>
@@ -15638,8 +15638,8 @@
         </p:nvSpPr>
         <p:spPr>
           <a:xfrm>
-            <a:off x="484632" y="1975104"/>
-            <a:ext cx="2194560" cy="228600"/>
+            <a:off x="484632" y="1965960"/>
+            <a:ext cx="2194560" cy="219456"/>
           </a:xfrm>
           <a:prstGeom prst="rect">
             <a:avLst/>
@@ -15673,8 +15673,8 @@
         </p:nvSpPr>
         <p:spPr>
           <a:xfrm>
-            <a:off x="2770632" y="1975104"/>
-            <a:ext cx="914400" cy="228600"/>
+            <a:off x="2770632" y="1965960"/>
+            <a:ext cx="914400" cy="219456"/>
           </a:xfrm>
           <a:prstGeom prst="rect">
             <a:avLst/>
@@ -15708,23 +15708,23 @@
         </p:nvSpPr>
         <p:spPr>
           <a:xfrm>
-            <a:off x="3776472" y="1975104"/>
-            <a:ext cx="1115568" cy="228600"/>
-          </a:xfrm>
-          <a:prstGeom prst="rect">
-            <a:avLst/>
-          </a:prstGeom>
-          <a:noFill/>
-        </p:spPr>
-        <p:txBody>
-          <a:bodyPr wrap="square">
-            <a:spAutoFit/>
-          </a:bodyPr>
-          <a:lstStyle/>
-          <a:p>
-            <a:pPr algn="l"/>
-            <a:r>
-              <a:rPr sz="700" b="0" i="0">
+            <a:off x="3776472" y="1965960"/>
+            <a:ext cx="1115568" cy="219456"/>
+          </a:xfrm>
+          <a:prstGeom prst="rect">
+            <a:avLst/>
+          </a:prstGeom>
+          <a:noFill/>
+        </p:spPr>
+        <p:txBody>
+          <a:bodyPr wrap="square">
+            <a:spAutoFit/>
+          </a:bodyPr>
+          <a:lstStyle/>
+          <a:p>
+            <a:pPr algn="l"/>
+            <a:r>
+              <a:rPr sz="750" b="0" i="0">
                 <a:solidFill>
                   <a:srgbClr val="6B7FA0"/>
                 </a:solidFill>
@@ -15743,8 +15743,8 @@
         </p:nvSpPr>
         <p:spPr>
           <a:xfrm>
-            <a:off x="411480" y="2203704"/>
-            <a:ext cx="4572000" cy="283464"/>
+            <a:off x="411480" y="2185416"/>
+            <a:ext cx="4572000" cy="265176"/>
           </a:xfrm>
           <a:prstGeom prst="rect">
             <a:avLst/>
@@ -15788,8 +15788,8 @@
         </p:nvSpPr>
         <p:spPr>
           <a:xfrm>
-            <a:off x="484632" y="2258568"/>
-            <a:ext cx="2194560" cy="228600"/>
+            <a:off x="484632" y="2231136"/>
+            <a:ext cx="2194560" cy="219456"/>
           </a:xfrm>
           <a:prstGeom prst="rect">
             <a:avLst/>
@@ -15823,8 +15823,8 @@
         </p:nvSpPr>
         <p:spPr>
           <a:xfrm>
-            <a:off x="2770632" y="2258568"/>
-            <a:ext cx="914400" cy="228600"/>
+            <a:off x="2770632" y="2231136"/>
+            <a:ext cx="914400" cy="219456"/>
           </a:xfrm>
           <a:prstGeom prst="rect">
             <a:avLst/>
@@ -15858,23 +15858,23 @@
         </p:nvSpPr>
         <p:spPr>
           <a:xfrm>
-            <a:off x="3776472" y="2258568"/>
-            <a:ext cx="1115568" cy="228600"/>
-          </a:xfrm>
-          <a:prstGeom prst="rect">
-            <a:avLst/>
-          </a:prstGeom>
-          <a:noFill/>
-        </p:spPr>
-        <p:txBody>
-          <a:bodyPr wrap="square">
-            <a:spAutoFit/>
-          </a:bodyPr>
-          <a:lstStyle/>
-          <a:p>
-            <a:pPr algn="l"/>
-            <a:r>
-              <a:rPr sz="700" b="0" i="0">
+            <a:off x="3776472" y="2231136"/>
+            <a:ext cx="1115568" cy="219456"/>
+          </a:xfrm>
+          <a:prstGeom prst="rect">
+            <a:avLst/>
+          </a:prstGeom>
+          <a:noFill/>
+        </p:spPr>
+        <p:txBody>
+          <a:bodyPr wrap="square">
+            <a:spAutoFit/>
+          </a:bodyPr>
+          <a:lstStyle/>
+          <a:p>
+            <a:pPr algn="l"/>
+            <a:r>
+              <a:rPr sz="750" b="0" i="0">
                 <a:solidFill>
                   <a:srgbClr val="6B7FA0"/>
                 </a:solidFill>
@@ -15893,8 +15893,8 @@
         </p:nvSpPr>
         <p:spPr>
           <a:xfrm>
-            <a:off x="411480" y="2487168"/>
-            <a:ext cx="4572000" cy="283464"/>
+            <a:off x="411480" y="2450592"/>
+            <a:ext cx="4572000" cy="265176"/>
           </a:xfrm>
           <a:prstGeom prst="rect">
             <a:avLst/>
@@ -15938,8 +15938,8 @@
         </p:nvSpPr>
         <p:spPr>
           <a:xfrm>
-            <a:off x="484632" y="2542032"/>
-            <a:ext cx="2194560" cy="228600"/>
+            <a:off x="484632" y="2496312"/>
+            <a:ext cx="2194560" cy="219456"/>
           </a:xfrm>
           <a:prstGeom prst="rect">
             <a:avLst/>
@@ -15973,8 +15973,8 @@
         </p:nvSpPr>
         <p:spPr>
           <a:xfrm>
-            <a:off x="2770632" y="2542032"/>
-            <a:ext cx="914400" cy="228600"/>
+            <a:off x="2770632" y="2496312"/>
+            <a:ext cx="914400" cy="219456"/>
           </a:xfrm>
           <a:prstGeom prst="rect">
             <a:avLst/>
@@ -16008,23 +16008,23 @@
         </p:nvSpPr>
         <p:spPr>
           <a:xfrm>
-            <a:off x="3776472" y="2542032"/>
-            <a:ext cx="1115568" cy="228600"/>
-          </a:xfrm>
-          <a:prstGeom prst="rect">
-            <a:avLst/>
-          </a:prstGeom>
-          <a:noFill/>
-        </p:spPr>
-        <p:txBody>
-          <a:bodyPr wrap="square">
-            <a:spAutoFit/>
-          </a:bodyPr>
-          <a:lstStyle/>
-          <a:p>
-            <a:pPr algn="l"/>
-            <a:r>
-              <a:rPr sz="700" b="0" i="0">
+            <a:off x="3776472" y="2496312"/>
+            <a:ext cx="1115568" cy="219456"/>
+          </a:xfrm>
+          <a:prstGeom prst="rect">
+            <a:avLst/>
+          </a:prstGeom>
+          <a:noFill/>
+        </p:spPr>
+        <p:txBody>
+          <a:bodyPr wrap="square">
+            <a:spAutoFit/>
+          </a:bodyPr>
+          <a:lstStyle/>
+          <a:p>
+            <a:pPr algn="l"/>
+            <a:r>
+              <a:rPr sz="750" b="0" i="0">
                 <a:solidFill>
                   <a:srgbClr val="6B7FA0"/>
                 </a:solidFill>
@@ -16043,8 +16043,8 @@
         </p:nvSpPr>
         <p:spPr>
           <a:xfrm>
-            <a:off x="411480" y="2770632"/>
-            <a:ext cx="4572000" cy="283464"/>
+            <a:off x="411480" y="2715768"/>
+            <a:ext cx="4572000" cy="265176"/>
           </a:xfrm>
           <a:prstGeom prst="rect">
             <a:avLst/>
@@ -16088,8 +16088,8 @@
         </p:nvSpPr>
         <p:spPr>
           <a:xfrm>
-            <a:off x="484632" y="2825496"/>
-            <a:ext cx="2194560" cy="228600"/>
+            <a:off x="484632" y="2761488"/>
+            <a:ext cx="2194560" cy="219456"/>
           </a:xfrm>
           <a:prstGeom prst="rect">
             <a:avLst/>
@@ -16123,8 +16123,8 @@
         </p:nvSpPr>
         <p:spPr>
           <a:xfrm>
-            <a:off x="2770632" y="2825496"/>
-            <a:ext cx="914400" cy="228600"/>
+            <a:off x="2770632" y="2761488"/>
+            <a:ext cx="914400" cy="219456"/>
           </a:xfrm>
           <a:prstGeom prst="rect">
             <a:avLst/>
@@ -16158,23 +16158,23 @@
         </p:nvSpPr>
         <p:spPr>
           <a:xfrm>
-            <a:off x="3776472" y="2825496"/>
-            <a:ext cx="1115568" cy="228600"/>
-          </a:xfrm>
-          <a:prstGeom prst="rect">
-            <a:avLst/>
-          </a:prstGeom>
-          <a:noFill/>
-        </p:spPr>
-        <p:txBody>
-          <a:bodyPr wrap="square">
-            <a:spAutoFit/>
-          </a:bodyPr>
-          <a:lstStyle/>
-          <a:p>
-            <a:pPr algn="l"/>
-            <a:r>
-              <a:rPr sz="700" b="0" i="0">
+            <a:off x="3776472" y="2761488"/>
+            <a:ext cx="1115568" cy="219456"/>
+          </a:xfrm>
+          <a:prstGeom prst="rect">
+            <a:avLst/>
+          </a:prstGeom>
+          <a:noFill/>
+        </p:spPr>
+        <p:txBody>
+          <a:bodyPr wrap="square">
+            <a:spAutoFit/>
+          </a:bodyPr>
+          <a:lstStyle/>
+          <a:p>
+            <a:pPr algn="l"/>
+            <a:r>
+              <a:rPr sz="750" b="0" i="0">
                 <a:solidFill>
                   <a:srgbClr val="6B7FA0"/>
                 </a:solidFill>
@@ -16193,8 +16193,8 @@
         </p:nvSpPr>
         <p:spPr>
           <a:xfrm>
-            <a:off x="411480" y="3054096"/>
-            <a:ext cx="4572000" cy="283464"/>
+            <a:off x="411480" y="2980944"/>
+            <a:ext cx="4572000" cy="265176"/>
           </a:xfrm>
           <a:prstGeom prst="rect">
             <a:avLst/>
@@ -16238,8 +16238,8 @@
         </p:nvSpPr>
         <p:spPr>
           <a:xfrm>
-            <a:off x="484632" y="3108960"/>
-            <a:ext cx="2194560" cy="228600"/>
+            <a:off x="484632" y="3026664"/>
+            <a:ext cx="2194560" cy="219456"/>
           </a:xfrm>
           <a:prstGeom prst="rect">
             <a:avLst/>
@@ -16273,8 +16273,8 @@
         </p:nvSpPr>
         <p:spPr>
           <a:xfrm>
-            <a:off x="2770632" y="3108960"/>
-            <a:ext cx="914400" cy="228600"/>
+            <a:off x="2770632" y="3026664"/>
+            <a:ext cx="914400" cy="219456"/>
           </a:xfrm>
           <a:prstGeom prst="rect">
             <a:avLst/>
@@ -16308,23 +16308,23 @@
         </p:nvSpPr>
         <p:spPr>
           <a:xfrm>
-            <a:off x="3776472" y="3108960"/>
-            <a:ext cx="1115568" cy="228600"/>
-          </a:xfrm>
-          <a:prstGeom prst="rect">
-            <a:avLst/>
-          </a:prstGeom>
-          <a:noFill/>
-        </p:spPr>
-        <p:txBody>
-          <a:bodyPr wrap="square">
-            <a:spAutoFit/>
-          </a:bodyPr>
-          <a:lstStyle/>
-          <a:p>
-            <a:pPr algn="l"/>
-            <a:r>
-              <a:rPr sz="700" b="0" i="0">
+            <a:off x="3776472" y="3026664"/>
+            <a:ext cx="1115568" cy="219456"/>
+          </a:xfrm>
+          <a:prstGeom prst="rect">
+            <a:avLst/>
+          </a:prstGeom>
+          <a:noFill/>
+        </p:spPr>
+        <p:txBody>
+          <a:bodyPr wrap="square">
+            <a:spAutoFit/>
+          </a:bodyPr>
+          <a:lstStyle/>
+          <a:p>
+            <a:pPr algn="l"/>
+            <a:r>
+              <a:rPr sz="750" b="0" i="0">
                 <a:solidFill>
                   <a:srgbClr val="6B7FA0"/>
                 </a:solidFill>
@@ -16343,8 +16343,8 @@
         </p:nvSpPr>
         <p:spPr>
           <a:xfrm>
-            <a:off x="411480" y="3337560"/>
-            <a:ext cx="4572000" cy="283464"/>
+            <a:off x="411480" y="3246120"/>
+            <a:ext cx="4572000" cy="265176"/>
           </a:xfrm>
           <a:prstGeom prst="rect">
             <a:avLst/>
@@ -16388,8 +16388,8 @@
         </p:nvSpPr>
         <p:spPr>
           <a:xfrm>
-            <a:off x="484632" y="3392424"/>
-            <a:ext cx="2194560" cy="228600"/>
+            <a:off x="484632" y="3291840"/>
+            <a:ext cx="2194560" cy="219456"/>
           </a:xfrm>
           <a:prstGeom prst="rect">
             <a:avLst/>
@@ -16423,8 +16423,8 @@
         </p:nvSpPr>
         <p:spPr>
           <a:xfrm>
-            <a:off x="2770632" y="3392424"/>
-            <a:ext cx="914400" cy="228600"/>
+            <a:off x="2770632" y="3291840"/>
+            <a:ext cx="914400" cy="219456"/>
           </a:xfrm>
           <a:prstGeom prst="rect">
             <a:avLst/>
@@ -16458,23 +16458,23 @@
         </p:nvSpPr>
         <p:spPr>
           <a:xfrm>
-            <a:off x="3776472" y="3392424"/>
-            <a:ext cx="1115568" cy="228600"/>
-          </a:xfrm>
-          <a:prstGeom prst="rect">
-            <a:avLst/>
-          </a:prstGeom>
-          <a:noFill/>
-        </p:spPr>
-        <p:txBody>
-          <a:bodyPr wrap="square">
-            <a:spAutoFit/>
-          </a:bodyPr>
-          <a:lstStyle/>
-          <a:p>
-            <a:pPr algn="l"/>
-            <a:r>
-              <a:rPr sz="700" b="0" i="0">
+            <a:off x="3776472" y="3291840"/>
+            <a:ext cx="1115568" cy="219456"/>
+          </a:xfrm>
+          <a:prstGeom prst="rect">
+            <a:avLst/>
+          </a:prstGeom>
+          <a:noFill/>
+        </p:spPr>
+        <p:txBody>
+          <a:bodyPr wrap="square">
+            <a:spAutoFit/>
+          </a:bodyPr>
+          <a:lstStyle/>
+          <a:p>
+            <a:pPr algn="l"/>
+            <a:r>
+              <a:rPr sz="750" b="0" i="0">
                 <a:solidFill>
                   <a:srgbClr val="6B7FA0"/>
                 </a:solidFill>
@@ -16493,8 +16493,8 @@
         </p:nvSpPr>
         <p:spPr>
           <a:xfrm>
-            <a:off x="411480" y="3621024"/>
-            <a:ext cx="4572000" cy="283464"/>
+            <a:off x="411480" y="3511296"/>
+            <a:ext cx="4572000" cy="265176"/>
           </a:xfrm>
           <a:prstGeom prst="rect">
             <a:avLst/>
@@ -16538,8 +16538,8 @@
         </p:nvSpPr>
         <p:spPr>
           <a:xfrm>
-            <a:off x="484632" y="3675888"/>
-            <a:ext cx="2194560" cy="228600"/>
+            <a:off x="484632" y="3557016"/>
+            <a:ext cx="2194560" cy="219456"/>
           </a:xfrm>
           <a:prstGeom prst="rect">
             <a:avLst/>
@@ -16573,8 +16573,8 @@
         </p:nvSpPr>
         <p:spPr>
           <a:xfrm>
-            <a:off x="2770632" y="3675888"/>
-            <a:ext cx="914400" cy="228600"/>
+            <a:off x="2770632" y="3557016"/>
+            <a:ext cx="914400" cy="219456"/>
           </a:xfrm>
           <a:prstGeom prst="rect">
             <a:avLst/>
@@ -16608,23 +16608,23 @@
         </p:nvSpPr>
         <p:spPr>
           <a:xfrm>
-            <a:off x="3776472" y="3675888"/>
-            <a:ext cx="1115568" cy="228600"/>
-          </a:xfrm>
-          <a:prstGeom prst="rect">
-            <a:avLst/>
-          </a:prstGeom>
-          <a:noFill/>
-        </p:spPr>
-        <p:txBody>
-          <a:bodyPr wrap="square">
-            <a:spAutoFit/>
-          </a:bodyPr>
-          <a:lstStyle/>
-          <a:p>
-            <a:pPr algn="l"/>
-            <a:r>
-              <a:rPr sz="700" b="0" i="0">
+            <a:off x="3776472" y="3557016"/>
+            <a:ext cx="1115568" cy="219456"/>
+          </a:xfrm>
+          <a:prstGeom prst="rect">
+            <a:avLst/>
+          </a:prstGeom>
+          <a:noFill/>
+        </p:spPr>
+        <p:txBody>
+          <a:bodyPr wrap="square">
+            <a:spAutoFit/>
+          </a:bodyPr>
+          <a:lstStyle/>
+          <a:p>
+            <a:pPr algn="l"/>
+            <a:r>
+              <a:rPr sz="750" b="0" i="0">
                 <a:solidFill>
                   <a:srgbClr val="6B7FA0"/>
                 </a:solidFill>
@@ -16643,7 +16643,7 @@
         </p:nvSpPr>
         <p:spPr>
           <a:xfrm>
-            <a:off x="411480" y="4014216"/>
+            <a:off x="411480" y="3849624"/>
             <a:ext cx="4572000" cy="256032"/>
           </a:xfrm>
           <a:prstGeom prst="rect">
@@ -16686,7 +16686,7 @@
         </p:nvSpPr>
         <p:spPr>
           <a:xfrm>
-            <a:off x="502920" y="4050792"/>
+            <a:off x="502920" y="3886200"/>
             <a:ext cx="4389120" cy="201168"/>
           </a:xfrm>
           <a:prstGeom prst="rect">
@@ -16721,7 +16721,7 @@
         </p:nvSpPr>
         <p:spPr>
           <a:xfrm>
-            <a:off x="502920" y="4361688"/>
+            <a:off x="502920" y="4187952"/>
             <a:ext cx="73152" cy="73152"/>
           </a:xfrm>
           <a:prstGeom prst="rect">
@@ -16764,8 +16764,8 @@
         </p:nvSpPr>
         <p:spPr>
           <a:xfrm>
-            <a:off x="667512" y="4288536"/>
-            <a:ext cx="4224528" cy="274320"/>
+            <a:off x="667512" y="4123944"/>
+            <a:ext cx="4224528" cy="237744"/>
           </a:xfrm>
           <a:prstGeom prst="rect">
             <a:avLst/>
@@ -16799,7 +16799,7 @@
         </p:nvSpPr>
         <p:spPr>
           <a:xfrm>
-            <a:off x="502920" y="4636008"/>
+            <a:off x="502920" y="4434840"/>
             <a:ext cx="73152" cy="73152"/>
           </a:xfrm>
           <a:prstGeom prst="rect">
@@ -16842,8 +16842,8 @@
         </p:nvSpPr>
         <p:spPr>
           <a:xfrm>
-            <a:off x="667512" y="4562856"/>
-            <a:ext cx="4224528" cy="274320"/>
+            <a:off x="667512" y="4370831"/>
+            <a:ext cx="4224528" cy="237744"/>
           </a:xfrm>
           <a:prstGeom prst="rect">
             <a:avLst/>
@@ -16877,7 +16877,7 @@
         </p:nvSpPr>
         <p:spPr>
           <a:xfrm>
-            <a:off x="502920" y="4910328"/>
+            <a:off x="502920" y="4681727"/>
             <a:ext cx="73152" cy="73152"/>
           </a:xfrm>
           <a:prstGeom prst="rect">
@@ -16920,8 +16920,8 @@
         </p:nvSpPr>
         <p:spPr>
           <a:xfrm>
-            <a:off x="667512" y="4837176"/>
-            <a:ext cx="4224528" cy="274320"/>
+            <a:off x="667512" y="4617719"/>
+            <a:ext cx="4224528" cy="237744"/>
           </a:xfrm>
           <a:prstGeom prst="rect">
             <a:avLst/>
@@ -16955,7 +16955,7 @@
         </p:nvSpPr>
         <p:spPr>
           <a:xfrm>
-            <a:off x="502920" y="5184648"/>
+            <a:off x="502920" y="4928615"/>
             <a:ext cx="73152" cy="73152"/>
           </a:xfrm>
           <a:prstGeom prst="rect">
@@ -16998,8 +16998,8 @@
         </p:nvSpPr>
         <p:spPr>
           <a:xfrm>
-            <a:off x="667512" y="5111496"/>
-            <a:ext cx="4224528" cy="274320"/>
+            <a:off x="667512" y="4864607"/>
+            <a:ext cx="4224528" cy="237744"/>
           </a:xfrm>
           <a:prstGeom prst="rect">
             <a:avLst/>
@@ -17033,7 +17033,7 @@
         </p:nvSpPr>
         <p:spPr>
           <a:xfrm>
-            <a:off x="502920" y="5458968"/>
+            <a:off x="502920" y="5175503"/>
             <a:ext cx="73152" cy="73152"/>
           </a:xfrm>
           <a:prstGeom prst="rect">
@@ -17076,8 +17076,8 @@
         </p:nvSpPr>
         <p:spPr>
           <a:xfrm>
-            <a:off x="667512" y="5385816"/>
-            <a:ext cx="4224528" cy="274320"/>
+            <a:off x="667512" y="5111495"/>
+            <a:ext cx="4224528" cy="237744"/>
           </a:xfrm>
           <a:prstGeom prst="rect">
             <a:avLst/>
@@ -17111,7 +17111,7 @@
         </p:nvSpPr>
         <p:spPr>
           <a:xfrm>
-            <a:off x="502920" y="5733288"/>
+            <a:off x="502920" y="5422391"/>
             <a:ext cx="73152" cy="73152"/>
           </a:xfrm>
           <a:prstGeom prst="rect">
@@ -17154,8 +17154,8 @@
         </p:nvSpPr>
         <p:spPr>
           <a:xfrm>
-            <a:off x="667512" y="5660136"/>
-            <a:ext cx="4224528" cy="274320"/>
+            <a:off x="667512" y="5358383"/>
+            <a:ext cx="4224528" cy="237744"/>
           </a:xfrm>
           <a:prstGeom prst="rect">
             <a:avLst/>
@@ -18658,7 +18658,7 @@
         <p:spPr>
           <a:xfrm>
             <a:off x="411480" y="1920240"/>
-            <a:ext cx="4572000" cy="283464"/>
+            <a:ext cx="4572000" cy="265176"/>
           </a:xfrm>
           <a:prstGeom prst="rect">
             <a:avLst/>
@@ -18702,8 +18702,8 @@
         </p:nvSpPr>
         <p:spPr>
           <a:xfrm>
-            <a:off x="484632" y="1975104"/>
-            <a:ext cx="2194560" cy="228600"/>
+            <a:off x="484632" y="1965960"/>
+            <a:ext cx="2194560" cy="219456"/>
           </a:xfrm>
           <a:prstGeom prst="rect">
             <a:avLst/>
@@ -18737,8 +18737,8 @@
         </p:nvSpPr>
         <p:spPr>
           <a:xfrm>
-            <a:off x="2770632" y="1975104"/>
-            <a:ext cx="914400" cy="228600"/>
+            <a:off x="2770632" y="1965960"/>
+            <a:ext cx="914400" cy="219456"/>
           </a:xfrm>
           <a:prstGeom prst="rect">
             <a:avLst/>
@@ -18772,23 +18772,23 @@
         </p:nvSpPr>
         <p:spPr>
           <a:xfrm>
-            <a:off x="3776472" y="1975104"/>
-            <a:ext cx="1115568" cy="228600"/>
-          </a:xfrm>
-          <a:prstGeom prst="rect">
-            <a:avLst/>
-          </a:prstGeom>
-          <a:noFill/>
-        </p:spPr>
-        <p:txBody>
-          <a:bodyPr wrap="square">
-            <a:spAutoFit/>
-          </a:bodyPr>
-          <a:lstStyle/>
-          <a:p>
-            <a:pPr algn="l"/>
-            <a:r>
-              <a:rPr sz="700" b="0" i="0">
+            <a:off x="3776472" y="1965960"/>
+            <a:ext cx="1115568" cy="219456"/>
+          </a:xfrm>
+          <a:prstGeom prst="rect">
+            <a:avLst/>
+          </a:prstGeom>
+          <a:noFill/>
+        </p:spPr>
+        <p:txBody>
+          <a:bodyPr wrap="square">
+            <a:spAutoFit/>
+          </a:bodyPr>
+          <a:lstStyle/>
+          <a:p>
+            <a:pPr algn="l"/>
+            <a:r>
+              <a:rPr sz="750" b="0" i="0">
                 <a:solidFill>
                   <a:srgbClr val="6B7FA0"/>
                 </a:solidFill>
@@ -18807,8 +18807,8 @@
         </p:nvSpPr>
         <p:spPr>
           <a:xfrm>
-            <a:off x="411480" y="2203704"/>
-            <a:ext cx="4572000" cy="283464"/>
+            <a:off x="411480" y="2185416"/>
+            <a:ext cx="4572000" cy="265176"/>
           </a:xfrm>
           <a:prstGeom prst="rect">
             <a:avLst/>
@@ -18852,8 +18852,8 @@
         </p:nvSpPr>
         <p:spPr>
           <a:xfrm>
-            <a:off x="484632" y="2258568"/>
-            <a:ext cx="2194560" cy="228600"/>
+            <a:off x="484632" y="2231136"/>
+            <a:ext cx="2194560" cy="219456"/>
           </a:xfrm>
           <a:prstGeom prst="rect">
             <a:avLst/>
@@ -18887,8 +18887,8 @@
         </p:nvSpPr>
         <p:spPr>
           <a:xfrm>
-            <a:off x="2770632" y="2258568"/>
-            <a:ext cx="914400" cy="228600"/>
+            <a:off x="2770632" y="2231136"/>
+            <a:ext cx="914400" cy="219456"/>
           </a:xfrm>
           <a:prstGeom prst="rect">
             <a:avLst/>
@@ -18922,23 +18922,23 @@
         </p:nvSpPr>
         <p:spPr>
           <a:xfrm>
-            <a:off x="3776472" y="2258568"/>
-            <a:ext cx="1115568" cy="228600"/>
-          </a:xfrm>
-          <a:prstGeom prst="rect">
-            <a:avLst/>
-          </a:prstGeom>
-          <a:noFill/>
-        </p:spPr>
-        <p:txBody>
-          <a:bodyPr wrap="square">
-            <a:spAutoFit/>
-          </a:bodyPr>
-          <a:lstStyle/>
-          <a:p>
-            <a:pPr algn="l"/>
-            <a:r>
-              <a:rPr sz="700" b="0" i="0">
+            <a:off x="3776472" y="2231136"/>
+            <a:ext cx="1115568" cy="219456"/>
+          </a:xfrm>
+          <a:prstGeom prst="rect">
+            <a:avLst/>
+          </a:prstGeom>
+          <a:noFill/>
+        </p:spPr>
+        <p:txBody>
+          <a:bodyPr wrap="square">
+            <a:spAutoFit/>
+          </a:bodyPr>
+          <a:lstStyle/>
+          <a:p>
+            <a:pPr algn="l"/>
+            <a:r>
+              <a:rPr sz="750" b="0" i="0">
                 <a:solidFill>
                   <a:srgbClr val="6B7FA0"/>
                 </a:solidFill>
@@ -18957,8 +18957,8 @@
         </p:nvSpPr>
         <p:spPr>
           <a:xfrm>
-            <a:off x="411480" y="2487168"/>
-            <a:ext cx="4572000" cy="283464"/>
+            <a:off x="411480" y="2450592"/>
+            <a:ext cx="4572000" cy="265176"/>
           </a:xfrm>
           <a:prstGeom prst="rect">
             <a:avLst/>
@@ -19002,8 +19002,8 @@
         </p:nvSpPr>
         <p:spPr>
           <a:xfrm>
-            <a:off x="484632" y="2542032"/>
-            <a:ext cx="2194560" cy="228600"/>
+            <a:off x="484632" y="2496312"/>
+            <a:ext cx="2194560" cy="219456"/>
           </a:xfrm>
           <a:prstGeom prst="rect">
             <a:avLst/>
@@ -19037,8 +19037,8 @@
         </p:nvSpPr>
         <p:spPr>
           <a:xfrm>
-            <a:off x="2770632" y="2542032"/>
-            <a:ext cx="914400" cy="228600"/>
+            <a:off x="2770632" y="2496312"/>
+            <a:ext cx="914400" cy="219456"/>
           </a:xfrm>
           <a:prstGeom prst="rect">
             <a:avLst/>
@@ -19072,23 +19072,23 @@
         </p:nvSpPr>
         <p:spPr>
           <a:xfrm>
-            <a:off x="3776472" y="2542032"/>
-            <a:ext cx="1115568" cy="228600"/>
-          </a:xfrm>
-          <a:prstGeom prst="rect">
-            <a:avLst/>
-          </a:prstGeom>
-          <a:noFill/>
-        </p:spPr>
-        <p:txBody>
-          <a:bodyPr wrap="square">
-            <a:spAutoFit/>
-          </a:bodyPr>
-          <a:lstStyle/>
-          <a:p>
-            <a:pPr algn="l"/>
-            <a:r>
-              <a:rPr sz="700" b="0" i="0">
+            <a:off x="3776472" y="2496312"/>
+            <a:ext cx="1115568" cy="219456"/>
+          </a:xfrm>
+          <a:prstGeom prst="rect">
+            <a:avLst/>
+          </a:prstGeom>
+          <a:noFill/>
+        </p:spPr>
+        <p:txBody>
+          <a:bodyPr wrap="square">
+            <a:spAutoFit/>
+          </a:bodyPr>
+          <a:lstStyle/>
+          <a:p>
+            <a:pPr algn="l"/>
+            <a:r>
+              <a:rPr sz="750" b="0" i="0">
                 <a:solidFill>
                   <a:srgbClr val="6B7FA0"/>
                 </a:solidFill>
@@ -19107,8 +19107,8 @@
         </p:nvSpPr>
         <p:spPr>
           <a:xfrm>
-            <a:off x="411480" y="2770632"/>
-            <a:ext cx="4572000" cy="283464"/>
+            <a:off x="411480" y="2715768"/>
+            <a:ext cx="4572000" cy="265176"/>
           </a:xfrm>
           <a:prstGeom prst="rect">
             <a:avLst/>
@@ -19152,8 +19152,8 @@
         </p:nvSpPr>
         <p:spPr>
           <a:xfrm>
-            <a:off x="484632" y="2825496"/>
-            <a:ext cx="2194560" cy="228600"/>
+            <a:off x="484632" y="2761488"/>
+            <a:ext cx="2194560" cy="219456"/>
           </a:xfrm>
           <a:prstGeom prst="rect">
             <a:avLst/>
@@ -19187,8 +19187,8 @@
         </p:nvSpPr>
         <p:spPr>
           <a:xfrm>
-            <a:off x="2770632" y="2825496"/>
-            <a:ext cx="914400" cy="228600"/>
+            <a:off x="2770632" y="2761488"/>
+            <a:ext cx="914400" cy="219456"/>
           </a:xfrm>
           <a:prstGeom prst="rect">
             <a:avLst/>
@@ -19222,23 +19222,23 @@
         </p:nvSpPr>
         <p:spPr>
           <a:xfrm>
-            <a:off x="3776472" y="2825496"/>
-            <a:ext cx="1115568" cy="228600"/>
-          </a:xfrm>
-          <a:prstGeom prst="rect">
-            <a:avLst/>
-          </a:prstGeom>
-          <a:noFill/>
-        </p:spPr>
-        <p:txBody>
-          <a:bodyPr wrap="square">
-            <a:spAutoFit/>
-          </a:bodyPr>
-          <a:lstStyle/>
-          <a:p>
-            <a:pPr algn="l"/>
-            <a:r>
-              <a:rPr sz="700" b="0" i="0">
+            <a:off x="3776472" y="2761488"/>
+            <a:ext cx="1115568" cy="219456"/>
+          </a:xfrm>
+          <a:prstGeom prst="rect">
+            <a:avLst/>
+          </a:prstGeom>
+          <a:noFill/>
+        </p:spPr>
+        <p:txBody>
+          <a:bodyPr wrap="square">
+            <a:spAutoFit/>
+          </a:bodyPr>
+          <a:lstStyle/>
+          <a:p>
+            <a:pPr algn="l"/>
+            <a:r>
+              <a:rPr sz="750" b="0" i="0">
                 <a:solidFill>
                   <a:srgbClr val="6B7FA0"/>
                 </a:solidFill>
@@ -19257,8 +19257,8 @@
         </p:nvSpPr>
         <p:spPr>
           <a:xfrm>
-            <a:off x="411480" y="3054096"/>
-            <a:ext cx="4572000" cy="283464"/>
+            <a:off x="411480" y="2980944"/>
+            <a:ext cx="4572000" cy="265176"/>
           </a:xfrm>
           <a:prstGeom prst="rect">
             <a:avLst/>
@@ -19302,8 +19302,8 @@
         </p:nvSpPr>
         <p:spPr>
           <a:xfrm>
-            <a:off x="484632" y="3108960"/>
-            <a:ext cx="2194560" cy="228600"/>
+            <a:off x="484632" y="3026664"/>
+            <a:ext cx="2194560" cy="219456"/>
           </a:xfrm>
           <a:prstGeom prst="rect">
             <a:avLst/>
@@ -19337,8 +19337,8 @@
         </p:nvSpPr>
         <p:spPr>
           <a:xfrm>
-            <a:off x="2770632" y="3108960"/>
-            <a:ext cx="914400" cy="228600"/>
+            <a:off x="2770632" y="3026664"/>
+            <a:ext cx="914400" cy="219456"/>
           </a:xfrm>
           <a:prstGeom prst="rect">
             <a:avLst/>
@@ -19372,23 +19372,23 @@
         </p:nvSpPr>
         <p:spPr>
           <a:xfrm>
-            <a:off x="3776472" y="3108960"/>
-            <a:ext cx="1115568" cy="228600"/>
-          </a:xfrm>
-          <a:prstGeom prst="rect">
-            <a:avLst/>
-          </a:prstGeom>
-          <a:noFill/>
-        </p:spPr>
-        <p:txBody>
-          <a:bodyPr wrap="square">
-            <a:spAutoFit/>
-          </a:bodyPr>
-          <a:lstStyle/>
-          <a:p>
-            <a:pPr algn="l"/>
-            <a:r>
-              <a:rPr sz="700" b="0" i="0">
+            <a:off x="3776472" y="3026664"/>
+            <a:ext cx="1115568" cy="219456"/>
+          </a:xfrm>
+          <a:prstGeom prst="rect">
+            <a:avLst/>
+          </a:prstGeom>
+          <a:noFill/>
+        </p:spPr>
+        <p:txBody>
+          <a:bodyPr wrap="square">
+            <a:spAutoFit/>
+          </a:bodyPr>
+          <a:lstStyle/>
+          <a:p>
+            <a:pPr algn="l"/>
+            <a:r>
+              <a:rPr sz="750" b="0" i="0">
                 <a:solidFill>
                   <a:srgbClr val="6B7FA0"/>
                 </a:solidFill>
@@ -19407,8 +19407,8 @@
         </p:nvSpPr>
         <p:spPr>
           <a:xfrm>
-            <a:off x="411480" y="3337560"/>
-            <a:ext cx="4572000" cy="283464"/>
+            <a:off x="411480" y="3246120"/>
+            <a:ext cx="4572000" cy="265176"/>
           </a:xfrm>
           <a:prstGeom prst="rect">
             <a:avLst/>
@@ -19452,8 +19452,8 @@
         </p:nvSpPr>
         <p:spPr>
           <a:xfrm>
-            <a:off x="484632" y="3392424"/>
-            <a:ext cx="2194560" cy="228600"/>
+            <a:off x="484632" y="3291840"/>
+            <a:ext cx="2194560" cy="219456"/>
           </a:xfrm>
           <a:prstGeom prst="rect">
             <a:avLst/>
@@ -19487,8 +19487,8 @@
         </p:nvSpPr>
         <p:spPr>
           <a:xfrm>
-            <a:off x="2770632" y="3392424"/>
-            <a:ext cx="914400" cy="228600"/>
+            <a:off x="2770632" y="3291840"/>
+            <a:ext cx="914400" cy="219456"/>
           </a:xfrm>
           <a:prstGeom prst="rect">
             <a:avLst/>
@@ -19522,23 +19522,23 @@
         </p:nvSpPr>
         <p:spPr>
           <a:xfrm>
-            <a:off x="3776472" y="3392424"/>
-            <a:ext cx="1115568" cy="228600"/>
-          </a:xfrm>
-          <a:prstGeom prst="rect">
-            <a:avLst/>
-          </a:prstGeom>
-          <a:noFill/>
-        </p:spPr>
-        <p:txBody>
-          <a:bodyPr wrap="square">
-            <a:spAutoFit/>
-          </a:bodyPr>
-          <a:lstStyle/>
-          <a:p>
-            <a:pPr algn="l"/>
-            <a:r>
-              <a:rPr sz="700" b="0" i="0">
+            <a:off x="3776472" y="3291840"/>
+            <a:ext cx="1115568" cy="219456"/>
+          </a:xfrm>
+          <a:prstGeom prst="rect">
+            <a:avLst/>
+          </a:prstGeom>
+          <a:noFill/>
+        </p:spPr>
+        <p:txBody>
+          <a:bodyPr wrap="square">
+            <a:spAutoFit/>
+          </a:bodyPr>
+          <a:lstStyle/>
+          <a:p>
+            <a:pPr algn="l"/>
+            <a:r>
+              <a:rPr sz="750" b="0" i="0">
                 <a:solidFill>
                   <a:srgbClr val="6B7FA0"/>
                 </a:solidFill>
@@ -19557,8 +19557,8 @@
         </p:nvSpPr>
         <p:spPr>
           <a:xfrm>
-            <a:off x="411480" y="3621024"/>
-            <a:ext cx="4572000" cy="283464"/>
+            <a:off x="411480" y="3511296"/>
+            <a:ext cx="4572000" cy="265176"/>
           </a:xfrm>
           <a:prstGeom prst="rect">
             <a:avLst/>
@@ -19602,8 +19602,8 @@
         </p:nvSpPr>
         <p:spPr>
           <a:xfrm>
-            <a:off x="484632" y="3675888"/>
-            <a:ext cx="2194560" cy="228600"/>
+            <a:off x="484632" y="3557016"/>
+            <a:ext cx="2194560" cy="219456"/>
           </a:xfrm>
           <a:prstGeom prst="rect">
             <a:avLst/>
@@ -19637,8 +19637,8 @@
         </p:nvSpPr>
         <p:spPr>
           <a:xfrm>
-            <a:off x="2770632" y="3675888"/>
-            <a:ext cx="914400" cy="228600"/>
+            <a:off x="2770632" y="3557016"/>
+            <a:ext cx="914400" cy="219456"/>
           </a:xfrm>
           <a:prstGeom prst="rect">
             <a:avLst/>
@@ -19672,23 +19672,23 @@
         </p:nvSpPr>
         <p:spPr>
           <a:xfrm>
-            <a:off x="3776472" y="3675888"/>
-            <a:ext cx="1115568" cy="228600"/>
-          </a:xfrm>
-          <a:prstGeom prst="rect">
-            <a:avLst/>
-          </a:prstGeom>
-          <a:noFill/>
-        </p:spPr>
-        <p:txBody>
-          <a:bodyPr wrap="square">
-            <a:spAutoFit/>
-          </a:bodyPr>
-          <a:lstStyle/>
-          <a:p>
-            <a:pPr algn="l"/>
-            <a:r>
-              <a:rPr sz="700" b="0" i="0">
+            <a:off x="3776472" y="3557016"/>
+            <a:ext cx="1115568" cy="219456"/>
+          </a:xfrm>
+          <a:prstGeom prst="rect">
+            <a:avLst/>
+          </a:prstGeom>
+          <a:noFill/>
+        </p:spPr>
+        <p:txBody>
+          <a:bodyPr wrap="square">
+            <a:spAutoFit/>
+          </a:bodyPr>
+          <a:lstStyle/>
+          <a:p>
+            <a:pPr algn="l"/>
+            <a:r>
+              <a:rPr sz="750" b="0" i="0">
                 <a:solidFill>
                   <a:srgbClr val="6B7FA0"/>
                 </a:solidFill>
@@ -19707,7 +19707,7 @@
         </p:nvSpPr>
         <p:spPr>
           <a:xfrm>
-            <a:off x="411480" y="4014216"/>
+            <a:off x="411480" y="3849624"/>
             <a:ext cx="4572000" cy="256032"/>
           </a:xfrm>
           <a:prstGeom prst="rect">
@@ -19750,7 +19750,7 @@
         </p:nvSpPr>
         <p:spPr>
           <a:xfrm>
-            <a:off x="502920" y="4050792"/>
+            <a:off x="502920" y="3886200"/>
             <a:ext cx="4389120" cy="201168"/>
           </a:xfrm>
           <a:prstGeom prst="rect">
@@ -19785,7 +19785,7 @@
         </p:nvSpPr>
         <p:spPr>
           <a:xfrm>
-            <a:off x="502920" y="4361688"/>
+            <a:off x="502920" y="4187952"/>
             <a:ext cx="73152" cy="73152"/>
           </a:xfrm>
           <a:prstGeom prst="rect">
@@ -19828,8 +19828,8 @@
         </p:nvSpPr>
         <p:spPr>
           <a:xfrm>
-            <a:off x="667512" y="4288536"/>
-            <a:ext cx="4224528" cy="274320"/>
+            <a:off x="667512" y="4123944"/>
+            <a:ext cx="4224528" cy="237744"/>
           </a:xfrm>
           <a:prstGeom prst="rect">
             <a:avLst/>
@@ -19863,7 +19863,7 @@
         </p:nvSpPr>
         <p:spPr>
           <a:xfrm>
-            <a:off x="502920" y="4636008"/>
+            <a:off x="502920" y="4434840"/>
             <a:ext cx="73152" cy="73152"/>
           </a:xfrm>
           <a:prstGeom prst="rect">
@@ -19906,8 +19906,8 @@
         </p:nvSpPr>
         <p:spPr>
           <a:xfrm>
-            <a:off x="667512" y="4562856"/>
-            <a:ext cx="4224528" cy="274320"/>
+            <a:off x="667512" y="4370831"/>
+            <a:ext cx="4224528" cy="237744"/>
           </a:xfrm>
           <a:prstGeom prst="rect">
             <a:avLst/>
@@ -19941,7 +19941,7 @@
         </p:nvSpPr>
         <p:spPr>
           <a:xfrm>
-            <a:off x="502920" y="4910328"/>
+            <a:off x="502920" y="4681727"/>
             <a:ext cx="73152" cy="73152"/>
           </a:xfrm>
           <a:prstGeom prst="rect">
@@ -19984,8 +19984,8 @@
         </p:nvSpPr>
         <p:spPr>
           <a:xfrm>
-            <a:off x="667512" y="4837176"/>
-            <a:ext cx="4224528" cy="274320"/>
+            <a:off x="667512" y="4617719"/>
+            <a:ext cx="4224528" cy="237744"/>
           </a:xfrm>
           <a:prstGeom prst="rect">
             <a:avLst/>
@@ -20019,7 +20019,7 @@
         </p:nvSpPr>
         <p:spPr>
           <a:xfrm>
-            <a:off x="502920" y="5184648"/>
+            <a:off x="502920" y="4928615"/>
             <a:ext cx="73152" cy="73152"/>
           </a:xfrm>
           <a:prstGeom prst="rect">
@@ -20062,8 +20062,8 @@
         </p:nvSpPr>
         <p:spPr>
           <a:xfrm>
-            <a:off x="667512" y="5111496"/>
-            <a:ext cx="4224528" cy="274320"/>
+            <a:off x="667512" y="4864607"/>
+            <a:ext cx="4224528" cy="237744"/>
           </a:xfrm>
           <a:prstGeom prst="rect">
             <a:avLst/>
@@ -20097,7 +20097,7 @@
         </p:nvSpPr>
         <p:spPr>
           <a:xfrm>
-            <a:off x="502920" y="5458968"/>
+            <a:off x="502920" y="5175503"/>
             <a:ext cx="73152" cy="73152"/>
           </a:xfrm>
           <a:prstGeom prst="rect">
@@ -20140,8 +20140,8 @@
         </p:nvSpPr>
         <p:spPr>
           <a:xfrm>
-            <a:off x="667512" y="5385816"/>
-            <a:ext cx="4224528" cy="274320"/>
+            <a:off x="667512" y="5111495"/>
+            <a:ext cx="4224528" cy="237744"/>
           </a:xfrm>
           <a:prstGeom prst="rect">
             <a:avLst/>
@@ -21574,7 +21574,7 @@
         <p:spPr>
           <a:xfrm>
             <a:off x="411480" y="1920240"/>
-            <a:ext cx="4572000" cy="283464"/>
+            <a:ext cx="4572000" cy="265176"/>
           </a:xfrm>
           <a:prstGeom prst="rect">
             <a:avLst/>
@@ -21618,8 +21618,8 @@
         </p:nvSpPr>
         <p:spPr>
           <a:xfrm>
-            <a:off x="484632" y="1975104"/>
-            <a:ext cx="2194560" cy="228600"/>
+            <a:off x="484632" y="1965960"/>
+            <a:ext cx="2194560" cy="219456"/>
           </a:xfrm>
           <a:prstGeom prst="rect">
             <a:avLst/>
@@ -21653,8 +21653,8 @@
         </p:nvSpPr>
         <p:spPr>
           <a:xfrm>
-            <a:off x="2770632" y="1975104"/>
-            <a:ext cx="914400" cy="228600"/>
+            <a:off x="2770632" y="1965960"/>
+            <a:ext cx="914400" cy="219456"/>
           </a:xfrm>
           <a:prstGeom prst="rect">
             <a:avLst/>
@@ -21688,23 +21688,23 @@
         </p:nvSpPr>
         <p:spPr>
           <a:xfrm>
-            <a:off x="3776472" y="1975104"/>
-            <a:ext cx="1115568" cy="228600"/>
-          </a:xfrm>
-          <a:prstGeom prst="rect">
-            <a:avLst/>
-          </a:prstGeom>
-          <a:noFill/>
-        </p:spPr>
-        <p:txBody>
-          <a:bodyPr wrap="square">
-            <a:spAutoFit/>
-          </a:bodyPr>
-          <a:lstStyle/>
-          <a:p>
-            <a:pPr algn="l"/>
-            <a:r>
-              <a:rPr sz="700" b="0" i="0">
+            <a:off x="3776472" y="1965960"/>
+            <a:ext cx="1115568" cy="219456"/>
+          </a:xfrm>
+          <a:prstGeom prst="rect">
+            <a:avLst/>
+          </a:prstGeom>
+          <a:noFill/>
+        </p:spPr>
+        <p:txBody>
+          <a:bodyPr wrap="square">
+            <a:spAutoFit/>
+          </a:bodyPr>
+          <a:lstStyle/>
+          <a:p>
+            <a:pPr algn="l"/>
+            <a:r>
+              <a:rPr sz="750" b="0" i="0">
                 <a:solidFill>
                   <a:srgbClr val="6B7FA0"/>
                 </a:solidFill>
@@ -21723,8 +21723,8 @@
         </p:nvSpPr>
         <p:spPr>
           <a:xfrm>
-            <a:off x="411480" y="2203704"/>
-            <a:ext cx="4572000" cy="283464"/>
+            <a:off x="411480" y="2185416"/>
+            <a:ext cx="4572000" cy="265176"/>
           </a:xfrm>
           <a:prstGeom prst="rect">
             <a:avLst/>
@@ -21768,8 +21768,8 @@
         </p:nvSpPr>
         <p:spPr>
           <a:xfrm>
-            <a:off x="484632" y="2258568"/>
-            <a:ext cx="2194560" cy="228600"/>
+            <a:off x="484632" y="2231136"/>
+            <a:ext cx="2194560" cy="219456"/>
           </a:xfrm>
           <a:prstGeom prst="rect">
             <a:avLst/>
@@ -21803,8 +21803,8 @@
         </p:nvSpPr>
         <p:spPr>
           <a:xfrm>
-            <a:off x="2770632" y="2258568"/>
-            <a:ext cx="914400" cy="228600"/>
+            <a:off x="2770632" y="2231136"/>
+            <a:ext cx="914400" cy="219456"/>
           </a:xfrm>
           <a:prstGeom prst="rect">
             <a:avLst/>
@@ -21838,23 +21838,23 @@
         </p:nvSpPr>
         <p:spPr>
           <a:xfrm>
-            <a:off x="3776472" y="2258568"/>
-            <a:ext cx="1115568" cy="228600"/>
-          </a:xfrm>
-          <a:prstGeom prst="rect">
-            <a:avLst/>
-          </a:prstGeom>
-          <a:noFill/>
-        </p:spPr>
-        <p:txBody>
-          <a:bodyPr wrap="square">
-            <a:spAutoFit/>
-          </a:bodyPr>
-          <a:lstStyle/>
-          <a:p>
-            <a:pPr algn="l"/>
-            <a:r>
-              <a:rPr sz="700" b="0" i="0">
+            <a:off x="3776472" y="2231136"/>
+            <a:ext cx="1115568" cy="219456"/>
+          </a:xfrm>
+          <a:prstGeom prst="rect">
+            <a:avLst/>
+          </a:prstGeom>
+          <a:noFill/>
+        </p:spPr>
+        <p:txBody>
+          <a:bodyPr wrap="square">
+            <a:spAutoFit/>
+          </a:bodyPr>
+          <a:lstStyle/>
+          <a:p>
+            <a:pPr algn="l"/>
+            <a:r>
+              <a:rPr sz="750" b="0" i="0">
                 <a:solidFill>
                   <a:srgbClr val="6B7FA0"/>
                 </a:solidFill>
@@ -21873,8 +21873,8 @@
         </p:nvSpPr>
         <p:spPr>
           <a:xfrm>
-            <a:off x="411480" y="2487168"/>
-            <a:ext cx="4572000" cy="283464"/>
+            <a:off x="411480" y="2450592"/>
+            <a:ext cx="4572000" cy="265176"/>
           </a:xfrm>
           <a:prstGeom prst="rect">
             <a:avLst/>
@@ -21918,8 +21918,8 @@
         </p:nvSpPr>
         <p:spPr>
           <a:xfrm>
-            <a:off x="484632" y="2542032"/>
-            <a:ext cx="2194560" cy="228600"/>
+            <a:off x="484632" y="2496312"/>
+            <a:ext cx="2194560" cy="219456"/>
           </a:xfrm>
           <a:prstGeom prst="rect">
             <a:avLst/>
@@ -21953,8 +21953,8 @@
         </p:nvSpPr>
         <p:spPr>
           <a:xfrm>
-            <a:off x="2770632" y="2542032"/>
-            <a:ext cx="914400" cy="228600"/>
+            <a:off x="2770632" y="2496312"/>
+            <a:ext cx="914400" cy="219456"/>
           </a:xfrm>
           <a:prstGeom prst="rect">
             <a:avLst/>
@@ -21988,23 +21988,23 @@
         </p:nvSpPr>
         <p:spPr>
           <a:xfrm>
-            <a:off x="3776472" y="2542032"/>
-            <a:ext cx="1115568" cy="228600"/>
-          </a:xfrm>
-          <a:prstGeom prst="rect">
-            <a:avLst/>
-          </a:prstGeom>
-          <a:noFill/>
-        </p:spPr>
-        <p:txBody>
-          <a:bodyPr wrap="square">
-            <a:spAutoFit/>
-          </a:bodyPr>
-          <a:lstStyle/>
-          <a:p>
-            <a:pPr algn="l"/>
-            <a:r>
-              <a:rPr sz="700" b="0" i="0">
+            <a:off x="3776472" y="2496312"/>
+            <a:ext cx="1115568" cy="219456"/>
+          </a:xfrm>
+          <a:prstGeom prst="rect">
+            <a:avLst/>
+          </a:prstGeom>
+          <a:noFill/>
+        </p:spPr>
+        <p:txBody>
+          <a:bodyPr wrap="square">
+            <a:spAutoFit/>
+          </a:bodyPr>
+          <a:lstStyle/>
+          <a:p>
+            <a:pPr algn="l"/>
+            <a:r>
+              <a:rPr sz="750" b="0" i="0">
                 <a:solidFill>
                   <a:srgbClr val="6B7FA0"/>
                 </a:solidFill>
@@ -22023,8 +22023,8 @@
         </p:nvSpPr>
         <p:spPr>
           <a:xfrm>
-            <a:off x="411480" y="2770632"/>
-            <a:ext cx="4572000" cy="283464"/>
+            <a:off x="411480" y="2715768"/>
+            <a:ext cx="4572000" cy="265176"/>
           </a:xfrm>
           <a:prstGeom prst="rect">
             <a:avLst/>
@@ -22068,8 +22068,8 @@
         </p:nvSpPr>
         <p:spPr>
           <a:xfrm>
-            <a:off x="484632" y="2825496"/>
-            <a:ext cx="2194560" cy="228600"/>
+            <a:off x="484632" y="2761488"/>
+            <a:ext cx="2194560" cy="219456"/>
           </a:xfrm>
           <a:prstGeom prst="rect">
             <a:avLst/>
@@ -22103,8 +22103,8 @@
         </p:nvSpPr>
         <p:spPr>
           <a:xfrm>
-            <a:off x="2770632" y="2825496"/>
-            <a:ext cx="914400" cy="228600"/>
+            <a:off x="2770632" y="2761488"/>
+            <a:ext cx="914400" cy="219456"/>
           </a:xfrm>
           <a:prstGeom prst="rect">
             <a:avLst/>
@@ -22138,23 +22138,23 @@
         </p:nvSpPr>
         <p:spPr>
           <a:xfrm>
-            <a:off x="3776472" y="2825496"/>
-            <a:ext cx="1115568" cy="228600"/>
-          </a:xfrm>
-          <a:prstGeom prst="rect">
-            <a:avLst/>
-          </a:prstGeom>
-          <a:noFill/>
-        </p:spPr>
-        <p:txBody>
-          <a:bodyPr wrap="square">
-            <a:spAutoFit/>
-          </a:bodyPr>
-          <a:lstStyle/>
-          <a:p>
-            <a:pPr algn="l"/>
-            <a:r>
-              <a:rPr sz="700" b="0" i="0">
+            <a:off x="3776472" y="2761488"/>
+            <a:ext cx="1115568" cy="219456"/>
+          </a:xfrm>
+          <a:prstGeom prst="rect">
+            <a:avLst/>
+          </a:prstGeom>
+          <a:noFill/>
+        </p:spPr>
+        <p:txBody>
+          <a:bodyPr wrap="square">
+            <a:spAutoFit/>
+          </a:bodyPr>
+          <a:lstStyle/>
+          <a:p>
+            <a:pPr algn="l"/>
+            <a:r>
+              <a:rPr sz="750" b="0" i="0">
                 <a:solidFill>
                   <a:srgbClr val="6B7FA0"/>
                 </a:solidFill>
@@ -22173,8 +22173,8 @@
         </p:nvSpPr>
         <p:spPr>
           <a:xfrm>
-            <a:off x="411480" y="3054096"/>
-            <a:ext cx="4572000" cy="283464"/>
+            <a:off x="411480" y="2980944"/>
+            <a:ext cx="4572000" cy="265176"/>
           </a:xfrm>
           <a:prstGeom prst="rect">
             <a:avLst/>
@@ -22218,8 +22218,8 @@
         </p:nvSpPr>
         <p:spPr>
           <a:xfrm>
-            <a:off x="484632" y="3108960"/>
-            <a:ext cx="2194560" cy="228600"/>
+            <a:off x="484632" y="3026664"/>
+            <a:ext cx="2194560" cy="219456"/>
           </a:xfrm>
           <a:prstGeom prst="rect">
             <a:avLst/>
@@ -22253,8 +22253,8 @@
         </p:nvSpPr>
         <p:spPr>
           <a:xfrm>
-            <a:off x="2770632" y="3108960"/>
-            <a:ext cx="914400" cy="228600"/>
+            <a:off x="2770632" y="3026664"/>
+            <a:ext cx="914400" cy="219456"/>
           </a:xfrm>
           <a:prstGeom prst="rect">
             <a:avLst/>
@@ -22288,23 +22288,23 @@
         </p:nvSpPr>
         <p:spPr>
           <a:xfrm>
-            <a:off x="3776472" y="3108960"/>
-            <a:ext cx="1115568" cy="228600"/>
-          </a:xfrm>
-          <a:prstGeom prst="rect">
-            <a:avLst/>
-          </a:prstGeom>
-          <a:noFill/>
-        </p:spPr>
-        <p:txBody>
-          <a:bodyPr wrap="square">
-            <a:spAutoFit/>
-          </a:bodyPr>
-          <a:lstStyle/>
-          <a:p>
-            <a:pPr algn="l"/>
-            <a:r>
-              <a:rPr sz="700" b="0" i="0">
+            <a:off x="3776472" y="3026664"/>
+            <a:ext cx="1115568" cy="219456"/>
+          </a:xfrm>
+          <a:prstGeom prst="rect">
+            <a:avLst/>
+          </a:prstGeom>
+          <a:noFill/>
+        </p:spPr>
+        <p:txBody>
+          <a:bodyPr wrap="square">
+            <a:spAutoFit/>
+          </a:bodyPr>
+          <a:lstStyle/>
+          <a:p>
+            <a:pPr algn="l"/>
+            <a:r>
+              <a:rPr sz="750" b="0" i="0">
                 <a:solidFill>
                   <a:srgbClr val="6B7FA0"/>
                 </a:solidFill>
@@ -22323,8 +22323,8 @@
         </p:nvSpPr>
         <p:spPr>
           <a:xfrm>
-            <a:off x="411480" y="3337560"/>
-            <a:ext cx="4572000" cy="283464"/>
+            <a:off x="411480" y="3246120"/>
+            <a:ext cx="4572000" cy="265176"/>
           </a:xfrm>
           <a:prstGeom prst="rect">
             <a:avLst/>
@@ -22368,8 +22368,8 @@
         </p:nvSpPr>
         <p:spPr>
           <a:xfrm>
-            <a:off x="484632" y="3392424"/>
-            <a:ext cx="2194560" cy="228600"/>
+            <a:off x="484632" y="3291840"/>
+            <a:ext cx="2194560" cy="219456"/>
           </a:xfrm>
           <a:prstGeom prst="rect">
             <a:avLst/>
@@ -22403,8 +22403,8 @@
         </p:nvSpPr>
         <p:spPr>
           <a:xfrm>
-            <a:off x="2770632" y="3392424"/>
-            <a:ext cx="914400" cy="228600"/>
+            <a:off x="2770632" y="3291840"/>
+            <a:ext cx="914400" cy="219456"/>
           </a:xfrm>
           <a:prstGeom prst="rect">
             <a:avLst/>
@@ -22438,23 +22438,23 @@
         </p:nvSpPr>
         <p:spPr>
           <a:xfrm>
-            <a:off x="3776472" y="3392424"/>
-            <a:ext cx="1115568" cy="228600"/>
-          </a:xfrm>
-          <a:prstGeom prst="rect">
-            <a:avLst/>
-          </a:prstGeom>
-          <a:noFill/>
-        </p:spPr>
-        <p:txBody>
-          <a:bodyPr wrap="square">
-            <a:spAutoFit/>
-          </a:bodyPr>
-          <a:lstStyle/>
-          <a:p>
-            <a:pPr algn="l"/>
-            <a:r>
-              <a:rPr sz="700" b="0" i="0">
+            <a:off x="3776472" y="3291840"/>
+            <a:ext cx="1115568" cy="219456"/>
+          </a:xfrm>
+          <a:prstGeom prst="rect">
+            <a:avLst/>
+          </a:prstGeom>
+          <a:noFill/>
+        </p:spPr>
+        <p:txBody>
+          <a:bodyPr wrap="square">
+            <a:spAutoFit/>
+          </a:bodyPr>
+          <a:lstStyle/>
+          <a:p>
+            <a:pPr algn="l"/>
+            <a:r>
+              <a:rPr sz="750" b="0" i="0">
                 <a:solidFill>
                   <a:srgbClr val="6B7FA0"/>
                 </a:solidFill>
@@ -22473,7 +22473,7 @@
         </p:nvSpPr>
         <p:spPr>
           <a:xfrm>
-            <a:off x="411480" y="3730752"/>
+            <a:off x="411480" y="3584448"/>
             <a:ext cx="4572000" cy="256032"/>
           </a:xfrm>
           <a:prstGeom prst="rect">
@@ -22516,7 +22516,7 @@
         </p:nvSpPr>
         <p:spPr>
           <a:xfrm>
-            <a:off x="502920" y="3767328"/>
+            <a:off x="502920" y="3621024"/>
             <a:ext cx="4389120" cy="201168"/>
           </a:xfrm>
           <a:prstGeom prst="rect">
@@ -22551,7 +22551,7 @@
         </p:nvSpPr>
         <p:spPr>
           <a:xfrm>
-            <a:off x="502920" y="4078224"/>
+            <a:off x="502920" y="3922776"/>
             <a:ext cx="73152" cy="73152"/>
           </a:xfrm>
           <a:prstGeom prst="rect">
@@ -22594,8 +22594,8 @@
         </p:nvSpPr>
         <p:spPr>
           <a:xfrm>
-            <a:off x="667512" y="4005072"/>
-            <a:ext cx="4224528" cy="274320"/>
+            <a:off x="667512" y="3858768"/>
+            <a:ext cx="4224528" cy="237744"/>
           </a:xfrm>
           <a:prstGeom prst="rect">
             <a:avLst/>
@@ -22629,7 +22629,7 @@
         </p:nvSpPr>
         <p:spPr>
           <a:xfrm>
-            <a:off x="502920" y="4352544"/>
+            <a:off x="502920" y="4169664"/>
             <a:ext cx="73152" cy="73152"/>
           </a:xfrm>
           <a:prstGeom prst="rect">
@@ -22672,8 +22672,8 @@
         </p:nvSpPr>
         <p:spPr>
           <a:xfrm>
-            <a:off x="667512" y="4279392"/>
-            <a:ext cx="4224528" cy="274320"/>
+            <a:off x="667512" y="4105656"/>
+            <a:ext cx="4224528" cy="237744"/>
           </a:xfrm>
           <a:prstGeom prst="rect">
             <a:avLst/>
@@ -22707,7 +22707,7 @@
         </p:nvSpPr>
         <p:spPr>
           <a:xfrm>
-            <a:off x="502920" y="4626864"/>
+            <a:off x="502920" y="4416552"/>
             <a:ext cx="73152" cy="73152"/>
           </a:xfrm>
           <a:prstGeom prst="rect">
@@ -22750,8 +22750,8 @@
         </p:nvSpPr>
         <p:spPr>
           <a:xfrm>
-            <a:off x="667512" y="4553712"/>
-            <a:ext cx="4224528" cy="274320"/>
+            <a:off x="667512" y="4352544"/>
+            <a:ext cx="4224528" cy="237744"/>
           </a:xfrm>
           <a:prstGeom prst="rect">
             <a:avLst/>
@@ -22785,7 +22785,7 @@
         </p:nvSpPr>
         <p:spPr>
           <a:xfrm>
-            <a:off x="502920" y="4901183"/>
+            <a:off x="502920" y="4663440"/>
             <a:ext cx="73152" cy="73152"/>
           </a:xfrm>
           <a:prstGeom prst="rect">
@@ -22828,8 +22828,8 @@
         </p:nvSpPr>
         <p:spPr>
           <a:xfrm>
-            <a:off x="667512" y="4828031"/>
-            <a:ext cx="4224528" cy="274320"/>
+            <a:off x="667512" y="4599431"/>
+            <a:ext cx="4224528" cy="237744"/>
           </a:xfrm>
           <a:prstGeom prst="rect">
             <a:avLst/>
@@ -22863,7 +22863,7 @@
         </p:nvSpPr>
         <p:spPr>
           <a:xfrm>
-            <a:off x="502920" y="5175503"/>
+            <a:off x="502920" y="4910327"/>
             <a:ext cx="73152" cy="73152"/>
           </a:xfrm>
           <a:prstGeom prst="rect">
@@ -22906,8 +22906,8 @@
         </p:nvSpPr>
         <p:spPr>
           <a:xfrm>
-            <a:off x="667512" y="5102351"/>
-            <a:ext cx="4224528" cy="274320"/>
+            <a:off x="667512" y="4846319"/>
+            <a:ext cx="4224528" cy="237744"/>
           </a:xfrm>
           <a:prstGeom prst="rect">
             <a:avLst/>
@@ -22941,7 +22941,7 @@
         </p:nvSpPr>
         <p:spPr>
           <a:xfrm>
-            <a:off x="502920" y="5449823"/>
+            <a:off x="502920" y="5157215"/>
             <a:ext cx="73152" cy="73152"/>
           </a:xfrm>
           <a:prstGeom prst="rect">
@@ -22984,8 +22984,8 @@
         </p:nvSpPr>
         <p:spPr>
           <a:xfrm>
-            <a:off x="667512" y="5376671"/>
-            <a:ext cx="4224528" cy="274320"/>
+            <a:off x="667512" y="5093207"/>
+            <a:ext cx="4224528" cy="237744"/>
           </a:xfrm>
           <a:prstGeom prst="rect">
             <a:avLst/>
@@ -24453,7 +24453,7 @@
         <p:spPr>
           <a:xfrm>
             <a:off x="411480" y="1920240"/>
-            <a:ext cx="4572000" cy="283464"/>
+            <a:ext cx="4572000" cy="265176"/>
           </a:xfrm>
           <a:prstGeom prst="rect">
             <a:avLst/>
@@ -24497,8 +24497,8 @@
         </p:nvSpPr>
         <p:spPr>
           <a:xfrm>
-            <a:off x="484632" y="1975104"/>
-            <a:ext cx="2194560" cy="228600"/>
+            <a:off x="484632" y="1965960"/>
+            <a:ext cx="2194560" cy="219456"/>
           </a:xfrm>
           <a:prstGeom prst="rect">
             <a:avLst/>
@@ -24532,8 +24532,8 @@
         </p:nvSpPr>
         <p:spPr>
           <a:xfrm>
-            <a:off x="2770632" y="1975104"/>
-            <a:ext cx="914400" cy="228600"/>
+            <a:off x="2770632" y="1965960"/>
+            <a:ext cx="914400" cy="219456"/>
           </a:xfrm>
           <a:prstGeom prst="rect">
             <a:avLst/>
@@ -24567,23 +24567,23 @@
         </p:nvSpPr>
         <p:spPr>
           <a:xfrm>
-            <a:off x="3776472" y="1975104"/>
-            <a:ext cx="1115568" cy="228600"/>
-          </a:xfrm>
-          <a:prstGeom prst="rect">
-            <a:avLst/>
-          </a:prstGeom>
-          <a:noFill/>
-        </p:spPr>
-        <p:txBody>
-          <a:bodyPr wrap="square">
-            <a:spAutoFit/>
-          </a:bodyPr>
-          <a:lstStyle/>
-          <a:p>
-            <a:pPr algn="l"/>
-            <a:r>
-              <a:rPr sz="700" b="0" i="0">
+            <a:off x="3776472" y="1965960"/>
+            <a:ext cx="1115568" cy="219456"/>
+          </a:xfrm>
+          <a:prstGeom prst="rect">
+            <a:avLst/>
+          </a:prstGeom>
+          <a:noFill/>
+        </p:spPr>
+        <p:txBody>
+          <a:bodyPr wrap="square">
+            <a:spAutoFit/>
+          </a:bodyPr>
+          <a:lstStyle/>
+          <a:p>
+            <a:pPr algn="l"/>
+            <a:r>
+              <a:rPr sz="750" b="0" i="0">
                 <a:solidFill>
                   <a:srgbClr val="6B7FA0"/>
                 </a:solidFill>
@@ -24602,8 +24602,8 @@
         </p:nvSpPr>
         <p:spPr>
           <a:xfrm>
-            <a:off x="411480" y="2203704"/>
-            <a:ext cx="4572000" cy="283464"/>
+            <a:off x="411480" y="2185416"/>
+            <a:ext cx="4572000" cy="265176"/>
           </a:xfrm>
           <a:prstGeom prst="rect">
             <a:avLst/>
@@ -24647,8 +24647,8 @@
         </p:nvSpPr>
         <p:spPr>
           <a:xfrm>
-            <a:off x="484632" y="2258568"/>
-            <a:ext cx="2194560" cy="228600"/>
+            <a:off x="484632" y="2231136"/>
+            <a:ext cx="2194560" cy="219456"/>
           </a:xfrm>
           <a:prstGeom prst="rect">
             <a:avLst/>
@@ -24682,8 +24682,8 @@
         </p:nvSpPr>
         <p:spPr>
           <a:xfrm>
-            <a:off x="2770632" y="2258568"/>
-            <a:ext cx="914400" cy="228600"/>
+            <a:off x="2770632" y="2231136"/>
+            <a:ext cx="914400" cy="219456"/>
           </a:xfrm>
           <a:prstGeom prst="rect">
             <a:avLst/>
@@ -24717,23 +24717,23 @@
         </p:nvSpPr>
         <p:spPr>
           <a:xfrm>
-            <a:off x="3776472" y="2258568"/>
-            <a:ext cx="1115568" cy="228600"/>
-          </a:xfrm>
-          <a:prstGeom prst="rect">
-            <a:avLst/>
-          </a:prstGeom>
-          <a:noFill/>
-        </p:spPr>
-        <p:txBody>
-          <a:bodyPr wrap="square">
-            <a:spAutoFit/>
-          </a:bodyPr>
-          <a:lstStyle/>
-          <a:p>
-            <a:pPr algn="l"/>
-            <a:r>
-              <a:rPr sz="700" b="0" i="0">
+            <a:off x="3776472" y="2231136"/>
+            <a:ext cx="1115568" cy="219456"/>
+          </a:xfrm>
+          <a:prstGeom prst="rect">
+            <a:avLst/>
+          </a:prstGeom>
+          <a:noFill/>
+        </p:spPr>
+        <p:txBody>
+          <a:bodyPr wrap="square">
+            <a:spAutoFit/>
+          </a:bodyPr>
+          <a:lstStyle/>
+          <a:p>
+            <a:pPr algn="l"/>
+            <a:r>
+              <a:rPr sz="750" b="0" i="0">
                 <a:solidFill>
                   <a:srgbClr val="6B7FA0"/>
                 </a:solidFill>
@@ -24752,8 +24752,8 @@
         </p:nvSpPr>
         <p:spPr>
           <a:xfrm>
-            <a:off x="411480" y="2487168"/>
-            <a:ext cx="4572000" cy="283464"/>
+            <a:off x="411480" y="2450592"/>
+            <a:ext cx="4572000" cy="265176"/>
           </a:xfrm>
           <a:prstGeom prst="rect">
             <a:avLst/>
@@ -24797,8 +24797,8 @@
         </p:nvSpPr>
         <p:spPr>
           <a:xfrm>
-            <a:off x="484632" y="2542032"/>
-            <a:ext cx="2194560" cy="228600"/>
+            <a:off x="484632" y="2496312"/>
+            <a:ext cx="2194560" cy="219456"/>
           </a:xfrm>
           <a:prstGeom prst="rect">
             <a:avLst/>
@@ -24832,8 +24832,8 @@
         </p:nvSpPr>
         <p:spPr>
           <a:xfrm>
-            <a:off x="2770632" y="2542032"/>
-            <a:ext cx="914400" cy="228600"/>
+            <a:off x="2770632" y="2496312"/>
+            <a:ext cx="914400" cy="219456"/>
           </a:xfrm>
           <a:prstGeom prst="rect">
             <a:avLst/>
@@ -24867,23 +24867,23 @@
         </p:nvSpPr>
         <p:spPr>
           <a:xfrm>
-            <a:off x="3776472" y="2542032"/>
-            <a:ext cx="1115568" cy="228600"/>
-          </a:xfrm>
-          <a:prstGeom prst="rect">
-            <a:avLst/>
-          </a:prstGeom>
-          <a:noFill/>
-        </p:spPr>
-        <p:txBody>
-          <a:bodyPr wrap="square">
-            <a:spAutoFit/>
-          </a:bodyPr>
-          <a:lstStyle/>
-          <a:p>
-            <a:pPr algn="l"/>
-            <a:r>
-              <a:rPr sz="700" b="0" i="0">
+            <a:off x="3776472" y="2496312"/>
+            <a:ext cx="1115568" cy="219456"/>
+          </a:xfrm>
+          <a:prstGeom prst="rect">
+            <a:avLst/>
+          </a:prstGeom>
+          <a:noFill/>
+        </p:spPr>
+        <p:txBody>
+          <a:bodyPr wrap="square">
+            <a:spAutoFit/>
+          </a:bodyPr>
+          <a:lstStyle/>
+          <a:p>
+            <a:pPr algn="l"/>
+            <a:r>
+              <a:rPr sz="750" b="0" i="0">
                 <a:solidFill>
                   <a:srgbClr val="6B7FA0"/>
                 </a:solidFill>
@@ -24902,8 +24902,8 @@
         </p:nvSpPr>
         <p:spPr>
           <a:xfrm>
-            <a:off x="411480" y="2770632"/>
-            <a:ext cx="4572000" cy="283464"/>
+            <a:off x="411480" y="2715768"/>
+            <a:ext cx="4572000" cy="265176"/>
           </a:xfrm>
           <a:prstGeom prst="rect">
             <a:avLst/>
@@ -24947,8 +24947,8 @@
         </p:nvSpPr>
         <p:spPr>
           <a:xfrm>
-            <a:off x="484632" y="2825496"/>
-            <a:ext cx="2194560" cy="228600"/>
+            <a:off x="484632" y="2761488"/>
+            <a:ext cx="2194560" cy="219456"/>
           </a:xfrm>
           <a:prstGeom prst="rect">
             <a:avLst/>
@@ -24982,8 +24982,8 @@
         </p:nvSpPr>
         <p:spPr>
           <a:xfrm>
-            <a:off x="2770632" y="2825496"/>
-            <a:ext cx="914400" cy="228600"/>
+            <a:off x="2770632" y="2761488"/>
+            <a:ext cx="914400" cy="219456"/>
           </a:xfrm>
           <a:prstGeom prst="rect">
             <a:avLst/>
@@ -25017,23 +25017,23 @@
         </p:nvSpPr>
         <p:spPr>
           <a:xfrm>
-            <a:off x="3776472" y="2825496"/>
-            <a:ext cx="1115568" cy="228600"/>
-          </a:xfrm>
-          <a:prstGeom prst="rect">
-            <a:avLst/>
-          </a:prstGeom>
-          <a:noFill/>
-        </p:spPr>
-        <p:txBody>
-          <a:bodyPr wrap="square">
-            <a:spAutoFit/>
-          </a:bodyPr>
-          <a:lstStyle/>
-          <a:p>
-            <a:pPr algn="l"/>
-            <a:r>
-              <a:rPr sz="700" b="0" i="0">
+            <a:off x="3776472" y="2761488"/>
+            <a:ext cx="1115568" cy="219456"/>
+          </a:xfrm>
+          <a:prstGeom prst="rect">
+            <a:avLst/>
+          </a:prstGeom>
+          <a:noFill/>
+        </p:spPr>
+        <p:txBody>
+          <a:bodyPr wrap="square">
+            <a:spAutoFit/>
+          </a:bodyPr>
+          <a:lstStyle/>
+          <a:p>
+            <a:pPr algn="l"/>
+            <a:r>
+              <a:rPr sz="750" b="0" i="0">
                 <a:solidFill>
                   <a:srgbClr val="6B7FA0"/>
                 </a:solidFill>
@@ -25052,8 +25052,8 @@
         </p:nvSpPr>
         <p:spPr>
           <a:xfrm>
-            <a:off x="411480" y="3054096"/>
-            <a:ext cx="4572000" cy="283464"/>
+            <a:off x="411480" y="2980944"/>
+            <a:ext cx="4572000" cy="265176"/>
           </a:xfrm>
           <a:prstGeom prst="rect">
             <a:avLst/>
@@ -25097,8 +25097,8 @@
         </p:nvSpPr>
         <p:spPr>
           <a:xfrm>
-            <a:off x="484632" y="3108960"/>
-            <a:ext cx="2194560" cy="228600"/>
+            <a:off x="484632" y="3026664"/>
+            <a:ext cx="2194560" cy="219456"/>
           </a:xfrm>
           <a:prstGeom prst="rect">
             <a:avLst/>
@@ -25132,8 +25132,8 @@
         </p:nvSpPr>
         <p:spPr>
           <a:xfrm>
-            <a:off x="2770632" y="3108960"/>
-            <a:ext cx="914400" cy="228600"/>
+            <a:off x="2770632" y="3026664"/>
+            <a:ext cx="914400" cy="219456"/>
           </a:xfrm>
           <a:prstGeom prst="rect">
             <a:avLst/>
@@ -25167,23 +25167,23 @@
         </p:nvSpPr>
         <p:spPr>
           <a:xfrm>
-            <a:off x="3776472" y="3108960"/>
-            <a:ext cx="1115568" cy="228600"/>
-          </a:xfrm>
-          <a:prstGeom prst="rect">
-            <a:avLst/>
-          </a:prstGeom>
-          <a:noFill/>
-        </p:spPr>
-        <p:txBody>
-          <a:bodyPr wrap="square">
-            <a:spAutoFit/>
-          </a:bodyPr>
-          <a:lstStyle/>
-          <a:p>
-            <a:pPr algn="l"/>
-            <a:r>
-              <a:rPr sz="700" b="0" i="0">
+            <a:off x="3776472" y="3026664"/>
+            <a:ext cx="1115568" cy="219456"/>
+          </a:xfrm>
+          <a:prstGeom prst="rect">
+            <a:avLst/>
+          </a:prstGeom>
+          <a:noFill/>
+        </p:spPr>
+        <p:txBody>
+          <a:bodyPr wrap="square">
+            <a:spAutoFit/>
+          </a:bodyPr>
+          <a:lstStyle/>
+          <a:p>
+            <a:pPr algn="l"/>
+            <a:r>
+              <a:rPr sz="750" b="0" i="0">
                 <a:solidFill>
                   <a:srgbClr val="6B7FA0"/>
                 </a:solidFill>
@@ -25202,7 +25202,7 @@
         </p:nvSpPr>
         <p:spPr>
           <a:xfrm>
-            <a:off x="411480" y="3447288"/>
+            <a:off x="411480" y="3319272"/>
             <a:ext cx="4572000" cy="256032"/>
           </a:xfrm>
           <a:prstGeom prst="rect">
@@ -25245,7 +25245,7 @@
         </p:nvSpPr>
         <p:spPr>
           <a:xfrm>
-            <a:off x="502920" y="3483864"/>
+            <a:off x="502920" y="3355848"/>
             <a:ext cx="4389120" cy="201168"/>
           </a:xfrm>
           <a:prstGeom prst="rect">
@@ -25280,7 +25280,7 @@
         </p:nvSpPr>
         <p:spPr>
           <a:xfrm>
-            <a:off x="502920" y="3794760"/>
+            <a:off x="502920" y="3657600"/>
             <a:ext cx="73152" cy="73152"/>
           </a:xfrm>
           <a:prstGeom prst="rect">
@@ -25323,8 +25323,8 @@
         </p:nvSpPr>
         <p:spPr>
           <a:xfrm>
-            <a:off x="667512" y="3721608"/>
-            <a:ext cx="4224528" cy="274320"/>
+            <a:off x="667512" y="3593592"/>
+            <a:ext cx="4224528" cy="237744"/>
           </a:xfrm>
           <a:prstGeom prst="rect">
             <a:avLst/>
@@ -25358,7 +25358,7 @@
         </p:nvSpPr>
         <p:spPr>
           <a:xfrm>
-            <a:off x="502920" y="4069080"/>
+            <a:off x="502920" y="3904487"/>
             <a:ext cx="73152" cy="73152"/>
           </a:xfrm>
           <a:prstGeom prst="rect">
@@ -25401,8 +25401,8 @@
         </p:nvSpPr>
         <p:spPr>
           <a:xfrm>
-            <a:off x="667512" y="3995928"/>
-            <a:ext cx="4224528" cy="274320"/>
+            <a:off x="667512" y="3840479"/>
+            <a:ext cx="4224528" cy="237744"/>
           </a:xfrm>
           <a:prstGeom prst="rect">
             <a:avLst/>
@@ -25436,7 +25436,7 @@
         </p:nvSpPr>
         <p:spPr>
           <a:xfrm>
-            <a:off x="502920" y="4343400"/>
+            <a:off x="502920" y="4151375"/>
             <a:ext cx="73152" cy="73152"/>
           </a:xfrm>
           <a:prstGeom prst="rect">
@@ -25479,8 +25479,8 @@
         </p:nvSpPr>
         <p:spPr>
           <a:xfrm>
-            <a:off x="667512" y="4270248"/>
-            <a:ext cx="4224528" cy="274320"/>
+            <a:off x="667512" y="4087367"/>
+            <a:ext cx="4224528" cy="237744"/>
           </a:xfrm>
           <a:prstGeom prst="rect">
             <a:avLst/>
@@ -25514,7 +25514,7 @@
         </p:nvSpPr>
         <p:spPr>
           <a:xfrm>
-            <a:off x="502920" y="4617720"/>
+            <a:off x="502920" y="4398263"/>
             <a:ext cx="73152" cy="73152"/>
           </a:xfrm>
           <a:prstGeom prst="rect">
@@ -25557,8 +25557,8 @@
         </p:nvSpPr>
         <p:spPr>
           <a:xfrm>
-            <a:off x="667512" y="4544568"/>
-            <a:ext cx="4224528" cy="274320"/>
+            <a:off x="667512" y="4334255"/>
+            <a:ext cx="4224528" cy="237744"/>
           </a:xfrm>
           <a:prstGeom prst="rect">
             <a:avLst/>
@@ -25592,7 +25592,7 @@
         </p:nvSpPr>
         <p:spPr>
           <a:xfrm>
-            <a:off x="502920" y="4892040"/>
+            <a:off x="502920" y="4645151"/>
             <a:ext cx="73152" cy="73152"/>
           </a:xfrm>
           <a:prstGeom prst="rect">
@@ -25635,8 +25635,8 @@
         </p:nvSpPr>
         <p:spPr>
           <a:xfrm>
-            <a:off x="667512" y="4818888"/>
-            <a:ext cx="4224528" cy="274320"/>
+            <a:off x="667512" y="4581143"/>
+            <a:ext cx="4224528" cy="237744"/>
           </a:xfrm>
           <a:prstGeom prst="rect">
             <a:avLst/>
@@ -27763,7 +27763,7 @@
         <p:spPr>
           <a:xfrm>
             <a:off x="365760" y="4462272"/>
-            <a:ext cx="5394960" cy="329184"/>
+            <a:ext cx="5394960" cy="493776"/>
           </a:xfrm>
           <a:prstGeom prst="rect">
             <a:avLst/>
@@ -27805,8 +27805,8 @@
         </p:nvSpPr>
         <p:spPr>
           <a:xfrm>
-            <a:off x="475488" y="4517136"/>
-            <a:ext cx="5175504" cy="237744"/>
+            <a:off x="475488" y="4507992"/>
+            <a:ext cx="5175504" cy="201168"/>
           </a:xfrm>
           <a:prstGeom prst="rect">
             <a:avLst/>
@@ -27827,7 +27827,7 @@
                 </a:solidFill>
                 <a:latin typeface="Calibri"/>
               </a:rPr>
-              <a:t>Filter bar:  Product · Brand · Channel (FOOD / MASS / C-STORE) · Account · Units / $ toggle</a:t>
+              <a:t>Filter bar:  Product  ·  Brand  ·  Channel (FOOD / MASS / C-STORE)  ·  Account  ·  Units / $ toggle</a:t>
             </a:r>
           </a:p>
         </p:txBody>
@@ -27840,29 +27840,29 @@
         </p:nvSpPr>
         <p:spPr>
           <a:xfrm>
-            <a:off x="475488" y="4672584"/>
-            <a:ext cx="5175504" cy="146304"/>
-          </a:xfrm>
-          <a:prstGeom prst="rect">
-            <a:avLst/>
-          </a:prstGeom>
-          <a:noFill/>
-        </p:spPr>
-        <p:txBody>
-          <a:bodyPr wrap="square">
-            <a:spAutoFit/>
-          </a:bodyPr>
-          <a:lstStyle/>
-          <a:p>
-            <a:pPr algn="l"/>
-            <a:r>
-              <a:rPr sz="750" b="0" i="1">
+            <a:off x="475488" y="4709160"/>
+            <a:ext cx="5175504" cy="201168"/>
+          </a:xfrm>
+          <a:prstGeom prst="rect">
+            <a:avLst/>
+          </a:prstGeom>
+          <a:noFill/>
+        </p:spPr>
+        <p:txBody>
+          <a:bodyPr wrap="square">
+            <a:spAutoFit/>
+          </a:bodyPr>
+          <a:lstStyle/>
+          <a:p>
+            <a:pPr algn="l"/>
+            <a:r>
+              <a:rPr sz="800" b="0" i="1">
                 <a:solidFill>
                   <a:srgbClr val="6B7FA0"/>
                 </a:solidFill>
                 <a:latin typeface="Calibri"/>
               </a:rPr>
-              <a:t>Demo defaults: BUILT Puff  +  KROGER  +  WALMART    |    MULO excluded from all Trends views</a:t>
+              <a:t>Demo defaults:  BUILT Puff  ·  KROGER + WALMART    |    MULO excluded from all Trends views</a:t>
             </a:r>
           </a:p>
         </p:txBody>
@@ -27876,7 +27876,7 @@
         <p:spPr>
           <a:xfrm>
             <a:off x="6126480" y="1097280"/>
-            <a:ext cx="5715000" cy="292608"/>
+            <a:ext cx="5715000" cy="438912"/>
           </a:xfrm>
           <a:prstGeom prst="rect">
             <a:avLst/>
@@ -27919,41 +27919,76 @@
         <p:spPr>
           <a:xfrm>
             <a:off x="6236208" y="1133856"/>
-            <a:ext cx="5495544" cy="219456"/>
-          </a:xfrm>
-          <a:prstGeom prst="rect">
-            <a:avLst/>
-          </a:prstGeom>
-          <a:noFill/>
-        </p:spPr>
-        <p:txBody>
-          <a:bodyPr wrap="square">
-            <a:spAutoFit/>
-          </a:bodyPr>
-          <a:lstStyle/>
-          <a:p>
-            <a:pPr algn="l"/>
-            <a:r>
-              <a:rPr sz="800" b="1" i="0">
+            <a:ext cx="5495544" cy="201168"/>
+          </a:xfrm>
+          <a:prstGeom prst="rect">
+            <a:avLst/>
+          </a:prstGeom>
+          <a:noFill/>
+        </p:spPr>
+        <p:txBody>
+          <a:bodyPr wrap="square">
+            <a:spAutoFit/>
+          </a:bodyPr>
+          <a:lstStyle/>
+          <a:p>
+            <a:pPr algn="l"/>
+            <a:r>
+              <a:rPr sz="900" b="1" i="0">
                 <a:solidFill>
                   <a:srgbClr val="FFFFFF"/>
                 </a:solidFill>
                 <a:latin typeface="Calibri"/>
               </a:rPr>
-              <a:t>07  ·  EXTERNAL SIGNALS — commercial redistribution required for all</a:t>
-            </a:r>
-          </a:p>
-        </p:txBody>
-      </p:sp>
-      <p:sp>
-        <p:nvSpPr>
-          <p:cNvPr id="38" name="Rectangle 37"/>
+              <a:t>07  ·  EXTERNAL SIGNALS</a:t>
+            </a:r>
+          </a:p>
+        </p:txBody>
+      </p:sp>
+      <p:sp>
+        <p:nvSpPr>
+          <p:cNvPr id="38" name="TextBox 37"/>
+          <p:cNvSpPr txBox="1"/>
+          <p:nvPr/>
+        </p:nvSpPr>
+        <p:spPr>
+          <a:xfrm>
+            <a:off x="6236208" y="1316736"/>
+            <a:ext cx="5495544" cy="182880"/>
+          </a:xfrm>
+          <a:prstGeom prst="rect">
+            <a:avLst/>
+          </a:prstGeom>
+          <a:noFill/>
+        </p:spPr>
+        <p:txBody>
+          <a:bodyPr wrap="square">
+            <a:spAutoFit/>
+          </a:bodyPr>
+          <a:lstStyle/>
+          <a:p>
+            <a:pPr algn="l"/>
+            <a:r>
+              <a:rPr sz="750" b="0" i="0">
+                <a:solidFill>
+                  <a:srgbClr val="B0E0C0"/>
+                </a:solidFill>
+                <a:latin typeface="Calibri"/>
+              </a:rPr>
+              <a:t>Commercial redistribution license required for all sources listed.</a:t>
+            </a:r>
+          </a:p>
+        </p:txBody>
+      </p:sp>
+      <p:sp>
+        <p:nvSpPr>
+          <p:cNvPr id="39" name="Rectangle 38"/>
           <p:cNvSpPr/>
           <p:nvPr/>
         </p:nvSpPr>
         <p:spPr>
           <a:xfrm>
-            <a:off x="6126480" y="1389888"/>
+            <a:off x="6126480" y="1536192"/>
             <a:ext cx="5715000" cy="237744"/>
           </a:xfrm>
           <a:prstGeom prst="rect">
@@ -27990,13 +28025,13 @@
       </p:sp>
       <p:sp>
         <p:nvSpPr>
-          <p:cNvPr id="39" name="TextBox 38"/>
-          <p:cNvSpPr txBox="1"/>
-          <p:nvPr/>
-        </p:nvSpPr>
-        <p:spPr>
-          <a:xfrm>
-            <a:off x="6236208" y="1417320"/>
+          <p:cNvPr id="40" name="TextBox 39"/>
+          <p:cNvSpPr txBox="1"/>
+          <p:nvPr/>
+        </p:nvSpPr>
+        <p:spPr>
+          <a:xfrm>
+            <a:off x="6236208" y="1563624"/>
             <a:ext cx="5495544" cy="182880"/>
           </a:xfrm>
           <a:prstGeom prst="rect">
@@ -28025,13 +28060,13 @@
       </p:sp>
       <p:sp>
         <p:nvSpPr>
-          <p:cNvPr id="40" name="Rectangle 39"/>
+          <p:cNvPr id="41" name="Rectangle 40"/>
           <p:cNvSpPr/>
           <p:nvPr/>
         </p:nvSpPr>
         <p:spPr>
           <a:xfrm>
-            <a:off x="6126480" y="1627632"/>
+            <a:off x="6126480" y="1773936"/>
             <a:ext cx="5715000" cy="329184"/>
           </a:xfrm>
           <a:prstGeom prst="rect">
@@ -28070,13 +28105,13 @@
       </p:sp>
       <p:sp>
         <p:nvSpPr>
-          <p:cNvPr id="41" name="Rectangle 40"/>
+          <p:cNvPr id="42" name="Rectangle 41"/>
           <p:cNvSpPr/>
           <p:nvPr/>
         </p:nvSpPr>
         <p:spPr>
           <a:xfrm>
-            <a:off x="6126480" y="1627632"/>
+            <a:off x="6126480" y="1773936"/>
             <a:ext cx="64008" cy="329184"/>
           </a:xfrm>
           <a:prstGeom prst="rect">
@@ -28113,13 +28148,13 @@
       </p:sp>
       <p:sp>
         <p:nvSpPr>
-          <p:cNvPr id="42" name="TextBox 41"/>
-          <p:cNvSpPr txBox="1"/>
-          <p:nvPr/>
-        </p:nvSpPr>
-        <p:spPr>
-          <a:xfrm>
-            <a:off x="6272784" y="1682496"/>
+          <p:cNvPr id="43" name="TextBox 42"/>
+          <p:cNvSpPr txBox="1"/>
+          <p:nvPr/>
+        </p:nvSpPr>
+        <p:spPr>
+          <a:xfrm>
+            <a:off x="6272784" y="1828800"/>
             <a:ext cx="1920240" cy="237744"/>
           </a:xfrm>
           <a:prstGeom prst="rect">
@@ -28148,13 +28183,13 @@
       </p:sp>
       <p:sp>
         <p:nvSpPr>
-          <p:cNvPr id="43" name="TextBox 42"/>
-          <p:cNvSpPr txBox="1"/>
-          <p:nvPr/>
-        </p:nvSpPr>
-        <p:spPr>
-          <a:xfrm>
-            <a:off x="8275320" y="1682496"/>
+          <p:cNvPr id="44" name="TextBox 43"/>
+          <p:cNvSpPr txBox="1"/>
+          <p:nvPr/>
+        </p:nvSpPr>
+        <p:spPr>
+          <a:xfrm>
+            <a:off x="8275320" y="1828800"/>
             <a:ext cx="3474720" cy="237744"/>
           </a:xfrm>
           <a:prstGeom prst="rect">
@@ -28183,13 +28218,13 @@
       </p:sp>
       <p:sp>
         <p:nvSpPr>
-          <p:cNvPr id="44" name="Rectangle 43"/>
+          <p:cNvPr id="45" name="Rectangle 44"/>
           <p:cNvSpPr/>
           <p:nvPr/>
         </p:nvSpPr>
         <p:spPr>
           <a:xfrm>
-            <a:off x="6126480" y="1956816"/>
+            <a:off x="6126480" y="2103120"/>
             <a:ext cx="5715000" cy="329184"/>
           </a:xfrm>
           <a:prstGeom prst="rect">
@@ -28228,13 +28263,13 @@
       </p:sp>
       <p:sp>
         <p:nvSpPr>
-          <p:cNvPr id="45" name="Rectangle 44"/>
+          <p:cNvPr id="46" name="Rectangle 45"/>
           <p:cNvSpPr/>
           <p:nvPr/>
         </p:nvSpPr>
         <p:spPr>
           <a:xfrm>
-            <a:off x="6126480" y="1956816"/>
+            <a:off x="6126480" y="2103120"/>
             <a:ext cx="64008" cy="329184"/>
           </a:xfrm>
           <a:prstGeom prst="rect">
@@ -28271,13 +28306,13 @@
       </p:sp>
       <p:sp>
         <p:nvSpPr>
-          <p:cNvPr id="46" name="TextBox 45"/>
-          <p:cNvSpPr txBox="1"/>
-          <p:nvPr/>
-        </p:nvSpPr>
-        <p:spPr>
-          <a:xfrm>
-            <a:off x="6272784" y="2011680"/>
+          <p:cNvPr id="47" name="TextBox 46"/>
+          <p:cNvSpPr txBox="1"/>
+          <p:nvPr/>
+        </p:nvSpPr>
+        <p:spPr>
+          <a:xfrm>
+            <a:off x="6272784" y="2157984"/>
             <a:ext cx="1920240" cy="237744"/>
           </a:xfrm>
           <a:prstGeom prst="rect">
@@ -28306,13 +28341,13 @@
       </p:sp>
       <p:sp>
         <p:nvSpPr>
-          <p:cNvPr id="47" name="TextBox 46"/>
-          <p:cNvSpPr txBox="1"/>
-          <p:nvPr/>
-        </p:nvSpPr>
-        <p:spPr>
-          <a:xfrm>
-            <a:off x="8275320" y="2011680"/>
+          <p:cNvPr id="48" name="TextBox 47"/>
+          <p:cNvSpPr txBox="1"/>
+          <p:nvPr/>
+        </p:nvSpPr>
+        <p:spPr>
+          <a:xfrm>
+            <a:off x="8275320" y="2157984"/>
             <a:ext cx="3474720" cy="237744"/>
           </a:xfrm>
           <a:prstGeom prst="rect">
@@ -28341,13 +28376,13 @@
       </p:sp>
       <p:sp>
         <p:nvSpPr>
-          <p:cNvPr id="48" name="Rectangle 47"/>
+          <p:cNvPr id="49" name="Rectangle 48"/>
           <p:cNvSpPr/>
           <p:nvPr/>
         </p:nvSpPr>
         <p:spPr>
           <a:xfrm>
-            <a:off x="6126480" y="2377440"/>
+            <a:off x="6126480" y="2523744"/>
             <a:ext cx="5715000" cy="237744"/>
           </a:xfrm>
           <a:prstGeom prst="rect">
@@ -28384,13 +28419,13 @@
       </p:sp>
       <p:sp>
         <p:nvSpPr>
-          <p:cNvPr id="49" name="TextBox 48"/>
-          <p:cNvSpPr txBox="1"/>
-          <p:nvPr/>
-        </p:nvSpPr>
-        <p:spPr>
-          <a:xfrm>
-            <a:off x="6236208" y="2414016"/>
+          <p:cNvPr id="50" name="TextBox 49"/>
+          <p:cNvSpPr txBox="1"/>
+          <p:nvPr/>
+        </p:nvSpPr>
+        <p:spPr>
+          <a:xfrm>
+            <a:off x="6236208" y="2560320"/>
             <a:ext cx="5495544" cy="182880"/>
           </a:xfrm>
           <a:prstGeom prst="rect">
@@ -28419,13 +28454,13 @@
       </p:sp>
       <p:sp>
         <p:nvSpPr>
-          <p:cNvPr id="50" name="Rectangle 49"/>
+          <p:cNvPr id="51" name="Rectangle 50"/>
           <p:cNvSpPr/>
           <p:nvPr/>
         </p:nvSpPr>
         <p:spPr>
           <a:xfrm>
-            <a:off x="6126480" y="2615184"/>
+            <a:off x="6126480" y="2761487"/>
             <a:ext cx="5715000" cy="329184"/>
           </a:xfrm>
           <a:prstGeom prst="rect">
@@ -28464,13 +28499,13 @@
       </p:sp>
       <p:sp>
         <p:nvSpPr>
-          <p:cNvPr id="51" name="Rectangle 50"/>
+          <p:cNvPr id="52" name="Rectangle 51"/>
           <p:cNvSpPr/>
           <p:nvPr/>
         </p:nvSpPr>
         <p:spPr>
           <a:xfrm>
-            <a:off x="6126480" y="2615184"/>
+            <a:off x="6126480" y="2761487"/>
             <a:ext cx="64008" cy="329184"/>
           </a:xfrm>
           <a:prstGeom prst="rect">
@@ -28507,13 +28542,13 @@
       </p:sp>
       <p:sp>
         <p:nvSpPr>
-          <p:cNvPr id="52" name="TextBox 51"/>
-          <p:cNvSpPr txBox="1"/>
-          <p:nvPr/>
-        </p:nvSpPr>
-        <p:spPr>
-          <a:xfrm>
-            <a:off x="6272784" y="2670048"/>
+          <p:cNvPr id="53" name="TextBox 52"/>
+          <p:cNvSpPr txBox="1"/>
+          <p:nvPr/>
+        </p:nvSpPr>
+        <p:spPr>
+          <a:xfrm>
+            <a:off x="6272784" y="2816351"/>
             <a:ext cx="1920240" cy="237744"/>
           </a:xfrm>
           <a:prstGeom prst="rect">
@@ -28542,13 +28577,13 @@
       </p:sp>
       <p:sp>
         <p:nvSpPr>
-          <p:cNvPr id="53" name="TextBox 52"/>
-          <p:cNvSpPr txBox="1"/>
-          <p:nvPr/>
-        </p:nvSpPr>
-        <p:spPr>
-          <a:xfrm>
-            <a:off x="8275320" y="2670048"/>
+          <p:cNvPr id="54" name="TextBox 53"/>
+          <p:cNvSpPr txBox="1"/>
+          <p:nvPr/>
+        </p:nvSpPr>
+        <p:spPr>
+          <a:xfrm>
+            <a:off x="8275320" y="2816351"/>
             <a:ext cx="3474720" cy="237744"/>
           </a:xfrm>
           <a:prstGeom prst="rect">
@@ -28577,13 +28612,13 @@
       </p:sp>
       <p:sp>
         <p:nvSpPr>
-          <p:cNvPr id="54" name="Rectangle 53"/>
+          <p:cNvPr id="55" name="Rectangle 54"/>
           <p:cNvSpPr/>
           <p:nvPr/>
         </p:nvSpPr>
         <p:spPr>
           <a:xfrm>
-            <a:off x="6126480" y="2944368"/>
+            <a:off x="6126480" y="3090671"/>
             <a:ext cx="5715000" cy="329184"/>
           </a:xfrm>
           <a:prstGeom prst="rect">
@@ -28622,13 +28657,13 @@
       </p:sp>
       <p:sp>
         <p:nvSpPr>
-          <p:cNvPr id="55" name="Rectangle 54"/>
+          <p:cNvPr id="56" name="Rectangle 55"/>
           <p:cNvSpPr/>
           <p:nvPr/>
         </p:nvSpPr>
         <p:spPr>
           <a:xfrm>
-            <a:off x="6126480" y="2944368"/>
+            <a:off x="6126480" y="3090671"/>
             <a:ext cx="64008" cy="329184"/>
           </a:xfrm>
           <a:prstGeom prst="rect">
@@ -28665,13 +28700,13 @@
       </p:sp>
       <p:sp>
         <p:nvSpPr>
-          <p:cNvPr id="56" name="TextBox 55"/>
-          <p:cNvSpPr txBox="1"/>
-          <p:nvPr/>
-        </p:nvSpPr>
-        <p:spPr>
-          <a:xfrm>
-            <a:off x="6272784" y="2999232"/>
+          <p:cNvPr id="57" name="TextBox 56"/>
+          <p:cNvSpPr txBox="1"/>
+          <p:nvPr/>
+        </p:nvSpPr>
+        <p:spPr>
+          <a:xfrm>
+            <a:off x="6272784" y="3145535"/>
             <a:ext cx="1920240" cy="237744"/>
           </a:xfrm>
           <a:prstGeom prst="rect">
@@ -28700,13 +28735,13 @@
       </p:sp>
       <p:sp>
         <p:nvSpPr>
-          <p:cNvPr id="57" name="TextBox 56"/>
-          <p:cNvSpPr txBox="1"/>
-          <p:nvPr/>
-        </p:nvSpPr>
-        <p:spPr>
-          <a:xfrm>
-            <a:off x="8275320" y="2999232"/>
+          <p:cNvPr id="58" name="TextBox 57"/>
+          <p:cNvSpPr txBox="1"/>
+          <p:nvPr/>
+        </p:nvSpPr>
+        <p:spPr>
+          <a:xfrm>
+            <a:off x="8275320" y="3145535"/>
             <a:ext cx="3474720" cy="237744"/>
           </a:xfrm>
           <a:prstGeom prst="rect">
@@ -28735,13 +28770,13 @@
       </p:sp>
       <p:sp>
         <p:nvSpPr>
-          <p:cNvPr id="58" name="Rectangle 57"/>
+          <p:cNvPr id="59" name="Rectangle 58"/>
           <p:cNvSpPr/>
           <p:nvPr/>
         </p:nvSpPr>
         <p:spPr>
           <a:xfrm>
-            <a:off x="6126480" y="3273552"/>
+            <a:off x="6126480" y="3419855"/>
             <a:ext cx="5715000" cy="329184"/>
           </a:xfrm>
           <a:prstGeom prst="rect">
@@ -28780,13 +28815,13 @@
       </p:sp>
       <p:sp>
         <p:nvSpPr>
-          <p:cNvPr id="59" name="Rectangle 58"/>
+          <p:cNvPr id="60" name="Rectangle 59"/>
           <p:cNvSpPr/>
           <p:nvPr/>
         </p:nvSpPr>
         <p:spPr>
           <a:xfrm>
-            <a:off x="6126480" y="3273552"/>
+            <a:off x="6126480" y="3419855"/>
             <a:ext cx="64008" cy="329184"/>
           </a:xfrm>
           <a:prstGeom prst="rect">
@@ -28823,13 +28858,13 @@
       </p:sp>
       <p:sp>
         <p:nvSpPr>
-          <p:cNvPr id="60" name="TextBox 59"/>
-          <p:cNvSpPr txBox="1"/>
-          <p:nvPr/>
-        </p:nvSpPr>
-        <p:spPr>
-          <a:xfrm>
-            <a:off x="6272784" y="3328416"/>
+          <p:cNvPr id="61" name="TextBox 60"/>
+          <p:cNvSpPr txBox="1"/>
+          <p:nvPr/>
+        </p:nvSpPr>
+        <p:spPr>
+          <a:xfrm>
+            <a:off x="6272784" y="3474719"/>
             <a:ext cx="1920240" cy="237744"/>
           </a:xfrm>
           <a:prstGeom prst="rect">
@@ -28858,13 +28893,13 @@
       </p:sp>
       <p:sp>
         <p:nvSpPr>
-          <p:cNvPr id="61" name="TextBox 60"/>
-          <p:cNvSpPr txBox="1"/>
-          <p:nvPr/>
-        </p:nvSpPr>
-        <p:spPr>
-          <a:xfrm>
-            <a:off x="8275320" y="3328416"/>
+          <p:cNvPr id="62" name="TextBox 61"/>
+          <p:cNvSpPr txBox="1"/>
+          <p:nvPr/>
+        </p:nvSpPr>
+        <p:spPr>
+          <a:xfrm>
+            <a:off x="8275320" y="3474719"/>
             <a:ext cx="3474720" cy="237744"/>
           </a:xfrm>
           <a:prstGeom prst="rect">
@@ -28893,13 +28928,13 @@
       </p:sp>
       <p:sp>
         <p:nvSpPr>
-          <p:cNvPr id="62" name="Rectangle 61"/>
+          <p:cNvPr id="63" name="Rectangle 62"/>
           <p:cNvSpPr/>
           <p:nvPr/>
         </p:nvSpPr>
         <p:spPr>
           <a:xfrm>
-            <a:off x="6126480" y="3602736"/>
+            <a:off x="6126480" y="3749039"/>
             <a:ext cx="5715000" cy="329184"/>
           </a:xfrm>
           <a:prstGeom prst="rect">
@@ -28938,13 +28973,13 @@
       </p:sp>
       <p:sp>
         <p:nvSpPr>
-          <p:cNvPr id="63" name="Rectangle 62"/>
+          <p:cNvPr id="64" name="Rectangle 63"/>
           <p:cNvSpPr/>
           <p:nvPr/>
         </p:nvSpPr>
         <p:spPr>
           <a:xfrm>
-            <a:off x="6126480" y="3602736"/>
+            <a:off x="6126480" y="3749039"/>
             <a:ext cx="64008" cy="329184"/>
           </a:xfrm>
           <a:prstGeom prst="rect">
@@ -28981,13 +29016,13 @@
       </p:sp>
       <p:sp>
         <p:nvSpPr>
-          <p:cNvPr id="64" name="TextBox 63"/>
-          <p:cNvSpPr txBox="1"/>
-          <p:nvPr/>
-        </p:nvSpPr>
-        <p:spPr>
-          <a:xfrm>
-            <a:off x="6272784" y="3657600"/>
+          <p:cNvPr id="65" name="TextBox 64"/>
+          <p:cNvSpPr txBox="1"/>
+          <p:nvPr/>
+        </p:nvSpPr>
+        <p:spPr>
+          <a:xfrm>
+            <a:off x="6272784" y="3803903"/>
             <a:ext cx="1920240" cy="237744"/>
           </a:xfrm>
           <a:prstGeom prst="rect">
@@ -29016,13 +29051,13 @@
       </p:sp>
       <p:sp>
         <p:nvSpPr>
-          <p:cNvPr id="65" name="TextBox 64"/>
-          <p:cNvSpPr txBox="1"/>
-          <p:nvPr/>
-        </p:nvSpPr>
-        <p:spPr>
-          <a:xfrm>
-            <a:off x="8275320" y="3657600"/>
+          <p:cNvPr id="66" name="TextBox 65"/>
+          <p:cNvSpPr txBox="1"/>
+          <p:nvPr/>
+        </p:nvSpPr>
+        <p:spPr>
+          <a:xfrm>
+            <a:off x="8275320" y="3803903"/>
             <a:ext cx="3474720" cy="237744"/>
           </a:xfrm>
           <a:prstGeom prst="rect">
@@ -29051,13 +29086,13 @@
       </p:sp>
       <p:sp>
         <p:nvSpPr>
-          <p:cNvPr id="66" name="Rectangle 65"/>
+          <p:cNvPr id="67" name="Rectangle 66"/>
           <p:cNvSpPr/>
           <p:nvPr/>
         </p:nvSpPr>
         <p:spPr>
           <a:xfrm>
-            <a:off x="6126480" y="3931920"/>
+            <a:off x="6126480" y="4078224"/>
             <a:ext cx="5715000" cy="329184"/>
           </a:xfrm>
           <a:prstGeom prst="rect">
@@ -29096,13 +29131,13 @@
       </p:sp>
       <p:sp>
         <p:nvSpPr>
-          <p:cNvPr id="67" name="Rectangle 66"/>
+          <p:cNvPr id="68" name="Rectangle 67"/>
           <p:cNvSpPr/>
           <p:nvPr/>
         </p:nvSpPr>
         <p:spPr>
           <a:xfrm>
-            <a:off x="6126480" y="3931920"/>
+            <a:off x="6126480" y="4078224"/>
             <a:ext cx="64008" cy="329184"/>
           </a:xfrm>
           <a:prstGeom prst="rect">
@@ -29139,13 +29174,13 @@
       </p:sp>
       <p:sp>
         <p:nvSpPr>
-          <p:cNvPr id="68" name="TextBox 67"/>
-          <p:cNvSpPr txBox="1"/>
-          <p:nvPr/>
-        </p:nvSpPr>
-        <p:spPr>
-          <a:xfrm>
-            <a:off x="6272784" y="3986783"/>
+          <p:cNvPr id="69" name="TextBox 68"/>
+          <p:cNvSpPr txBox="1"/>
+          <p:nvPr/>
+        </p:nvSpPr>
+        <p:spPr>
+          <a:xfrm>
+            <a:off x="6272784" y="4133087"/>
             <a:ext cx="1920240" cy="237744"/>
           </a:xfrm>
           <a:prstGeom prst="rect">
@@ -29174,13 +29209,13 @@
       </p:sp>
       <p:sp>
         <p:nvSpPr>
-          <p:cNvPr id="69" name="TextBox 68"/>
-          <p:cNvSpPr txBox="1"/>
-          <p:nvPr/>
-        </p:nvSpPr>
-        <p:spPr>
-          <a:xfrm>
-            <a:off x="8275320" y="3986783"/>
+          <p:cNvPr id="70" name="TextBox 69"/>
+          <p:cNvSpPr txBox="1"/>
+          <p:nvPr/>
+        </p:nvSpPr>
+        <p:spPr>
+          <a:xfrm>
+            <a:off x="8275320" y="4133087"/>
             <a:ext cx="3474720" cy="237744"/>
           </a:xfrm>
           <a:prstGeom prst="rect">
@@ -29209,7 +29244,7 @@
       </p:sp>
       <p:sp>
         <p:nvSpPr>
-          <p:cNvPr id="70" name="TextBox 69"/>
+          <p:cNvPr id="71" name="TextBox 70"/>
           <p:cNvSpPr txBox="1"/>
           <p:nvPr/>
         </p:nvSpPr>

</xml_diff>

<commit_message>
Redesign Slide 10 timeline: fix truncation, eliminate empty space, add deliverable strips
- Increase card header height 0.5→0.72" and title font 11→13pt so two-line titles
  ("Iterate & / Phase 2 Scope") render without clipping
- Reduce card height 4.5→3.8" to eliminate the ~3" of blank space below content
- Add 4th bullet to each card for completeness
- Add colored Deliverable strip at the bottom of each card (key output per phase)
- Replace horizontal arrow+circles with simple → connectors between cards
- Bottom note moved up to match new card geometry

Co-Authored-By: Claude Sonnet 4.6 <noreply@anthropic.com>
</commit_message>
<xml_diff>
--- a/mockups/mo_data_ops_kickoff.pptx
+++ b/mockups/mo_data_ops_kickoff.pptx
@@ -4096,129 +4096,8 @@
         </p:nvSpPr>
         <p:spPr>
           <a:xfrm>
-            <a:off x="457200" y="1874519"/>
-            <a:ext cx="11292840" cy="54864"/>
-          </a:xfrm>
-          <a:prstGeom prst="rect">
-            <a:avLst/>
-          </a:prstGeom>
-          <a:solidFill>
-            <a:srgbClr val="4078D0"/>
-          </a:solidFill>
-          <a:ln>
-            <a:noFill/>
-          </a:ln>
-        </p:spPr>
-        <p:style>
-          <a:lnRef idx="1">
-            <a:schemeClr val="accent1"/>
-          </a:lnRef>
-          <a:fillRef idx="3">
-            <a:schemeClr val="accent1"/>
-          </a:fillRef>
-          <a:effectRef idx="2">
-            <a:schemeClr val="accent1"/>
-          </a:effectRef>
-          <a:fontRef idx="minor">
-            <a:schemeClr val="lt1"/>
-          </a:fontRef>
-        </p:style>
-        <p:txBody>
-          <a:bodyPr rtlCol="0" anchor="ctr"/>
-          <a:lstStyle/>
-          <a:p>
-            <a:pPr algn="ctr"/>
-          </a:p>
-        </p:txBody>
-      </p:sp>
-      <p:sp>
-        <p:nvSpPr>
-          <p:cNvPr id="8" name="TextBox 7"/>
-          <p:cNvSpPr txBox="1"/>
-          <p:nvPr/>
-        </p:nvSpPr>
-        <p:spPr>
-          <a:xfrm>
-            <a:off x="11612880" y="1764791"/>
-            <a:ext cx="365760" cy="274320"/>
-          </a:xfrm>
-          <a:prstGeom prst="rect">
-            <a:avLst/>
-          </a:prstGeom>
-          <a:noFill/>
-        </p:spPr>
-        <p:txBody>
-          <a:bodyPr wrap="square">
-            <a:spAutoFit/>
-          </a:bodyPr>
-          <a:lstStyle/>
-          <a:p>
-            <a:pPr algn="l"/>
-            <a:r>
-              <a:rPr sz="1400" b="0" i="0">
-                <a:solidFill>
-                  <a:srgbClr val="4078D0"/>
-                </a:solidFill>
-                <a:latin typeface="Calibri"/>
-              </a:rPr>
-              <a:t>▶</a:t>
-            </a:r>
-          </a:p>
-        </p:txBody>
-      </p:sp>
-      <p:sp>
-        <p:nvSpPr>
-          <p:cNvPr id="9" name="Oval 8"/>
-          <p:cNvSpPr/>
-          <p:nvPr/>
-        </p:nvSpPr>
-        <p:spPr>
-          <a:xfrm>
-            <a:off x="1613916" y="1746503"/>
-            <a:ext cx="292608" cy="292608"/>
-          </a:xfrm>
-          <a:prstGeom prst="ellipse">
-            <a:avLst/>
-          </a:prstGeom>
-          <a:solidFill>
-            <a:srgbClr val="4078D0"/>
-          </a:solidFill>
-          <a:ln>
-            <a:noFill/>
-          </a:ln>
-        </p:spPr>
-        <p:style>
-          <a:lnRef idx="1">
-            <a:schemeClr val="accent1"/>
-          </a:lnRef>
-          <a:fillRef idx="3">
-            <a:schemeClr val="accent1"/>
-          </a:fillRef>
-          <a:effectRef idx="2">
-            <a:schemeClr val="accent1"/>
-          </a:effectRef>
-          <a:fontRef idx="minor">
-            <a:schemeClr val="lt1"/>
-          </a:fontRef>
-        </p:style>
-        <p:txBody>
-          <a:bodyPr rtlCol="0" anchor="ctr"/>
-          <a:lstStyle/>
-          <a:p>
-            <a:pPr algn="ctr"/>
-          </a:p>
-        </p:txBody>
-      </p:sp>
-      <p:sp>
-        <p:nvSpPr>
-          <p:cNvPr id="10" name="Rectangle 9"/>
-          <p:cNvSpPr/>
-          <p:nvPr/>
-        </p:nvSpPr>
-        <p:spPr>
-          <a:xfrm>
-            <a:off x="457200" y="1234440"/>
-            <a:ext cx="2606040" cy="4114800"/>
+            <a:off x="457200" y="1188720"/>
+            <a:ext cx="2606040" cy="3474720"/>
           </a:xfrm>
           <a:prstGeom prst="rect">
             <a:avLst/>
@@ -4256,14 +4135,14 @@
       </p:sp>
       <p:sp>
         <p:nvSpPr>
-          <p:cNvPr id="11" name="Rectangle 10"/>
+          <p:cNvPr id="8" name="Rectangle 7"/>
           <p:cNvSpPr/>
           <p:nvPr/>
         </p:nvSpPr>
         <p:spPr>
           <a:xfrm>
-            <a:off x="457200" y="1234440"/>
-            <a:ext cx="2606040" cy="457200"/>
+            <a:off x="457200" y="1188720"/>
+            <a:ext cx="2606040" cy="658368"/>
           </a:xfrm>
           <a:prstGeom prst="rect">
             <a:avLst/>
@@ -4299,29 +4178,29 @@
       </p:sp>
       <p:sp>
         <p:nvSpPr>
-          <p:cNvPr id="12" name="TextBox 11"/>
-          <p:cNvSpPr txBox="1"/>
-          <p:nvPr/>
-        </p:nvSpPr>
-        <p:spPr>
-          <a:xfrm>
-            <a:off x="566928" y="1289304"/>
-            <a:ext cx="2386584" cy="164592"/>
-          </a:xfrm>
-          <a:prstGeom prst="rect">
-            <a:avLst/>
-          </a:prstGeom>
-          <a:noFill/>
-        </p:spPr>
-        <p:txBody>
-          <a:bodyPr wrap="square">
-            <a:spAutoFit/>
-          </a:bodyPr>
-          <a:lstStyle/>
-          <a:p>
-            <a:pPr algn="l"/>
-            <a:r>
-              <a:rPr sz="750" b="1" i="0">
+          <p:cNvPr id="9" name="TextBox 8"/>
+          <p:cNvSpPr txBox="1"/>
+          <p:nvPr/>
+        </p:nvSpPr>
+        <p:spPr>
+          <a:xfrm>
+            <a:off x="566928" y="1252728"/>
+            <a:ext cx="2386584" cy="182880"/>
+          </a:xfrm>
+          <a:prstGeom prst="rect">
+            <a:avLst/>
+          </a:prstGeom>
+          <a:noFill/>
+        </p:spPr>
+        <p:txBody>
+          <a:bodyPr wrap="square">
+            <a:spAutoFit/>
+          </a:bodyPr>
+          <a:lstStyle/>
+          <a:p>
+            <a:pPr algn="l"/>
+            <a:r>
+              <a:rPr sz="800" b="1" i="0">
                 <a:solidFill>
                   <a:srgbClr val="FFFFFF"/>
                 </a:solidFill>
@@ -4334,29 +4213,29 @@
       </p:sp>
       <p:sp>
         <p:nvSpPr>
-          <p:cNvPr id="13" name="TextBox 12"/>
-          <p:cNvSpPr txBox="1"/>
-          <p:nvPr/>
-        </p:nvSpPr>
-        <p:spPr>
-          <a:xfrm>
-            <a:off x="566928" y="1453896"/>
-            <a:ext cx="2386584" cy="274320"/>
-          </a:xfrm>
-          <a:prstGeom prst="rect">
-            <a:avLst/>
-          </a:prstGeom>
-          <a:noFill/>
-        </p:spPr>
-        <p:txBody>
-          <a:bodyPr wrap="square">
-            <a:spAutoFit/>
-          </a:bodyPr>
-          <a:lstStyle/>
-          <a:p>
-            <a:pPr algn="l"/>
-            <a:r>
-              <a:rPr sz="1100" b="1" i="0">
+          <p:cNvPr id="10" name="TextBox 9"/>
+          <p:cNvSpPr txBox="1"/>
+          <p:nvPr/>
+        </p:nvSpPr>
+        <p:spPr>
+          <a:xfrm>
+            <a:off x="566928" y="1435608"/>
+            <a:ext cx="2386584" cy="438912"/>
+          </a:xfrm>
+          <a:prstGeom prst="rect">
+            <a:avLst/>
+          </a:prstGeom>
+          <a:noFill/>
+        </p:spPr>
+        <p:txBody>
+          <a:bodyPr wrap="square">
+            <a:spAutoFit/>
+          </a:bodyPr>
+          <a:lstStyle/>
+          <a:p>
+            <a:pPr algn="l"/>
+            <a:r>
+              <a:rPr sz="1300" b="1" i="0">
                 <a:solidFill>
                   <a:srgbClr val="FFFFFF"/>
                 </a:solidFill>
@@ -4370,14 +4249,14 @@
       </p:sp>
       <p:sp>
         <p:nvSpPr>
-          <p:cNvPr id="14" name="Rectangle 13"/>
+          <p:cNvPr id="11" name="Rectangle 10"/>
           <p:cNvSpPr/>
           <p:nvPr/>
         </p:nvSpPr>
         <p:spPr>
           <a:xfrm>
-            <a:off x="457200" y="1691640"/>
-            <a:ext cx="2606040" cy="3657600"/>
+            <a:off x="457200" y="1847088"/>
+            <a:ext cx="2606040" cy="2414016"/>
           </a:xfrm>
           <a:prstGeom prst="rect">
             <a:avLst/>
@@ -4415,57 +4294,58 @@
       </p:sp>
       <p:sp>
         <p:nvSpPr>
-          <p:cNvPr id="15" name="TextBox 14"/>
-          <p:cNvSpPr txBox="1"/>
-          <p:nvPr/>
-        </p:nvSpPr>
-        <p:spPr>
-          <a:xfrm>
-            <a:off x="585216" y="1783080"/>
-            <a:ext cx="2350008" cy="3474720"/>
-          </a:xfrm>
-          <a:prstGeom prst="rect">
-            <a:avLst/>
-          </a:prstGeom>
-          <a:noFill/>
-        </p:spPr>
-        <p:txBody>
-          <a:bodyPr wrap="square">
-            <a:spAutoFit/>
-          </a:bodyPr>
-          <a:lstStyle/>
-          <a:p>
-            <a:pPr algn="l"/>
-            <a:r>
-              <a:rPr sz="900" b="0" i="0">
+          <p:cNvPr id="12" name="TextBox 11"/>
+          <p:cNvSpPr txBox="1"/>
+          <p:nvPr/>
+        </p:nvSpPr>
+        <p:spPr>
+          <a:xfrm>
+            <a:off x="585216" y="1956816"/>
+            <a:ext cx="2350008" cy="2249424"/>
+          </a:xfrm>
+          <a:prstGeom prst="rect">
+            <a:avLst/>
+          </a:prstGeom>
+          <a:noFill/>
+        </p:spPr>
+        <p:txBody>
+          <a:bodyPr wrap="square">
+            <a:spAutoFit/>
+          </a:bodyPr>
+          <a:lstStyle/>
+          <a:p>
+            <a:pPr algn="l"/>
+            <a:r>
+              <a:rPr sz="950" b="0" i="0">
                 <a:solidFill>
                   <a:srgbClr val="111827"/>
                 </a:solidFill>
                 <a:latin typeface="Calibri"/>
               </a:rPr>
-              <a:t>BUILT confirms SPINS export format and schedule
-Aevah confirms storage, file-watch trigger, and QA gate configuration
-Both teams agree on data scope and contact points</a:t>
-            </a:r>
-          </a:p>
-        </p:txBody>
-      </p:sp>
-      <p:sp>
-        <p:nvSpPr>
-          <p:cNvPr id="16" name="Oval 15"/>
+              <a:t>BUILT confirms SPINS export format and deposit schedule
+Aevah configures storage, file-watch trigger, and QA gates
+Both teams agree on data scope and stakeholder map
+Kickoff RACI reviewed and signed off by both teams</a:t>
+            </a:r>
+          </a:p>
+        </p:txBody>
+      </p:sp>
+      <p:sp>
+        <p:nvSpPr>
+          <p:cNvPr id="13" name="Rectangle 12"/>
           <p:cNvSpPr/>
           <p:nvPr/>
         </p:nvSpPr>
         <p:spPr>
           <a:xfrm>
-            <a:off x="4585716" y="1746503"/>
-            <a:ext cx="292608" cy="292608"/>
-          </a:xfrm>
-          <a:prstGeom prst="ellipse">
+            <a:off x="457200" y="4261103"/>
+            <a:ext cx="2606040" cy="402336"/>
+          </a:xfrm>
+          <a:prstGeom prst="rect">
             <a:avLst/>
           </a:prstGeom>
           <a:solidFill>
-            <a:srgbClr val="0E5E38"/>
+            <a:srgbClr val="4078D0"/>
           </a:solidFill>
           <a:ln>
             <a:noFill/>
@@ -4495,14 +4375,84 @@
       </p:sp>
       <p:sp>
         <p:nvSpPr>
-          <p:cNvPr id="17" name="Rectangle 16"/>
+          <p:cNvPr id="14" name="TextBox 13"/>
+          <p:cNvSpPr txBox="1"/>
+          <p:nvPr/>
+        </p:nvSpPr>
+        <p:spPr>
+          <a:xfrm>
+            <a:off x="566928" y="4343399"/>
+            <a:ext cx="2386584" cy="292608"/>
+          </a:xfrm>
+          <a:prstGeom prst="rect">
+            <a:avLst/>
+          </a:prstGeom>
+          <a:noFill/>
+        </p:spPr>
+        <p:txBody>
+          <a:bodyPr wrap="square">
+            <a:spAutoFit/>
+          </a:bodyPr>
+          <a:lstStyle/>
+          <a:p>
+            <a:pPr algn="l"/>
+            <a:r>
+              <a:rPr sz="800" b="0" i="0">
+                <a:solidFill>
+                  <a:srgbClr val="FFFFFF"/>
+                </a:solidFill>
+                <a:latin typeface="Calibri"/>
+              </a:rPr>
+              <a:t>Deliverable:  Data Commitment confirmed + storage access granted</a:t>
+            </a:r>
+          </a:p>
+        </p:txBody>
+      </p:sp>
+      <p:sp>
+        <p:nvSpPr>
+          <p:cNvPr id="15" name="TextBox 14"/>
+          <p:cNvSpPr txBox="1"/>
+          <p:nvPr/>
+        </p:nvSpPr>
+        <p:spPr>
+          <a:xfrm>
+            <a:off x="3081528" y="2816352"/>
+            <a:ext cx="329184" cy="256032"/>
+          </a:xfrm>
+          <a:prstGeom prst="rect">
+            <a:avLst/>
+          </a:prstGeom>
+          <a:noFill/>
+        </p:spPr>
+        <p:txBody>
+          <a:bodyPr wrap="square">
+            <a:spAutoFit/>
+          </a:bodyPr>
+          <a:lstStyle/>
+          <a:p>
+            <a:pPr algn="ctr"/>
+            <a:r>
+              <a:rPr sz="1600" b="1" i="0">
+                <a:solidFill>
+                  <a:srgbClr val="4078D0"/>
+                </a:solidFill>
+                <a:latin typeface="Calibri"/>
+              </a:rPr>
+              <a:t>→</a:t>
+            </a:r>
+          </a:p>
+        </p:txBody>
+      </p:sp>
+      <p:sp>
+        <p:nvSpPr>
+          <p:cNvPr id="16" name="Rectangle 15"/>
           <p:cNvSpPr/>
           <p:nvPr/>
         </p:nvSpPr>
         <p:spPr>
           <a:xfrm>
-            <a:off x="3429000" y="1234440"/>
-            <a:ext cx="2606040" cy="4114800"/>
+            <a:off x="3429000" y="1188720"/>
+            <a:ext cx="2606040" cy="3474720"/>
           </a:xfrm>
           <a:prstGeom prst="rect">
             <a:avLst/>
@@ -4540,14 +4490,14 @@
       </p:sp>
       <p:sp>
         <p:nvSpPr>
-          <p:cNvPr id="18" name="Rectangle 17"/>
+          <p:cNvPr id="17" name="Rectangle 16"/>
           <p:cNvSpPr/>
           <p:nvPr/>
         </p:nvSpPr>
         <p:spPr>
           <a:xfrm>
-            <a:off x="3429000" y="1234440"/>
-            <a:ext cx="2606040" cy="457200"/>
+            <a:off x="3429000" y="1188720"/>
+            <a:ext cx="2606040" cy="658368"/>
           </a:xfrm>
           <a:prstGeom prst="rect">
             <a:avLst/>
@@ -4583,64 +4533,64 @@
       </p:sp>
       <p:sp>
         <p:nvSpPr>
+          <p:cNvPr id="18" name="TextBox 17"/>
+          <p:cNvSpPr txBox="1"/>
+          <p:nvPr/>
+        </p:nvSpPr>
+        <p:spPr>
+          <a:xfrm>
+            <a:off x="3538728" y="1252728"/>
+            <a:ext cx="2386584" cy="182880"/>
+          </a:xfrm>
+          <a:prstGeom prst="rect">
+            <a:avLst/>
+          </a:prstGeom>
+          <a:noFill/>
+        </p:spPr>
+        <p:txBody>
+          <a:bodyPr wrap="square">
+            <a:spAutoFit/>
+          </a:bodyPr>
+          <a:lstStyle/>
+          <a:p>
+            <a:pPr algn="l"/>
+            <a:r>
+              <a:rPr sz="800" b="1" i="0">
+                <a:solidFill>
+                  <a:srgbClr val="FFFFFF"/>
+                </a:solidFill>
+                <a:latin typeface="Calibri"/>
+              </a:rPr>
+              <a:t>Weeks 3–6</a:t>
+            </a:r>
+          </a:p>
+        </p:txBody>
+      </p:sp>
+      <p:sp>
+        <p:nvSpPr>
           <p:cNvPr id="19" name="TextBox 18"/>
           <p:cNvSpPr txBox="1"/>
           <p:nvPr/>
         </p:nvSpPr>
         <p:spPr>
           <a:xfrm>
-            <a:off x="3538728" y="1289304"/>
-            <a:ext cx="2386584" cy="164592"/>
-          </a:xfrm>
-          <a:prstGeom prst="rect">
-            <a:avLst/>
-          </a:prstGeom>
-          <a:noFill/>
-        </p:spPr>
-        <p:txBody>
-          <a:bodyPr wrap="square">
-            <a:spAutoFit/>
-          </a:bodyPr>
-          <a:lstStyle/>
-          <a:p>
-            <a:pPr algn="l"/>
-            <a:r>
-              <a:rPr sz="750" b="1" i="0">
-                <a:solidFill>
-                  <a:srgbClr val="FFFFFF"/>
-                </a:solidFill>
-                <a:latin typeface="Calibri"/>
-              </a:rPr>
-              <a:t>Weeks 3–6</a:t>
-            </a:r>
-          </a:p>
-        </p:txBody>
-      </p:sp>
-      <p:sp>
-        <p:nvSpPr>
-          <p:cNvPr id="20" name="TextBox 19"/>
-          <p:cNvSpPr txBox="1"/>
-          <p:nvPr/>
-        </p:nvSpPr>
-        <p:spPr>
-          <a:xfrm>
-            <a:off x="3538728" y="1453896"/>
-            <a:ext cx="2386584" cy="274320"/>
-          </a:xfrm>
-          <a:prstGeom prst="rect">
-            <a:avLst/>
-          </a:prstGeom>
-          <a:noFill/>
-        </p:spPr>
-        <p:txBody>
-          <a:bodyPr wrap="square">
-            <a:spAutoFit/>
-          </a:bodyPr>
-          <a:lstStyle/>
-          <a:p>
-            <a:pPr algn="l"/>
-            <a:r>
-              <a:rPr sz="1100" b="1" i="0">
+            <a:off x="3538728" y="1435608"/>
+            <a:ext cx="2386584" cy="438912"/>
+          </a:xfrm>
+          <a:prstGeom prst="rect">
+            <a:avLst/>
+          </a:prstGeom>
+          <a:noFill/>
+        </p:spPr>
+        <p:txBody>
+          <a:bodyPr wrap="square">
+            <a:spAutoFit/>
+          </a:bodyPr>
+          <a:lstStyle/>
+          <a:p>
+            <a:pPr algn="l"/>
+            <a:r>
+              <a:rPr sz="1300" b="1" i="0">
                 <a:solidFill>
                   <a:srgbClr val="FFFFFF"/>
                 </a:solidFill>
@@ -4654,14 +4604,14 @@
       </p:sp>
       <p:sp>
         <p:nvSpPr>
-          <p:cNvPr id="21" name="Rectangle 20"/>
+          <p:cNvPr id="20" name="Rectangle 19"/>
           <p:cNvSpPr/>
           <p:nvPr/>
         </p:nvSpPr>
         <p:spPr>
           <a:xfrm>
-            <a:off x="3429000" y="1691640"/>
-            <a:ext cx="2606040" cy="3657600"/>
+            <a:off x="3429000" y="1847088"/>
+            <a:ext cx="2606040" cy="2414016"/>
           </a:xfrm>
           <a:prstGeom prst="rect">
             <a:avLst/>
@@ -4699,57 +4649,58 @@
       </p:sp>
       <p:sp>
         <p:nvSpPr>
-          <p:cNvPr id="22" name="TextBox 21"/>
-          <p:cNvSpPr txBox="1"/>
-          <p:nvPr/>
-        </p:nvSpPr>
-        <p:spPr>
-          <a:xfrm>
-            <a:off x="3557016" y="1783080"/>
-            <a:ext cx="2350008" cy="3474720"/>
-          </a:xfrm>
-          <a:prstGeom prst="rect">
-            <a:avLst/>
-          </a:prstGeom>
-          <a:noFill/>
-        </p:spPr>
-        <p:txBody>
-          <a:bodyPr wrap="square">
-            <a:spAutoFit/>
-          </a:bodyPr>
-          <a:lstStyle/>
-          <a:p>
-            <a:pPr algn="l"/>
-            <a:r>
-              <a:rPr sz="900" b="0" i="0">
+          <p:cNvPr id="21" name="TextBox 20"/>
+          <p:cNvSpPr txBox="1"/>
+          <p:nvPr/>
+        </p:nvSpPr>
+        <p:spPr>
+          <a:xfrm>
+            <a:off x="3557016" y="1956816"/>
+            <a:ext cx="2350008" cy="2249424"/>
+          </a:xfrm>
+          <a:prstGeom prst="rect">
+            <a:avLst/>
+          </a:prstGeom>
+          <a:noFill/>
+        </p:spPr>
+        <p:txBody>
+          <a:bodyPr wrap="square">
+            <a:spAutoFit/>
+          </a:bodyPr>
+          <a:lstStyle/>
+          <a:p>
+            <a:pPr algn="l"/>
+            <a:r>
+              <a:rPr sz="950" b="0" i="0">
                 <a:solidFill>
                   <a:srgbClr val="111827"/>
                 </a:solidFill>
                 <a:latin typeface="Calibri"/>
               </a:rPr>
-              <a:t>Aevah: ingest → QA → feature engineering → model training → scoring
-Aevah delivers QA report for BUILT review
-BUILT validates: does the data look right?</a:t>
-            </a:r>
-          </a:p>
-        </p:txBody>
-      </p:sp>
-      <p:sp>
-        <p:nvSpPr>
-          <p:cNvPr id="23" name="Oval 22"/>
+              <a:t>Aevah: ingest → QA → feature engineering → model training
+Aevah delivers QA report for BUILT data team review
+BUILT validates data looks right for Modules 01–02
+Data issues flagged and resolved before UI deployment</a:t>
+            </a:r>
+          </a:p>
+        </p:txBody>
+      </p:sp>
+      <p:sp>
+        <p:nvSpPr>
+          <p:cNvPr id="22" name="Rectangle 21"/>
           <p:cNvSpPr/>
           <p:nvPr/>
         </p:nvSpPr>
         <p:spPr>
           <a:xfrm>
-            <a:off x="7557516" y="1746503"/>
-            <a:ext cx="292608" cy="292608"/>
-          </a:xfrm>
-          <a:prstGeom prst="ellipse">
+            <a:off x="3429000" y="4261103"/>
+            <a:ext cx="2606040" cy="402336"/>
+          </a:xfrm>
+          <a:prstGeom prst="rect">
             <a:avLst/>
           </a:prstGeom>
           <a:solidFill>
-            <a:srgbClr val="8A4800"/>
+            <a:srgbClr val="0E5E38"/>
           </a:solidFill>
           <a:ln>
             <a:noFill/>
@@ -4779,14 +4730,84 @@
       </p:sp>
       <p:sp>
         <p:nvSpPr>
-          <p:cNvPr id="24" name="Rectangle 23"/>
+          <p:cNvPr id="23" name="TextBox 22"/>
+          <p:cNvSpPr txBox="1"/>
+          <p:nvPr/>
+        </p:nvSpPr>
+        <p:spPr>
+          <a:xfrm>
+            <a:off x="3538728" y="4343399"/>
+            <a:ext cx="2386584" cy="292608"/>
+          </a:xfrm>
+          <a:prstGeom prst="rect">
+            <a:avLst/>
+          </a:prstGeom>
+          <a:noFill/>
+        </p:spPr>
+        <p:txBody>
+          <a:bodyPr wrap="square">
+            <a:spAutoFit/>
+          </a:bodyPr>
+          <a:lstStyle/>
+          <a:p>
+            <a:pPr algn="l"/>
+            <a:r>
+              <a:rPr sz="800" b="0" i="0">
+                <a:solidFill>
+                  <a:srgbClr val="FFFFFF"/>
+                </a:solidFill>
+                <a:latin typeface="Calibri"/>
+              </a:rPr>
+              <a:t>Deliverable:  QA report delivered; Module 01–02 models trained</a:t>
+            </a:r>
+          </a:p>
+        </p:txBody>
+      </p:sp>
+      <p:sp>
+        <p:nvSpPr>
+          <p:cNvPr id="24" name="TextBox 23"/>
+          <p:cNvSpPr txBox="1"/>
+          <p:nvPr/>
+        </p:nvSpPr>
+        <p:spPr>
+          <a:xfrm>
+            <a:off x="6053327" y="2816352"/>
+            <a:ext cx="329184" cy="256032"/>
+          </a:xfrm>
+          <a:prstGeom prst="rect">
+            <a:avLst/>
+          </a:prstGeom>
+          <a:noFill/>
+        </p:spPr>
+        <p:txBody>
+          <a:bodyPr wrap="square">
+            <a:spAutoFit/>
+          </a:bodyPr>
+          <a:lstStyle/>
+          <a:p>
+            <a:pPr algn="ctr"/>
+            <a:r>
+              <a:rPr sz="1600" b="1" i="0">
+                <a:solidFill>
+                  <a:srgbClr val="4078D0"/>
+                </a:solidFill>
+                <a:latin typeface="Calibri"/>
+              </a:rPr>
+              <a:t>→</a:t>
+            </a:r>
+          </a:p>
+        </p:txBody>
+      </p:sp>
+      <p:sp>
+        <p:nvSpPr>
+          <p:cNvPr id="25" name="Rectangle 24"/>
           <p:cNvSpPr/>
           <p:nvPr/>
         </p:nvSpPr>
         <p:spPr>
           <a:xfrm>
-            <a:off x="6400800" y="1234440"/>
-            <a:ext cx="2606040" cy="4114800"/>
+            <a:off x="6400800" y="1188720"/>
+            <a:ext cx="2606040" cy="3474720"/>
           </a:xfrm>
           <a:prstGeom prst="rect">
             <a:avLst/>
@@ -4824,14 +4845,14 @@
       </p:sp>
       <p:sp>
         <p:nvSpPr>
-          <p:cNvPr id="25" name="Rectangle 24"/>
+          <p:cNvPr id="26" name="Rectangle 25"/>
           <p:cNvSpPr/>
           <p:nvPr/>
         </p:nvSpPr>
         <p:spPr>
           <a:xfrm>
-            <a:off x="6400800" y="1234440"/>
-            <a:ext cx="2606040" cy="457200"/>
+            <a:off x="6400800" y="1188720"/>
+            <a:ext cx="2606040" cy="658368"/>
           </a:xfrm>
           <a:prstGeom prst="rect">
             <a:avLst/>
@@ -4867,29 +4888,29 @@
       </p:sp>
       <p:sp>
         <p:nvSpPr>
-          <p:cNvPr id="26" name="TextBox 25"/>
-          <p:cNvSpPr txBox="1"/>
-          <p:nvPr/>
-        </p:nvSpPr>
-        <p:spPr>
-          <a:xfrm>
-            <a:off x="6510528" y="1289304"/>
-            <a:ext cx="2386584" cy="164592"/>
-          </a:xfrm>
-          <a:prstGeom prst="rect">
-            <a:avLst/>
-          </a:prstGeom>
-          <a:noFill/>
-        </p:spPr>
-        <p:txBody>
-          <a:bodyPr wrap="square">
-            <a:spAutoFit/>
-          </a:bodyPr>
-          <a:lstStyle/>
-          <a:p>
-            <a:pPr algn="l"/>
-            <a:r>
-              <a:rPr sz="750" b="1" i="0">
+          <p:cNvPr id="27" name="TextBox 26"/>
+          <p:cNvSpPr txBox="1"/>
+          <p:nvPr/>
+        </p:nvSpPr>
+        <p:spPr>
+          <a:xfrm>
+            <a:off x="6510528" y="1252728"/>
+            <a:ext cx="2386584" cy="182880"/>
+          </a:xfrm>
+          <a:prstGeom prst="rect">
+            <a:avLst/>
+          </a:prstGeom>
+          <a:noFill/>
+        </p:spPr>
+        <p:txBody>
+          <a:bodyPr wrap="square">
+            <a:spAutoFit/>
+          </a:bodyPr>
+          <a:lstStyle/>
+          <a:p>
+            <a:pPr algn="l"/>
+            <a:r>
+              <a:rPr sz="800" b="1" i="0">
                 <a:solidFill>
                   <a:srgbClr val="FFFFFF"/>
                 </a:solidFill>
@@ -4902,29 +4923,29 @@
       </p:sp>
       <p:sp>
         <p:nvSpPr>
-          <p:cNvPr id="27" name="TextBox 26"/>
-          <p:cNvSpPr txBox="1"/>
-          <p:nvPr/>
-        </p:nvSpPr>
-        <p:spPr>
-          <a:xfrm>
-            <a:off x="6510528" y="1453896"/>
-            <a:ext cx="2386584" cy="274320"/>
-          </a:xfrm>
-          <a:prstGeom prst="rect">
-            <a:avLst/>
-          </a:prstGeom>
-          <a:noFill/>
-        </p:spPr>
-        <p:txBody>
-          <a:bodyPr wrap="square">
-            <a:spAutoFit/>
-          </a:bodyPr>
-          <a:lstStyle/>
-          <a:p>
-            <a:pPr algn="l"/>
-            <a:r>
-              <a:rPr sz="1100" b="1" i="0">
+          <p:cNvPr id="28" name="TextBox 27"/>
+          <p:cNvSpPr txBox="1"/>
+          <p:nvPr/>
+        </p:nvSpPr>
+        <p:spPr>
+          <a:xfrm>
+            <a:off x="6510528" y="1435608"/>
+            <a:ext cx="2386584" cy="438912"/>
+          </a:xfrm>
+          <a:prstGeom prst="rect">
+            <a:avLst/>
+          </a:prstGeom>
+          <a:noFill/>
+        </p:spPr>
+        <p:txBody>
+          <a:bodyPr wrap="square">
+            <a:spAutoFit/>
+          </a:bodyPr>
+          <a:lstStyle/>
+          <a:p>
+            <a:pPr algn="l"/>
+            <a:r>
+              <a:rPr sz="1300" b="1" i="0">
                 <a:solidFill>
                   <a:srgbClr val="FFFFFF"/>
                 </a:solidFill>
@@ -4938,14 +4959,14 @@
       </p:sp>
       <p:sp>
         <p:nvSpPr>
-          <p:cNvPr id="28" name="Rectangle 27"/>
+          <p:cNvPr id="29" name="Rectangle 28"/>
           <p:cNvSpPr/>
           <p:nvPr/>
         </p:nvSpPr>
         <p:spPr>
           <a:xfrm>
-            <a:off x="6400800" y="1691640"/>
-            <a:ext cx="2606040" cy="3657600"/>
+            <a:off x="6400800" y="1847088"/>
+            <a:ext cx="2606040" cy="2414016"/>
           </a:xfrm>
           <a:prstGeom prst="rect">
             <a:avLst/>
@@ -4983,57 +5004,58 @@
       </p:sp>
       <p:sp>
         <p:nvSpPr>
-          <p:cNvPr id="29" name="TextBox 28"/>
-          <p:cNvSpPr txBox="1"/>
-          <p:nvPr/>
-        </p:nvSpPr>
-        <p:spPr>
-          <a:xfrm>
-            <a:off x="6528816" y="1783080"/>
-            <a:ext cx="2350008" cy="3474720"/>
-          </a:xfrm>
-          <a:prstGeom prst="rect">
-            <a:avLst/>
-          </a:prstGeom>
-          <a:noFill/>
-        </p:spPr>
-        <p:txBody>
-          <a:bodyPr wrap="square">
-            <a:spAutoFit/>
-          </a:bodyPr>
-          <a:lstStyle/>
-          <a:p>
-            <a:pPr algn="l"/>
-            <a:r>
-              <a:rPr sz="900" b="0" i="0">
+          <p:cNvPr id="30" name="TextBox 29"/>
+          <p:cNvSpPr txBox="1"/>
+          <p:nvPr/>
+        </p:nvSpPr>
+        <p:spPr>
+          <a:xfrm>
+            <a:off x="6528816" y="1956816"/>
+            <a:ext cx="2350008" cy="2249424"/>
+          </a:xfrm>
+          <a:prstGeom prst="rect">
+            <a:avLst/>
+          </a:prstGeom>
+          <a:noFill/>
+        </p:spPr>
+        <p:txBody>
+          <a:bodyPr wrap="square">
+            <a:spAutoFit/>
+          </a:bodyPr>
+          <a:lstStyle/>
+          <a:p>
+            <a:pPr algn="l"/>
+            <a:r>
+              <a:rPr sz="950" b="0" i="0">
                 <a:solidFill>
                   <a:srgbClr val="111827"/>
                 </a:solidFill>
                 <a:latin typeface="Calibri"/>
               </a:rPr>
               <a:t>Cannibalization Risk + Price Elasticity live in Mo UI
-Live demo with Brian + Connor — FOOD-channel accounts
-Connor + team provide UI feedback and projection validation</a:t>
-            </a:r>
-          </a:p>
-        </p:txBody>
-      </p:sp>
-      <p:sp>
-        <p:nvSpPr>
-          <p:cNvPr id="30" name="Oval 29"/>
+Live walkthrough with Brian + Connor — FOOD-channel accounts
+Connor + team validate projections against market knowledge
+Priority UI feedback addressed in follow-up sprint</a:t>
+            </a:r>
+          </a:p>
+        </p:txBody>
+      </p:sp>
+      <p:sp>
+        <p:nvSpPr>
+          <p:cNvPr id="31" name="Rectangle 30"/>
           <p:cNvSpPr/>
           <p:nvPr/>
         </p:nvSpPr>
         <p:spPr>
           <a:xfrm>
-            <a:off x="10529316" y="1746503"/>
-            <a:ext cx="292608" cy="292608"/>
-          </a:xfrm>
-          <a:prstGeom prst="ellipse">
+            <a:off x="6400800" y="4261103"/>
+            <a:ext cx="2606040" cy="402336"/>
+          </a:xfrm>
+          <a:prstGeom prst="rect">
             <a:avLst/>
           </a:prstGeom>
           <a:solidFill>
-            <a:srgbClr val="4B2D8A"/>
+            <a:srgbClr val="8A4800"/>
           </a:solidFill>
           <a:ln>
             <a:noFill/>
@@ -5063,14 +5085,84 @@
       </p:sp>
       <p:sp>
         <p:nvSpPr>
-          <p:cNvPr id="31" name="Rectangle 30"/>
+          <p:cNvPr id="32" name="TextBox 31"/>
+          <p:cNvSpPr txBox="1"/>
+          <p:nvPr/>
+        </p:nvSpPr>
+        <p:spPr>
+          <a:xfrm>
+            <a:off x="6510528" y="4343399"/>
+            <a:ext cx="2386584" cy="292608"/>
+          </a:xfrm>
+          <a:prstGeom prst="rect">
+            <a:avLst/>
+          </a:prstGeom>
+          <a:noFill/>
+        </p:spPr>
+        <p:txBody>
+          <a:bodyPr wrap="square">
+            <a:spAutoFit/>
+          </a:bodyPr>
+          <a:lstStyle/>
+          <a:p>
+            <a:pPr algn="l"/>
+            <a:r>
+              <a:rPr sz="800" b="0" i="0">
+                <a:solidFill>
+                  <a:srgbClr val="FFFFFF"/>
+                </a:solidFill>
+                <a:latin typeface="Calibri"/>
+              </a:rPr>
+              <a:t>Deliverable:  Phase 1 live in Mo; validation session complete</a:t>
+            </a:r>
+          </a:p>
+        </p:txBody>
+      </p:sp>
+      <p:sp>
+        <p:nvSpPr>
+          <p:cNvPr id="33" name="TextBox 32"/>
+          <p:cNvSpPr txBox="1"/>
+          <p:nvPr/>
+        </p:nvSpPr>
+        <p:spPr>
+          <a:xfrm>
+            <a:off x="9025128" y="2816352"/>
+            <a:ext cx="329184" cy="256032"/>
+          </a:xfrm>
+          <a:prstGeom prst="rect">
+            <a:avLst/>
+          </a:prstGeom>
+          <a:noFill/>
+        </p:spPr>
+        <p:txBody>
+          <a:bodyPr wrap="square">
+            <a:spAutoFit/>
+          </a:bodyPr>
+          <a:lstStyle/>
+          <a:p>
+            <a:pPr algn="ctr"/>
+            <a:r>
+              <a:rPr sz="1600" b="1" i="0">
+                <a:solidFill>
+                  <a:srgbClr val="4078D0"/>
+                </a:solidFill>
+                <a:latin typeface="Calibri"/>
+              </a:rPr>
+              <a:t>→</a:t>
+            </a:r>
+          </a:p>
+        </p:txBody>
+      </p:sp>
+      <p:sp>
+        <p:nvSpPr>
+          <p:cNvPr id="34" name="Rectangle 33"/>
           <p:cNvSpPr/>
           <p:nvPr/>
         </p:nvSpPr>
         <p:spPr>
           <a:xfrm>
-            <a:off x="9372600" y="1234440"/>
-            <a:ext cx="2606040" cy="4114800"/>
+            <a:off x="9372600" y="1188720"/>
+            <a:ext cx="2606040" cy="3474720"/>
           </a:xfrm>
           <a:prstGeom prst="rect">
             <a:avLst/>
@@ -5108,14 +5200,14 @@
       </p:sp>
       <p:sp>
         <p:nvSpPr>
-          <p:cNvPr id="32" name="Rectangle 31"/>
+          <p:cNvPr id="35" name="Rectangle 34"/>
           <p:cNvSpPr/>
           <p:nvPr/>
         </p:nvSpPr>
         <p:spPr>
           <a:xfrm>
-            <a:off x="9372600" y="1234440"/>
-            <a:ext cx="2606040" cy="457200"/>
+            <a:off x="9372600" y="1188720"/>
+            <a:ext cx="2606040" cy="658368"/>
           </a:xfrm>
           <a:prstGeom prst="rect">
             <a:avLst/>
@@ -5151,29 +5243,29 @@
       </p:sp>
       <p:sp>
         <p:nvSpPr>
-          <p:cNvPr id="33" name="TextBox 32"/>
-          <p:cNvSpPr txBox="1"/>
-          <p:nvPr/>
-        </p:nvSpPr>
-        <p:spPr>
-          <a:xfrm>
-            <a:off x="9482328" y="1289304"/>
-            <a:ext cx="2386584" cy="164592"/>
-          </a:xfrm>
-          <a:prstGeom prst="rect">
-            <a:avLst/>
-          </a:prstGeom>
-          <a:noFill/>
-        </p:spPr>
-        <p:txBody>
-          <a:bodyPr wrap="square">
-            <a:spAutoFit/>
-          </a:bodyPr>
-          <a:lstStyle/>
-          <a:p>
-            <a:pPr algn="l"/>
-            <a:r>
-              <a:rPr sz="750" b="1" i="0">
+          <p:cNvPr id="36" name="TextBox 35"/>
+          <p:cNvSpPr txBox="1"/>
+          <p:nvPr/>
+        </p:nvSpPr>
+        <p:spPr>
+          <a:xfrm>
+            <a:off x="9482328" y="1252728"/>
+            <a:ext cx="2386584" cy="182880"/>
+          </a:xfrm>
+          <a:prstGeom prst="rect">
+            <a:avLst/>
+          </a:prstGeom>
+          <a:noFill/>
+        </p:spPr>
+        <p:txBody>
+          <a:bodyPr wrap="square">
+            <a:spAutoFit/>
+          </a:bodyPr>
+          <a:lstStyle/>
+          <a:p>
+            <a:pPr algn="l"/>
+            <a:r>
+              <a:rPr sz="800" b="1" i="0">
                 <a:solidFill>
                   <a:srgbClr val="FFFFFF"/>
                 </a:solidFill>
@@ -5186,29 +5278,29 @@
       </p:sp>
       <p:sp>
         <p:nvSpPr>
-          <p:cNvPr id="34" name="TextBox 33"/>
-          <p:cNvSpPr txBox="1"/>
-          <p:nvPr/>
-        </p:nvSpPr>
-        <p:spPr>
-          <a:xfrm>
-            <a:off x="9482328" y="1453896"/>
-            <a:ext cx="2386584" cy="274320"/>
-          </a:xfrm>
-          <a:prstGeom prst="rect">
-            <a:avLst/>
-          </a:prstGeom>
-          <a:noFill/>
-        </p:spPr>
-        <p:txBody>
-          <a:bodyPr wrap="square">
-            <a:spAutoFit/>
-          </a:bodyPr>
-          <a:lstStyle/>
-          <a:p>
-            <a:pPr algn="l"/>
-            <a:r>
-              <a:rPr sz="1100" b="1" i="0">
+          <p:cNvPr id="37" name="TextBox 36"/>
+          <p:cNvSpPr txBox="1"/>
+          <p:nvPr/>
+        </p:nvSpPr>
+        <p:spPr>
+          <a:xfrm>
+            <a:off x="9482328" y="1435608"/>
+            <a:ext cx="2386584" cy="438912"/>
+          </a:xfrm>
+          <a:prstGeom prst="rect">
+            <a:avLst/>
+          </a:prstGeom>
+          <a:noFill/>
+        </p:spPr>
+        <p:txBody>
+          <a:bodyPr wrap="square">
+            <a:spAutoFit/>
+          </a:bodyPr>
+          <a:lstStyle/>
+          <a:p>
+            <a:pPr algn="l"/>
+            <a:r>
+              <a:rPr sz="1300" b="1" i="0">
                 <a:solidFill>
                   <a:srgbClr val="FFFFFF"/>
                 </a:solidFill>
@@ -5222,14 +5314,14 @@
       </p:sp>
       <p:sp>
         <p:nvSpPr>
-          <p:cNvPr id="35" name="Rectangle 34"/>
+          <p:cNvPr id="38" name="Rectangle 37"/>
           <p:cNvSpPr/>
           <p:nvPr/>
         </p:nvSpPr>
         <p:spPr>
           <a:xfrm>
-            <a:off x="9372600" y="1691640"/>
-            <a:ext cx="2606040" cy="3657600"/>
+            <a:off x="9372600" y="1847088"/>
+            <a:ext cx="2606040" cy="2414016"/>
           </a:xfrm>
           <a:prstGeom prst="rect">
             <a:avLst/>
@@ -5267,51 +5359,130 @@
       </p:sp>
       <p:sp>
         <p:nvSpPr>
-          <p:cNvPr id="36" name="TextBox 35"/>
-          <p:cNvSpPr txBox="1"/>
-          <p:nvPr/>
-        </p:nvSpPr>
-        <p:spPr>
-          <a:xfrm>
-            <a:off x="9500616" y="1783080"/>
-            <a:ext cx="2350008" cy="3474720"/>
-          </a:xfrm>
-          <a:prstGeom prst="rect">
-            <a:avLst/>
-          </a:prstGeom>
-          <a:noFill/>
-        </p:spPr>
-        <p:txBody>
-          <a:bodyPr wrap="square">
-            <a:spAutoFit/>
-          </a:bodyPr>
-          <a:lstStyle/>
-          <a:p>
-            <a:pPr algn="l"/>
-            <a:r>
-              <a:rPr sz="900" b="0" i="0">
+          <p:cNvPr id="39" name="TextBox 38"/>
+          <p:cNvSpPr txBox="1"/>
+          <p:nvPr/>
+        </p:nvSpPr>
+        <p:spPr>
+          <a:xfrm>
+            <a:off x="9500616" y="1956816"/>
+            <a:ext cx="2350008" cy="2249424"/>
+          </a:xfrm>
+          <a:prstGeom prst="rect">
+            <a:avLst/>
+          </a:prstGeom>
+          <a:noFill/>
+        </p:spPr>
+        <p:txBody>
+          <a:bodyPr wrap="square">
+            <a:spAutoFit/>
+          </a:bodyPr>
+          <a:lstStyle/>
+          <a:p>
+            <a:pPr algn="l"/>
+            <a:r>
+              <a:rPr sz="950" b="0" i="0">
                 <a:solidFill>
                   <a:srgbClr val="111827"/>
                 </a:solidFill>
                 <a:latin typeface="Calibri"/>
               </a:rPr>
-              <a:t>Address feedback; tune models based on BUILT market knowledge
+              <a:t>Address feedback; tune models on BUILT market knowledge
 Phase 1 milestone sign-off by both teams
-Begin scoping Modules 3–5 and automation roadmap for Phase 2</a:t>
-            </a:r>
-          </a:p>
-        </p:txBody>
-      </p:sp>
-      <p:sp>
-        <p:nvSpPr>
-          <p:cNvPr id="37" name="Rectangle 36"/>
+Begin scoping Modules 3–5 for Phase 2
+Connor's actuals data shared for forecast backtesting</a:t>
+            </a:r>
+          </a:p>
+        </p:txBody>
+      </p:sp>
+      <p:sp>
+        <p:nvSpPr>
+          <p:cNvPr id="40" name="Rectangle 39"/>
           <p:cNvSpPr/>
           <p:nvPr/>
         </p:nvSpPr>
         <p:spPr>
           <a:xfrm>
-            <a:off x="457200" y="5650992"/>
-            <a:ext cx="11292840" cy="475488"/>
+            <a:off x="9372600" y="4261103"/>
+            <a:ext cx="2606040" cy="402336"/>
+          </a:xfrm>
+          <a:prstGeom prst="rect">
+            <a:avLst/>
+          </a:prstGeom>
+          <a:solidFill>
+            <a:srgbClr val="4B2D8A"/>
+          </a:solidFill>
+          <a:ln>
+            <a:noFill/>
+          </a:ln>
+        </p:spPr>
+        <p:style>
+          <a:lnRef idx="1">
+            <a:schemeClr val="accent1"/>
+          </a:lnRef>
+          <a:fillRef idx="3">
+            <a:schemeClr val="accent1"/>
+          </a:fillRef>
+          <a:effectRef idx="2">
+            <a:schemeClr val="accent1"/>
+          </a:effectRef>
+          <a:fontRef idx="minor">
+            <a:schemeClr val="lt1"/>
+          </a:fontRef>
+        </p:style>
+        <p:txBody>
+          <a:bodyPr rtlCol="0" anchor="ctr"/>
+          <a:lstStyle/>
+          <a:p>
+            <a:pPr algn="ctr"/>
+          </a:p>
+        </p:txBody>
+      </p:sp>
+      <p:sp>
+        <p:nvSpPr>
+          <p:cNvPr id="41" name="TextBox 40"/>
+          <p:cNvSpPr txBox="1"/>
+          <p:nvPr/>
+        </p:nvSpPr>
+        <p:spPr>
+          <a:xfrm>
+            <a:off x="9482328" y="4343399"/>
+            <a:ext cx="2386584" cy="292608"/>
+          </a:xfrm>
+          <a:prstGeom prst="rect">
+            <a:avLst/>
+          </a:prstGeom>
+          <a:noFill/>
+        </p:spPr>
+        <p:txBody>
+          <a:bodyPr wrap="square">
+            <a:spAutoFit/>
+          </a:bodyPr>
+          <a:lstStyle/>
+          <a:p>
+            <a:pPr algn="l"/>
+            <a:r>
+              <a:rPr sz="800" b="0" i="0">
+                <a:solidFill>
+                  <a:srgbClr val="FFFFFF"/>
+                </a:solidFill>
+                <a:latin typeface="Calibri"/>
+              </a:rPr>
+              <a:t>Deliverable:  Phase 1 signed off; Phase 2 roadmap agreed</a:t>
+            </a:r>
+          </a:p>
+        </p:txBody>
+      </p:sp>
+      <p:sp>
+        <p:nvSpPr>
+          <p:cNvPr id="42" name="Rectangle 41"/>
+          <p:cNvSpPr/>
+          <p:nvPr/>
+        </p:nvSpPr>
+        <p:spPr>
+          <a:xfrm>
+            <a:off x="457200" y="4864607"/>
+            <a:ext cx="11292840" cy="493776"/>
           </a:xfrm>
           <a:prstGeom prst="rect">
             <a:avLst/>
@@ -5347,14 +5518,14 @@
       </p:sp>
       <p:sp>
         <p:nvSpPr>
-          <p:cNvPr id="38" name="TextBox 37"/>
-          <p:cNvSpPr txBox="1"/>
-          <p:nvPr/>
-        </p:nvSpPr>
-        <p:spPr>
-          <a:xfrm>
-            <a:off x="594360" y="5705856"/>
-            <a:ext cx="11064240" cy="384048"/>
+          <p:cNvPr id="43" name="TextBox 42"/>
+          <p:cNvSpPr txBox="1"/>
+          <p:nvPr/>
+        </p:nvSpPr>
+        <p:spPr>
+          <a:xfrm>
+            <a:off x="594360" y="4919471"/>
+            <a:ext cx="11064240" cy="402336"/>
           </a:xfrm>
           <a:prstGeom prst="rect">
             <a:avLst/>
@@ -5375,14 +5546,14 @@
                 </a:solidFill>
                 <a:latin typeface="Calibri"/>
               </a:rPr>
-              <a:t>Phase 2 (Modules 3–5: Promotional Response, Demand Forecast, Launch Monitoring) begins after Phase 1 sign-off milestone. Automation roadmap (incremental ingest, orchestration shell, file-watch trigger) runs in parallel as an Aevah-internal engineering sprint — no BUILT action required.</a:t>
-            </a:r>
-          </a:p>
-        </p:txBody>
-      </p:sp>
-      <p:sp>
-        <p:nvSpPr>
-          <p:cNvPr id="39" name="TextBox 38"/>
+              <a:t>Phase 2 (Modules 3–5: Promotional Response, Demand Forecast, Launch Monitoring) begins after Phase 1 sign-off. Automation roadmap (incremental ingest, orchestration shell, file-watch trigger) runs as an Aevah-internal engineering sprint — no BUILT action required.</a:t>
+            </a:r>
+          </a:p>
+        </p:txBody>
+      </p:sp>
+      <p:sp>
+        <p:nvSpPr>
+          <p:cNvPr id="44" name="TextBox 43"/>
           <p:cNvSpPr txBox="1"/>
           <p:nvPr/>
         </p:nvSpPr>

</xml_diff>

<commit_message>
Timeline slide: add colored bullet dots, distribute items evenly through card body
Replace single text block with individually rendered bullet items using colored square
dots (matching each card's header color) — same pattern as RACI and pipeline slides.
Bullets are evenly spaced to fill the full card body height rather than stacking
at the top with empty space below.

Co-Authored-By: Claude Sonnet 4.6 <noreply@anthropic.com>
</commit_message>
<xml_diff>
--- a/mockups/mo_data_ops_kickoff.pptx
+++ b/mockups/mo_data_ops_kickoff.pptx
@@ -4294,52 +4294,14 @@
       </p:sp>
       <p:sp>
         <p:nvSpPr>
-          <p:cNvPr id="12" name="TextBox 11"/>
-          <p:cNvSpPr txBox="1"/>
-          <p:nvPr/>
-        </p:nvSpPr>
-        <p:spPr>
-          <a:xfrm>
-            <a:off x="585216" y="1956816"/>
-            <a:ext cx="2350008" cy="2249424"/>
-          </a:xfrm>
-          <a:prstGeom prst="rect">
-            <a:avLst/>
-          </a:prstGeom>
-          <a:noFill/>
-        </p:spPr>
-        <p:txBody>
-          <a:bodyPr wrap="square">
-            <a:spAutoFit/>
-          </a:bodyPr>
-          <a:lstStyle/>
-          <a:p>
-            <a:pPr algn="l"/>
-            <a:r>
-              <a:rPr sz="950" b="0" i="0">
-                <a:solidFill>
-                  <a:srgbClr val="111827"/>
-                </a:solidFill>
-                <a:latin typeface="Calibri"/>
-              </a:rPr>
-              <a:t>BUILT confirms SPINS export format and deposit schedule
-Aevah configures storage, file-watch trigger, and QA gates
-Both teams agree on data scope and stakeholder map
-Kickoff RACI reviewed and signed off by both teams</a:t>
-            </a:r>
-          </a:p>
-        </p:txBody>
-      </p:sp>
-      <p:sp>
-        <p:nvSpPr>
-          <p:cNvPr id="13" name="Rectangle 12"/>
+          <p:cNvPr id="12" name="Rectangle 11"/>
           <p:cNvSpPr/>
           <p:nvPr/>
         </p:nvSpPr>
         <p:spPr>
           <a:xfrm>
-            <a:off x="457200" y="4261103"/>
-            <a:ext cx="2606040" cy="402336"/>
+            <a:off x="585216" y="2057400"/>
+            <a:ext cx="64008" cy="64008"/>
           </a:xfrm>
           <a:prstGeom prst="rect">
             <a:avLst/>
@@ -4375,7 +4337,319 @@
       </p:sp>
       <p:sp>
         <p:nvSpPr>
-          <p:cNvPr id="14" name="TextBox 13"/>
+          <p:cNvPr id="13" name="TextBox 12"/>
+          <p:cNvSpPr txBox="1"/>
+          <p:nvPr/>
+        </p:nvSpPr>
+        <p:spPr>
+          <a:xfrm>
+            <a:off x="713232" y="1975104"/>
+            <a:ext cx="2221992" cy="502920"/>
+          </a:xfrm>
+          <a:prstGeom prst="rect">
+            <a:avLst/>
+          </a:prstGeom>
+          <a:noFill/>
+        </p:spPr>
+        <p:txBody>
+          <a:bodyPr wrap="square">
+            <a:spAutoFit/>
+          </a:bodyPr>
+          <a:lstStyle/>
+          <a:p>
+            <a:pPr algn="l"/>
+            <a:r>
+              <a:rPr sz="950" b="0" i="0">
+                <a:solidFill>
+                  <a:srgbClr val="111827"/>
+                </a:solidFill>
+                <a:latin typeface="Calibri"/>
+              </a:rPr>
+              <a:t>BUILT confirms SPINS export format and deposit schedule</a:t>
+            </a:r>
+          </a:p>
+        </p:txBody>
+      </p:sp>
+      <p:sp>
+        <p:nvSpPr>
+          <p:cNvPr id="14" name="Rectangle 13"/>
+          <p:cNvSpPr/>
+          <p:nvPr/>
+        </p:nvSpPr>
+        <p:spPr>
+          <a:xfrm>
+            <a:off x="585216" y="2606040"/>
+            <a:ext cx="64008" cy="64008"/>
+          </a:xfrm>
+          <a:prstGeom prst="rect">
+            <a:avLst/>
+          </a:prstGeom>
+          <a:solidFill>
+            <a:srgbClr val="4078D0"/>
+          </a:solidFill>
+          <a:ln>
+            <a:noFill/>
+          </a:ln>
+        </p:spPr>
+        <p:style>
+          <a:lnRef idx="1">
+            <a:schemeClr val="accent1"/>
+          </a:lnRef>
+          <a:fillRef idx="3">
+            <a:schemeClr val="accent1"/>
+          </a:fillRef>
+          <a:effectRef idx="2">
+            <a:schemeClr val="accent1"/>
+          </a:effectRef>
+          <a:fontRef idx="minor">
+            <a:schemeClr val="lt1"/>
+          </a:fontRef>
+        </p:style>
+        <p:txBody>
+          <a:bodyPr rtlCol="0" anchor="ctr"/>
+          <a:lstStyle/>
+          <a:p>
+            <a:pPr algn="ctr"/>
+          </a:p>
+        </p:txBody>
+      </p:sp>
+      <p:sp>
+        <p:nvSpPr>
+          <p:cNvPr id="15" name="TextBox 14"/>
+          <p:cNvSpPr txBox="1"/>
+          <p:nvPr/>
+        </p:nvSpPr>
+        <p:spPr>
+          <a:xfrm>
+            <a:off x="713232" y="2523744"/>
+            <a:ext cx="2221992" cy="502920"/>
+          </a:xfrm>
+          <a:prstGeom prst="rect">
+            <a:avLst/>
+          </a:prstGeom>
+          <a:noFill/>
+        </p:spPr>
+        <p:txBody>
+          <a:bodyPr wrap="square">
+            <a:spAutoFit/>
+          </a:bodyPr>
+          <a:lstStyle/>
+          <a:p>
+            <a:pPr algn="l"/>
+            <a:r>
+              <a:rPr sz="950" b="0" i="0">
+                <a:solidFill>
+                  <a:srgbClr val="111827"/>
+                </a:solidFill>
+                <a:latin typeface="Calibri"/>
+              </a:rPr>
+              <a:t>Aevah configures storage, file-watch trigger, and QA gates</a:t>
+            </a:r>
+          </a:p>
+        </p:txBody>
+      </p:sp>
+      <p:sp>
+        <p:nvSpPr>
+          <p:cNvPr id="16" name="Rectangle 15"/>
+          <p:cNvSpPr/>
+          <p:nvPr/>
+        </p:nvSpPr>
+        <p:spPr>
+          <a:xfrm>
+            <a:off x="585216" y="3154680"/>
+            <a:ext cx="64008" cy="64008"/>
+          </a:xfrm>
+          <a:prstGeom prst="rect">
+            <a:avLst/>
+          </a:prstGeom>
+          <a:solidFill>
+            <a:srgbClr val="4078D0"/>
+          </a:solidFill>
+          <a:ln>
+            <a:noFill/>
+          </a:ln>
+        </p:spPr>
+        <p:style>
+          <a:lnRef idx="1">
+            <a:schemeClr val="accent1"/>
+          </a:lnRef>
+          <a:fillRef idx="3">
+            <a:schemeClr val="accent1"/>
+          </a:fillRef>
+          <a:effectRef idx="2">
+            <a:schemeClr val="accent1"/>
+          </a:effectRef>
+          <a:fontRef idx="minor">
+            <a:schemeClr val="lt1"/>
+          </a:fontRef>
+        </p:style>
+        <p:txBody>
+          <a:bodyPr rtlCol="0" anchor="ctr"/>
+          <a:lstStyle/>
+          <a:p>
+            <a:pPr algn="ctr"/>
+          </a:p>
+        </p:txBody>
+      </p:sp>
+      <p:sp>
+        <p:nvSpPr>
+          <p:cNvPr id="17" name="TextBox 16"/>
+          <p:cNvSpPr txBox="1"/>
+          <p:nvPr/>
+        </p:nvSpPr>
+        <p:spPr>
+          <a:xfrm>
+            <a:off x="713232" y="3072384"/>
+            <a:ext cx="2221992" cy="502920"/>
+          </a:xfrm>
+          <a:prstGeom prst="rect">
+            <a:avLst/>
+          </a:prstGeom>
+          <a:noFill/>
+        </p:spPr>
+        <p:txBody>
+          <a:bodyPr wrap="square">
+            <a:spAutoFit/>
+          </a:bodyPr>
+          <a:lstStyle/>
+          <a:p>
+            <a:pPr algn="l"/>
+            <a:r>
+              <a:rPr sz="950" b="0" i="0">
+                <a:solidFill>
+                  <a:srgbClr val="111827"/>
+                </a:solidFill>
+                <a:latin typeface="Calibri"/>
+              </a:rPr>
+              <a:t>Both teams agree on data scope and stakeholder map</a:t>
+            </a:r>
+          </a:p>
+        </p:txBody>
+      </p:sp>
+      <p:sp>
+        <p:nvSpPr>
+          <p:cNvPr id="18" name="Rectangle 17"/>
+          <p:cNvSpPr/>
+          <p:nvPr/>
+        </p:nvSpPr>
+        <p:spPr>
+          <a:xfrm>
+            <a:off x="585216" y="3703320"/>
+            <a:ext cx="64008" cy="64008"/>
+          </a:xfrm>
+          <a:prstGeom prst="rect">
+            <a:avLst/>
+          </a:prstGeom>
+          <a:solidFill>
+            <a:srgbClr val="4078D0"/>
+          </a:solidFill>
+          <a:ln>
+            <a:noFill/>
+          </a:ln>
+        </p:spPr>
+        <p:style>
+          <a:lnRef idx="1">
+            <a:schemeClr val="accent1"/>
+          </a:lnRef>
+          <a:fillRef idx="3">
+            <a:schemeClr val="accent1"/>
+          </a:fillRef>
+          <a:effectRef idx="2">
+            <a:schemeClr val="accent1"/>
+          </a:effectRef>
+          <a:fontRef idx="minor">
+            <a:schemeClr val="lt1"/>
+          </a:fontRef>
+        </p:style>
+        <p:txBody>
+          <a:bodyPr rtlCol="0" anchor="ctr"/>
+          <a:lstStyle/>
+          <a:p>
+            <a:pPr algn="ctr"/>
+          </a:p>
+        </p:txBody>
+      </p:sp>
+      <p:sp>
+        <p:nvSpPr>
+          <p:cNvPr id="19" name="TextBox 18"/>
+          <p:cNvSpPr txBox="1"/>
+          <p:nvPr/>
+        </p:nvSpPr>
+        <p:spPr>
+          <a:xfrm>
+            <a:off x="713232" y="3621024"/>
+            <a:ext cx="2221992" cy="502920"/>
+          </a:xfrm>
+          <a:prstGeom prst="rect">
+            <a:avLst/>
+          </a:prstGeom>
+          <a:noFill/>
+        </p:spPr>
+        <p:txBody>
+          <a:bodyPr wrap="square">
+            <a:spAutoFit/>
+          </a:bodyPr>
+          <a:lstStyle/>
+          <a:p>
+            <a:pPr algn="l"/>
+            <a:r>
+              <a:rPr sz="950" b="0" i="0">
+                <a:solidFill>
+                  <a:srgbClr val="111827"/>
+                </a:solidFill>
+                <a:latin typeface="Calibri"/>
+              </a:rPr>
+              <a:t>Kickoff RACI reviewed and signed off by both teams</a:t>
+            </a:r>
+          </a:p>
+        </p:txBody>
+      </p:sp>
+      <p:sp>
+        <p:nvSpPr>
+          <p:cNvPr id="20" name="Rectangle 19"/>
+          <p:cNvSpPr/>
+          <p:nvPr/>
+        </p:nvSpPr>
+        <p:spPr>
+          <a:xfrm>
+            <a:off x="457200" y="4261103"/>
+            <a:ext cx="2606040" cy="402336"/>
+          </a:xfrm>
+          <a:prstGeom prst="rect">
+            <a:avLst/>
+          </a:prstGeom>
+          <a:solidFill>
+            <a:srgbClr val="4078D0"/>
+          </a:solidFill>
+          <a:ln>
+            <a:noFill/>
+          </a:ln>
+        </p:spPr>
+        <p:style>
+          <a:lnRef idx="1">
+            <a:schemeClr val="accent1"/>
+          </a:lnRef>
+          <a:fillRef idx="3">
+            <a:schemeClr val="accent1"/>
+          </a:fillRef>
+          <a:effectRef idx="2">
+            <a:schemeClr val="accent1"/>
+          </a:effectRef>
+          <a:fontRef idx="minor">
+            <a:schemeClr val="lt1"/>
+          </a:fontRef>
+        </p:style>
+        <p:txBody>
+          <a:bodyPr rtlCol="0" anchor="ctr"/>
+          <a:lstStyle/>
+          <a:p>
+            <a:pPr algn="ctr"/>
+          </a:p>
+        </p:txBody>
+      </p:sp>
+      <p:sp>
+        <p:nvSpPr>
+          <p:cNvPr id="21" name="TextBox 20"/>
           <p:cNvSpPr txBox="1"/>
           <p:nvPr/>
         </p:nvSpPr>
@@ -4410,7 +4684,7 @@
       </p:sp>
       <p:sp>
         <p:nvSpPr>
-          <p:cNvPr id="15" name="TextBox 14"/>
+          <p:cNvPr id="22" name="TextBox 21"/>
           <p:cNvSpPr txBox="1"/>
           <p:nvPr/>
         </p:nvSpPr>
@@ -4445,7 +4719,7 @@
       </p:sp>
       <p:sp>
         <p:nvSpPr>
-          <p:cNvPr id="16" name="Rectangle 15"/>
+          <p:cNvPr id="23" name="Rectangle 22"/>
           <p:cNvSpPr/>
           <p:nvPr/>
         </p:nvSpPr>
@@ -4490,7 +4764,7 @@
       </p:sp>
       <p:sp>
         <p:nvSpPr>
-          <p:cNvPr id="17" name="Rectangle 16"/>
+          <p:cNvPr id="24" name="Rectangle 23"/>
           <p:cNvSpPr/>
           <p:nvPr/>
         </p:nvSpPr>
@@ -4533,7 +4807,7 @@
       </p:sp>
       <p:sp>
         <p:nvSpPr>
-          <p:cNvPr id="18" name="TextBox 17"/>
+          <p:cNvPr id="25" name="TextBox 24"/>
           <p:cNvSpPr txBox="1"/>
           <p:nvPr/>
         </p:nvSpPr>
@@ -4568,7 +4842,7 @@
       </p:sp>
       <p:sp>
         <p:nvSpPr>
-          <p:cNvPr id="19" name="TextBox 18"/>
+          <p:cNvPr id="26" name="TextBox 25"/>
           <p:cNvSpPr txBox="1"/>
           <p:nvPr/>
         </p:nvSpPr>
@@ -4604,7 +4878,7 @@
       </p:sp>
       <p:sp>
         <p:nvSpPr>
-          <p:cNvPr id="20" name="Rectangle 19"/>
+          <p:cNvPr id="27" name="Rectangle 26"/>
           <p:cNvSpPr/>
           <p:nvPr/>
         </p:nvSpPr>
@@ -4649,52 +4923,14 @@
       </p:sp>
       <p:sp>
         <p:nvSpPr>
-          <p:cNvPr id="21" name="TextBox 20"/>
-          <p:cNvSpPr txBox="1"/>
-          <p:nvPr/>
-        </p:nvSpPr>
-        <p:spPr>
-          <a:xfrm>
-            <a:off x="3557016" y="1956816"/>
-            <a:ext cx="2350008" cy="2249424"/>
-          </a:xfrm>
-          <a:prstGeom prst="rect">
-            <a:avLst/>
-          </a:prstGeom>
-          <a:noFill/>
-        </p:spPr>
-        <p:txBody>
-          <a:bodyPr wrap="square">
-            <a:spAutoFit/>
-          </a:bodyPr>
-          <a:lstStyle/>
-          <a:p>
-            <a:pPr algn="l"/>
-            <a:r>
-              <a:rPr sz="950" b="0" i="0">
-                <a:solidFill>
-                  <a:srgbClr val="111827"/>
-                </a:solidFill>
-                <a:latin typeface="Calibri"/>
-              </a:rPr>
-              <a:t>Aevah: ingest → QA → feature engineering → model training
-Aevah delivers QA report for BUILT data team review
-BUILT validates data looks right for Modules 01–02
-Data issues flagged and resolved before UI deployment</a:t>
-            </a:r>
-          </a:p>
-        </p:txBody>
-      </p:sp>
-      <p:sp>
-        <p:nvSpPr>
-          <p:cNvPr id="22" name="Rectangle 21"/>
+          <p:cNvPr id="28" name="Rectangle 27"/>
           <p:cNvSpPr/>
           <p:nvPr/>
         </p:nvSpPr>
         <p:spPr>
           <a:xfrm>
-            <a:off x="3429000" y="4261103"/>
-            <a:ext cx="2606040" cy="402336"/>
+            <a:off x="3557016" y="2057400"/>
+            <a:ext cx="64008" cy="64008"/>
           </a:xfrm>
           <a:prstGeom prst="rect">
             <a:avLst/>
@@ -4730,7 +4966,319 @@
       </p:sp>
       <p:sp>
         <p:nvSpPr>
-          <p:cNvPr id="23" name="TextBox 22"/>
+          <p:cNvPr id="29" name="TextBox 28"/>
+          <p:cNvSpPr txBox="1"/>
+          <p:nvPr/>
+        </p:nvSpPr>
+        <p:spPr>
+          <a:xfrm>
+            <a:off x="3685032" y="1975104"/>
+            <a:ext cx="2221992" cy="502920"/>
+          </a:xfrm>
+          <a:prstGeom prst="rect">
+            <a:avLst/>
+          </a:prstGeom>
+          <a:noFill/>
+        </p:spPr>
+        <p:txBody>
+          <a:bodyPr wrap="square">
+            <a:spAutoFit/>
+          </a:bodyPr>
+          <a:lstStyle/>
+          <a:p>
+            <a:pPr algn="l"/>
+            <a:r>
+              <a:rPr sz="950" b="0" i="0">
+                <a:solidFill>
+                  <a:srgbClr val="111827"/>
+                </a:solidFill>
+                <a:latin typeface="Calibri"/>
+              </a:rPr>
+              <a:t>Aevah: ingest → QA → feature engineering → model training</a:t>
+            </a:r>
+          </a:p>
+        </p:txBody>
+      </p:sp>
+      <p:sp>
+        <p:nvSpPr>
+          <p:cNvPr id="30" name="Rectangle 29"/>
+          <p:cNvSpPr/>
+          <p:nvPr/>
+        </p:nvSpPr>
+        <p:spPr>
+          <a:xfrm>
+            <a:off x="3557016" y="2606040"/>
+            <a:ext cx="64008" cy="64008"/>
+          </a:xfrm>
+          <a:prstGeom prst="rect">
+            <a:avLst/>
+          </a:prstGeom>
+          <a:solidFill>
+            <a:srgbClr val="0E5E38"/>
+          </a:solidFill>
+          <a:ln>
+            <a:noFill/>
+          </a:ln>
+        </p:spPr>
+        <p:style>
+          <a:lnRef idx="1">
+            <a:schemeClr val="accent1"/>
+          </a:lnRef>
+          <a:fillRef idx="3">
+            <a:schemeClr val="accent1"/>
+          </a:fillRef>
+          <a:effectRef idx="2">
+            <a:schemeClr val="accent1"/>
+          </a:effectRef>
+          <a:fontRef idx="minor">
+            <a:schemeClr val="lt1"/>
+          </a:fontRef>
+        </p:style>
+        <p:txBody>
+          <a:bodyPr rtlCol="0" anchor="ctr"/>
+          <a:lstStyle/>
+          <a:p>
+            <a:pPr algn="ctr"/>
+          </a:p>
+        </p:txBody>
+      </p:sp>
+      <p:sp>
+        <p:nvSpPr>
+          <p:cNvPr id="31" name="TextBox 30"/>
+          <p:cNvSpPr txBox="1"/>
+          <p:nvPr/>
+        </p:nvSpPr>
+        <p:spPr>
+          <a:xfrm>
+            <a:off x="3685032" y="2523744"/>
+            <a:ext cx="2221992" cy="502920"/>
+          </a:xfrm>
+          <a:prstGeom prst="rect">
+            <a:avLst/>
+          </a:prstGeom>
+          <a:noFill/>
+        </p:spPr>
+        <p:txBody>
+          <a:bodyPr wrap="square">
+            <a:spAutoFit/>
+          </a:bodyPr>
+          <a:lstStyle/>
+          <a:p>
+            <a:pPr algn="l"/>
+            <a:r>
+              <a:rPr sz="950" b="0" i="0">
+                <a:solidFill>
+                  <a:srgbClr val="111827"/>
+                </a:solidFill>
+                <a:latin typeface="Calibri"/>
+              </a:rPr>
+              <a:t>Aevah delivers QA report for BUILT data team review</a:t>
+            </a:r>
+          </a:p>
+        </p:txBody>
+      </p:sp>
+      <p:sp>
+        <p:nvSpPr>
+          <p:cNvPr id="32" name="Rectangle 31"/>
+          <p:cNvSpPr/>
+          <p:nvPr/>
+        </p:nvSpPr>
+        <p:spPr>
+          <a:xfrm>
+            <a:off x="3557016" y="3154680"/>
+            <a:ext cx="64008" cy="64008"/>
+          </a:xfrm>
+          <a:prstGeom prst="rect">
+            <a:avLst/>
+          </a:prstGeom>
+          <a:solidFill>
+            <a:srgbClr val="0E5E38"/>
+          </a:solidFill>
+          <a:ln>
+            <a:noFill/>
+          </a:ln>
+        </p:spPr>
+        <p:style>
+          <a:lnRef idx="1">
+            <a:schemeClr val="accent1"/>
+          </a:lnRef>
+          <a:fillRef idx="3">
+            <a:schemeClr val="accent1"/>
+          </a:fillRef>
+          <a:effectRef idx="2">
+            <a:schemeClr val="accent1"/>
+          </a:effectRef>
+          <a:fontRef idx="minor">
+            <a:schemeClr val="lt1"/>
+          </a:fontRef>
+        </p:style>
+        <p:txBody>
+          <a:bodyPr rtlCol="0" anchor="ctr"/>
+          <a:lstStyle/>
+          <a:p>
+            <a:pPr algn="ctr"/>
+          </a:p>
+        </p:txBody>
+      </p:sp>
+      <p:sp>
+        <p:nvSpPr>
+          <p:cNvPr id="33" name="TextBox 32"/>
+          <p:cNvSpPr txBox="1"/>
+          <p:nvPr/>
+        </p:nvSpPr>
+        <p:spPr>
+          <a:xfrm>
+            <a:off x="3685032" y="3072384"/>
+            <a:ext cx="2221992" cy="502920"/>
+          </a:xfrm>
+          <a:prstGeom prst="rect">
+            <a:avLst/>
+          </a:prstGeom>
+          <a:noFill/>
+        </p:spPr>
+        <p:txBody>
+          <a:bodyPr wrap="square">
+            <a:spAutoFit/>
+          </a:bodyPr>
+          <a:lstStyle/>
+          <a:p>
+            <a:pPr algn="l"/>
+            <a:r>
+              <a:rPr sz="950" b="0" i="0">
+                <a:solidFill>
+                  <a:srgbClr val="111827"/>
+                </a:solidFill>
+                <a:latin typeface="Calibri"/>
+              </a:rPr>
+              <a:t>BUILT validates data looks right for Modules 01–02</a:t>
+            </a:r>
+          </a:p>
+        </p:txBody>
+      </p:sp>
+      <p:sp>
+        <p:nvSpPr>
+          <p:cNvPr id="34" name="Rectangle 33"/>
+          <p:cNvSpPr/>
+          <p:nvPr/>
+        </p:nvSpPr>
+        <p:spPr>
+          <a:xfrm>
+            <a:off x="3557016" y="3703320"/>
+            <a:ext cx="64008" cy="64008"/>
+          </a:xfrm>
+          <a:prstGeom prst="rect">
+            <a:avLst/>
+          </a:prstGeom>
+          <a:solidFill>
+            <a:srgbClr val="0E5E38"/>
+          </a:solidFill>
+          <a:ln>
+            <a:noFill/>
+          </a:ln>
+        </p:spPr>
+        <p:style>
+          <a:lnRef idx="1">
+            <a:schemeClr val="accent1"/>
+          </a:lnRef>
+          <a:fillRef idx="3">
+            <a:schemeClr val="accent1"/>
+          </a:fillRef>
+          <a:effectRef idx="2">
+            <a:schemeClr val="accent1"/>
+          </a:effectRef>
+          <a:fontRef idx="minor">
+            <a:schemeClr val="lt1"/>
+          </a:fontRef>
+        </p:style>
+        <p:txBody>
+          <a:bodyPr rtlCol="0" anchor="ctr"/>
+          <a:lstStyle/>
+          <a:p>
+            <a:pPr algn="ctr"/>
+          </a:p>
+        </p:txBody>
+      </p:sp>
+      <p:sp>
+        <p:nvSpPr>
+          <p:cNvPr id="35" name="TextBox 34"/>
+          <p:cNvSpPr txBox="1"/>
+          <p:nvPr/>
+        </p:nvSpPr>
+        <p:spPr>
+          <a:xfrm>
+            <a:off x="3685032" y="3621024"/>
+            <a:ext cx="2221992" cy="502920"/>
+          </a:xfrm>
+          <a:prstGeom prst="rect">
+            <a:avLst/>
+          </a:prstGeom>
+          <a:noFill/>
+        </p:spPr>
+        <p:txBody>
+          <a:bodyPr wrap="square">
+            <a:spAutoFit/>
+          </a:bodyPr>
+          <a:lstStyle/>
+          <a:p>
+            <a:pPr algn="l"/>
+            <a:r>
+              <a:rPr sz="950" b="0" i="0">
+                <a:solidFill>
+                  <a:srgbClr val="111827"/>
+                </a:solidFill>
+                <a:latin typeface="Calibri"/>
+              </a:rPr>
+              <a:t>Data issues flagged and resolved before UI deployment</a:t>
+            </a:r>
+          </a:p>
+        </p:txBody>
+      </p:sp>
+      <p:sp>
+        <p:nvSpPr>
+          <p:cNvPr id="36" name="Rectangle 35"/>
+          <p:cNvSpPr/>
+          <p:nvPr/>
+        </p:nvSpPr>
+        <p:spPr>
+          <a:xfrm>
+            <a:off x="3429000" y="4261103"/>
+            <a:ext cx="2606040" cy="402336"/>
+          </a:xfrm>
+          <a:prstGeom prst="rect">
+            <a:avLst/>
+          </a:prstGeom>
+          <a:solidFill>
+            <a:srgbClr val="0E5E38"/>
+          </a:solidFill>
+          <a:ln>
+            <a:noFill/>
+          </a:ln>
+        </p:spPr>
+        <p:style>
+          <a:lnRef idx="1">
+            <a:schemeClr val="accent1"/>
+          </a:lnRef>
+          <a:fillRef idx="3">
+            <a:schemeClr val="accent1"/>
+          </a:fillRef>
+          <a:effectRef idx="2">
+            <a:schemeClr val="accent1"/>
+          </a:effectRef>
+          <a:fontRef idx="minor">
+            <a:schemeClr val="lt1"/>
+          </a:fontRef>
+        </p:style>
+        <p:txBody>
+          <a:bodyPr rtlCol="0" anchor="ctr"/>
+          <a:lstStyle/>
+          <a:p>
+            <a:pPr algn="ctr"/>
+          </a:p>
+        </p:txBody>
+      </p:sp>
+      <p:sp>
+        <p:nvSpPr>
+          <p:cNvPr id="37" name="TextBox 36"/>
           <p:cNvSpPr txBox="1"/>
           <p:nvPr/>
         </p:nvSpPr>
@@ -4765,7 +5313,7 @@
       </p:sp>
       <p:sp>
         <p:nvSpPr>
-          <p:cNvPr id="24" name="TextBox 23"/>
+          <p:cNvPr id="38" name="TextBox 37"/>
           <p:cNvSpPr txBox="1"/>
           <p:nvPr/>
         </p:nvSpPr>
@@ -4800,7 +5348,7 @@
       </p:sp>
       <p:sp>
         <p:nvSpPr>
-          <p:cNvPr id="25" name="Rectangle 24"/>
+          <p:cNvPr id="39" name="Rectangle 38"/>
           <p:cNvSpPr/>
           <p:nvPr/>
         </p:nvSpPr>
@@ -4845,7 +5393,7 @@
       </p:sp>
       <p:sp>
         <p:nvSpPr>
-          <p:cNvPr id="26" name="Rectangle 25"/>
+          <p:cNvPr id="40" name="Rectangle 39"/>
           <p:cNvSpPr/>
           <p:nvPr/>
         </p:nvSpPr>
@@ -4888,7 +5436,7 @@
       </p:sp>
       <p:sp>
         <p:nvSpPr>
-          <p:cNvPr id="27" name="TextBox 26"/>
+          <p:cNvPr id="41" name="TextBox 40"/>
           <p:cNvSpPr txBox="1"/>
           <p:nvPr/>
         </p:nvSpPr>
@@ -4923,7 +5471,7 @@
       </p:sp>
       <p:sp>
         <p:nvSpPr>
-          <p:cNvPr id="28" name="TextBox 27"/>
+          <p:cNvPr id="42" name="TextBox 41"/>
           <p:cNvSpPr txBox="1"/>
           <p:nvPr/>
         </p:nvSpPr>
@@ -4959,7 +5507,7 @@
       </p:sp>
       <p:sp>
         <p:nvSpPr>
-          <p:cNvPr id="29" name="Rectangle 28"/>
+          <p:cNvPr id="43" name="Rectangle 42"/>
           <p:cNvSpPr/>
           <p:nvPr/>
         </p:nvSpPr>
@@ -5004,52 +5552,14 @@
       </p:sp>
       <p:sp>
         <p:nvSpPr>
-          <p:cNvPr id="30" name="TextBox 29"/>
-          <p:cNvSpPr txBox="1"/>
-          <p:nvPr/>
-        </p:nvSpPr>
-        <p:spPr>
-          <a:xfrm>
-            <a:off x="6528816" y="1956816"/>
-            <a:ext cx="2350008" cy="2249424"/>
-          </a:xfrm>
-          <a:prstGeom prst="rect">
-            <a:avLst/>
-          </a:prstGeom>
-          <a:noFill/>
-        </p:spPr>
-        <p:txBody>
-          <a:bodyPr wrap="square">
-            <a:spAutoFit/>
-          </a:bodyPr>
-          <a:lstStyle/>
-          <a:p>
-            <a:pPr algn="l"/>
-            <a:r>
-              <a:rPr sz="950" b="0" i="0">
-                <a:solidFill>
-                  <a:srgbClr val="111827"/>
-                </a:solidFill>
-                <a:latin typeface="Calibri"/>
-              </a:rPr>
-              <a:t>Cannibalization Risk + Price Elasticity live in Mo UI
-Live walkthrough with Brian + Connor — FOOD-channel accounts
-Connor + team validate projections against market knowledge
-Priority UI feedback addressed in follow-up sprint</a:t>
-            </a:r>
-          </a:p>
-        </p:txBody>
-      </p:sp>
-      <p:sp>
-        <p:nvSpPr>
-          <p:cNvPr id="31" name="Rectangle 30"/>
+          <p:cNvPr id="44" name="Rectangle 43"/>
           <p:cNvSpPr/>
           <p:nvPr/>
         </p:nvSpPr>
         <p:spPr>
           <a:xfrm>
-            <a:off x="6400800" y="4261103"/>
-            <a:ext cx="2606040" cy="402336"/>
+            <a:off x="6528816" y="2057400"/>
+            <a:ext cx="64008" cy="64008"/>
           </a:xfrm>
           <a:prstGeom prst="rect">
             <a:avLst/>
@@ -5085,7 +5595,319 @@
       </p:sp>
       <p:sp>
         <p:nvSpPr>
-          <p:cNvPr id="32" name="TextBox 31"/>
+          <p:cNvPr id="45" name="TextBox 44"/>
+          <p:cNvSpPr txBox="1"/>
+          <p:nvPr/>
+        </p:nvSpPr>
+        <p:spPr>
+          <a:xfrm>
+            <a:off x="6656832" y="1975104"/>
+            <a:ext cx="2221992" cy="502920"/>
+          </a:xfrm>
+          <a:prstGeom prst="rect">
+            <a:avLst/>
+          </a:prstGeom>
+          <a:noFill/>
+        </p:spPr>
+        <p:txBody>
+          <a:bodyPr wrap="square">
+            <a:spAutoFit/>
+          </a:bodyPr>
+          <a:lstStyle/>
+          <a:p>
+            <a:pPr algn="l"/>
+            <a:r>
+              <a:rPr sz="950" b="0" i="0">
+                <a:solidFill>
+                  <a:srgbClr val="111827"/>
+                </a:solidFill>
+                <a:latin typeface="Calibri"/>
+              </a:rPr>
+              <a:t>Cannibalization Risk + Price Elasticity live in Mo UI</a:t>
+            </a:r>
+          </a:p>
+        </p:txBody>
+      </p:sp>
+      <p:sp>
+        <p:nvSpPr>
+          <p:cNvPr id="46" name="Rectangle 45"/>
+          <p:cNvSpPr/>
+          <p:nvPr/>
+        </p:nvSpPr>
+        <p:spPr>
+          <a:xfrm>
+            <a:off x="6528816" y="2606040"/>
+            <a:ext cx="64008" cy="64008"/>
+          </a:xfrm>
+          <a:prstGeom prst="rect">
+            <a:avLst/>
+          </a:prstGeom>
+          <a:solidFill>
+            <a:srgbClr val="8A4800"/>
+          </a:solidFill>
+          <a:ln>
+            <a:noFill/>
+          </a:ln>
+        </p:spPr>
+        <p:style>
+          <a:lnRef idx="1">
+            <a:schemeClr val="accent1"/>
+          </a:lnRef>
+          <a:fillRef idx="3">
+            <a:schemeClr val="accent1"/>
+          </a:fillRef>
+          <a:effectRef idx="2">
+            <a:schemeClr val="accent1"/>
+          </a:effectRef>
+          <a:fontRef idx="minor">
+            <a:schemeClr val="lt1"/>
+          </a:fontRef>
+        </p:style>
+        <p:txBody>
+          <a:bodyPr rtlCol="0" anchor="ctr"/>
+          <a:lstStyle/>
+          <a:p>
+            <a:pPr algn="ctr"/>
+          </a:p>
+        </p:txBody>
+      </p:sp>
+      <p:sp>
+        <p:nvSpPr>
+          <p:cNvPr id="47" name="TextBox 46"/>
+          <p:cNvSpPr txBox="1"/>
+          <p:nvPr/>
+        </p:nvSpPr>
+        <p:spPr>
+          <a:xfrm>
+            <a:off x="6656832" y="2523744"/>
+            <a:ext cx="2221992" cy="502920"/>
+          </a:xfrm>
+          <a:prstGeom prst="rect">
+            <a:avLst/>
+          </a:prstGeom>
+          <a:noFill/>
+        </p:spPr>
+        <p:txBody>
+          <a:bodyPr wrap="square">
+            <a:spAutoFit/>
+          </a:bodyPr>
+          <a:lstStyle/>
+          <a:p>
+            <a:pPr algn="l"/>
+            <a:r>
+              <a:rPr sz="950" b="0" i="0">
+                <a:solidFill>
+                  <a:srgbClr val="111827"/>
+                </a:solidFill>
+                <a:latin typeface="Calibri"/>
+              </a:rPr>
+              <a:t>Live walkthrough with Brian + Connor — FOOD-channel accounts</a:t>
+            </a:r>
+          </a:p>
+        </p:txBody>
+      </p:sp>
+      <p:sp>
+        <p:nvSpPr>
+          <p:cNvPr id="48" name="Rectangle 47"/>
+          <p:cNvSpPr/>
+          <p:nvPr/>
+        </p:nvSpPr>
+        <p:spPr>
+          <a:xfrm>
+            <a:off x="6528816" y="3154680"/>
+            <a:ext cx="64008" cy="64008"/>
+          </a:xfrm>
+          <a:prstGeom prst="rect">
+            <a:avLst/>
+          </a:prstGeom>
+          <a:solidFill>
+            <a:srgbClr val="8A4800"/>
+          </a:solidFill>
+          <a:ln>
+            <a:noFill/>
+          </a:ln>
+        </p:spPr>
+        <p:style>
+          <a:lnRef idx="1">
+            <a:schemeClr val="accent1"/>
+          </a:lnRef>
+          <a:fillRef idx="3">
+            <a:schemeClr val="accent1"/>
+          </a:fillRef>
+          <a:effectRef idx="2">
+            <a:schemeClr val="accent1"/>
+          </a:effectRef>
+          <a:fontRef idx="minor">
+            <a:schemeClr val="lt1"/>
+          </a:fontRef>
+        </p:style>
+        <p:txBody>
+          <a:bodyPr rtlCol="0" anchor="ctr"/>
+          <a:lstStyle/>
+          <a:p>
+            <a:pPr algn="ctr"/>
+          </a:p>
+        </p:txBody>
+      </p:sp>
+      <p:sp>
+        <p:nvSpPr>
+          <p:cNvPr id="49" name="TextBox 48"/>
+          <p:cNvSpPr txBox="1"/>
+          <p:nvPr/>
+        </p:nvSpPr>
+        <p:spPr>
+          <a:xfrm>
+            <a:off x="6656832" y="3072384"/>
+            <a:ext cx="2221992" cy="502920"/>
+          </a:xfrm>
+          <a:prstGeom prst="rect">
+            <a:avLst/>
+          </a:prstGeom>
+          <a:noFill/>
+        </p:spPr>
+        <p:txBody>
+          <a:bodyPr wrap="square">
+            <a:spAutoFit/>
+          </a:bodyPr>
+          <a:lstStyle/>
+          <a:p>
+            <a:pPr algn="l"/>
+            <a:r>
+              <a:rPr sz="950" b="0" i="0">
+                <a:solidFill>
+                  <a:srgbClr val="111827"/>
+                </a:solidFill>
+                <a:latin typeface="Calibri"/>
+              </a:rPr>
+              <a:t>Connor + team validate projections against market knowledge</a:t>
+            </a:r>
+          </a:p>
+        </p:txBody>
+      </p:sp>
+      <p:sp>
+        <p:nvSpPr>
+          <p:cNvPr id="50" name="Rectangle 49"/>
+          <p:cNvSpPr/>
+          <p:nvPr/>
+        </p:nvSpPr>
+        <p:spPr>
+          <a:xfrm>
+            <a:off x="6528816" y="3703320"/>
+            <a:ext cx="64008" cy="64008"/>
+          </a:xfrm>
+          <a:prstGeom prst="rect">
+            <a:avLst/>
+          </a:prstGeom>
+          <a:solidFill>
+            <a:srgbClr val="8A4800"/>
+          </a:solidFill>
+          <a:ln>
+            <a:noFill/>
+          </a:ln>
+        </p:spPr>
+        <p:style>
+          <a:lnRef idx="1">
+            <a:schemeClr val="accent1"/>
+          </a:lnRef>
+          <a:fillRef idx="3">
+            <a:schemeClr val="accent1"/>
+          </a:fillRef>
+          <a:effectRef idx="2">
+            <a:schemeClr val="accent1"/>
+          </a:effectRef>
+          <a:fontRef idx="minor">
+            <a:schemeClr val="lt1"/>
+          </a:fontRef>
+        </p:style>
+        <p:txBody>
+          <a:bodyPr rtlCol="0" anchor="ctr"/>
+          <a:lstStyle/>
+          <a:p>
+            <a:pPr algn="ctr"/>
+          </a:p>
+        </p:txBody>
+      </p:sp>
+      <p:sp>
+        <p:nvSpPr>
+          <p:cNvPr id="51" name="TextBox 50"/>
+          <p:cNvSpPr txBox="1"/>
+          <p:nvPr/>
+        </p:nvSpPr>
+        <p:spPr>
+          <a:xfrm>
+            <a:off x="6656832" y="3621024"/>
+            <a:ext cx="2221992" cy="502920"/>
+          </a:xfrm>
+          <a:prstGeom prst="rect">
+            <a:avLst/>
+          </a:prstGeom>
+          <a:noFill/>
+        </p:spPr>
+        <p:txBody>
+          <a:bodyPr wrap="square">
+            <a:spAutoFit/>
+          </a:bodyPr>
+          <a:lstStyle/>
+          <a:p>
+            <a:pPr algn="l"/>
+            <a:r>
+              <a:rPr sz="950" b="0" i="0">
+                <a:solidFill>
+                  <a:srgbClr val="111827"/>
+                </a:solidFill>
+                <a:latin typeface="Calibri"/>
+              </a:rPr>
+              <a:t>Priority UI feedback addressed in follow-up sprint</a:t>
+            </a:r>
+          </a:p>
+        </p:txBody>
+      </p:sp>
+      <p:sp>
+        <p:nvSpPr>
+          <p:cNvPr id="52" name="Rectangle 51"/>
+          <p:cNvSpPr/>
+          <p:nvPr/>
+        </p:nvSpPr>
+        <p:spPr>
+          <a:xfrm>
+            <a:off x="6400800" y="4261103"/>
+            <a:ext cx="2606040" cy="402336"/>
+          </a:xfrm>
+          <a:prstGeom prst="rect">
+            <a:avLst/>
+          </a:prstGeom>
+          <a:solidFill>
+            <a:srgbClr val="8A4800"/>
+          </a:solidFill>
+          <a:ln>
+            <a:noFill/>
+          </a:ln>
+        </p:spPr>
+        <p:style>
+          <a:lnRef idx="1">
+            <a:schemeClr val="accent1"/>
+          </a:lnRef>
+          <a:fillRef idx="3">
+            <a:schemeClr val="accent1"/>
+          </a:fillRef>
+          <a:effectRef idx="2">
+            <a:schemeClr val="accent1"/>
+          </a:effectRef>
+          <a:fontRef idx="minor">
+            <a:schemeClr val="lt1"/>
+          </a:fontRef>
+        </p:style>
+        <p:txBody>
+          <a:bodyPr rtlCol="0" anchor="ctr"/>
+          <a:lstStyle/>
+          <a:p>
+            <a:pPr algn="ctr"/>
+          </a:p>
+        </p:txBody>
+      </p:sp>
+      <p:sp>
+        <p:nvSpPr>
+          <p:cNvPr id="53" name="TextBox 52"/>
           <p:cNvSpPr txBox="1"/>
           <p:nvPr/>
         </p:nvSpPr>
@@ -5120,7 +5942,7 @@
       </p:sp>
       <p:sp>
         <p:nvSpPr>
-          <p:cNvPr id="33" name="TextBox 32"/>
+          <p:cNvPr id="54" name="TextBox 53"/>
           <p:cNvSpPr txBox="1"/>
           <p:nvPr/>
         </p:nvSpPr>
@@ -5155,7 +5977,7 @@
       </p:sp>
       <p:sp>
         <p:nvSpPr>
-          <p:cNvPr id="34" name="Rectangle 33"/>
+          <p:cNvPr id="55" name="Rectangle 54"/>
           <p:cNvSpPr/>
           <p:nvPr/>
         </p:nvSpPr>
@@ -5200,7 +6022,7 @@
       </p:sp>
       <p:sp>
         <p:nvSpPr>
-          <p:cNvPr id="35" name="Rectangle 34"/>
+          <p:cNvPr id="56" name="Rectangle 55"/>
           <p:cNvSpPr/>
           <p:nvPr/>
         </p:nvSpPr>
@@ -5243,7 +6065,7 @@
       </p:sp>
       <p:sp>
         <p:nvSpPr>
-          <p:cNvPr id="36" name="TextBox 35"/>
+          <p:cNvPr id="57" name="TextBox 56"/>
           <p:cNvSpPr txBox="1"/>
           <p:nvPr/>
         </p:nvSpPr>
@@ -5278,7 +6100,7 @@
       </p:sp>
       <p:sp>
         <p:nvSpPr>
-          <p:cNvPr id="37" name="TextBox 36"/>
+          <p:cNvPr id="58" name="TextBox 57"/>
           <p:cNvSpPr txBox="1"/>
           <p:nvPr/>
         </p:nvSpPr>
@@ -5314,7 +6136,7 @@
       </p:sp>
       <p:sp>
         <p:nvSpPr>
-          <p:cNvPr id="38" name="Rectangle 37"/>
+          <p:cNvPr id="59" name="Rectangle 58"/>
           <p:cNvSpPr/>
           <p:nvPr/>
         </p:nvSpPr>
@@ -5359,52 +6181,14 @@
       </p:sp>
       <p:sp>
         <p:nvSpPr>
-          <p:cNvPr id="39" name="TextBox 38"/>
-          <p:cNvSpPr txBox="1"/>
-          <p:nvPr/>
-        </p:nvSpPr>
-        <p:spPr>
-          <a:xfrm>
-            <a:off x="9500616" y="1956816"/>
-            <a:ext cx="2350008" cy="2249424"/>
-          </a:xfrm>
-          <a:prstGeom prst="rect">
-            <a:avLst/>
-          </a:prstGeom>
-          <a:noFill/>
-        </p:spPr>
-        <p:txBody>
-          <a:bodyPr wrap="square">
-            <a:spAutoFit/>
-          </a:bodyPr>
-          <a:lstStyle/>
-          <a:p>
-            <a:pPr algn="l"/>
-            <a:r>
-              <a:rPr sz="950" b="0" i="0">
-                <a:solidFill>
-                  <a:srgbClr val="111827"/>
-                </a:solidFill>
-                <a:latin typeface="Calibri"/>
-              </a:rPr>
-              <a:t>Address feedback; tune models on BUILT market knowledge
-Phase 1 milestone sign-off by both teams
-Begin scoping Modules 3–5 for Phase 2
-Connor's actuals data shared for forecast backtesting</a:t>
-            </a:r>
-          </a:p>
-        </p:txBody>
-      </p:sp>
-      <p:sp>
-        <p:nvSpPr>
-          <p:cNvPr id="40" name="Rectangle 39"/>
+          <p:cNvPr id="60" name="Rectangle 59"/>
           <p:cNvSpPr/>
           <p:nvPr/>
         </p:nvSpPr>
         <p:spPr>
           <a:xfrm>
-            <a:off x="9372600" y="4261103"/>
-            <a:ext cx="2606040" cy="402336"/>
+            <a:off x="9500616" y="2057400"/>
+            <a:ext cx="64008" cy="64008"/>
           </a:xfrm>
           <a:prstGeom prst="rect">
             <a:avLst/>
@@ -5440,7 +6224,319 @@
       </p:sp>
       <p:sp>
         <p:nvSpPr>
-          <p:cNvPr id="41" name="TextBox 40"/>
+          <p:cNvPr id="61" name="TextBox 60"/>
+          <p:cNvSpPr txBox="1"/>
+          <p:nvPr/>
+        </p:nvSpPr>
+        <p:spPr>
+          <a:xfrm>
+            <a:off x="9628632" y="1975104"/>
+            <a:ext cx="2221992" cy="502920"/>
+          </a:xfrm>
+          <a:prstGeom prst="rect">
+            <a:avLst/>
+          </a:prstGeom>
+          <a:noFill/>
+        </p:spPr>
+        <p:txBody>
+          <a:bodyPr wrap="square">
+            <a:spAutoFit/>
+          </a:bodyPr>
+          <a:lstStyle/>
+          <a:p>
+            <a:pPr algn="l"/>
+            <a:r>
+              <a:rPr sz="950" b="0" i="0">
+                <a:solidFill>
+                  <a:srgbClr val="111827"/>
+                </a:solidFill>
+                <a:latin typeface="Calibri"/>
+              </a:rPr>
+              <a:t>Address feedback; tune models on BUILT market knowledge</a:t>
+            </a:r>
+          </a:p>
+        </p:txBody>
+      </p:sp>
+      <p:sp>
+        <p:nvSpPr>
+          <p:cNvPr id="62" name="Rectangle 61"/>
+          <p:cNvSpPr/>
+          <p:nvPr/>
+        </p:nvSpPr>
+        <p:spPr>
+          <a:xfrm>
+            <a:off x="9500616" y="2606040"/>
+            <a:ext cx="64008" cy="64008"/>
+          </a:xfrm>
+          <a:prstGeom prst="rect">
+            <a:avLst/>
+          </a:prstGeom>
+          <a:solidFill>
+            <a:srgbClr val="4B2D8A"/>
+          </a:solidFill>
+          <a:ln>
+            <a:noFill/>
+          </a:ln>
+        </p:spPr>
+        <p:style>
+          <a:lnRef idx="1">
+            <a:schemeClr val="accent1"/>
+          </a:lnRef>
+          <a:fillRef idx="3">
+            <a:schemeClr val="accent1"/>
+          </a:fillRef>
+          <a:effectRef idx="2">
+            <a:schemeClr val="accent1"/>
+          </a:effectRef>
+          <a:fontRef idx="minor">
+            <a:schemeClr val="lt1"/>
+          </a:fontRef>
+        </p:style>
+        <p:txBody>
+          <a:bodyPr rtlCol="0" anchor="ctr"/>
+          <a:lstStyle/>
+          <a:p>
+            <a:pPr algn="ctr"/>
+          </a:p>
+        </p:txBody>
+      </p:sp>
+      <p:sp>
+        <p:nvSpPr>
+          <p:cNvPr id="63" name="TextBox 62"/>
+          <p:cNvSpPr txBox="1"/>
+          <p:nvPr/>
+        </p:nvSpPr>
+        <p:spPr>
+          <a:xfrm>
+            <a:off x="9628632" y="2523744"/>
+            <a:ext cx="2221992" cy="502920"/>
+          </a:xfrm>
+          <a:prstGeom prst="rect">
+            <a:avLst/>
+          </a:prstGeom>
+          <a:noFill/>
+        </p:spPr>
+        <p:txBody>
+          <a:bodyPr wrap="square">
+            <a:spAutoFit/>
+          </a:bodyPr>
+          <a:lstStyle/>
+          <a:p>
+            <a:pPr algn="l"/>
+            <a:r>
+              <a:rPr sz="950" b="0" i="0">
+                <a:solidFill>
+                  <a:srgbClr val="111827"/>
+                </a:solidFill>
+                <a:latin typeface="Calibri"/>
+              </a:rPr>
+              <a:t>Phase 1 milestone sign-off by both teams</a:t>
+            </a:r>
+          </a:p>
+        </p:txBody>
+      </p:sp>
+      <p:sp>
+        <p:nvSpPr>
+          <p:cNvPr id="64" name="Rectangle 63"/>
+          <p:cNvSpPr/>
+          <p:nvPr/>
+        </p:nvSpPr>
+        <p:spPr>
+          <a:xfrm>
+            <a:off x="9500616" y="3154680"/>
+            <a:ext cx="64008" cy="64008"/>
+          </a:xfrm>
+          <a:prstGeom prst="rect">
+            <a:avLst/>
+          </a:prstGeom>
+          <a:solidFill>
+            <a:srgbClr val="4B2D8A"/>
+          </a:solidFill>
+          <a:ln>
+            <a:noFill/>
+          </a:ln>
+        </p:spPr>
+        <p:style>
+          <a:lnRef idx="1">
+            <a:schemeClr val="accent1"/>
+          </a:lnRef>
+          <a:fillRef idx="3">
+            <a:schemeClr val="accent1"/>
+          </a:fillRef>
+          <a:effectRef idx="2">
+            <a:schemeClr val="accent1"/>
+          </a:effectRef>
+          <a:fontRef idx="minor">
+            <a:schemeClr val="lt1"/>
+          </a:fontRef>
+        </p:style>
+        <p:txBody>
+          <a:bodyPr rtlCol="0" anchor="ctr"/>
+          <a:lstStyle/>
+          <a:p>
+            <a:pPr algn="ctr"/>
+          </a:p>
+        </p:txBody>
+      </p:sp>
+      <p:sp>
+        <p:nvSpPr>
+          <p:cNvPr id="65" name="TextBox 64"/>
+          <p:cNvSpPr txBox="1"/>
+          <p:nvPr/>
+        </p:nvSpPr>
+        <p:spPr>
+          <a:xfrm>
+            <a:off x="9628632" y="3072384"/>
+            <a:ext cx="2221992" cy="502920"/>
+          </a:xfrm>
+          <a:prstGeom prst="rect">
+            <a:avLst/>
+          </a:prstGeom>
+          <a:noFill/>
+        </p:spPr>
+        <p:txBody>
+          <a:bodyPr wrap="square">
+            <a:spAutoFit/>
+          </a:bodyPr>
+          <a:lstStyle/>
+          <a:p>
+            <a:pPr algn="l"/>
+            <a:r>
+              <a:rPr sz="950" b="0" i="0">
+                <a:solidFill>
+                  <a:srgbClr val="111827"/>
+                </a:solidFill>
+                <a:latin typeface="Calibri"/>
+              </a:rPr>
+              <a:t>Begin scoping Modules 3–5 for Phase 2</a:t>
+            </a:r>
+          </a:p>
+        </p:txBody>
+      </p:sp>
+      <p:sp>
+        <p:nvSpPr>
+          <p:cNvPr id="66" name="Rectangle 65"/>
+          <p:cNvSpPr/>
+          <p:nvPr/>
+        </p:nvSpPr>
+        <p:spPr>
+          <a:xfrm>
+            <a:off x="9500616" y="3703320"/>
+            <a:ext cx="64008" cy="64008"/>
+          </a:xfrm>
+          <a:prstGeom prst="rect">
+            <a:avLst/>
+          </a:prstGeom>
+          <a:solidFill>
+            <a:srgbClr val="4B2D8A"/>
+          </a:solidFill>
+          <a:ln>
+            <a:noFill/>
+          </a:ln>
+        </p:spPr>
+        <p:style>
+          <a:lnRef idx="1">
+            <a:schemeClr val="accent1"/>
+          </a:lnRef>
+          <a:fillRef idx="3">
+            <a:schemeClr val="accent1"/>
+          </a:fillRef>
+          <a:effectRef idx="2">
+            <a:schemeClr val="accent1"/>
+          </a:effectRef>
+          <a:fontRef idx="minor">
+            <a:schemeClr val="lt1"/>
+          </a:fontRef>
+        </p:style>
+        <p:txBody>
+          <a:bodyPr rtlCol="0" anchor="ctr"/>
+          <a:lstStyle/>
+          <a:p>
+            <a:pPr algn="ctr"/>
+          </a:p>
+        </p:txBody>
+      </p:sp>
+      <p:sp>
+        <p:nvSpPr>
+          <p:cNvPr id="67" name="TextBox 66"/>
+          <p:cNvSpPr txBox="1"/>
+          <p:nvPr/>
+        </p:nvSpPr>
+        <p:spPr>
+          <a:xfrm>
+            <a:off x="9628632" y="3621024"/>
+            <a:ext cx="2221992" cy="502920"/>
+          </a:xfrm>
+          <a:prstGeom prst="rect">
+            <a:avLst/>
+          </a:prstGeom>
+          <a:noFill/>
+        </p:spPr>
+        <p:txBody>
+          <a:bodyPr wrap="square">
+            <a:spAutoFit/>
+          </a:bodyPr>
+          <a:lstStyle/>
+          <a:p>
+            <a:pPr algn="l"/>
+            <a:r>
+              <a:rPr sz="950" b="0" i="0">
+                <a:solidFill>
+                  <a:srgbClr val="111827"/>
+                </a:solidFill>
+                <a:latin typeface="Calibri"/>
+              </a:rPr>
+              <a:t>Connor's actuals data shared for forecast backtesting</a:t>
+            </a:r>
+          </a:p>
+        </p:txBody>
+      </p:sp>
+      <p:sp>
+        <p:nvSpPr>
+          <p:cNvPr id="68" name="Rectangle 67"/>
+          <p:cNvSpPr/>
+          <p:nvPr/>
+        </p:nvSpPr>
+        <p:spPr>
+          <a:xfrm>
+            <a:off x="9372600" y="4261103"/>
+            <a:ext cx="2606040" cy="402336"/>
+          </a:xfrm>
+          <a:prstGeom prst="rect">
+            <a:avLst/>
+          </a:prstGeom>
+          <a:solidFill>
+            <a:srgbClr val="4B2D8A"/>
+          </a:solidFill>
+          <a:ln>
+            <a:noFill/>
+          </a:ln>
+        </p:spPr>
+        <p:style>
+          <a:lnRef idx="1">
+            <a:schemeClr val="accent1"/>
+          </a:lnRef>
+          <a:fillRef idx="3">
+            <a:schemeClr val="accent1"/>
+          </a:fillRef>
+          <a:effectRef idx="2">
+            <a:schemeClr val="accent1"/>
+          </a:effectRef>
+          <a:fontRef idx="minor">
+            <a:schemeClr val="lt1"/>
+          </a:fontRef>
+        </p:style>
+        <p:txBody>
+          <a:bodyPr rtlCol="0" anchor="ctr"/>
+          <a:lstStyle/>
+          <a:p>
+            <a:pPr algn="ctr"/>
+          </a:p>
+        </p:txBody>
+      </p:sp>
+      <p:sp>
+        <p:nvSpPr>
+          <p:cNvPr id="69" name="TextBox 68"/>
           <p:cNvSpPr txBox="1"/>
           <p:nvPr/>
         </p:nvSpPr>
@@ -5475,7 +6571,7 @@
       </p:sp>
       <p:sp>
         <p:nvSpPr>
-          <p:cNvPr id="42" name="Rectangle 41"/>
+          <p:cNvPr id="70" name="Rectangle 69"/>
           <p:cNvSpPr/>
           <p:nvPr/>
         </p:nvSpPr>
@@ -5518,7 +6614,7 @@
       </p:sp>
       <p:sp>
         <p:nvSpPr>
-          <p:cNvPr id="43" name="TextBox 42"/>
+          <p:cNvPr id="71" name="TextBox 70"/>
           <p:cNvSpPr txBox="1"/>
           <p:nvPr/>
         </p:nvSpPr>
@@ -5553,7 +6649,7 @@
       </p:sp>
       <p:sp>
         <p:nvSpPr>
-          <p:cNvPr id="44" name="TextBox 43"/>
+          <p:cNvPr id="72" name="TextBox 71"/>
           <p:cNvSpPr txBox="1"/>
           <p:nvPr/>
         </p:nvSpPr>

</xml_diff>

<commit_message>
README update 87: incorporate Brian kickoff meeting feedback into PPTX
Module 04 (Demand Forecast) promoted to Phase 1 priority per Brian Cluster's explicit ask.
Phase 1 = Modules 01+02+04; Phase 2 = Modules 03+05. Module 04 now leads the module section.
Connor demoted R→C on projection review + UI feedback rows. BUILT PROVIDES updated with
product data + regional seasonality indexes. Includes meeting transcript and Rob's edited PPTX.

Co-Authored-By: Claude Sonnet 4.6 <noreply@anthropic.com>
</commit_message>
<xml_diff>
--- a/mockups/mo_data_ops_kickoff.pptx
+++ b/mockups/mo_data_ops_kickoff.pptx
@@ -3377,7 +3377,7 @@
         <p:spPr>
           <a:xfrm>
             <a:off x="457200" y="4242816"/>
-            <a:ext cx="5577840" cy="685800"/>
+            <a:ext cx="3630168" cy="685800"/>
           </a:xfrm>
           <a:prstGeom prst="rect">
             <a:avLst/>
@@ -3419,29 +3419,29 @@
         </p:nvSpPr>
         <p:spPr>
           <a:xfrm>
-            <a:off x="594360" y="4453128"/>
-            <a:ext cx="5303520" cy="347472"/>
-          </a:xfrm>
-          <a:prstGeom prst="rect">
-            <a:avLst/>
-          </a:prstGeom>
-          <a:noFill/>
-        </p:spPr>
-        <p:txBody>
-          <a:bodyPr wrap="square">
-            <a:spAutoFit/>
-          </a:bodyPr>
-          <a:lstStyle/>
-          <a:p>
-            <a:pPr algn="ctr"/>
-            <a:r>
-              <a:rPr sz="1500" b="1" i="0">
+            <a:off x="548640" y="4453128"/>
+            <a:ext cx="3447288" cy="347472"/>
+          </a:xfrm>
+          <a:prstGeom prst="rect">
+            <a:avLst/>
+          </a:prstGeom>
+          <a:noFill/>
+        </p:spPr>
+        <p:txBody>
+          <a:bodyPr wrap="square">
+            <a:spAutoFit/>
+          </a:bodyPr>
+          <a:lstStyle/>
+          <a:p>
+            <a:pPr algn="ctr"/>
+            <a:r>
+              <a:rPr sz="1300" b="1" i="0">
                 <a:solidFill>
                   <a:srgbClr val="FFFFFF"/>
                 </a:solidFill>
                 <a:latin typeface="Calibri"/>
               </a:rPr>
-              <a:t>Cannibalization Risk</a:t>
+              <a:t>Demand Forecast</a:t>
             </a:r>
           </a:p>
         </p:txBody>
@@ -3454,8 +3454,8 @@
         </p:nvSpPr>
         <p:spPr>
           <a:xfrm>
-            <a:off x="6217920" y="4242816"/>
-            <a:ext cx="5577840" cy="685800"/>
+            <a:off x="4270248" y="4242816"/>
+            <a:ext cx="3630168" cy="685800"/>
           </a:xfrm>
           <a:prstGeom prst="rect">
             <a:avLst/>
@@ -3497,28 +3497,106 @@
         </p:nvSpPr>
         <p:spPr>
           <a:xfrm>
-            <a:off x="6355080" y="4453128"/>
-            <a:ext cx="5303520" cy="347472"/>
-          </a:xfrm>
-          <a:prstGeom prst="rect">
-            <a:avLst/>
-          </a:prstGeom>
-          <a:noFill/>
-        </p:spPr>
-        <p:txBody>
-          <a:bodyPr wrap="square">
-            <a:spAutoFit/>
-          </a:bodyPr>
-          <a:lstStyle/>
-          <a:p>
-            <a:pPr algn="ctr"/>
-            <a:r>
-              <a:rPr sz="1500" b="1" i="0">
+            <a:off x="4361688" y="4453128"/>
+            <a:ext cx="3447288" cy="347472"/>
+          </a:xfrm>
+          <a:prstGeom prst="rect">
+            <a:avLst/>
+          </a:prstGeom>
+          <a:noFill/>
+        </p:spPr>
+        <p:txBody>
+          <a:bodyPr wrap="square">
+            <a:spAutoFit/>
+          </a:bodyPr>
+          <a:lstStyle/>
+          <a:p>
+            <a:pPr algn="ctr"/>
+            <a:r>
+              <a:rPr sz="1300" b="1" i="0">
                 <a:solidFill>
                   <a:srgbClr val="FFFFFF"/>
                 </a:solidFill>
                 <a:latin typeface="Calibri"/>
               </a:rPr>
+              <a:t>Cannibalization Risk</a:t>
+            </a:r>
+          </a:p>
+        </p:txBody>
+      </p:sp>
+      <p:sp>
+        <p:nvSpPr>
+          <p:cNvPr id="13" name="Rectangle 12"/>
+          <p:cNvSpPr/>
+          <p:nvPr/>
+        </p:nvSpPr>
+        <p:spPr>
+          <a:xfrm>
+            <a:off x="8083296" y="4242816"/>
+            <a:ext cx="3630168" cy="685800"/>
+          </a:xfrm>
+          <a:prstGeom prst="rect">
+            <a:avLst/>
+          </a:prstGeom>
+          <a:solidFill>
+            <a:srgbClr val="204070"/>
+          </a:solidFill>
+          <a:ln>
+            <a:noFill/>
+          </a:ln>
+        </p:spPr>
+        <p:style>
+          <a:lnRef idx="1">
+            <a:schemeClr val="accent1"/>
+          </a:lnRef>
+          <a:fillRef idx="3">
+            <a:schemeClr val="accent1"/>
+          </a:fillRef>
+          <a:effectRef idx="2">
+            <a:schemeClr val="accent1"/>
+          </a:effectRef>
+          <a:fontRef idx="minor">
+            <a:schemeClr val="lt1"/>
+          </a:fontRef>
+        </p:style>
+        <p:txBody>
+          <a:bodyPr rtlCol="0" anchor="ctr"/>
+          <a:lstStyle/>
+          <a:p>
+            <a:pPr algn="ctr"/>
+          </a:p>
+        </p:txBody>
+      </p:sp>
+      <p:sp>
+        <p:nvSpPr>
+          <p:cNvPr id="14" name="TextBox 13"/>
+          <p:cNvSpPr txBox="1"/>
+          <p:nvPr/>
+        </p:nvSpPr>
+        <p:spPr>
+          <a:xfrm>
+            <a:off x="8174736" y="4453128"/>
+            <a:ext cx="3447288" cy="347472"/>
+          </a:xfrm>
+          <a:prstGeom prst="rect">
+            <a:avLst/>
+          </a:prstGeom>
+          <a:noFill/>
+        </p:spPr>
+        <p:txBody>
+          <a:bodyPr wrap="square">
+            <a:spAutoFit/>
+          </a:bodyPr>
+          <a:lstStyle/>
+          <a:p>
+            <a:pPr algn="ctr"/>
+            <a:r>
+              <a:rPr sz="1300" b="1" i="0">
+                <a:solidFill>
+                  <a:srgbClr val="FFFFFF"/>
+                </a:solidFill>
+                <a:latin typeface="Calibri"/>
+              </a:rPr>
               <a:t>Price Elasticity</a:t>
             </a:r>
           </a:p>
@@ -3526,7 +3604,7 @@
       </p:sp>
       <p:sp>
         <p:nvSpPr>
-          <p:cNvPr id="13" name="Rectangle 12"/>
+          <p:cNvPr id="15" name="Rectangle 14"/>
           <p:cNvSpPr/>
           <p:nvPr/>
         </p:nvSpPr>
@@ -3569,7 +3647,7 @@
       </p:sp>
       <p:sp>
         <p:nvSpPr>
-          <p:cNvPr id="14" name="TextBox 13"/>
+          <p:cNvPr id="16" name="TextBox 15"/>
           <p:cNvSpPr txBox="1"/>
           <p:nvPr/>
         </p:nvSpPr>
@@ -3604,14 +3682,14 @@
       </p:sp>
       <p:sp>
         <p:nvSpPr>
-          <p:cNvPr id="15" name="Rectangle 14"/>
+          <p:cNvPr id="17" name="Rectangle 16"/>
           <p:cNvSpPr/>
           <p:nvPr/>
         </p:nvSpPr>
         <p:spPr>
           <a:xfrm>
             <a:off x="457200" y="5422392"/>
-            <a:ext cx="3657600" cy="594360"/>
+            <a:ext cx="5577840" cy="594360"/>
           </a:xfrm>
           <a:prstGeom prst="rect">
             <a:avLst/>
@@ -3647,14 +3725,14 @@
       </p:sp>
       <p:sp>
         <p:nvSpPr>
-          <p:cNvPr id="16" name="TextBox 15"/>
-          <p:cNvSpPr txBox="1"/>
-          <p:nvPr/>
-        </p:nvSpPr>
-        <p:spPr>
-          <a:xfrm>
-            <a:off x="548640" y="5586983"/>
-            <a:ext cx="3474720" cy="310896"/>
+          <p:cNvPr id="18" name="TextBox 17"/>
+          <p:cNvSpPr txBox="1"/>
+          <p:nvPr/>
+        </p:nvSpPr>
+        <p:spPr>
+          <a:xfrm>
+            <a:off x="594360" y="5586983"/>
+            <a:ext cx="5303520" cy="310896"/>
           </a:xfrm>
           <a:prstGeom prst="rect">
             <a:avLst/>
@@ -3682,14 +3760,14 @@
       </p:sp>
       <p:sp>
         <p:nvSpPr>
-          <p:cNvPr id="17" name="Rectangle 16"/>
+          <p:cNvPr id="19" name="Rectangle 18"/>
           <p:cNvSpPr/>
           <p:nvPr/>
         </p:nvSpPr>
         <p:spPr>
           <a:xfrm>
-            <a:off x="4297680" y="5422392"/>
-            <a:ext cx="3657600" cy="594360"/>
+            <a:off x="6217920" y="5422392"/>
+            <a:ext cx="5577840" cy="594360"/>
           </a:xfrm>
           <a:prstGeom prst="rect">
             <a:avLst/>
@@ -3725,92 +3803,14 @@
       </p:sp>
       <p:sp>
         <p:nvSpPr>
-          <p:cNvPr id="18" name="TextBox 17"/>
-          <p:cNvSpPr txBox="1"/>
-          <p:nvPr/>
-        </p:nvSpPr>
-        <p:spPr>
-          <a:xfrm>
-            <a:off x="4389120" y="5586983"/>
-            <a:ext cx="3474720" cy="310896"/>
-          </a:xfrm>
-          <a:prstGeom prst="rect">
-            <a:avLst/>
-          </a:prstGeom>
-          <a:noFill/>
-        </p:spPr>
-        <p:txBody>
-          <a:bodyPr wrap="square">
-            <a:spAutoFit/>
-          </a:bodyPr>
-          <a:lstStyle/>
-          <a:p>
-            <a:pPr algn="ctr"/>
-            <a:r>
-              <a:rPr sz="1200" b="1" i="0">
-                <a:solidFill>
-                  <a:srgbClr val="D4DAE6"/>
-                </a:solidFill>
-                <a:latin typeface="Calibri"/>
-              </a:rPr>
-              <a:t>Demand Forecast</a:t>
-            </a:r>
-          </a:p>
-        </p:txBody>
-      </p:sp>
-      <p:sp>
-        <p:nvSpPr>
-          <p:cNvPr id="19" name="Rectangle 18"/>
-          <p:cNvSpPr/>
-          <p:nvPr/>
-        </p:nvSpPr>
-        <p:spPr>
-          <a:xfrm>
-            <a:off x="8138160" y="5422392"/>
-            <a:ext cx="3657600" cy="594360"/>
-          </a:xfrm>
-          <a:prstGeom prst="rect">
-            <a:avLst/>
-          </a:prstGeom>
-          <a:solidFill>
-            <a:srgbClr val="2E384A"/>
-          </a:solidFill>
-          <a:ln>
-            <a:noFill/>
-          </a:ln>
-        </p:spPr>
-        <p:style>
-          <a:lnRef idx="1">
-            <a:schemeClr val="accent1"/>
-          </a:lnRef>
-          <a:fillRef idx="3">
-            <a:schemeClr val="accent1"/>
-          </a:fillRef>
-          <a:effectRef idx="2">
-            <a:schemeClr val="accent1"/>
-          </a:effectRef>
-          <a:fontRef idx="minor">
-            <a:schemeClr val="lt1"/>
-          </a:fontRef>
-        </p:style>
-        <p:txBody>
-          <a:bodyPr rtlCol="0" anchor="ctr"/>
-          <a:lstStyle/>
-          <a:p>
-            <a:pPr algn="ctr"/>
-          </a:p>
-        </p:txBody>
-      </p:sp>
-      <p:sp>
-        <p:nvSpPr>
           <p:cNvPr id="20" name="TextBox 19"/>
           <p:cNvSpPr txBox="1"/>
           <p:nvPr/>
         </p:nvSpPr>
         <p:spPr>
           <a:xfrm>
-            <a:off x="8229600" y="5586983"/>
-            <a:ext cx="3474720" cy="310896"/>
+            <a:off x="6355080" y="5586983"/>
+            <a:ext cx="5303520" cy="310896"/>
           </a:xfrm>
           <a:prstGeom prst="rect">
             <a:avLst/>
@@ -5150,7 +5150,7 @@
                 </a:solidFill>
                 <a:latin typeface="Calibri"/>
               </a:rPr>
-              <a:t>BUILT validates data looks right for Modules 01–02</a:t>
+              <a:t>BUILT validates data looks right for all three Phase 1 modules</a:t>
             </a:r>
           </a:p>
         </p:txBody>
@@ -5306,7 +5306,7 @@
                 </a:solidFill>
                 <a:latin typeface="Calibri"/>
               </a:rPr>
-              <a:t>Deliverable:  QA report delivered; Module 01–02 models trained</a:t>
+              <a:t>Deliverable:  QA report delivered; Phase 1 models trained</a:t>
             </a:r>
           </a:p>
         </p:txBody>
@@ -5623,7 +5623,7 @@
                 </a:solidFill>
                 <a:latin typeface="Calibri"/>
               </a:rPr>
-              <a:t>Cannibalization Risk + Price Elasticity live in Mo UI</a:t>
+              <a:t>Demand Forecast + Cannibalization Risk + Price Elasticity live in Mo UI</a:t>
             </a:r>
           </a:p>
         </p:txBody>
@@ -10680,7 +10680,7 @@
                 </a:solidFill>
                 <a:latin typeface="Calibri"/>
               </a:rPr>
-              <a:t>Model training and scoring: cannibalization risk + price elasticity (Phase 1)</a:t>
+              <a:t>Model training and scoring: demand velocity &amp; forecast + cannibalization risk + price elasticity (Phase 1)</a:t>
             </a:r>
           </a:p>
         </p:txBody>
@@ -11148,7 +11148,7 @@
                 </a:solidFill>
                 <a:latin typeface="Calibri"/>
               </a:rPr>
-              <a:t>ERP / data warehouse access — for Phase 2 data sources and Connor's actuals</a:t>
+              <a:t>Product master data + regional seasonality indexes — supplemental inputs for Phase 1 demand forecast</a:t>
             </a:r>
           </a:p>
         </p:txBody>
@@ -11226,7 +11226,7 @@
                 </a:solidFill>
                 <a:latin typeface="Calibri"/>
               </a:rPr>
-              <a:t>Stakeholder availability: kickoff, data QA review, demo sessions, and sign-off</a:t>
+              <a:t>ERP / data warehouse access — for Phase 2 data sources and Connor's actuals</a:t>
             </a:r>
           </a:p>
         </p:txBody>
@@ -11304,7 +11304,7 @@
                 </a:solidFill>
                 <a:latin typeface="Calibri"/>
               </a:rPr>
-              <a:t>Projection validation: Connor + Brian confirm whether findings match their market knowledge</a:t>
+              <a:t>Stakeholder availability: kickoff, data QA review, demo sessions, and sign-off</a:t>
             </a:r>
           </a:p>
         </p:txBody>
@@ -11382,7 +11382,7 @@
                 </a:solidFill>
                 <a:latin typeface="Calibri"/>
               </a:rPr>
-              <a:t>UI feedback: what information helps the job get done — what to add, change, or remove</a:t>
+              <a:t>Projection validation: Connor + Brian confirm whether findings match their market knowledge</a:t>
             </a:r>
           </a:p>
         </p:txBody>
@@ -11460,6 +11460,84 @@
                 </a:solidFill>
                 <a:latin typeface="Calibri"/>
               </a:rPr>
+              <a:t>UI feedback: what information helps the job get done — what to add, change, or remove</a:t>
+            </a:r>
+          </a:p>
+        </p:txBody>
+      </p:sp>
+      <p:sp>
+        <p:nvSpPr>
+          <p:cNvPr id="37" name="Rectangle 36"/>
+          <p:cNvSpPr/>
+          <p:nvPr/>
+        </p:nvSpPr>
+        <p:spPr>
+          <a:xfrm>
+            <a:off x="6373368" y="3602735"/>
+            <a:ext cx="73152" cy="73152"/>
+          </a:xfrm>
+          <a:prstGeom prst="rect">
+            <a:avLst/>
+          </a:prstGeom>
+          <a:solidFill>
+            <a:srgbClr val="0E5E38"/>
+          </a:solidFill>
+          <a:ln>
+            <a:noFill/>
+          </a:ln>
+        </p:spPr>
+        <p:style>
+          <a:lnRef idx="1">
+            <a:schemeClr val="accent1"/>
+          </a:lnRef>
+          <a:fillRef idx="3">
+            <a:schemeClr val="accent1"/>
+          </a:fillRef>
+          <a:effectRef idx="2">
+            <a:schemeClr val="accent1"/>
+          </a:effectRef>
+          <a:fontRef idx="minor">
+            <a:schemeClr val="lt1"/>
+          </a:fontRef>
+        </p:style>
+        <p:txBody>
+          <a:bodyPr rtlCol="0" anchor="ctr"/>
+          <a:lstStyle/>
+          <a:p>
+            <a:pPr algn="ctr"/>
+          </a:p>
+        </p:txBody>
+      </p:sp>
+      <p:sp>
+        <p:nvSpPr>
+          <p:cNvPr id="38" name="TextBox 37"/>
+          <p:cNvSpPr txBox="1"/>
+          <p:nvPr/>
+        </p:nvSpPr>
+        <p:spPr>
+          <a:xfrm>
+            <a:off x="6537959" y="3529583"/>
+            <a:ext cx="5193792" cy="292608"/>
+          </a:xfrm>
+          <a:prstGeom prst="rect">
+            <a:avLst/>
+          </a:prstGeom>
+          <a:noFill/>
+        </p:spPr>
+        <p:txBody>
+          <a:bodyPr wrap="square">
+            <a:spAutoFit/>
+          </a:bodyPr>
+          <a:lstStyle/>
+          <a:p>
+            <a:pPr algn="l"/>
+            <a:r>
+              <a:rPr sz="1000" b="0" i="0">
+                <a:solidFill>
+                  <a:srgbClr val="111827"/>
+                </a:solidFill>
+                <a:latin typeface="Calibri"/>
+              </a:rPr>
               <a:t>Phase 1 milestone sign-off before proceeding to Phase 2 scope</a:t>
             </a:r>
           </a:p>
@@ -11467,7 +11545,7 @@
       </p:sp>
       <p:sp>
         <p:nvSpPr>
-          <p:cNvPr id="37" name="Rectangle 36"/>
+          <p:cNvPr id="39" name="Rectangle 38"/>
           <p:cNvSpPr/>
           <p:nvPr/>
         </p:nvSpPr>
@@ -11510,7 +11588,7 @@
       </p:sp>
       <p:sp>
         <p:nvSpPr>
-          <p:cNvPr id="38" name="TextBox 37"/>
+          <p:cNvPr id="40" name="TextBox 39"/>
           <p:cNvSpPr txBox="1"/>
           <p:nvPr/>
         </p:nvSpPr>
@@ -11545,7 +11623,7 @@
       </p:sp>
       <p:sp>
         <p:nvSpPr>
-          <p:cNvPr id="39" name="TextBox 38"/>
+          <p:cNvPr id="41" name="TextBox 40"/>
           <p:cNvSpPr txBox="1"/>
           <p:nvPr/>
         </p:nvSpPr>
@@ -11580,7 +11658,7 @@
       </p:sp>
       <p:sp>
         <p:nvSpPr>
-          <p:cNvPr id="40" name="TextBox 39"/>
+          <p:cNvPr id="42" name="TextBox 41"/>
           <p:cNvSpPr txBox="1"/>
           <p:nvPr/>
         </p:nvSpPr>
@@ -11615,7 +11693,7 @@
       </p:sp>
       <p:sp>
         <p:nvSpPr>
-          <p:cNvPr id="41" name="TextBox 40"/>
+          <p:cNvPr id="43" name="TextBox 42"/>
           <p:cNvSpPr txBox="1"/>
           <p:nvPr/>
         </p:nvSpPr>
@@ -11650,7 +11728,7 @@
       </p:sp>
       <p:sp>
         <p:nvSpPr>
-          <p:cNvPr id="42" name="TextBox 41"/>
+          <p:cNvPr id="44" name="TextBox 43"/>
           <p:cNvSpPr txBox="1"/>
           <p:nvPr/>
         </p:nvSpPr>
@@ -11685,7 +11763,7 @@
       </p:sp>
       <p:sp>
         <p:nvSpPr>
-          <p:cNvPr id="43" name="TextBox 42"/>
+          <p:cNvPr id="45" name="TextBox 44"/>
           <p:cNvSpPr txBox="1"/>
           <p:nvPr/>
         </p:nvSpPr>
@@ -11720,7 +11798,7 @@
       </p:sp>
       <p:sp>
         <p:nvSpPr>
-          <p:cNvPr id="44" name="Rectangle 43"/>
+          <p:cNvPr id="46" name="Rectangle 45"/>
           <p:cNvSpPr/>
           <p:nvPr/>
         </p:nvSpPr>
@@ -11765,7 +11843,7 @@
       </p:sp>
       <p:sp>
         <p:nvSpPr>
-          <p:cNvPr id="45" name="TextBox 44"/>
+          <p:cNvPr id="47" name="TextBox 46"/>
           <p:cNvSpPr txBox="1"/>
           <p:nvPr/>
         </p:nvSpPr>
@@ -11800,7 +11878,7 @@
       </p:sp>
       <p:sp>
         <p:nvSpPr>
-          <p:cNvPr id="46" name="TextBox 45"/>
+          <p:cNvPr id="48" name="TextBox 47"/>
           <p:cNvSpPr txBox="1"/>
           <p:nvPr/>
         </p:nvSpPr>
@@ -11835,7 +11913,7 @@
       </p:sp>
       <p:sp>
         <p:nvSpPr>
-          <p:cNvPr id="47" name="TextBox 46"/>
+          <p:cNvPr id="49" name="TextBox 48"/>
           <p:cNvSpPr txBox="1"/>
           <p:nvPr/>
         </p:nvSpPr>
@@ -11870,7 +11948,7 @@
       </p:sp>
       <p:sp>
         <p:nvSpPr>
-          <p:cNvPr id="48" name="TextBox 47"/>
+          <p:cNvPr id="50" name="TextBox 49"/>
           <p:cNvSpPr txBox="1"/>
           <p:nvPr/>
         </p:nvSpPr>
@@ -11905,7 +11983,7 @@
       </p:sp>
       <p:sp>
         <p:nvSpPr>
-          <p:cNvPr id="49" name="TextBox 48"/>
+          <p:cNvPr id="51" name="TextBox 50"/>
           <p:cNvSpPr txBox="1"/>
           <p:nvPr/>
         </p:nvSpPr>
@@ -11940,7 +12018,7 @@
       </p:sp>
       <p:sp>
         <p:nvSpPr>
-          <p:cNvPr id="50" name="TextBox 49"/>
+          <p:cNvPr id="52" name="TextBox 51"/>
           <p:cNvSpPr txBox="1"/>
           <p:nvPr/>
         </p:nvSpPr>
@@ -11975,7 +12053,7 @@
       </p:sp>
       <p:sp>
         <p:nvSpPr>
-          <p:cNvPr id="51" name="Rectangle 50"/>
+          <p:cNvPr id="53" name="Rectangle 52"/>
           <p:cNvSpPr/>
           <p:nvPr/>
         </p:nvSpPr>
@@ -12020,7 +12098,7 @@
       </p:sp>
       <p:sp>
         <p:nvSpPr>
-          <p:cNvPr id="52" name="TextBox 51"/>
+          <p:cNvPr id="54" name="TextBox 53"/>
           <p:cNvSpPr txBox="1"/>
           <p:nvPr/>
         </p:nvSpPr>
@@ -12055,7 +12133,7 @@
       </p:sp>
       <p:sp>
         <p:nvSpPr>
-          <p:cNvPr id="53" name="TextBox 52"/>
+          <p:cNvPr id="55" name="TextBox 54"/>
           <p:cNvSpPr txBox="1"/>
           <p:nvPr/>
         </p:nvSpPr>
@@ -12090,7 +12168,7 @@
       </p:sp>
       <p:sp>
         <p:nvSpPr>
-          <p:cNvPr id="54" name="TextBox 53"/>
+          <p:cNvPr id="56" name="TextBox 55"/>
           <p:cNvSpPr txBox="1"/>
           <p:nvPr/>
         </p:nvSpPr>
@@ -12125,7 +12203,7 @@
       </p:sp>
       <p:sp>
         <p:nvSpPr>
-          <p:cNvPr id="55" name="TextBox 54"/>
+          <p:cNvPr id="57" name="TextBox 56"/>
           <p:cNvSpPr txBox="1"/>
           <p:nvPr/>
         </p:nvSpPr>
@@ -12160,7 +12238,7 @@
       </p:sp>
       <p:sp>
         <p:nvSpPr>
-          <p:cNvPr id="56" name="TextBox 55"/>
+          <p:cNvPr id="58" name="TextBox 57"/>
           <p:cNvSpPr txBox="1"/>
           <p:nvPr/>
         </p:nvSpPr>
@@ -12195,7 +12273,7 @@
       </p:sp>
       <p:sp>
         <p:nvSpPr>
-          <p:cNvPr id="57" name="TextBox 56"/>
+          <p:cNvPr id="59" name="TextBox 58"/>
           <p:cNvSpPr txBox="1"/>
           <p:nvPr/>
         </p:nvSpPr>
@@ -12230,7 +12308,7 @@
       </p:sp>
       <p:sp>
         <p:nvSpPr>
-          <p:cNvPr id="58" name="Rectangle 57"/>
+          <p:cNvPr id="60" name="Rectangle 59"/>
           <p:cNvSpPr/>
           <p:nvPr/>
         </p:nvSpPr>
@@ -12275,7 +12353,7 @@
       </p:sp>
       <p:sp>
         <p:nvSpPr>
-          <p:cNvPr id="59" name="TextBox 58"/>
+          <p:cNvPr id="61" name="TextBox 60"/>
           <p:cNvSpPr txBox="1"/>
           <p:nvPr/>
         </p:nvSpPr>
@@ -12310,7 +12388,7 @@
       </p:sp>
       <p:sp>
         <p:nvSpPr>
-          <p:cNvPr id="60" name="TextBox 59"/>
+          <p:cNvPr id="62" name="TextBox 61"/>
           <p:cNvSpPr txBox="1"/>
           <p:nvPr/>
         </p:nvSpPr>
@@ -12345,7 +12423,7 @@
       </p:sp>
       <p:sp>
         <p:nvSpPr>
-          <p:cNvPr id="61" name="TextBox 60"/>
+          <p:cNvPr id="63" name="TextBox 62"/>
           <p:cNvSpPr txBox="1"/>
           <p:nvPr/>
         </p:nvSpPr>
@@ -12380,7 +12458,7 @@
       </p:sp>
       <p:sp>
         <p:nvSpPr>
-          <p:cNvPr id="62" name="TextBox 61"/>
+          <p:cNvPr id="64" name="TextBox 63"/>
           <p:cNvSpPr txBox="1"/>
           <p:nvPr/>
         </p:nvSpPr>
@@ -12415,7 +12493,7 @@
       </p:sp>
       <p:sp>
         <p:nvSpPr>
-          <p:cNvPr id="63" name="TextBox 62"/>
+          <p:cNvPr id="65" name="TextBox 64"/>
           <p:cNvSpPr txBox="1"/>
           <p:nvPr/>
         </p:nvSpPr>
@@ -12450,7 +12528,7 @@
       </p:sp>
       <p:sp>
         <p:nvSpPr>
-          <p:cNvPr id="64" name="TextBox 63"/>
+          <p:cNvPr id="66" name="TextBox 65"/>
           <p:cNvSpPr txBox="1"/>
           <p:nvPr/>
         </p:nvSpPr>
@@ -12485,7 +12563,7 @@
       </p:sp>
       <p:sp>
         <p:nvSpPr>
-          <p:cNvPr id="65" name="Rectangle 64"/>
+          <p:cNvPr id="67" name="Rectangle 66"/>
           <p:cNvSpPr/>
           <p:nvPr/>
         </p:nvSpPr>
@@ -12530,7 +12608,7 @@
       </p:sp>
       <p:sp>
         <p:nvSpPr>
-          <p:cNvPr id="66" name="TextBox 65"/>
+          <p:cNvPr id="68" name="TextBox 67"/>
           <p:cNvSpPr txBox="1"/>
           <p:nvPr/>
         </p:nvSpPr>
@@ -12565,7 +12643,7 @@
       </p:sp>
       <p:sp>
         <p:nvSpPr>
-          <p:cNvPr id="67" name="TextBox 66"/>
+          <p:cNvPr id="69" name="TextBox 68"/>
           <p:cNvSpPr txBox="1"/>
           <p:nvPr/>
         </p:nvSpPr>
@@ -12600,7 +12678,7 @@
       </p:sp>
       <p:sp>
         <p:nvSpPr>
-          <p:cNvPr id="68" name="TextBox 67"/>
+          <p:cNvPr id="70" name="TextBox 69"/>
           <p:cNvSpPr txBox="1"/>
           <p:nvPr/>
         </p:nvSpPr>
@@ -12635,7 +12713,7 @@
       </p:sp>
       <p:sp>
         <p:nvSpPr>
-          <p:cNvPr id="69" name="TextBox 68"/>
+          <p:cNvPr id="71" name="TextBox 70"/>
           <p:cNvSpPr txBox="1"/>
           <p:nvPr/>
         </p:nvSpPr>
@@ -12657,20 +12735,20 @@
           <a:p>
             <a:pPr algn="ctr"/>
             <a:r>
-              <a:rPr sz="900" b="1" i="0">
-                <a:solidFill>
-                  <a:srgbClr val="4078D0"/>
-                </a:solidFill>
-                <a:latin typeface="Calibri"/>
-              </a:rPr>
-              <a:t>R</a:t>
-            </a:r>
-          </a:p>
-        </p:txBody>
-      </p:sp>
-      <p:sp>
-        <p:nvSpPr>
-          <p:cNvPr id="70" name="TextBox 69"/>
+              <a:rPr sz="900" b="0" i="0">
+                <a:solidFill>
+                  <a:srgbClr val="111827"/>
+                </a:solidFill>
+                <a:latin typeface="Calibri"/>
+              </a:rPr>
+              <a:t>C</a:t>
+            </a:r>
+          </a:p>
+        </p:txBody>
+      </p:sp>
+      <p:sp>
+        <p:nvSpPr>
+          <p:cNvPr id="72" name="TextBox 71"/>
           <p:cNvSpPr txBox="1"/>
           <p:nvPr/>
         </p:nvSpPr>
@@ -12705,7 +12783,7 @@
       </p:sp>
       <p:sp>
         <p:nvSpPr>
-          <p:cNvPr id="71" name="TextBox 70"/>
+          <p:cNvPr id="73" name="TextBox 72"/>
           <p:cNvSpPr txBox="1"/>
           <p:nvPr/>
         </p:nvSpPr>
@@ -12740,7 +12818,7 @@
       </p:sp>
       <p:sp>
         <p:nvSpPr>
-          <p:cNvPr id="72" name="Rectangle 71"/>
+          <p:cNvPr id="74" name="Rectangle 73"/>
           <p:cNvSpPr/>
           <p:nvPr/>
         </p:nvSpPr>
@@ -12785,7 +12863,7 @@
       </p:sp>
       <p:sp>
         <p:nvSpPr>
-          <p:cNvPr id="73" name="TextBox 72"/>
+          <p:cNvPr id="75" name="TextBox 74"/>
           <p:cNvSpPr txBox="1"/>
           <p:nvPr/>
         </p:nvSpPr>
@@ -12820,7 +12898,7 @@
       </p:sp>
       <p:sp>
         <p:nvSpPr>
-          <p:cNvPr id="74" name="TextBox 73"/>
+          <p:cNvPr id="76" name="TextBox 75"/>
           <p:cNvSpPr txBox="1"/>
           <p:nvPr/>
         </p:nvSpPr>
@@ -12855,7 +12933,7 @@
       </p:sp>
       <p:sp>
         <p:nvSpPr>
-          <p:cNvPr id="75" name="TextBox 74"/>
+          <p:cNvPr id="77" name="TextBox 76"/>
           <p:cNvSpPr txBox="1"/>
           <p:nvPr/>
         </p:nvSpPr>
@@ -12890,7 +12968,7 @@
       </p:sp>
       <p:sp>
         <p:nvSpPr>
-          <p:cNvPr id="76" name="TextBox 75"/>
+          <p:cNvPr id="78" name="TextBox 77"/>
           <p:cNvSpPr txBox="1"/>
           <p:nvPr/>
         </p:nvSpPr>
@@ -12912,20 +12990,20 @@
           <a:p>
             <a:pPr algn="ctr"/>
             <a:r>
-              <a:rPr sz="900" b="1" i="0">
-                <a:solidFill>
-                  <a:srgbClr val="4078D0"/>
-                </a:solidFill>
-                <a:latin typeface="Calibri"/>
-              </a:rPr>
-              <a:t>R</a:t>
-            </a:r>
-          </a:p>
-        </p:txBody>
-      </p:sp>
-      <p:sp>
-        <p:nvSpPr>
-          <p:cNvPr id="77" name="TextBox 76"/>
+              <a:rPr sz="900" b="0" i="0">
+                <a:solidFill>
+                  <a:srgbClr val="111827"/>
+                </a:solidFill>
+                <a:latin typeface="Calibri"/>
+              </a:rPr>
+              <a:t>C</a:t>
+            </a:r>
+          </a:p>
+        </p:txBody>
+      </p:sp>
+      <p:sp>
+        <p:nvSpPr>
+          <p:cNvPr id="79" name="TextBox 78"/>
           <p:cNvSpPr txBox="1"/>
           <p:nvPr/>
         </p:nvSpPr>
@@ -12960,7 +13038,7 @@
       </p:sp>
       <p:sp>
         <p:nvSpPr>
-          <p:cNvPr id="78" name="TextBox 77"/>
+          <p:cNvPr id="80" name="TextBox 79"/>
           <p:cNvSpPr txBox="1"/>
           <p:nvPr/>
         </p:nvSpPr>
@@ -12995,7 +13073,7 @@
       </p:sp>
       <p:sp>
         <p:nvSpPr>
-          <p:cNvPr id="79" name="Rectangle 78"/>
+          <p:cNvPr id="81" name="Rectangle 80"/>
           <p:cNvSpPr/>
           <p:nvPr/>
         </p:nvSpPr>
@@ -13040,7 +13118,7 @@
       </p:sp>
       <p:sp>
         <p:nvSpPr>
-          <p:cNvPr id="80" name="TextBox 79"/>
+          <p:cNvPr id="82" name="TextBox 81"/>
           <p:cNvSpPr txBox="1"/>
           <p:nvPr/>
         </p:nvSpPr>
@@ -13075,7 +13153,7 @@
       </p:sp>
       <p:sp>
         <p:nvSpPr>
-          <p:cNvPr id="81" name="TextBox 80"/>
+          <p:cNvPr id="83" name="TextBox 82"/>
           <p:cNvSpPr txBox="1"/>
           <p:nvPr/>
         </p:nvSpPr>
@@ -13110,7 +13188,7 @@
       </p:sp>
       <p:sp>
         <p:nvSpPr>
-          <p:cNvPr id="82" name="TextBox 81"/>
+          <p:cNvPr id="84" name="TextBox 83"/>
           <p:cNvSpPr txBox="1"/>
           <p:nvPr/>
         </p:nvSpPr>
@@ -13145,7 +13223,7 @@
       </p:sp>
       <p:sp>
         <p:nvSpPr>
-          <p:cNvPr id="83" name="TextBox 82"/>
+          <p:cNvPr id="85" name="TextBox 84"/>
           <p:cNvSpPr txBox="1"/>
           <p:nvPr/>
         </p:nvSpPr>
@@ -13180,7 +13258,7 @@
       </p:sp>
       <p:sp>
         <p:nvSpPr>
-          <p:cNvPr id="84" name="TextBox 83"/>
+          <p:cNvPr id="86" name="TextBox 85"/>
           <p:cNvSpPr txBox="1"/>
           <p:nvPr/>
         </p:nvSpPr>
@@ -13215,7 +13293,7 @@
       </p:sp>
       <p:sp>
         <p:nvSpPr>
-          <p:cNvPr id="85" name="TextBox 84"/>
+          <p:cNvPr id="87" name="TextBox 86"/>
           <p:cNvSpPr txBox="1"/>
           <p:nvPr/>
         </p:nvSpPr>
@@ -13250,7 +13328,7 @@
       </p:sp>
       <p:sp>
         <p:nvSpPr>
-          <p:cNvPr id="86" name="TextBox 85"/>
+          <p:cNvPr id="88" name="TextBox 87"/>
           <p:cNvSpPr txBox="1"/>
           <p:nvPr/>
         </p:nvSpPr>
@@ -13285,7 +13363,7 @@
       </p:sp>
       <p:sp>
         <p:nvSpPr>
-          <p:cNvPr id="87" name="TextBox 86"/>
+          <p:cNvPr id="89" name="TextBox 88"/>
           <p:cNvSpPr txBox="1"/>
           <p:nvPr/>
         </p:nvSpPr>
@@ -13495,7 +13573,7 @@
                 </a:solidFill>
                 <a:latin typeface="Calibri"/>
               </a:rPr>
-              <a:t>MODULE 01</a:t>
+              <a:t>MODULE 04</a:t>
             </a:r>
           </a:p>
         </p:txBody>
@@ -13565,7 +13643,7 @@
                 </a:solidFill>
                 <a:latin typeface="Calibri"/>
               </a:rPr>
-              <a:t>Cannibalization Risk</a:t>
+              <a:t>Demand Velocity &amp; Forecast</a:t>
             </a:r>
           </a:p>
         </p:txBody>
@@ -13600,7 +13678,7 @@
                 </a:solidFill>
                 <a:latin typeface="Calibri"/>
               </a:rPr>
-              <a:t>"Is this new SKU pulling demand from an existing one, or adding net-new buyers?"</a:t>
+              <a:t>"What will this SKU sell in the next 13 weeks, by retailer account?"</a:t>
             </a:r>
           </a:p>
         </p:txBody>
@@ -13906,7 +13984,7 @@
                 </a:solidFill>
                 <a:latin typeface="Calibri"/>
               </a:rPr>
-              <a:t>Weekly units sold</a:t>
+              <a:t>52-week weekly units sold</a:t>
             </a:r>
           </a:p>
         </p:txBody>
@@ -13976,7 +14054,7 @@
                 </a:solidFill>
                 <a:latin typeface="Calibri"/>
               </a:rPr>
-              <a:t>Before/after demand</a:t>
+              <a:t>Demand history</a:t>
             </a:r>
           </a:p>
         </p:txBody>
@@ -14056,7 +14134,7 @@
                 </a:solidFill>
                 <a:latin typeface="Calibri"/>
               </a:rPr>
-              <a:t>Base units (non-promo)</a:t>
+              <a:t>Distribution (stores selling)</a:t>
             </a:r>
           </a:p>
         </p:txBody>
@@ -14126,7 +14204,7 @@
                 </a:solidFill>
                 <a:latin typeface="Calibri"/>
               </a:rPr>
-              <a:t>Isolate organic demand</a:t>
+              <a:t>Distribution control</a:t>
             </a:r>
           </a:p>
         </p:txBody>
@@ -14206,7 +14284,7 @@
                 </a:solidFill>
                 <a:latin typeface="Calibri"/>
               </a:rPr>
-              <a:t>Distribution — stores selling</a:t>
+              <a:t>Average retail price</a:t>
             </a:r>
           </a:p>
         </p:txBody>
@@ -14276,7 +14354,7 @@
                 </a:solidFill>
                 <a:latin typeface="Calibri"/>
               </a:rPr>
-              <a:t>Demand vs. distrib. loss</a:t>
+              <a:t>Price signal</a:t>
             </a:r>
           </a:p>
         </p:txBody>
@@ -14356,7 +14434,7 @@
                 </a:solidFill>
                 <a:latin typeface="Calibri"/>
               </a:rPr>
-              <a:t>Average retail price</a:t>
+              <a:t>% weeks on promotion</a:t>
             </a:r>
           </a:p>
         </p:txBody>
@@ -14426,7 +14504,7 @@
                 </a:solidFill>
                 <a:latin typeface="Calibri"/>
               </a:rPr>
-              <a:t>Rule out price effect</a:t>
+              <a:t>Promo flag</a:t>
             </a:r>
           </a:p>
         </p:txBody>
@@ -14506,7 +14584,7 @@
                 </a:solidFill>
                 <a:latin typeface="Calibri"/>
               </a:rPr>
-              <a:t>First week selling (launch date)</a:t>
+              <a:t>Retail account</a:t>
             </a:r>
           </a:p>
         </p:txBody>
@@ -14576,7 +14654,7 @@
                 </a:solidFill>
                 <a:latin typeface="Calibri"/>
               </a:rPr>
-              <a:t>Launch anchor date</a:t>
+              <a:t>Per-account model</a:t>
             </a:r>
           </a:p>
         </p:txBody>
@@ -14656,7 +14734,7 @@
                 </a:solidFill>
                 <a:latin typeface="Calibri"/>
               </a:rPr>
-              <a:t>Pack count, flavor, brand line</a:t>
+              <a:t>Week end date</a:t>
             </a:r>
           </a:p>
         </p:txBody>
@@ -14726,7 +14804,7 @@
                 </a:solidFill>
                 <a:latin typeface="Calibri"/>
               </a:rPr>
-              <a:t>Find substitute SKUs</a:t>
+              <a:t>Seasonality features</a:t>
             </a:r>
           </a:p>
         </p:txBody>
@@ -14739,157 +14817,7 @@
         </p:nvSpPr>
         <p:spPr>
           <a:xfrm>
-            <a:off x="411480" y="3511296"/>
-            <a:ext cx="4572000" cy="265176"/>
-          </a:xfrm>
-          <a:prstGeom prst="rect">
-            <a:avLst/>
-          </a:prstGeom>
-          <a:solidFill>
-            <a:srgbClr val="F8FAFD"/>
-          </a:solidFill>
-          <a:ln w="6350">
-            <a:solidFill>
-              <a:srgbClr val="CCD8EE"/>
-            </a:solidFill>
-          </a:ln>
-        </p:spPr>
-        <p:style>
-          <a:lnRef idx="1">
-            <a:schemeClr val="accent1"/>
-          </a:lnRef>
-          <a:fillRef idx="3">
-            <a:schemeClr val="accent1"/>
-          </a:fillRef>
-          <a:effectRef idx="2">
-            <a:schemeClr val="accent1"/>
-          </a:effectRef>
-          <a:fontRef idx="minor">
-            <a:schemeClr val="lt1"/>
-          </a:fontRef>
-        </p:style>
-        <p:txBody>
-          <a:bodyPr rtlCol="0" anchor="ctr"/>
-          <a:lstStyle/>
-          <a:p>
-            <a:pPr algn="ctr"/>
-          </a:p>
-        </p:txBody>
-      </p:sp>
-      <p:sp>
-        <p:nvSpPr>
-          <p:cNvPr id="40" name="TextBox 39"/>
-          <p:cNvSpPr txBox="1"/>
-          <p:nvPr/>
-        </p:nvSpPr>
-        <p:spPr>
-          <a:xfrm>
-            <a:off x="484632" y="3557016"/>
-            <a:ext cx="2194560" cy="219456"/>
-          </a:xfrm>
-          <a:prstGeom prst="rect">
-            <a:avLst/>
-          </a:prstGeom>
-          <a:noFill/>
-        </p:spPr>
-        <p:txBody>
-          <a:bodyPr wrap="square">
-            <a:spAutoFit/>
-          </a:bodyPr>
-          <a:lstStyle/>
-          <a:p>
-            <a:pPr algn="l"/>
-            <a:r>
-              <a:rPr sz="850" b="1" i="0">
-                <a:solidFill>
-                  <a:srgbClr val="111827"/>
-                </a:solidFill>
-                <a:latin typeface="Calibri"/>
-              </a:rPr>
-              <a:t>Weeks on promotion</a:t>
-            </a:r>
-          </a:p>
-        </p:txBody>
-      </p:sp>
-      <p:sp>
-        <p:nvSpPr>
-          <p:cNvPr id="41" name="TextBox 40"/>
-          <p:cNvSpPr txBox="1"/>
-          <p:nvPr/>
-        </p:nvSpPr>
-        <p:spPr>
-          <a:xfrm>
-            <a:off x="2770632" y="3557016"/>
-            <a:ext cx="914400" cy="219456"/>
-          </a:xfrm>
-          <a:prstGeom prst="rect">
-            <a:avLst/>
-          </a:prstGeom>
-          <a:noFill/>
-        </p:spPr>
-        <p:txBody>
-          <a:bodyPr wrap="square">
-            <a:spAutoFit/>
-          </a:bodyPr>
-          <a:lstStyle/>
-          <a:p>
-            <a:pPr algn="l"/>
-            <a:r>
-              <a:rPr sz="800" b="1" i="0">
-                <a:solidFill>
-                  <a:srgbClr val="4078D0"/>
-                </a:solidFill>
-                <a:latin typeface="Calibri"/>
-              </a:rPr>
-              <a:t>SPINS</a:t>
-            </a:r>
-          </a:p>
-        </p:txBody>
-      </p:sp>
-      <p:sp>
-        <p:nvSpPr>
-          <p:cNvPr id="42" name="TextBox 41"/>
-          <p:cNvSpPr txBox="1"/>
-          <p:nvPr/>
-        </p:nvSpPr>
-        <p:spPr>
-          <a:xfrm>
-            <a:off x="3776472" y="3557016"/>
-            <a:ext cx="1115568" cy="219456"/>
-          </a:xfrm>
-          <a:prstGeom prst="rect">
-            <a:avLst/>
-          </a:prstGeom>
-          <a:noFill/>
-        </p:spPr>
-        <p:txBody>
-          <a:bodyPr wrap="square">
-            <a:spAutoFit/>
-          </a:bodyPr>
-          <a:lstStyle/>
-          <a:p>
-            <a:pPr algn="l"/>
-            <a:r>
-              <a:rPr sz="750" b="0" i="0">
-                <a:solidFill>
-                  <a:srgbClr val="6B7FA0"/>
-                </a:solidFill>
-                <a:latin typeface="Calibri"/>
-              </a:rPr>
-              <a:t>Flag promo periods</a:t>
-            </a:r>
-          </a:p>
-        </p:txBody>
-      </p:sp>
-      <p:sp>
-        <p:nvSpPr>
-          <p:cNvPr id="43" name="Rectangle 42"/>
-          <p:cNvSpPr/>
-          <p:nvPr/>
-        </p:nvSpPr>
-        <p:spPr>
-          <a:xfrm>
-            <a:off x="411480" y="3849624"/>
+            <a:off x="411480" y="3584448"/>
             <a:ext cx="4572000" cy="256032"/>
           </a:xfrm>
           <a:prstGeom prst="rect">
@@ -14926,13 +14854,13 @@
       </p:sp>
       <p:sp>
         <p:nvSpPr>
-          <p:cNvPr id="44" name="TextBox 43"/>
-          <p:cNvSpPr txBox="1"/>
-          <p:nvPr/>
-        </p:nvSpPr>
-        <p:spPr>
-          <a:xfrm>
-            <a:off x="502920" y="3886200"/>
+          <p:cNvPr id="40" name="TextBox 39"/>
+          <p:cNvSpPr txBox="1"/>
+          <p:nvPr/>
+        </p:nvSpPr>
+        <p:spPr>
+          <a:xfrm>
+            <a:off x="502920" y="3621024"/>
             <a:ext cx="4389120" cy="201168"/>
           </a:xfrm>
           <a:prstGeom prst="rect">
@@ -14961,13 +14889,13 @@
       </p:sp>
       <p:sp>
         <p:nvSpPr>
-          <p:cNvPr id="45" name="Rectangle 44"/>
+          <p:cNvPr id="41" name="Rectangle 40"/>
           <p:cNvSpPr/>
           <p:nvPr/>
         </p:nvSpPr>
         <p:spPr>
           <a:xfrm>
-            <a:off x="502920" y="4187952"/>
+            <a:off x="502920" y="3922776"/>
             <a:ext cx="73152" cy="73152"/>
           </a:xfrm>
           <a:prstGeom prst="rect">
@@ -15004,13 +14932,13 @@
       </p:sp>
       <p:sp>
         <p:nvSpPr>
-          <p:cNvPr id="46" name="TextBox 45"/>
-          <p:cNvSpPr txBox="1"/>
-          <p:nvPr/>
-        </p:nvSpPr>
-        <p:spPr>
-          <a:xfrm>
-            <a:off x="667512" y="4123944"/>
+          <p:cNvPr id="42" name="TextBox 41"/>
+          <p:cNvSpPr txBox="1"/>
+          <p:nvPr/>
+        </p:nvSpPr>
+        <p:spPr>
+          <a:xfrm>
+            <a:off x="667512" y="3858768"/>
             <a:ext cx="4224528" cy="237744"/>
           </a:xfrm>
           <a:prstGeom prst="rect">
@@ -15032,20 +14960,20 @@
                 </a:solidFill>
                 <a:latin typeface="Calibri"/>
               </a:rPr>
-              <a:t>Build before/after windows (4-week, 13-week, 26-week) around each product launch</a:t>
-            </a:r>
-          </a:p>
-        </p:txBody>
-      </p:sp>
-      <p:sp>
-        <p:nvSpPr>
-          <p:cNvPr id="47" name="Rectangle 46"/>
+              <a:t>Normalize to non-zero TDP weeks — eliminate false troughs from shelf-presence gaps</a:t>
+            </a:r>
+          </a:p>
+        </p:txBody>
+      </p:sp>
+      <p:sp>
+        <p:nvSpPr>
+          <p:cNvPr id="43" name="Rectangle 42"/>
           <p:cNvSpPr/>
           <p:nvPr/>
         </p:nvSpPr>
         <p:spPr>
           <a:xfrm>
-            <a:off x="502920" y="4434840"/>
+            <a:off x="502920" y="4169664"/>
             <a:ext cx="73152" cy="73152"/>
           </a:xfrm>
           <a:prstGeom prst="rect">
@@ -15082,13 +15010,13 @@
       </p:sp>
       <p:sp>
         <p:nvSpPr>
-          <p:cNvPr id="48" name="TextBox 47"/>
-          <p:cNvSpPr txBox="1"/>
-          <p:nvPr/>
-        </p:nvSpPr>
-        <p:spPr>
-          <a:xfrm>
-            <a:off x="667512" y="4370831"/>
+          <p:cNvPr id="44" name="TextBox 43"/>
+          <p:cNvSpPr txBox="1"/>
+          <p:nvPr/>
+        </p:nvSpPr>
+        <p:spPr>
+          <a:xfrm>
+            <a:off x="667512" y="4105656"/>
             <a:ext cx="4224528" cy="237744"/>
           </a:xfrm>
           <a:prstGeom prst="rect">
@@ -15110,20 +15038,20 @@
                 </a:solidFill>
                 <a:latin typeface="Calibri"/>
               </a:rPr>
-              <a:t>Pair each focal SKU with candidate donors — same flavor, same pack family, competitor</a:t>
-            </a:r>
-          </a:p>
-        </p:txBody>
-      </p:sp>
-      <p:sp>
-        <p:nvSpPr>
-          <p:cNvPr id="49" name="Rectangle 48"/>
+              <a:t>Compute rolling averages (4-week, 13-week) to smooth noise while preserving trend</a:t>
+            </a:r>
+          </a:p>
+        </p:txBody>
+      </p:sp>
+      <p:sp>
+        <p:nvSpPr>
+          <p:cNvPr id="45" name="Rectangle 44"/>
           <p:cNvSpPr/>
           <p:nvPr/>
         </p:nvSpPr>
         <p:spPr>
           <a:xfrm>
-            <a:off x="502920" y="4681727"/>
+            <a:off x="502920" y="4416552"/>
             <a:ext cx="73152" cy="73152"/>
           </a:xfrm>
           <a:prstGeom prst="rect">
@@ -15160,13 +15088,13 @@
       </p:sp>
       <p:sp>
         <p:nvSpPr>
-          <p:cNvPr id="50" name="TextBox 49"/>
-          <p:cNvSpPr txBox="1"/>
-          <p:nvPr/>
-        </p:nvSpPr>
-        <p:spPr>
-          <a:xfrm>
-            <a:off x="667512" y="4617719"/>
+          <p:cNvPr id="46" name="TextBox 45"/>
+          <p:cNvSpPr txBox="1"/>
+          <p:nvPr/>
+        </p:nvSpPr>
+        <p:spPr>
+          <a:xfrm>
+            <a:off x="667512" y="4352544"/>
             <a:ext cx="4224528" cy="237744"/>
           </a:xfrm>
           <a:prstGeom prst="rect">
@@ -15188,20 +15116,20 @@
                 </a:solidFill>
                 <a:latin typeface="Calibri"/>
               </a:rPr>
-              <a:t>Measure whether focal demand rose while donor demand fell in the same stores and window</a:t>
-            </a:r>
-          </a:p>
-        </p:txBody>
-      </p:sp>
-      <p:sp>
-        <p:nvSpPr>
-          <p:cNvPr id="51" name="Rectangle 50"/>
+              <a:t>Build 12-month seasonality index — regional granularity available when BUILT provides geographic breakdown</a:t>
+            </a:r>
+          </a:p>
+        </p:txBody>
+      </p:sp>
+      <p:sp>
+        <p:nvSpPr>
+          <p:cNvPr id="47" name="Rectangle 46"/>
           <p:cNvSpPr/>
           <p:nvPr/>
         </p:nvSpPr>
         <p:spPr>
           <a:xfrm>
-            <a:off x="502920" y="4928615"/>
+            <a:off x="502920" y="4663440"/>
             <a:ext cx="73152" cy="73152"/>
           </a:xfrm>
           <a:prstGeom prst="rect">
@@ -15238,13 +15166,13 @@
       </p:sp>
       <p:sp>
         <p:nvSpPr>
-          <p:cNvPr id="52" name="TextBox 51"/>
-          <p:cNvSpPr txBox="1"/>
-          <p:nvPr/>
-        </p:nvSpPr>
-        <p:spPr>
-          <a:xfrm>
-            <a:off x="667512" y="4864607"/>
+          <p:cNvPr id="48" name="TextBox 47"/>
+          <p:cNvSpPr txBox="1"/>
+          <p:nvPr/>
+        </p:nvSpPr>
+        <p:spPr>
+          <a:xfrm>
+            <a:off x="667512" y="4599431"/>
             <a:ext cx="4224528" cy="237744"/>
           </a:xfrm>
           <a:prstGeom prst="rect">
@@ -15266,20 +15194,20 @@
                 </a:solidFill>
                 <a:latin typeface="Calibri"/>
               </a:rPr>
-              <a:t>Flag windows contaminated by promotions, distribution ramps, or supply events</a:t>
-            </a:r>
-          </a:p>
-        </p:txBody>
-      </p:sp>
-      <p:sp>
-        <p:nvSpPr>
-          <p:cNvPr id="53" name="Rectangle 52"/>
+              <a:t>Flag promo weeks so model learns baseline vs. promo-lifted demand separately</a:t>
+            </a:r>
+          </a:p>
+        </p:txBody>
+      </p:sp>
+      <p:sp>
+        <p:nvSpPr>
+          <p:cNvPr id="49" name="Rectangle 48"/>
           <p:cNvSpPr/>
           <p:nvPr/>
         </p:nvSpPr>
         <p:spPr>
           <a:xfrm>
-            <a:off x="502920" y="5175503"/>
+            <a:off x="502920" y="4910327"/>
             <a:ext cx="73152" cy="73152"/>
           </a:xfrm>
           <a:prstGeom prst="rect">
@@ -15316,13 +15244,13 @@
       </p:sp>
       <p:sp>
         <p:nvSpPr>
-          <p:cNvPr id="54" name="TextBox 53"/>
-          <p:cNvSpPr txBox="1"/>
-          <p:nvPr/>
-        </p:nvSpPr>
-        <p:spPr>
-          <a:xfrm>
-            <a:off x="667512" y="5111495"/>
+          <p:cNvPr id="50" name="TextBox 49"/>
+          <p:cNvSpPr txBox="1"/>
+          <p:nvPr/>
+        </p:nvSpPr>
+        <p:spPr>
+          <a:xfrm>
+            <a:off x="667512" y="4846319"/>
             <a:ext cx="4224528" cy="237744"/>
           </a:xfrm>
           <a:prstGeom prst="rect">
@@ -15344,20 +15272,20 @@
                 </a:solidFill>
                 <a:latin typeface="Calibri"/>
               </a:rPr>
-              <a:t>Calculate incremental share: net-new demand vs. demand transferred from a donor SKU</a:t>
-            </a:r>
-          </a:p>
-        </p:txBody>
-      </p:sp>
-      <p:sp>
-        <p:nvSpPr>
-          <p:cNvPr id="55" name="Rectangle 54"/>
+              <a:t>Train separate forecast per SKU × retailer — Kroger velocity ≠ Target velocity</a:t>
+            </a:r>
+          </a:p>
+        </p:txBody>
+      </p:sp>
+      <p:sp>
+        <p:nvSpPr>
+          <p:cNvPr id="51" name="Rectangle 50"/>
           <p:cNvSpPr/>
           <p:nvPr/>
         </p:nvSpPr>
         <p:spPr>
           <a:xfrm>
-            <a:off x="502920" y="5422391"/>
+            <a:off x="502920" y="5157215"/>
             <a:ext cx="73152" cy="73152"/>
           </a:xfrm>
           <a:prstGeom prst="rect">
@@ -15394,13 +15322,13 @@
       </p:sp>
       <p:sp>
         <p:nvSpPr>
-          <p:cNvPr id="56" name="TextBox 55"/>
-          <p:cNvSpPr txBox="1"/>
-          <p:nvPr/>
-        </p:nvSpPr>
-        <p:spPr>
-          <a:xfrm>
-            <a:off x="667512" y="5358383"/>
+          <p:cNvPr id="52" name="TextBox 51"/>
+          <p:cNvSpPr txBox="1"/>
+          <p:nvPr/>
+        </p:nvSpPr>
+        <p:spPr>
+          <a:xfrm>
+            <a:off x="667512" y="5093207"/>
             <a:ext cx="4224528" cy="237744"/>
           </a:xfrm>
           <a:prstGeom prst="rect">
@@ -15422,14 +15350,14 @@
                 </a:solidFill>
                 <a:latin typeface="Calibri"/>
               </a:rPr>
-              <a:t>Assign label (Cannibalizing / Watch / Incremental / Neutral) from observable evidence</a:t>
-            </a:r>
-          </a:p>
-        </p:txBody>
-      </p:sp>
-      <p:sp>
-        <p:nvSpPr>
-          <p:cNvPr id="57" name="Rectangle 56"/>
+              <a:t>Fall back to exponential smoothing (ETS) for SKUs with &lt;8 weeks of history</a:t>
+            </a:r>
+          </a:p>
+        </p:txBody>
+      </p:sp>
+      <p:sp>
+        <p:nvSpPr>
+          <p:cNvPr id="53" name="Rectangle 52"/>
           <p:cNvSpPr/>
           <p:nvPr/>
         </p:nvSpPr>
@@ -15472,7 +15400,7 @@
       </p:sp>
       <p:sp>
         <p:nvSpPr>
-          <p:cNvPr id="58" name="TextBox 57"/>
+          <p:cNvPr id="54" name="TextBox 53"/>
           <p:cNvSpPr txBox="1"/>
           <p:nvPr/>
         </p:nvSpPr>
@@ -15507,14 +15435,14 @@
       </p:sp>
       <p:sp>
         <p:nvSpPr>
-          <p:cNvPr id="59" name="Rectangle 58"/>
+          <p:cNvPr id="55" name="Rectangle 54"/>
           <p:cNvSpPr/>
           <p:nvPr/>
         </p:nvSpPr>
         <p:spPr>
           <a:xfrm>
             <a:off x="5349240" y="1691640"/>
-            <a:ext cx="6492240" cy="1691640"/>
+            <a:ext cx="6492240" cy="1371600"/>
           </a:xfrm>
           <a:prstGeom prst="rect">
             <a:avLst/>
@@ -15552,7 +15480,7 @@
       </p:sp>
       <p:sp>
         <p:nvSpPr>
-          <p:cNvPr id="60" name="TextBox 59"/>
+          <p:cNvPr id="56" name="TextBox 55"/>
           <p:cNvSpPr txBox="1"/>
           <p:nvPr/>
         </p:nvSpPr>
@@ -15580,14 +15508,14 @@
                 </a:solidFill>
                 <a:latin typeface="Calibri"/>
               </a:rPr>
-              <a:t>›  Risk score + confidence for each focal/donor pair</a:t>
-            </a:r>
-          </a:p>
-        </p:txBody>
-      </p:sp>
-      <p:sp>
-        <p:nvSpPr>
-          <p:cNvPr id="61" name="TextBox 60"/>
+              <a:t>›  13-week demand forecast per SKU × retailer account</a:t>
+            </a:r>
+          </a:p>
+        </p:txBody>
+      </p:sp>
+      <p:sp>
+        <p:nvSpPr>
+          <p:cNvPr id="57" name="TextBox 56"/>
           <p:cNvSpPr txBox="1"/>
           <p:nvPr/>
         </p:nvSpPr>
@@ -15615,14 +15543,14 @@
                 </a:solidFill>
                 <a:latin typeface="Calibri"/>
               </a:rPr>
-              <a:t>›  Status: Cannibalizing · Watch · Incremental · Neutral</a:t>
-            </a:r>
-          </a:p>
-        </p:txBody>
-      </p:sp>
-      <p:sp>
-        <p:nvSpPr>
-          <p:cNvPr id="62" name="TextBox 61"/>
+              <a:t>›  Confidence bands (low / base / high scenario)</a:t>
+            </a:r>
+          </a:p>
+        </p:txBody>
+      </p:sp>
+      <p:sp>
+        <p:nvSpPr>
+          <p:cNvPr id="58" name="TextBox 57"/>
           <p:cNvSpPr txBox="1"/>
           <p:nvPr/>
         </p:nvSpPr>
@@ -15650,14 +15578,14 @@
                 </a:solidFill>
                 <a:latin typeface="Calibri"/>
               </a:rPr>
-              <a:t>›  Ranked donors with evidence summary (focal lift, donor decline, distribution delta)</a:t>
-            </a:r>
-          </a:p>
-        </p:txBody>
-      </p:sp>
-      <p:sp>
-        <p:nvSpPr>
-          <p:cNvPr id="63" name="TextBox 62"/>
+              <a:t>›  Promo-uplift scenario — demand if a promotion is planned in the forecast window</a:t>
+            </a:r>
+          </a:p>
+        </p:txBody>
+      </p:sp>
+      <p:sp>
+        <p:nvSpPr>
+          <p:cNvPr id="59" name="TextBox 58"/>
           <p:cNvSpPr txBox="1"/>
           <p:nvPr/>
         </p:nvSpPr>
@@ -15685,55 +15613,20 @@
                 </a:solidFill>
                 <a:latin typeface="Calibri"/>
               </a:rPr>
-              <a:t>›  Incremental share — net-new demand vs. transferred demand  [FML-10]</a:t>
-            </a:r>
-          </a:p>
-        </p:txBody>
-      </p:sp>
-      <p:sp>
-        <p:nvSpPr>
-          <p:cNvPr id="64" name="TextBox 63"/>
-          <p:cNvSpPr txBox="1"/>
-          <p:nvPr/>
-        </p:nvSpPr>
-        <p:spPr>
-          <a:xfrm>
-            <a:off x="5623559" y="3035808"/>
-            <a:ext cx="6126479" cy="256032"/>
-          </a:xfrm>
-          <a:prstGeom prst="rect">
-            <a:avLst/>
-          </a:prstGeom>
-          <a:noFill/>
-        </p:spPr>
-        <p:txBody>
-          <a:bodyPr wrap="square">
-            <a:spAutoFit/>
-          </a:bodyPr>
-          <a:lstStyle/>
-          <a:p>
-            <a:pPr algn="l"/>
-            <a:r>
-              <a:rPr sz="950" b="0" i="0">
-                <a:solidFill>
-                  <a:srgbClr val="0E5E38"/>
-                </a:solidFill>
-                <a:latin typeface="Calibri"/>
-              </a:rPr>
-              <a:t>›  Cannibalization rate actuals + 13-week forward projection  [FML-09]</a:t>
-            </a:r>
-          </a:p>
-        </p:txBody>
-      </p:sp>
-      <p:sp>
-        <p:nvSpPr>
-          <p:cNvPr id="65" name="Rectangle 64"/>
+              <a:t>›  Forecast accuracy benchmark: 4% wMAPE vs. 7–10% industry baseline</a:t>
+            </a:r>
+          </a:p>
+        </p:txBody>
+      </p:sp>
+      <p:sp>
+        <p:nvSpPr>
+          <p:cNvPr id="60" name="Rectangle 59"/>
           <p:cNvSpPr/>
           <p:nvPr/>
         </p:nvSpPr>
         <p:spPr>
           <a:xfrm>
-            <a:off x="5349240" y="3493008"/>
+            <a:off x="5349240" y="3172968"/>
             <a:ext cx="6492240" cy="274320"/>
           </a:xfrm>
           <a:prstGeom prst="rect">
@@ -15770,13 +15663,13 @@
       </p:sp>
       <p:sp>
         <p:nvSpPr>
-          <p:cNvPr id="66" name="TextBox 65"/>
-          <p:cNvSpPr txBox="1"/>
-          <p:nvPr/>
-        </p:nvSpPr>
-        <p:spPr>
-          <a:xfrm>
-            <a:off x="5458968" y="3538728"/>
+          <p:cNvPr id="61" name="TextBox 60"/>
+          <p:cNvSpPr txBox="1"/>
+          <p:nvPr/>
+        </p:nvSpPr>
+        <p:spPr>
+          <a:xfrm>
+            <a:off x="5458968" y="3218688"/>
             <a:ext cx="6492240" cy="201168"/>
           </a:xfrm>
           <a:prstGeom prst="rect">
@@ -15805,13 +15698,13 @@
       </p:sp>
       <p:sp>
         <p:nvSpPr>
-          <p:cNvPr id="67" name="Rectangle 66"/>
+          <p:cNvPr id="62" name="Rectangle 61"/>
           <p:cNvSpPr/>
           <p:nvPr/>
         </p:nvSpPr>
         <p:spPr>
           <a:xfrm>
-            <a:off x="5349240" y="3767328"/>
+            <a:off x="5349240" y="3447288"/>
             <a:ext cx="6492240" cy="1371600"/>
           </a:xfrm>
           <a:prstGeom prst="rect">
@@ -15850,7 +15743,42 @@
       </p:sp>
       <p:sp>
         <p:nvSpPr>
-          <p:cNvPr id="68" name="TextBox 67"/>
+          <p:cNvPr id="63" name="TextBox 62"/>
+          <p:cNvSpPr txBox="1"/>
+          <p:nvPr/>
+        </p:nvSpPr>
+        <p:spPr>
+          <a:xfrm>
+            <a:off x="5623559" y="3511296"/>
+            <a:ext cx="6126479" cy="256032"/>
+          </a:xfrm>
+          <a:prstGeom prst="rect">
+            <a:avLst/>
+          </a:prstGeom>
+          <a:noFill/>
+        </p:spPr>
+        <p:txBody>
+          <a:bodyPr wrap="square">
+            <a:spAutoFit/>
+          </a:bodyPr>
+          <a:lstStyle/>
+          <a:p>
+            <a:pPr algn="l"/>
+            <a:r>
+              <a:rPr sz="950" b="0" i="0">
+                <a:solidFill>
+                  <a:srgbClr val="8A4800"/>
+                </a:solidFill>
+                <a:latin typeface="Calibri"/>
+              </a:rPr>
+              <a:t>›  52-week actual demand trend by SKU and retailer account</a:t>
+            </a:r>
+          </a:p>
+        </p:txBody>
+      </p:sp>
+      <p:sp>
+        <p:nvSpPr>
+          <p:cNvPr id="64" name="TextBox 63"/>
           <p:cNvSpPr txBox="1"/>
           <p:nvPr/>
         </p:nvSpPr>
@@ -15878,14 +15806,14 @@
                 </a:solidFill>
                 <a:latin typeface="Calibri"/>
               </a:rPr>
-              <a:t>›  Actual weekly demand trend for focal and donor SKUs</a:t>
-            </a:r>
-          </a:p>
-        </p:txBody>
-      </p:sp>
-      <p:sp>
-        <p:nvSpPr>
-          <p:cNvPr id="69" name="TextBox 68"/>
+              <a:t>›  Distribution (stores stocking) trend over the same period</a:t>
+            </a:r>
+          </a:p>
+        </p:txBody>
+      </p:sp>
+      <p:sp>
+        <p:nvSpPr>
+          <p:cNvPr id="65" name="TextBox 64"/>
           <p:cNvSpPr txBox="1"/>
           <p:nvPr/>
         </p:nvSpPr>
@@ -15913,14 +15841,14 @@
                 </a:solidFill>
                 <a:latin typeface="Calibri"/>
               </a:rPr>
-              <a:t>›  Distribution (TDP) trend — stores stocking each SKU over time</a:t>
-            </a:r>
-          </a:p>
-        </p:txBody>
-      </p:sp>
-      <p:sp>
-        <p:nvSpPr>
-          <p:cNvPr id="70" name="TextBox 69"/>
+              <a:t>›  Category average velocity — how this SKU compares to 13-week category norm</a:t>
+            </a:r>
+          </a:p>
+        </p:txBody>
+      </p:sp>
+      <p:sp>
+        <p:nvSpPr>
+          <p:cNvPr id="66" name="TextBox 65"/>
           <p:cNvSpPr txBox="1"/>
           <p:nvPr/>
         </p:nvSpPr>
@@ -15948,49 +15876,14 @@
                 </a:solidFill>
                 <a:latin typeface="Calibri"/>
               </a:rPr>
-              <a:t>›  Geography heatmap — which markets show the strongest demand transfer</a:t>
-            </a:r>
-          </a:p>
-        </p:txBody>
-      </p:sp>
-      <p:sp>
-        <p:nvSpPr>
-          <p:cNvPr id="71" name="TextBox 70"/>
-          <p:cNvSpPr txBox="1"/>
-          <p:nvPr/>
-        </p:nvSpPr>
-        <p:spPr>
-          <a:xfrm>
-            <a:off x="5623559" y="4791456"/>
-            <a:ext cx="6126479" cy="256032"/>
-          </a:xfrm>
-          <a:prstGeom prst="rect">
-            <a:avLst/>
-          </a:prstGeom>
-          <a:noFill/>
-        </p:spPr>
-        <p:txBody>
-          <a:bodyPr wrap="square">
-            <a:spAutoFit/>
-          </a:bodyPr>
-          <a:lstStyle/>
-          <a:p>
-            <a:pPr algn="l"/>
-            <a:r>
-              <a:rPr sz="950" b="0" i="0">
-                <a:solidFill>
-                  <a:srgbClr val="8A4800"/>
-                </a:solidFill>
-                <a:latin typeface="Calibri"/>
-              </a:rPr>
-              <a:t>›  Launch ramp chart — weeks 1–16 of distribution build vs. category norms</a:t>
-            </a:r>
-          </a:p>
-        </p:txBody>
-      </p:sp>
-      <p:sp>
-        <p:nvSpPr>
-          <p:cNvPr id="72" name="Rectangle 71"/>
+              <a:t>›  Seasonal index overlay — expected lift or drag on the forecast period</a:t>
+            </a:r>
+          </a:p>
+        </p:txBody>
+      </p:sp>
+      <p:sp>
+        <p:nvSpPr>
+          <p:cNvPr id="67" name="Rectangle 66"/>
           <p:cNvSpPr/>
           <p:nvPr/>
         </p:nvSpPr>
@@ -16033,7 +15926,7 @@
       </p:sp>
       <p:sp>
         <p:nvSpPr>
-          <p:cNvPr id="73" name="TextBox 72"/>
+          <p:cNvPr id="68" name="TextBox 67"/>
           <p:cNvSpPr txBox="1"/>
           <p:nvPr/>
         </p:nvSpPr>
@@ -16068,7 +15961,7 @@
       </p:sp>
       <p:sp>
         <p:nvSpPr>
-          <p:cNvPr id="74" name="Rectangle 73"/>
+          <p:cNvPr id="69" name="Rectangle 68"/>
           <p:cNvSpPr/>
           <p:nvPr/>
         </p:nvSpPr>
@@ -16113,7 +16006,7 @@
       </p:sp>
       <p:sp>
         <p:nvSpPr>
-          <p:cNvPr id="75" name="TextBox 74"/>
+          <p:cNvPr id="70" name="TextBox 69"/>
           <p:cNvSpPr txBox="1"/>
           <p:nvPr/>
         </p:nvSpPr>
@@ -16141,14 +16034,14 @@
                 </a:solidFill>
                 <a:latin typeface="Calibri"/>
               </a:rPr>
-              <a:t>Comparison pool build · Pairing model · Risk scoring · Publish to Mo UI · Monitor model drift</a:t>
-            </a:r>
-          </a:p>
-        </p:txBody>
-      </p:sp>
-      <p:sp>
-        <p:nvSpPr>
-          <p:cNvPr id="76" name="Rectangle 75"/>
+              <a:t>Seasonality index · Forecast model training · ETS fallback · Confidence bands · Publish 13-week projections to Mo UI</a:t>
+            </a:r>
+          </a:p>
+        </p:txBody>
+      </p:sp>
+      <p:sp>
+        <p:nvSpPr>
+          <p:cNvPr id="71" name="Rectangle 70"/>
           <p:cNvSpPr/>
           <p:nvPr/>
         </p:nvSpPr>
@@ -16191,7 +16084,7 @@
       </p:sp>
       <p:sp>
         <p:nvSpPr>
-          <p:cNvPr id="77" name="TextBox 76"/>
+          <p:cNvPr id="72" name="TextBox 71"/>
           <p:cNvSpPr txBox="1"/>
           <p:nvPr/>
         </p:nvSpPr>
@@ -16226,7 +16119,7 @@
       </p:sp>
       <p:sp>
         <p:nvSpPr>
-          <p:cNvPr id="78" name="Rectangle 77"/>
+          <p:cNvPr id="73" name="Rectangle 72"/>
           <p:cNvSpPr/>
           <p:nvPr/>
         </p:nvSpPr>
@@ -16271,7 +16164,7 @@
       </p:sp>
       <p:sp>
         <p:nvSpPr>
-          <p:cNvPr id="79" name="TextBox 78"/>
+          <p:cNvPr id="74" name="TextBox 73"/>
           <p:cNvSpPr txBox="1"/>
           <p:nvPr/>
         </p:nvSpPr>
@@ -16299,14 +16192,14 @@
                 </a:solidFill>
                 <a:latin typeface="Calibri"/>
               </a:rPr>
-              <a:t>SPINS export deposit · Review risk labels — do the identified donor pairs make business sense? · Validate threshold cutoffs with Brian</a:t>
-            </a:r>
-          </a:p>
-        </p:txBody>
-      </p:sp>
-      <p:sp>
-        <p:nvSpPr>
-          <p:cNvPr id="80" name="TextBox 79"/>
+              <a:t>SPINS export deposit · Share actuals data for forecast backtesting · Provide product data + regional seasonality indexes as supplemental inputs · Connor validates 13-week forecasts against FP&amp;A actuals</a:t>
+            </a:r>
+          </a:p>
+        </p:txBody>
+      </p:sp>
+      <p:sp>
+        <p:nvSpPr>
+          <p:cNvPr id="75" name="TextBox 74"/>
           <p:cNvSpPr txBox="1"/>
           <p:nvPr/>
         </p:nvSpPr>
@@ -16516,7 +16409,7 @@
                 </a:solidFill>
                 <a:latin typeface="Calibri"/>
               </a:rPr>
-              <a:t>MODULE 02</a:t>
+              <a:t>MODULE 01</a:t>
             </a:r>
           </a:p>
         </p:txBody>
@@ -16586,7 +16479,7 @@
                 </a:solidFill>
                 <a:latin typeface="Calibri"/>
               </a:rPr>
-              <a:t>Price Elasticity</a:t>
+              <a:t>Cannibalization Risk</a:t>
             </a:r>
           </a:p>
         </p:txBody>
@@ -16621,7 +16514,7 @@
                 </a:solidFill>
                 <a:latin typeface="Calibri"/>
               </a:rPr>
-              <a:t>"If we change price by X%, how much does demand change — and what is the optimal price point?"</a:t>
+              <a:t>"Is this new SKU pulling demand from an existing one, or adding net-new buyers?"</a:t>
             </a:r>
           </a:p>
         </p:txBody>
@@ -16927,7 +16820,7 @@
                 </a:solidFill>
                 <a:latin typeface="Calibri"/>
               </a:rPr>
-              <a:t>Average retail price</a:t>
+              <a:t>Weekly units sold</a:t>
             </a:r>
           </a:p>
         </p:txBody>
@@ -16997,7 +16890,7 @@
                 </a:solidFill>
                 <a:latin typeface="Calibri"/>
               </a:rPr>
-              <a:t>Price level measure</a:t>
+              <a:t>Before/after demand</a:t>
             </a:r>
           </a:p>
         </p:txBody>
@@ -17077,7 +16970,7 @@
                 </a:solidFill>
                 <a:latin typeface="Calibri"/>
               </a:rPr>
-              <a:t>Weekly units sold</a:t>
+              <a:t>Base units (non-promo)</a:t>
             </a:r>
           </a:p>
         </p:txBody>
@@ -17147,7 +17040,7 @@
                 </a:solidFill>
                 <a:latin typeface="Calibri"/>
               </a:rPr>
-              <a:t>Demand response</a:t>
+              <a:t>Isolate organic demand</a:t>
             </a:r>
           </a:p>
         </p:txBody>
@@ -17227,7 +17120,7 @@
                 </a:solidFill>
                 <a:latin typeface="Calibri"/>
               </a:rPr>
-              <a:t>Base price (non-promo ARP)</a:t>
+              <a:t>Distribution — stores selling</a:t>
             </a:r>
           </a:p>
         </p:txBody>
@@ -17297,7 +17190,7 @@
                 </a:solidFill>
                 <a:latin typeface="Calibri"/>
               </a:rPr>
-              <a:t>Everyday vs. promo</a:t>
+              <a:t>Demand vs. distrib. loss</a:t>
             </a:r>
           </a:p>
         </p:txBody>
@@ -17377,7 +17270,7 @@
                 </a:solidFill>
                 <a:latin typeface="Calibri"/>
               </a:rPr>
-              <a:t>Promo discount depth (%)</a:t>
+              <a:t>Average retail price</a:t>
             </a:r>
           </a:p>
         </p:txBody>
@@ -17447,7 +17340,7 @@
                 </a:solidFill>
                 <a:latin typeface="Calibri"/>
               </a:rPr>
-              <a:t>Quantify promo depth</a:t>
+              <a:t>Rule out price effect</a:t>
             </a:r>
           </a:p>
         </p:txBody>
@@ -17527,7 +17420,7 @@
                 </a:solidFill>
                 <a:latin typeface="Calibri"/>
               </a:rPr>
-              <a:t>Incremental units (promo-driven)</a:t>
+              <a:t>First week selling (launch date)</a:t>
             </a:r>
           </a:p>
         </p:txBody>
@@ -17597,7 +17490,7 @@
                 </a:solidFill>
                 <a:latin typeface="Calibri"/>
               </a:rPr>
-              <a:t>Isolate promo demand</a:t>
+              <a:t>Launch anchor date</a:t>
             </a:r>
           </a:p>
         </p:txBody>
@@ -17677,7 +17570,7 @@
                 </a:solidFill>
                 <a:latin typeface="Calibri"/>
               </a:rPr>
-              <a:t>Distribution (TDP)</a:t>
+              <a:t>Pack count, flavor, brand line</a:t>
             </a:r>
           </a:p>
         </p:txBody>
@@ -17747,7 +17640,7 @@
                 </a:solidFill>
                 <a:latin typeface="Calibri"/>
               </a:rPr>
-              <a:t>Distribution control</a:t>
+              <a:t>Find substitute SKUs</a:t>
             </a:r>
           </a:p>
         </p:txBody>
@@ -17827,7 +17720,7 @@
                 </a:solidFill>
                 <a:latin typeface="Calibri"/>
               </a:rPr>
-              <a:t>Competitor price (same flavor)</a:t>
+              <a:t>Weeks on promotion</a:t>
             </a:r>
           </a:p>
         </p:txBody>
@@ -17897,7 +17790,7 @@
                 </a:solidFill>
                 <a:latin typeface="Calibri"/>
               </a:rPr>
-              <a:t>Own vs. competitor</a:t>
+              <a:t>Flag promo periods</a:t>
             </a:r>
           </a:p>
         </p:txBody>
@@ -18053,7 +17946,7 @@
                 </a:solidFill>
                 <a:latin typeface="Calibri"/>
               </a:rPr>
-              <a:t>Normalize price to $/bar so singles and 12-packs are comparable</a:t>
+              <a:t>Build before/after windows (4-week, 13-week, 26-week) around each product launch</a:t>
             </a:r>
           </a:p>
         </p:txBody>
@@ -18131,7 +18024,7 @@
                 </a:solidFill>
                 <a:latin typeface="Calibri"/>
               </a:rPr>
-              <a:t>Build 13-week log-log regression windows per SKU × account</a:t>
+              <a:t>Pair each focal SKU with candidate donors — same flavor, same pack family, competitor</a:t>
             </a:r>
           </a:p>
         </p:txBody>
@@ -18209,7 +18102,7 @@
                 </a:solidFill>
                 <a:latin typeface="Calibri"/>
               </a:rPr>
-              <a:t>Separate promotional price changes from everyday price changes</a:t>
+              <a:t>Measure whether focal demand rose while donor demand fell in the same stores and window</a:t>
             </a:r>
           </a:p>
         </p:txBody>
@@ -18287,7 +18180,7 @@
                 </a:solidFill>
                 <a:latin typeface="Calibri"/>
               </a:rPr>
-              <a:t>Compare BUILT $/bar vs. same-flavor competitor in the same account and week</a:t>
+              <a:t>Flag windows contaminated by promotions, distribution ramps, or supply events</a:t>
             </a:r>
           </a:p>
         </p:txBody>
@@ -18365,7 +18258,7 @@
                 </a:solidFill>
                 <a:latin typeface="Calibri"/>
               </a:rPr>
-              <a:t>Compare $/bar across BUILT own pack sizes of the same flavor (pack-ladder check)</a:t>
+              <a:t>Calculate incremental share: net-new demand vs. demand transferred from a donor SKU</a:t>
             </a:r>
           </a:p>
         </p:txBody>
@@ -18443,7 +18336,7 @@
                 </a:solidFill>
                 <a:latin typeface="Calibri"/>
               </a:rPr>
-              <a:t>Reject windows where price moved &gt;40% in one week — data artifact guardrail</a:t>
+              <a:t>Assign label (Cannibalizing / Watch / Incremental / Neutral) from observable evidence</a:t>
             </a:r>
           </a:p>
         </p:txBody>
@@ -18601,7 +18494,7 @@
                 </a:solidFill>
                 <a:latin typeface="Calibri"/>
               </a:rPr>
-              <a:t>›  Own-price elasticity ε with confidence range (q10 / q50 / q90)</a:t>
+              <a:t>›  Risk score + confidence for each focal/donor pair</a:t>
             </a:r>
           </a:p>
         </p:txBody>
@@ -18636,7 +18529,7 @@
                 </a:solidFill>
                 <a:latin typeface="Calibri"/>
               </a:rPr>
-              <a:t>›  Cross-price elasticity — demand response to competitor price changes</a:t>
+              <a:t>›  Status: Cannibalizing · Watch · Incremental · Neutral</a:t>
             </a:r>
           </a:p>
         </p:txBody>
@@ -18671,7 +18564,7 @@
                 </a:solidFill>
                 <a:latin typeface="Calibri"/>
               </a:rPr>
-              <a:t>›  Promo elasticity curve — lift at each discount depth</a:t>
+              <a:t>›  Ranked donors with evidence summary (focal lift, donor decline, distribution delta)</a:t>
             </a:r>
           </a:p>
         </p:txBody>
@@ -18706,7 +18599,7 @@
                 </a:solidFill>
                 <a:latin typeface="Calibri"/>
               </a:rPr>
-              <a:t>›  What-if demand curves — projected units at alternative price points</a:t>
+              <a:t>›  Incremental share — net-new demand vs. transferred demand  [FML-10]</a:t>
             </a:r>
           </a:p>
         </p:txBody>
@@ -18741,7 +18634,7 @@
                 </a:solidFill>
                 <a:latin typeface="Calibri"/>
               </a:rPr>
-              <a:t>›  Pricing event queue — active competitive gaps or pack-ladder compression</a:t>
+              <a:t>›  Cannibalization rate actuals + 13-week forward projection  [FML-09]</a:t>
             </a:r>
           </a:p>
         </p:txBody>
@@ -18899,7 +18792,7 @@
                 </a:solidFill>
                 <a:latin typeface="Calibri"/>
               </a:rPr>
-              <a:t>›  Current $/bar and 52-week price trend by retailer account</a:t>
+              <a:t>›  Actual weekly demand trend for focal and donor SKUs</a:t>
             </a:r>
           </a:p>
         </p:txBody>
@@ -18934,7 +18827,7 @@
                 </a:solidFill>
                 <a:latin typeface="Calibri"/>
               </a:rPr>
-              <a:t>›  Pack price ladder — single / 4-pack / 12-pack side-by-side in the same account</a:t>
+              <a:t>›  Distribution (TDP) trend — stores stocking each SKU over time</a:t>
             </a:r>
           </a:p>
         </p:txBody>
@@ -18969,7 +18862,7 @@
                 </a:solidFill>
                 <a:latin typeface="Calibri"/>
               </a:rPr>
-              <a:t>›  Competitive price gap chart — BUILT vs. Tier 1 competitor in the same flavor</a:t>
+              <a:t>›  Geography heatmap — which markets show the strongest demand transfer</a:t>
             </a:r>
           </a:p>
         </p:txBody>
@@ -19004,7 +18897,7 @@
                 </a:solidFill>
                 <a:latin typeface="Calibri"/>
               </a:rPr>
-              <a:t>›  Category benchmark — BUILT $/bar vs. MULO FOOD category average</a:t>
+              <a:t>›  Launch ramp chart — weeks 1–16 of distribution build vs. category norms</a:t>
             </a:r>
           </a:p>
         </p:txBody>
@@ -19162,7 +19055,7 @@
                 </a:solidFill>
                 <a:latin typeface="Calibri"/>
               </a:rPr>
-              <a:t>$/bar normalization · Elasticity regression models · Score publishing · Pack-ladder + competitor comparisons · Publish to Mo UI</a:t>
+              <a:t>Comparison pool build · Pairing model · Risk scoring · Publish to Mo UI · Monitor model drift</a:t>
             </a:r>
           </a:p>
         </p:txBody>
@@ -19320,7 +19213,7 @@
                 </a:solidFill>
                 <a:latin typeface="Calibri"/>
               </a:rPr>
-              <a:t>SPINS export deposit · Validate elasticity values — do they match BUILT's commercial experience? · Confirm price-point recommendations with Brian</a:t>
+              <a:t>SPINS export deposit · Review risk labels — do the identified donor pairs make business sense? · Validate threshold cutoffs with Brian</a:t>
             </a:r>
           </a:p>
         </p:txBody>
@@ -19509,50 +19402,7 @@
       </p:sp>
       <p:sp>
         <p:nvSpPr>
-          <p:cNvPr id="5" name="Rectangle 4"/>
-          <p:cNvSpPr/>
-          <p:nvPr/>
-        </p:nvSpPr>
-        <p:spPr>
-          <a:xfrm>
-            <a:off x="0" y="0"/>
-            <a:ext cx="12191695" cy="1280160"/>
-          </a:xfrm>
-          <a:prstGeom prst="rect">
-            <a:avLst/>
-          </a:prstGeom>
-          <a:solidFill>
-            <a:srgbClr val="4A566A"/>
-          </a:solidFill>
-          <a:ln>
-            <a:noFill/>
-          </a:ln>
-        </p:spPr>
-        <p:style>
-          <a:lnRef idx="1">
-            <a:schemeClr val="accent1"/>
-          </a:lnRef>
-          <a:fillRef idx="3">
-            <a:schemeClr val="accent1"/>
-          </a:fillRef>
-          <a:effectRef idx="2">
-            <a:schemeClr val="accent1"/>
-          </a:effectRef>
-          <a:fontRef idx="minor">
-            <a:schemeClr val="lt1"/>
-          </a:fontRef>
-        </p:style>
-        <p:txBody>
-          <a:bodyPr rtlCol="0" anchor="ctr"/>
-          <a:lstStyle/>
-          <a:p>
-            <a:pPr algn="ctr"/>
-          </a:p>
-        </p:txBody>
-      </p:sp>
-      <p:sp>
-        <p:nvSpPr>
-          <p:cNvPr id="6" name="TextBox 5"/>
+          <p:cNvPr id="5" name="TextBox 4"/>
           <p:cNvSpPr txBox="1"/>
           <p:nvPr/>
         </p:nvSpPr>
@@ -19580,14 +19430,14 @@
                 </a:solidFill>
                 <a:latin typeface="Calibri"/>
               </a:rPr>
-              <a:t>MODULE 03</a:t>
-            </a:r>
-          </a:p>
-        </p:txBody>
-      </p:sp>
-      <p:sp>
-        <p:nvSpPr>
-          <p:cNvPr id="7" name="TextBox 6"/>
+              <a:t>MODULE 02</a:t>
+            </a:r>
+          </a:p>
+        </p:txBody>
+      </p:sp>
+      <p:sp>
+        <p:nvSpPr>
+          <p:cNvPr id="6" name="TextBox 5"/>
           <p:cNvSpPr txBox="1"/>
           <p:nvPr/>
         </p:nvSpPr>
@@ -19611,18 +19461,18 @@
             <a:r>
               <a:rPr sz="900" b="1" i="0">
                 <a:solidFill>
-                  <a:srgbClr val="D4DAE6"/>
-                </a:solidFill>
-                <a:latin typeface="Calibri"/>
-              </a:rPr>
-              <a:t>PHASE 2 — PLANNED 2027</a:t>
-            </a:r>
-          </a:p>
-        </p:txBody>
-      </p:sp>
-      <p:sp>
-        <p:nvSpPr>
-          <p:cNvPr id="8" name="TextBox 7"/>
+                  <a:srgbClr val="4078D0"/>
+                </a:solidFill>
+                <a:latin typeface="Calibri"/>
+              </a:rPr>
+              <a:t>PHASE 1 — NOW THROUGH DEC 2026</a:t>
+            </a:r>
+          </a:p>
+        </p:txBody>
+      </p:sp>
+      <p:sp>
+        <p:nvSpPr>
+          <p:cNvPr id="7" name="TextBox 6"/>
           <p:cNvSpPr txBox="1"/>
           <p:nvPr/>
         </p:nvSpPr>
@@ -19650,14 +19500,14 @@
                 </a:solidFill>
                 <a:latin typeface="Calibri"/>
               </a:rPr>
-              <a:t>Promotional Response</a:t>
-            </a:r>
-          </a:p>
-        </p:txBody>
-      </p:sp>
-      <p:sp>
-        <p:nvSpPr>
-          <p:cNvPr id="9" name="TextBox 8"/>
+              <a:t>Price Elasticity</a:t>
+            </a:r>
+          </a:p>
+        </p:txBody>
+      </p:sp>
+      <p:sp>
+        <p:nvSpPr>
+          <p:cNvPr id="8" name="TextBox 7"/>
           <p:cNvSpPr txBox="1"/>
           <p:nvPr/>
         </p:nvSpPr>
@@ -19685,14 +19535,14 @@
                 </a:solidFill>
                 <a:latin typeface="Calibri"/>
               </a:rPr>
-              <a:t>"How much incremental demand does a promotion generate — and what depth maximizes return?"</a:t>
-            </a:r>
-          </a:p>
-        </p:txBody>
-      </p:sp>
-      <p:sp>
-        <p:nvSpPr>
-          <p:cNvPr id="10" name="Rectangle 9"/>
+              <a:t>"If we change price by X%, how much does demand change — and what is the optimal price point?"</a:t>
+            </a:r>
+          </a:p>
+        </p:txBody>
+      </p:sp>
+      <p:sp>
+        <p:nvSpPr>
+          <p:cNvPr id="9" name="Rectangle 8"/>
           <p:cNvSpPr/>
           <p:nvPr/>
         </p:nvSpPr>
@@ -19735,7 +19585,7 @@
       </p:sp>
       <p:sp>
         <p:nvSpPr>
-          <p:cNvPr id="11" name="TextBox 10"/>
+          <p:cNvPr id="10" name="TextBox 9"/>
           <p:cNvSpPr txBox="1"/>
           <p:nvPr/>
         </p:nvSpPr>
@@ -19770,7 +19620,7 @@
       </p:sp>
       <p:sp>
         <p:nvSpPr>
-          <p:cNvPr id="12" name="Rectangle 11"/>
+          <p:cNvPr id="11" name="Rectangle 10"/>
           <p:cNvSpPr/>
           <p:nvPr/>
         </p:nvSpPr>
@@ -19813,7 +19663,7 @@
       </p:sp>
       <p:sp>
         <p:nvSpPr>
-          <p:cNvPr id="13" name="TextBox 12"/>
+          <p:cNvPr id="12" name="TextBox 11"/>
           <p:cNvSpPr txBox="1"/>
           <p:nvPr/>
         </p:nvSpPr>
@@ -19848,7 +19698,7 @@
       </p:sp>
       <p:sp>
         <p:nvSpPr>
-          <p:cNvPr id="14" name="TextBox 13"/>
+          <p:cNvPr id="13" name="TextBox 12"/>
           <p:cNvSpPr txBox="1"/>
           <p:nvPr/>
         </p:nvSpPr>
@@ -19883,7 +19733,7 @@
       </p:sp>
       <p:sp>
         <p:nvSpPr>
-          <p:cNvPr id="15" name="TextBox 14"/>
+          <p:cNvPr id="14" name="TextBox 13"/>
           <p:cNvSpPr txBox="1"/>
           <p:nvPr/>
         </p:nvSpPr>
@@ -19918,7 +19768,7 @@
       </p:sp>
       <p:sp>
         <p:nvSpPr>
-          <p:cNvPr id="16" name="Rectangle 15"/>
+          <p:cNvPr id="15" name="Rectangle 14"/>
           <p:cNvSpPr/>
           <p:nvPr/>
         </p:nvSpPr>
@@ -19963,7 +19813,7 @@
       </p:sp>
       <p:sp>
         <p:nvSpPr>
-          <p:cNvPr id="17" name="TextBox 16"/>
+          <p:cNvPr id="16" name="TextBox 15"/>
           <p:cNvSpPr txBox="1"/>
           <p:nvPr/>
         </p:nvSpPr>
@@ -19991,14 +19841,14 @@
                 </a:solidFill>
                 <a:latin typeface="Calibri"/>
               </a:rPr>
-              <a:t>Incremental units</a:t>
-            </a:r>
-          </a:p>
-        </p:txBody>
-      </p:sp>
-      <p:sp>
-        <p:nvSpPr>
-          <p:cNvPr id="18" name="TextBox 17"/>
+              <a:t>Average retail price</a:t>
+            </a:r>
+          </a:p>
+        </p:txBody>
+      </p:sp>
+      <p:sp>
+        <p:nvSpPr>
+          <p:cNvPr id="17" name="TextBox 16"/>
           <p:cNvSpPr txBox="1"/>
           <p:nvPr/>
         </p:nvSpPr>
@@ -20033,7 +19883,7 @@
       </p:sp>
       <p:sp>
         <p:nvSpPr>
-          <p:cNvPr id="19" name="TextBox 18"/>
+          <p:cNvPr id="18" name="TextBox 17"/>
           <p:cNvSpPr txBox="1"/>
           <p:nvPr/>
         </p:nvSpPr>
@@ -20061,14 +19911,14 @@
                 </a:solidFill>
                 <a:latin typeface="Calibri"/>
               </a:rPr>
-              <a:t>Above-baseline demand</a:t>
-            </a:r>
-          </a:p>
-        </p:txBody>
-      </p:sp>
-      <p:sp>
-        <p:nvSpPr>
-          <p:cNvPr id="20" name="Rectangle 19"/>
+              <a:t>Price level measure</a:t>
+            </a:r>
+          </a:p>
+        </p:txBody>
+      </p:sp>
+      <p:sp>
+        <p:nvSpPr>
+          <p:cNvPr id="19" name="Rectangle 18"/>
           <p:cNvSpPr/>
           <p:nvPr/>
         </p:nvSpPr>
@@ -20113,7 +19963,7 @@
       </p:sp>
       <p:sp>
         <p:nvSpPr>
-          <p:cNvPr id="21" name="TextBox 20"/>
+          <p:cNvPr id="20" name="TextBox 19"/>
           <p:cNvSpPr txBox="1"/>
           <p:nvPr/>
         </p:nvSpPr>
@@ -20141,14 +19991,14 @@
                 </a:solidFill>
                 <a:latin typeface="Calibri"/>
               </a:rPr>
-              <a:t>Base units (non-promo)</a:t>
-            </a:r>
-          </a:p>
-        </p:txBody>
-      </p:sp>
-      <p:sp>
-        <p:nvSpPr>
-          <p:cNvPr id="22" name="TextBox 21"/>
+              <a:t>Weekly units sold</a:t>
+            </a:r>
+          </a:p>
+        </p:txBody>
+      </p:sp>
+      <p:sp>
+        <p:nvSpPr>
+          <p:cNvPr id="21" name="TextBox 20"/>
           <p:cNvSpPr txBox="1"/>
           <p:nvPr/>
         </p:nvSpPr>
@@ -20183,7 +20033,7 @@
       </p:sp>
       <p:sp>
         <p:nvSpPr>
-          <p:cNvPr id="23" name="TextBox 22"/>
+          <p:cNvPr id="22" name="TextBox 21"/>
           <p:cNvSpPr txBox="1"/>
           <p:nvPr/>
         </p:nvSpPr>
@@ -20211,14 +20061,14 @@
                 </a:solidFill>
                 <a:latin typeface="Calibri"/>
               </a:rPr>
-              <a:t>Lift denominator</a:t>
-            </a:r>
-          </a:p>
-        </p:txBody>
-      </p:sp>
-      <p:sp>
-        <p:nvSpPr>
-          <p:cNvPr id="24" name="Rectangle 23"/>
+              <a:t>Demand response</a:t>
+            </a:r>
+          </a:p>
+        </p:txBody>
+      </p:sp>
+      <p:sp>
+        <p:nvSpPr>
+          <p:cNvPr id="23" name="Rectangle 22"/>
           <p:cNvSpPr/>
           <p:nvPr/>
         </p:nvSpPr>
@@ -20263,7 +20113,7 @@
       </p:sp>
       <p:sp>
         <p:nvSpPr>
-          <p:cNvPr id="25" name="TextBox 24"/>
+          <p:cNvPr id="24" name="TextBox 23"/>
           <p:cNvSpPr txBox="1"/>
           <p:nvPr/>
         </p:nvSpPr>
@@ -20291,14 +20141,14 @@
                 </a:solidFill>
                 <a:latin typeface="Calibri"/>
               </a:rPr>
-              <a:t>% units sold on promotion</a:t>
-            </a:r>
-          </a:p>
-        </p:txBody>
-      </p:sp>
-      <p:sp>
-        <p:nvSpPr>
-          <p:cNvPr id="26" name="TextBox 25"/>
+              <a:t>Base price (non-promo ARP)</a:t>
+            </a:r>
+          </a:p>
+        </p:txBody>
+      </p:sp>
+      <p:sp>
+        <p:nvSpPr>
+          <p:cNvPr id="25" name="TextBox 24"/>
           <p:cNvSpPr txBox="1"/>
           <p:nvPr/>
         </p:nvSpPr>
@@ -20333,7 +20183,7 @@
       </p:sp>
       <p:sp>
         <p:nvSpPr>
-          <p:cNvPr id="27" name="TextBox 26"/>
+          <p:cNvPr id="26" name="TextBox 25"/>
           <p:cNvSpPr txBox="1"/>
           <p:nvPr/>
         </p:nvSpPr>
@@ -20361,14 +20211,14 @@
                 </a:solidFill>
                 <a:latin typeface="Calibri"/>
               </a:rPr>
-              <a:t>Promo dependency</a:t>
-            </a:r>
-          </a:p>
-        </p:txBody>
-      </p:sp>
-      <p:sp>
-        <p:nvSpPr>
-          <p:cNvPr id="28" name="Rectangle 27"/>
+              <a:t>Everyday vs. promo</a:t>
+            </a:r>
+          </a:p>
+        </p:txBody>
+      </p:sp>
+      <p:sp>
+        <p:nvSpPr>
+          <p:cNvPr id="27" name="Rectangle 26"/>
           <p:cNvSpPr/>
           <p:nvPr/>
         </p:nvSpPr>
@@ -20413,7 +20263,7 @@
       </p:sp>
       <p:sp>
         <p:nvSpPr>
-          <p:cNvPr id="29" name="TextBox 28"/>
+          <p:cNvPr id="28" name="TextBox 27"/>
           <p:cNvSpPr txBox="1"/>
           <p:nvPr/>
         </p:nvSpPr>
@@ -20448,7 +20298,7 @@
       </p:sp>
       <p:sp>
         <p:nvSpPr>
-          <p:cNvPr id="30" name="TextBox 29"/>
+          <p:cNvPr id="29" name="TextBox 28"/>
           <p:cNvSpPr txBox="1"/>
           <p:nvPr/>
         </p:nvSpPr>
@@ -20483,7 +20333,7 @@
       </p:sp>
       <p:sp>
         <p:nvSpPr>
-          <p:cNvPr id="31" name="TextBox 30"/>
+          <p:cNvPr id="30" name="TextBox 29"/>
           <p:cNvSpPr txBox="1"/>
           <p:nvPr/>
         </p:nvSpPr>
@@ -20511,14 +20361,14 @@
                 </a:solidFill>
                 <a:latin typeface="Calibri"/>
               </a:rPr>
-              <a:t>Quantify discount</a:t>
-            </a:r>
-          </a:p>
-        </p:txBody>
-      </p:sp>
-      <p:sp>
-        <p:nvSpPr>
-          <p:cNvPr id="32" name="Rectangle 31"/>
+              <a:t>Quantify promo depth</a:t>
+            </a:r>
+          </a:p>
+        </p:txBody>
+      </p:sp>
+      <p:sp>
+        <p:nvSpPr>
+          <p:cNvPr id="31" name="Rectangle 30"/>
           <p:cNvSpPr/>
           <p:nvPr/>
         </p:nvSpPr>
@@ -20563,7 +20413,7 @@
       </p:sp>
       <p:sp>
         <p:nvSpPr>
-          <p:cNvPr id="33" name="TextBox 32"/>
+          <p:cNvPr id="32" name="TextBox 31"/>
           <p:cNvSpPr txBox="1"/>
           <p:nvPr/>
         </p:nvSpPr>
@@ -20591,14 +20441,14 @@
                 </a:solidFill>
                 <a:latin typeface="Calibri"/>
               </a:rPr>
-              <a:t>Channel (grocery / mass / c-store)</a:t>
-            </a:r>
-          </a:p>
-        </p:txBody>
-      </p:sp>
-      <p:sp>
-        <p:nvSpPr>
-          <p:cNvPr id="34" name="TextBox 33"/>
+              <a:t>Incremental units (promo-driven)</a:t>
+            </a:r>
+          </a:p>
+        </p:txBody>
+      </p:sp>
+      <p:sp>
+        <p:nvSpPr>
+          <p:cNvPr id="33" name="TextBox 32"/>
           <p:cNvSpPr txBox="1"/>
           <p:nvPr/>
         </p:nvSpPr>
@@ -20633,7 +20483,7 @@
       </p:sp>
       <p:sp>
         <p:nvSpPr>
-          <p:cNvPr id="35" name="TextBox 34"/>
+          <p:cNvPr id="34" name="TextBox 33"/>
           <p:cNvSpPr txBox="1"/>
           <p:nvPr/>
         </p:nvSpPr>
@@ -20661,14 +20511,14 @@
                 </a:solidFill>
                 <a:latin typeface="Calibri"/>
               </a:rPr>
-              <a:t>Channel response</a:t>
-            </a:r>
-          </a:p>
-        </p:txBody>
-      </p:sp>
-      <p:sp>
-        <p:nvSpPr>
-          <p:cNvPr id="36" name="Rectangle 35"/>
+              <a:t>Isolate promo demand</a:t>
+            </a:r>
+          </a:p>
+        </p:txBody>
+      </p:sp>
+      <p:sp>
+        <p:nvSpPr>
+          <p:cNvPr id="35" name="Rectangle 34"/>
           <p:cNvSpPr/>
           <p:nvPr/>
         </p:nvSpPr>
@@ -20713,7 +20563,7 @@
       </p:sp>
       <p:sp>
         <p:nvSpPr>
-          <p:cNvPr id="37" name="TextBox 36"/>
+          <p:cNvPr id="36" name="TextBox 35"/>
           <p:cNvSpPr txBox="1"/>
           <p:nvPr/>
         </p:nvSpPr>
@@ -20741,14 +20591,14 @@
                 </a:solidFill>
                 <a:latin typeface="Calibri"/>
               </a:rPr>
-              <a:t>Pack count</a:t>
-            </a:r>
-          </a:p>
-        </p:txBody>
-      </p:sp>
-      <p:sp>
-        <p:nvSpPr>
-          <p:cNvPr id="38" name="TextBox 37"/>
+              <a:t>Distribution (TDP)</a:t>
+            </a:r>
+          </a:p>
+        </p:txBody>
+      </p:sp>
+      <p:sp>
+        <p:nvSpPr>
+          <p:cNvPr id="37" name="TextBox 36"/>
           <p:cNvSpPr txBox="1"/>
           <p:nvPr/>
         </p:nvSpPr>
@@ -20783,7 +20633,7 @@
       </p:sp>
       <p:sp>
         <p:nvSpPr>
-          <p:cNvPr id="39" name="TextBox 38"/>
+          <p:cNvPr id="38" name="TextBox 37"/>
           <p:cNvSpPr txBox="1"/>
           <p:nvPr/>
         </p:nvSpPr>
@@ -20811,14 +20661,14 @@
                 </a:solidFill>
                 <a:latin typeface="Calibri"/>
               </a:rPr>
-              <a:t>Pack size behavior</a:t>
-            </a:r>
-          </a:p>
-        </p:txBody>
-      </p:sp>
-      <p:sp>
-        <p:nvSpPr>
-          <p:cNvPr id="40" name="Rectangle 39"/>
+              <a:t>Distribution control</a:t>
+            </a:r>
+          </a:p>
+        </p:txBody>
+      </p:sp>
+      <p:sp>
+        <p:nvSpPr>
+          <p:cNvPr id="39" name="Rectangle 38"/>
           <p:cNvSpPr/>
           <p:nvPr/>
         </p:nvSpPr>
@@ -20863,7 +20713,7 @@
       </p:sp>
       <p:sp>
         <p:nvSpPr>
-          <p:cNvPr id="41" name="TextBox 40"/>
+          <p:cNvPr id="40" name="TextBox 39"/>
           <p:cNvSpPr txBox="1"/>
           <p:nvPr/>
         </p:nvSpPr>
@@ -20891,14 +20741,14 @@
                 </a:solidFill>
                 <a:latin typeface="Calibri"/>
               </a:rPr>
-              <a:t>Distribution on promo (TDP, Any Promo)</a:t>
-            </a:r>
-          </a:p>
-        </p:txBody>
-      </p:sp>
-      <p:sp>
-        <p:nvSpPr>
-          <p:cNvPr id="42" name="TextBox 41"/>
+              <a:t>Competitor price (same flavor)</a:t>
+            </a:r>
+          </a:p>
+        </p:txBody>
+      </p:sp>
+      <p:sp>
+        <p:nvSpPr>
+          <p:cNvPr id="41" name="TextBox 40"/>
           <p:cNvSpPr txBox="1"/>
           <p:nvPr/>
         </p:nvSpPr>
@@ -20933,7 +20783,7 @@
       </p:sp>
       <p:sp>
         <p:nvSpPr>
-          <p:cNvPr id="43" name="TextBox 42"/>
+          <p:cNvPr id="42" name="TextBox 41"/>
           <p:cNvSpPr txBox="1"/>
           <p:nvPr/>
         </p:nvSpPr>
@@ -20961,14 +20811,14 @@
                 </a:solidFill>
                 <a:latin typeface="Calibri"/>
               </a:rPr>
-              <a:t>Display vs. price</a:t>
-            </a:r>
-          </a:p>
-        </p:txBody>
-      </p:sp>
-      <p:sp>
-        <p:nvSpPr>
-          <p:cNvPr id="44" name="Rectangle 43"/>
+              <a:t>Own vs. competitor</a:t>
+            </a:r>
+          </a:p>
+        </p:txBody>
+      </p:sp>
+      <p:sp>
+        <p:nvSpPr>
+          <p:cNvPr id="43" name="Rectangle 42"/>
           <p:cNvSpPr/>
           <p:nvPr/>
         </p:nvSpPr>
@@ -21011,7 +20861,7 @@
       </p:sp>
       <p:sp>
         <p:nvSpPr>
-          <p:cNvPr id="45" name="TextBox 44"/>
+          <p:cNvPr id="44" name="TextBox 43"/>
           <p:cNvSpPr txBox="1"/>
           <p:nvPr/>
         </p:nvSpPr>
@@ -21046,7 +20896,7 @@
       </p:sp>
       <p:sp>
         <p:nvSpPr>
-          <p:cNvPr id="46" name="Rectangle 45"/>
+          <p:cNvPr id="45" name="Rectangle 44"/>
           <p:cNvSpPr/>
           <p:nvPr/>
         </p:nvSpPr>
@@ -21089,7 +20939,7 @@
       </p:sp>
       <p:sp>
         <p:nvSpPr>
-          <p:cNvPr id="47" name="TextBox 46"/>
+          <p:cNvPr id="46" name="TextBox 45"/>
           <p:cNvSpPr txBox="1"/>
           <p:nvPr/>
         </p:nvSpPr>
@@ -21117,14 +20967,14 @@
                 </a:solidFill>
                 <a:latin typeface="Calibri"/>
               </a:rPr>
-              <a:t>Calculate promo lift ratio: incremental units ÷ base units, per SKU × account × event</a:t>
-            </a:r>
-          </a:p>
-        </p:txBody>
-      </p:sp>
-      <p:sp>
-        <p:nvSpPr>
-          <p:cNvPr id="48" name="Rectangle 47"/>
+              <a:t>Normalize price to $/bar so singles and 12-packs are comparable</a:t>
+            </a:r>
+          </a:p>
+        </p:txBody>
+      </p:sp>
+      <p:sp>
+        <p:nvSpPr>
+          <p:cNvPr id="47" name="Rectangle 46"/>
           <p:cNvSpPr/>
           <p:nvPr/>
         </p:nvSpPr>
@@ -21167,7 +21017,7 @@
       </p:sp>
       <p:sp>
         <p:nvSpPr>
-          <p:cNvPr id="49" name="TextBox 48"/>
+          <p:cNvPr id="48" name="TextBox 47"/>
           <p:cNvSpPr txBox="1"/>
           <p:nvPr/>
         </p:nvSpPr>
@@ -21195,14 +21045,14 @@
                 </a:solidFill>
                 <a:latin typeface="Calibri"/>
               </a:rPr>
-              <a:t>Group events into discount depth buckets (0–10%, 10–20%, 20–30%, 30%+)</a:t>
-            </a:r>
-          </a:p>
-        </p:txBody>
-      </p:sp>
-      <p:sp>
-        <p:nvSpPr>
-          <p:cNvPr id="50" name="Rectangle 49"/>
+              <a:t>Build 13-week log-log regression windows per SKU × account</a:t>
+            </a:r>
+          </a:p>
+        </p:txBody>
+      </p:sp>
+      <p:sp>
+        <p:nvSpPr>
+          <p:cNvPr id="49" name="Rectangle 48"/>
           <p:cNvSpPr/>
           <p:nvPr/>
         </p:nvSpPr>
@@ -21245,7 +21095,7 @@
       </p:sp>
       <p:sp>
         <p:nvSpPr>
-          <p:cNvPr id="51" name="TextBox 50"/>
+          <p:cNvPr id="50" name="TextBox 49"/>
           <p:cNvSpPr txBox="1"/>
           <p:nvPr/>
         </p:nvSpPr>
@@ -21273,14 +21123,14 @@
                 </a:solidFill>
                 <a:latin typeface="Calibri"/>
               </a:rPr>
-              <a:t>Separate response curves by channel — grocery and c-store show distinct lift profiles</a:t>
-            </a:r>
-          </a:p>
-        </p:txBody>
-      </p:sp>
-      <p:sp>
-        <p:nvSpPr>
-          <p:cNvPr id="52" name="Rectangle 51"/>
+              <a:t>Separate promotional price changes from everyday price changes</a:t>
+            </a:r>
+          </a:p>
+        </p:txBody>
+      </p:sp>
+      <p:sp>
+        <p:nvSpPr>
+          <p:cNvPr id="51" name="Rectangle 50"/>
           <p:cNvSpPr/>
           <p:nvPr/>
         </p:nvSpPr>
@@ -21323,7 +21173,7 @@
       </p:sp>
       <p:sp>
         <p:nvSpPr>
-          <p:cNvPr id="53" name="TextBox 52"/>
+          <p:cNvPr id="52" name="TextBox 51"/>
           <p:cNvSpPr txBox="1"/>
           <p:nvPr/>
         </p:nvSpPr>
@@ -21351,14 +21201,14 @@
                 </a:solidFill>
                 <a:latin typeface="Calibri"/>
               </a:rPr>
-              <a:t>Separate response curves by pack size — 12-packs show a 30%+ discount cliff</a:t>
-            </a:r>
-          </a:p>
-        </p:txBody>
-      </p:sp>
-      <p:sp>
-        <p:nvSpPr>
-          <p:cNvPr id="54" name="Rectangle 53"/>
+              <a:t>Compare BUILT $/bar vs. same-flavor competitor in the same account and week</a:t>
+            </a:r>
+          </a:p>
+        </p:txBody>
+      </p:sp>
+      <p:sp>
+        <p:nvSpPr>
+          <p:cNvPr id="53" name="Rectangle 52"/>
           <p:cNvSpPr/>
           <p:nvPr/>
         </p:nvSpPr>
@@ -21401,7 +21251,7 @@
       </p:sp>
       <p:sp>
         <p:nvSpPr>
-          <p:cNvPr id="55" name="TextBox 54"/>
+          <p:cNvPr id="54" name="TextBox 53"/>
           <p:cNvSpPr txBox="1"/>
           <p:nvPr/>
         </p:nvSpPr>
@@ -21429,14 +21279,92 @@
                 </a:solidFill>
                 <a:latin typeface="Calibri"/>
               </a:rPr>
-              <a:t>Identify the depth where marginal lift no longer justifies additional margin give-up</a:t>
-            </a:r>
-          </a:p>
-        </p:txBody>
-      </p:sp>
-      <p:sp>
-        <p:nvSpPr>
-          <p:cNvPr id="56" name="Rectangle 55"/>
+              <a:t>Compare $/bar across BUILT own pack sizes of the same flavor (pack-ladder check)</a:t>
+            </a:r>
+          </a:p>
+        </p:txBody>
+      </p:sp>
+      <p:sp>
+        <p:nvSpPr>
+          <p:cNvPr id="55" name="Rectangle 54"/>
+          <p:cNvSpPr/>
+          <p:nvPr/>
+        </p:nvSpPr>
+        <p:spPr>
+          <a:xfrm>
+            <a:off x="502920" y="5422391"/>
+            <a:ext cx="73152" cy="73152"/>
+          </a:xfrm>
+          <a:prstGeom prst="rect">
+            <a:avLst/>
+          </a:prstGeom>
+          <a:solidFill>
+            <a:srgbClr val="4078D0"/>
+          </a:solidFill>
+          <a:ln>
+            <a:noFill/>
+          </a:ln>
+        </p:spPr>
+        <p:style>
+          <a:lnRef idx="1">
+            <a:schemeClr val="accent1"/>
+          </a:lnRef>
+          <a:fillRef idx="3">
+            <a:schemeClr val="accent1"/>
+          </a:fillRef>
+          <a:effectRef idx="2">
+            <a:schemeClr val="accent1"/>
+          </a:effectRef>
+          <a:fontRef idx="minor">
+            <a:schemeClr val="lt1"/>
+          </a:fontRef>
+        </p:style>
+        <p:txBody>
+          <a:bodyPr rtlCol="0" anchor="ctr"/>
+          <a:lstStyle/>
+          <a:p>
+            <a:pPr algn="ctr"/>
+          </a:p>
+        </p:txBody>
+      </p:sp>
+      <p:sp>
+        <p:nvSpPr>
+          <p:cNvPr id="56" name="TextBox 55"/>
+          <p:cNvSpPr txBox="1"/>
+          <p:nvPr/>
+        </p:nvSpPr>
+        <p:spPr>
+          <a:xfrm>
+            <a:off x="667512" y="5358383"/>
+            <a:ext cx="4224528" cy="237744"/>
+          </a:xfrm>
+          <a:prstGeom prst="rect">
+            <a:avLst/>
+          </a:prstGeom>
+          <a:noFill/>
+        </p:spPr>
+        <p:txBody>
+          <a:bodyPr wrap="square">
+            <a:spAutoFit/>
+          </a:bodyPr>
+          <a:lstStyle/>
+          <a:p>
+            <a:pPr algn="l"/>
+            <a:r>
+              <a:rPr sz="850" b="0" i="0">
+                <a:solidFill>
+                  <a:srgbClr val="111827"/>
+                </a:solidFill>
+                <a:latin typeface="Calibri"/>
+              </a:rPr>
+              <a:t>Reject windows where price moved &gt;40% in one week — data artifact guardrail</a:t>
+            </a:r>
+          </a:p>
+        </p:txBody>
+      </p:sp>
+      <p:sp>
+        <p:nvSpPr>
+          <p:cNvPr id="57" name="Rectangle 56"/>
           <p:cNvSpPr/>
           <p:nvPr/>
         </p:nvSpPr>
@@ -21479,7 +21407,7 @@
       </p:sp>
       <p:sp>
         <p:nvSpPr>
-          <p:cNvPr id="57" name="TextBox 56"/>
+          <p:cNvPr id="58" name="TextBox 57"/>
           <p:cNvSpPr txBox="1"/>
           <p:nvPr/>
         </p:nvSpPr>
@@ -21514,14 +21442,14 @@
       </p:sp>
       <p:sp>
         <p:nvSpPr>
-          <p:cNvPr id="58" name="Rectangle 57"/>
+          <p:cNvPr id="59" name="Rectangle 58"/>
           <p:cNvSpPr/>
           <p:nvPr/>
         </p:nvSpPr>
         <p:spPr>
           <a:xfrm>
             <a:off x="5349240" y="1691640"/>
-            <a:ext cx="6492240" cy="1051560"/>
+            <a:ext cx="6492240" cy="1691640"/>
           </a:xfrm>
           <a:prstGeom prst="rect">
             <a:avLst/>
@@ -21559,7 +21487,7 @@
       </p:sp>
       <p:sp>
         <p:nvSpPr>
-          <p:cNvPr id="59" name="TextBox 58"/>
+          <p:cNvPr id="60" name="TextBox 59"/>
           <p:cNvSpPr txBox="1"/>
           <p:nvPr/>
         </p:nvSpPr>
@@ -21587,14 +21515,14 @@
                 </a:solidFill>
                 <a:latin typeface="Calibri"/>
               </a:rPr>
-              <a:t>›  Expected lift % at each discount depth for this SKU × channel × pack size</a:t>
-            </a:r>
-          </a:p>
-        </p:txBody>
-      </p:sp>
-      <p:sp>
-        <p:nvSpPr>
-          <p:cNvPr id="60" name="TextBox 59"/>
+              <a:t>›  Own-price elasticity ε with confidence range (q10 / q50 / q90)</a:t>
+            </a:r>
+          </a:p>
+        </p:txBody>
+      </p:sp>
+      <p:sp>
+        <p:nvSpPr>
+          <p:cNvPr id="61" name="TextBox 60"/>
           <p:cNvSpPr txBox="1"/>
           <p:nvPr/>
         </p:nvSpPr>
@@ -21622,14 +21550,14 @@
                 </a:solidFill>
                 <a:latin typeface="Calibri"/>
               </a:rPr>
-              <a:t>›  Optimal discount depth recommendation — where lift peaks before the cliff</a:t>
-            </a:r>
-          </a:p>
-        </p:txBody>
-      </p:sp>
-      <p:sp>
-        <p:nvSpPr>
-          <p:cNvPr id="61" name="TextBox 60"/>
+              <a:t>›  Cross-price elasticity — demand response to competitor price changes</a:t>
+            </a:r>
+          </a:p>
+        </p:txBody>
+      </p:sp>
+      <p:sp>
+        <p:nvSpPr>
+          <p:cNvPr id="62" name="TextBox 61"/>
           <p:cNvSpPr txBox="1"/>
           <p:nvPr/>
         </p:nvSpPr>
@@ -21657,20 +21585,90 @@
                 </a:solidFill>
                 <a:latin typeface="Calibri"/>
               </a:rPr>
-              <a:t>›  Incremental vs. cannibalized demand breakdown at each discount level</a:t>
-            </a:r>
-          </a:p>
-        </p:txBody>
-      </p:sp>
-      <p:sp>
-        <p:nvSpPr>
-          <p:cNvPr id="62" name="Rectangle 61"/>
+              <a:t>›  Promo elasticity curve — lift at each discount depth</a:t>
+            </a:r>
+          </a:p>
+        </p:txBody>
+      </p:sp>
+      <p:sp>
+        <p:nvSpPr>
+          <p:cNvPr id="63" name="TextBox 62"/>
+          <p:cNvSpPr txBox="1"/>
+          <p:nvPr/>
+        </p:nvSpPr>
+        <p:spPr>
+          <a:xfrm>
+            <a:off x="5623559" y="2715768"/>
+            <a:ext cx="6126479" cy="256032"/>
+          </a:xfrm>
+          <a:prstGeom prst="rect">
+            <a:avLst/>
+          </a:prstGeom>
+          <a:noFill/>
+        </p:spPr>
+        <p:txBody>
+          <a:bodyPr wrap="square">
+            <a:spAutoFit/>
+          </a:bodyPr>
+          <a:lstStyle/>
+          <a:p>
+            <a:pPr algn="l"/>
+            <a:r>
+              <a:rPr sz="950" b="0" i="0">
+                <a:solidFill>
+                  <a:srgbClr val="0E5E38"/>
+                </a:solidFill>
+                <a:latin typeface="Calibri"/>
+              </a:rPr>
+              <a:t>›  What-if demand curves — projected units at alternative price points</a:t>
+            </a:r>
+          </a:p>
+        </p:txBody>
+      </p:sp>
+      <p:sp>
+        <p:nvSpPr>
+          <p:cNvPr id="64" name="TextBox 63"/>
+          <p:cNvSpPr txBox="1"/>
+          <p:nvPr/>
+        </p:nvSpPr>
+        <p:spPr>
+          <a:xfrm>
+            <a:off x="5623559" y="3035808"/>
+            <a:ext cx="6126479" cy="256032"/>
+          </a:xfrm>
+          <a:prstGeom prst="rect">
+            <a:avLst/>
+          </a:prstGeom>
+          <a:noFill/>
+        </p:spPr>
+        <p:txBody>
+          <a:bodyPr wrap="square">
+            <a:spAutoFit/>
+          </a:bodyPr>
+          <a:lstStyle/>
+          <a:p>
+            <a:pPr algn="l"/>
+            <a:r>
+              <a:rPr sz="950" b="0" i="0">
+                <a:solidFill>
+                  <a:srgbClr val="0E5E38"/>
+                </a:solidFill>
+                <a:latin typeface="Calibri"/>
+              </a:rPr>
+              <a:t>›  Pricing event queue — active competitive gaps or pack-ladder compression</a:t>
+            </a:r>
+          </a:p>
+        </p:txBody>
+      </p:sp>
+      <p:sp>
+        <p:nvSpPr>
+          <p:cNvPr id="65" name="Rectangle 64"/>
           <p:cNvSpPr/>
           <p:nvPr/>
         </p:nvSpPr>
         <p:spPr>
           <a:xfrm>
-            <a:off x="5349240" y="2852928"/>
+            <a:off x="5349240" y="3493008"/>
             <a:ext cx="6492240" cy="274320"/>
           </a:xfrm>
           <a:prstGeom prst="rect">
@@ -21707,13 +21705,13 @@
       </p:sp>
       <p:sp>
         <p:nvSpPr>
-          <p:cNvPr id="63" name="TextBox 62"/>
-          <p:cNvSpPr txBox="1"/>
-          <p:nvPr/>
-        </p:nvSpPr>
-        <p:spPr>
-          <a:xfrm>
-            <a:off x="5458968" y="2898648"/>
+          <p:cNvPr id="66" name="TextBox 65"/>
+          <p:cNvSpPr txBox="1"/>
+          <p:nvPr/>
+        </p:nvSpPr>
+        <p:spPr>
+          <a:xfrm>
+            <a:off x="5458968" y="3538728"/>
             <a:ext cx="6492240" cy="201168"/>
           </a:xfrm>
           <a:prstGeom prst="rect">
@@ -21742,13 +21740,13 @@
       </p:sp>
       <p:sp>
         <p:nvSpPr>
-          <p:cNvPr id="64" name="Rectangle 63"/>
+          <p:cNvPr id="67" name="Rectangle 66"/>
           <p:cNvSpPr/>
           <p:nvPr/>
         </p:nvSpPr>
         <p:spPr>
           <a:xfrm>
-            <a:off x="5349240" y="3127248"/>
+            <a:off x="5349240" y="3767328"/>
             <a:ext cx="6492240" cy="1371600"/>
           </a:xfrm>
           <a:prstGeom prst="rect">
@@ -21787,77 +21785,7 @@
       </p:sp>
       <p:sp>
         <p:nvSpPr>
-          <p:cNvPr id="65" name="TextBox 64"/>
-          <p:cNvSpPr txBox="1"/>
-          <p:nvPr/>
-        </p:nvSpPr>
-        <p:spPr>
-          <a:xfrm>
-            <a:off x="5623559" y="3191256"/>
-            <a:ext cx="6126479" cy="256032"/>
-          </a:xfrm>
-          <a:prstGeom prst="rect">
-            <a:avLst/>
-          </a:prstGeom>
-          <a:noFill/>
-        </p:spPr>
-        <p:txBody>
-          <a:bodyPr wrap="square">
-            <a:spAutoFit/>
-          </a:bodyPr>
-          <a:lstStyle/>
-          <a:p>
-            <a:pPr algn="l"/>
-            <a:r>
-              <a:rPr sz="950" b="0" i="0">
-                <a:solidFill>
-                  <a:srgbClr val="8A4800"/>
-                </a:solidFill>
-                <a:latin typeface="Calibri"/>
-              </a:rPr>
-              <a:t>›  Historical promo events — discount depth, timing, and observed lift per event</a:t>
-            </a:r>
-          </a:p>
-        </p:txBody>
-      </p:sp>
-      <p:sp>
-        <p:nvSpPr>
-          <p:cNvPr id="66" name="TextBox 65"/>
-          <p:cNvSpPr txBox="1"/>
-          <p:nvPr/>
-        </p:nvSpPr>
-        <p:spPr>
-          <a:xfrm>
-            <a:off x="5623559" y="3511296"/>
-            <a:ext cx="6126479" cy="256032"/>
-          </a:xfrm>
-          <a:prstGeom prst="rect">
-            <a:avLst/>
-          </a:prstGeom>
-          <a:noFill/>
-        </p:spPr>
-        <p:txBody>
-          <a:bodyPr wrap="square">
-            <a:spAutoFit/>
-          </a:bodyPr>
-          <a:lstStyle/>
-          <a:p>
-            <a:pPr algn="l"/>
-            <a:r>
-              <a:rPr sz="950" b="0" i="0">
-                <a:solidFill>
-                  <a:srgbClr val="8A4800"/>
-                </a:solidFill>
-                <a:latin typeface="Calibri"/>
-              </a:rPr>
-              <a:t>›  Lift trend by event type — TPR vs. display vs. feature support</a:t>
-            </a:r>
-          </a:p>
-        </p:txBody>
-      </p:sp>
-      <p:sp>
-        <p:nvSpPr>
-          <p:cNvPr id="67" name="TextBox 66"/>
+          <p:cNvPr id="68" name="TextBox 67"/>
           <p:cNvSpPr txBox="1"/>
           <p:nvPr/>
         </p:nvSpPr>
@@ -21885,14 +21813,14 @@
                 </a:solidFill>
                 <a:latin typeface="Calibri"/>
               </a:rPr>
-              <a:t>›  % weeks on promo trend — is this SKU becoming promo-dependent?</a:t>
-            </a:r>
-          </a:p>
-        </p:txBody>
-      </p:sp>
-      <p:sp>
-        <p:nvSpPr>
-          <p:cNvPr id="68" name="TextBox 67"/>
+              <a:t>›  Current $/bar and 52-week price trend by retailer account</a:t>
+            </a:r>
+          </a:p>
+        </p:txBody>
+      </p:sp>
+      <p:sp>
+        <p:nvSpPr>
+          <p:cNvPr id="69" name="TextBox 68"/>
           <p:cNvSpPr txBox="1"/>
           <p:nvPr/>
         </p:nvSpPr>
@@ -21920,14 +21848,84 @@
                 </a:solidFill>
                 <a:latin typeface="Calibri"/>
               </a:rPr>
-              <a:t>›  Channel comparison — lift curve across grocery / mass / c-store for this SKU</a:t>
-            </a:r>
-          </a:p>
-        </p:txBody>
-      </p:sp>
-      <p:sp>
-        <p:nvSpPr>
-          <p:cNvPr id="69" name="Rectangle 68"/>
+              <a:t>›  Pack price ladder — single / 4-pack / 12-pack side-by-side in the same account</a:t>
+            </a:r>
+          </a:p>
+        </p:txBody>
+      </p:sp>
+      <p:sp>
+        <p:nvSpPr>
+          <p:cNvPr id="70" name="TextBox 69"/>
+          <p:cNvSpPr txBox="1"/>
+          <p:nvPr/>
+        </p:nvSpPr>
+        <p:spPr>
+          <a:xfrm>
+            <a:off x="5623559" y="4471416"/>
+            <a:ext cx="6126479" cy="256032"/>
+          </a:xfrm>
+          <a:prstGeom prst="rect">
+            <a:avLst/>
+          </a:prstGeom>
+          <a:noFill/>
+        </p:spPr>
+        <p:txBody>
+          <a:bodyPr wrap="square">
+            <a:spAutoFit/>
+          </a:bodyPr>
+          <a:lstStyle/>
+          <a:p>
+            <a:pPr algn="l"/>
+            <a:r>
+              <a:rPr sz="950" b="0" i="0">
+                <a:solidFill>
+                  <a:srgbClr val="8A4800"/>
+                </a:solidFill>
+                <a:latin typeface="Calibri"/>
+              </a:rPr>
+              <a:t>›  Competitive price gap chart — BUILT vs. Tier 1 competitor in the same flavor</a:t>
+            </a:r>
+          </a:p>
+        </p:txBody>
+      </p:sp>
+      <p:sp>
+        <p:nvSpPr>
+          <p:cNvPr id="71" name="TextBox 70"/>
+          <p:cNvSpPr txBox="1"/>
+          <p:nvPr/>
+        </p:nvSpPr>
+        <p:spPr>
+          <a:xfrm>
+            <a:off x="5623559" y="4791456"/>
+            <a:ext cx="6126479" cy="256032"/>
+          </a:xfrm>
+          <a:prstGeom prst="rect">
+            <a:avLst/>
+          </a:prstGeom>
+          <a:noFill/>
+        </p:spPr>
+        <p:txBody>
+          <a:bodyPr wrap="square">
+            <a:spAutoFit/>
+          </a:bodyPr>
+          <a:lstStyle/>
+          <a:p>
+            <a:pPr algn="l"/>
+            <a:r>
+              <a:rPr sz="950" b="0" i="0">
+                <a:solidFill>
+                  <a:srgbClr val="8A4800"/>
+                </a:solidFill>
+                <a:latin typeface="Calibri"/>
+              </a:rPr>
+              <a:t>›  Category benchmark — BUILT $/bar vs. MULO FOOD category average</a:t>
+            </a:r>
+          </a:p>
+        </p:txBody>
+      </p:sp>
+      <p:sp>
+        <p:nvSpPr>
+          <p:cNvPr id="72" name="Rectangle 71"/>
           <p:cNvSpPr/>
           <p:nvPr/>
         </p:nvSpPr>
@@ -21970,7 +21968,7 @@
       </p:sp>
       <p:sp>
         <p:nvSpPr>
-          <p:cNvPr id="70" name="TextBox 69"/>
+          <p:cNvPr id="73" name="TextBox 72"/>
           <p:cNvSpPr txBox="1"/>
           <p:nvPr/>
         </p:nvSpPr>
@@ -22005,7 +22003,7 @@
       </p:sp>
       <p:sp>
         <p:nvSpPr>
-          <p:cNvPr id="71" name="Rectangle 70"/>
+          <p:cNvPr id="74" name="Rectangle 73"/>
           <p:cNvSpPr/>
           <p:nvPr/>
         </p:nvSpPr>
@@ -22050,7 +22048,7 @@
       </p:sp>
       <p:sp>
         <p:nvSpPr>
-          <p:cNvPr id="72" name="TextBox 71"/>
+          <p:cNvPr id="75" name="TextBox 74"/>
           <p:cNvSpPr txBox="1"/>
           <p:nvPr/>
         </p:nvSpPr>
@@ -22078,14 +22076,14 @@
                 </a:solidFill>
                 <a:latin typeface="Calibri"/>
               </a:rPr>
-              <a:t>Lift curve modeling · Depth optimization scoring · Channel × pack separation · Publish to Mo UI</a:t>
-            </a:r>
-          </a:p>
-        </p:txBody>
-      </p:sp>
-      <p:sp>
-        <p:nvSpPr>
-          <p:cNvPr id="73" name="Rectangle 72"/>
+              <a:t>$/bar normalization · Elasticity regression models · Score publishing · Pack-ladder + competitor comparisons · Publish to Mo UI</a:t>
+            </a:r>
+          </a:p>
+        </p:txBody>
+      </p:sp>
+      <p:sp>
+        <p:nvSpPr>
+          <p:cNvPr id="76" name="Rectangle 75"/>
           <p:cNvSpPr/>
           <p:nvPr/>
         </p:nvSpPr>
@@ -22128,7 +22126,7 @@
       </p:sp>
       <p:sp>
         <p:nvSpPr>
-          <p:cNvPr id="74" name="TextBox 73"/>
+          <p:cNvPr id="77" name="TextBox 76"/>
           <p:cNvSpPr txBox="1"/>
           <p:nvPr/>
         </p:nvSpPr>
@@ -22163,7 +22161,7 @@
       </p:sp>
       <p:sp>
         <p:nvSpPr>
-          <p:cNvPr id="75" name="Rectangle 74"/>
+          <p:cNvPr id="78" name="Rectangle 77"/>
           <p:cNvSpPr/>
           <p:nvPr/>
         </p:nvSpPr>
@@ -22208,7 +22206,7 @@
       </p:sp>
       <p:sp>
         <p:nvSpPr>
-          <p:cNvPr id="76" name="TextBox 75"/>
+          <p:cNvPr id="79" name="TextBox 78"/>
           <p:cNvSpPr txBox="1"/>
           <p:nvPr/>
         </p:nvSpPr>
@@ -22236,14 +22234,14 @@
                 </a:solidFill>
                 <a:latin typeface="Calibri"/>
               </a:rPr>
-              <a:t>SPINS export deposit (including promo flags) · Review lift projections · Confirm discount depth guidance with trade marketing team</a:t>
-            </a:r>
-          </a:p>
-        </p:txBody>
-      </p:sp>
-      <p:sp>
-        <p:nvSpPr>
-          <p:cNvPr id="77" name="TextBox 76"/>
+              <a:t>SPINS export deposit · Validate elasticity values — do they match BUILT's commercial experience? · Confirm price-point recommendations with Brian</a:t>
+            </a:r>
+          </a:p>
+        </p:txBody>
+      </p:sp>
+      <p:sp>
+        <p:nvSpPr>
+          <p:cNvPr id="80" name="TextBox 79"/>
           <p:cNvSpPr txBox="1"/>
           <p:nvPr/>
         </p:nvSpPr>
@@ -22496,7 +22494,7 @@
                 </a:solidFill>
                 <a:latin typeface="Calibri"/>
               </a:rPr>
-              <a:t>MODULE 04</a:t>
+              <a:t>MODULE 03</a:t>
             </a:r>
           </a:p>
         </p:txBody>
@@ -22566,7 +22564,7 @@
                 </a:solidFill>
                 <a:latin typeface="Calibri"/>
               </a:rPr>
-              <a:t>Demand Velocity &amp; Forecast</a:t>
+              <a:t>Promotional Response</a:t>
             </a:r>
           </a:p>
         </p:txBody>
@@ -22601,7 +22599,7 @@
                 </a:solidFill>
                 <a:latin typeface="Calibri"/>
               </a:rPr>
-              <a:t>"What will this SKU sell in the next 13 weeks, by retailer account?"</a:t>
+              <a:t>"How much incremental demand does a promotion generate — and what depth maximizes return?"</a:t>
             </a:r>
           </a:p>
         </p:txBody>
@@ -22907,7 +22905,7 @@
                 </a:solidFill>
                 <a:latin typeface="Calibri"/>
               </a:rPr>
-              <a:t>52-week weekly units sold</a:t>
+              <a:t>Incremental units</a:t>
             </a:r>
           </a:p>
         </p:txBody>
@@ -22977,7 +22975,7 @@
                 </a:solidFill>
                 <a:latin typeface="Calibri"/>
               </a:rPr>
-              <a:t>Demand history</a:t>
+              <a:t>Above-baseline demand</a:t>
             </a:r>
           </a:p>
         </p:txBody>
@@ -23057,7 +23055,7 @@
                 </a:solidFill>
                 <a:latin typeface="Calibri"/>
               </a:rPr>
-              <a:t>Distribution (stores selling)</a:t>
+              <a:t>Base units (non-promo)</a:t>
             </a:r>
           </a:p>
         </p:txBody>
@@ -23127,7 +23125,7 @@
                 </a:solidFill>
                 <a:latin typeface="Calibri"/>
               </a:rPr>
-              <a:t>Distribution control</a:t>
+              <a:t>Lift denominator</a:t>
             </a:r>
           </a:p>
         </p:txBody>
@@ -23207,7 +23205,7 @@
                 </a:solidFill>
                 <a:latin typeface="Calibri"/>
               </a:rPr>
-              <a:t>Average retail price</a:t>
+              <a:t>% units sold on promotion</a:t>
             </a:r>
           </a:p>
         </p:txBody>
@@ -23277,7 +23275,7 @@
                 </a:solidFill>
                 <a:latin typeface="Calibri"/>
               </a:rPr>
-              <a:t>Price signal</a:t>
+              <a:t>Promo dependency</a:t>
             </a:r>
           </a:p>
         </p:txBody>
@@ -23357,7 +23355,7 @@
                 </a:solidFill>
                 <a:latin typeface="Calibri"/>
               </a:rPr>
-              <a:t>% weeks on promotion</a:t>
+              <a:t>Promo discount depth (%)</a:t>
             </a:r>
           </a:p>
         </p:txBody>
@@ -23427,7 +23425,7 @@
                 </a:solidFill>
                 <a:latin typeface="Calibri"/>
               </a:rPr>
-              <a:t>Promo flag</a:t>
+              <a:t>Quantify discount</a:t>
             </a:r>
           </a:p>
         </p:txBody>
@@ -23507,7 +23505,7 @@
                 </a:solidFill>
                 <a:latin typeface="Calibri"/>
               </a:rPr>
-              <a:t>Retail account</a:t>
+              <a:t>Channel (grocery / mass / c-store)</a:t>
             </a:r>
           </a:p>
         </p:txBody>
@@ -23577,7 +23575,7 @@
                 </a:solidFill>
                 <a:latin typeface="Calibri"/>
               </a:rPr>
-              <a:t>Per-account model</a:t>
+              <a:t>Channel response</a:t>
             </a:r>
           </a:p>
         </p:txBody>
@@ -23657,7 +23655,7 @@
                 </a:solidFill>
                 <a:latin typeface="Calibri"/>
               </a:rPr>
-              <a:t>Week end date</a:t>
+              <a:t>Pack count</a:t>
             </a:r>
           </a:p>
         </p:txBody>
@@ -23727,7 +23725,7 @@
                 </a:solidFill>
                 <a:latin typeface="Calibri"/>
               </a:rPr>
-              <a:t>Seasonality features</a:t>
+              <a:t>Pack size behavior</a:t>
             </a:r>
           </a:p>
         </p:txBody>
@@ -23740,7 +23738,157 @@
         </p:nvSpPr>
         <p:spPr>
           <a:xfrm>
-            <a:off x="411480" y="3584448"/>
+            <a:off x="411480" y="3511296"/>
+            <a:ext cx="4572000" cy="265176"/>
+          </a:xfrm>
+          <a:prstGeom prst="rect">
+            <a:avLst/>
+          </a:prstGeom>
+          <a:solidFill>
+            <a:srgbClr val="F8FAFD"/>
+          </a:solidFill>
+          <a:ln w="6350">
+            <a:solidFill>
+              <a:srgbClr val="CCD8EE"/>
+            </a:solidFill>
+          </a:ln>
+        </p:spPr>
+        <p:style>
+          <a:lnRef idx="1">
+            <a:schemeClr val="accent1"/>
+          </a:lnRef>
+          <a:fillRef idx="3">
+            <a:schemeClr val="accent1"/>
+          </a:fillRef>
+          <a:effectRef idx="2">
+            <a:schemeClr val="accent1"/>
+          </a:effectRef>
+          <a:fontRef idx="minor">
+            <a:schemeClr val="lt1"/>
+          </a:fontRef>
+        </p:style>
+        <p:txBody>
+          <a:bodyPr rtlCol="0" anchor="ctr"/>
+          <a:lstStyle/>
+          <a:p>
+            <a:pPr algn="ctr"/>
+          </a:p>
+        </p:txBody>
+      </p:sp>
+      <p:sp>
+        <p:nvSpPr>
+          <p:cNvPr id="41" name="TextBox 40"/>
+          <p:cNvSpPr txBox="1"/>
+          <p:nvPr/>
+        </p:nvSpPr>
+        <p:spPr>
+          <a:xfrm>
+            <a:off x="484632" y="3557016"/>
+            <a:ext cx="2194560" cy="219456"/>
+          </a:xfrm>
+          <a:prstGeom prst="rect">
+            <a:avLst/>
+          </a:prstGeom>
+          <a:noFill/>
+        </p:spPr>
+        <p:txBody>
+          <a:bodyPr wrap="square">
+            <a:spAutoFit/>
+          </a:bodyPr>
+          <a:lstStyle/>
+          <a:p>
+            <a:pPr algn="l"/>
+            <a:r>
+              <a:rPr sz="850" b="1" i="0">
+                <a:solidFill>
+                  <a:srgbClr val="111827"/>
+                </a:solidFill>
+                <a:latin typeface="Calibri"/>
+              </a:rPr>
+              <a:t>Distribution on promo (TDP, Any Promo)</a:t>
+            </a:r>
+          </a:p>
+        </p:txBody>
+      </p:sp>
+      <p:sp>
+        <p:nvSpPr>
+          <p:cNvPr id="42" name="TextBox 41"/>
+          <p:cNvSpPr txBox="1"/>
+          <p:nvPr/>
+        </p:nvSpPr>
+        <p:spPr>
+          <a:xfrm>
+            <a:off x="2770632" y="3557016"/>
+            <a:ext cx="914400" cy="219456"/>
+          </a:xfrm>
+          <a:prstGeom prst="rect">
+            <a:avLst/>
+          </a:prstGeom>
+          <a:noFill/>
+        </p:spPr>
+        <p:txBody>
+          <a:bodyPr wrap="square">
+            <a:spAutoFit/>
+          </a:bodyPr>
+          <a:lstStyle/>
+          <a:p>
+            <a:pPr algn="l"/>
+            <a:r>
+              <a:rPr sz="800" b="1" i="0">
+                <a:solidFill>
+                  <a:srgbClr val="4078D0"/>
+                </a:solidFill>
+                <a:latin typeface="Calibri"/>
+              </a:rPr>
+              <a:t>SPINS</a:t>
+            </a:r>
+          </a:p>
+        </p:txBody>
+      </p:sp>
+      <p:sp>
+        <p:nvSpPr>
+          <p:cNvPr id="43" name="TextBox 42"/>
+          <p:cNvSpPr txBox="1"/>
+          <p:nvPr/>
+        </p:nvSpPr>
+        <p:spPr>
+          <a:xfrm>
+            <a:off x="3776472" y="3557016"/>
+            <a:ext cx="1115568" cy="219456"/>
+          </a:xfrm>
+          <a:prstGeom prst="rect">
+            <a:avLst/>
+          </a:prstGeom>
+          <a:noFill/>
+        </p:spPr>
+        <p:txBody>
+          <a:bodyPr wrap="square">
+            <a:spAutoFit/>
+          </a:bodyPr>
+          <a:lstStyle/>
+          <a:p>
+            <a:pPr algn="l"/>
+            <a:r>
+              <a:rPr sz="750" b="0" i="0">
+                <a:solidFill>
+                  <a:srgbClr val="6B7FA0"/>
+                </a:solidFill>
+                <a:latin typeface="Calibri"/>
+              </a:rPr>
+              <a:t>Display vs. price</a:t>
+            </a:r>
+          </a:p>
+        </p:txBody>
+      </p:sp>
+      <p:sp>
+        <p:nvSpPr>
+          <p:cNvPr id="44" name="Rectangle 43"/>
+          <p:cNvSpPr/>
+          <p:nvPr/>
+        </p:nvSpPr>
+        <p:spPr>
+          <a:xfrm>
+            <a:off x="411480" y="3849624"/>
             <a:ext cx="4572000" cy="256032"/>
           </a:xfrm>
           <a:prstGeom prst="rect">
@@ -23777,13 +23925,13 @@
       </p:sp>
       <p:sp>
         <p:nvSpPr>
-          <p:cNvPr id="41" name="TextBox 40"/>
-          <p:cNvSpPr txBox="1"/>
-          <p:nvPr/>
-        </p:nvSpPr>
-        <p:spPr>
-          <a:xfrm>
-            <a:off x="502920" y="3621024"/>
+          <p:cNvPr id="45" name="TextBox 44"/>
+          <p:cNvSpPr txBox="1"/>
+          <p:nvPr/>
+        </p:nvSpPr>
+        <p:spPr>
+          <a:xfrm>
+            <a:off x="502920" y="3886200"/>
             <a:ext cx="4389120" cy="201168"/>
           </a:xfrm>
           <a:prstGeom prst="rect">
@@ -23812,13 +23960,13 @@
       </p:sp>
       <p:sp>
         <p:nvSpPr>
-          <p:cNvPr id="42" name="Rectangle 41"/>
+          <p:cNvPr id="46" name="Rectangle 45"/>
           <p:cNvSpPr/>
           <p:nvPr/>
         </p:nvSpPr>
         <p:spPr>
           <a:xfrm>
-            <a:off x="502920" y="3922776"/>
+            <a:off x="502920" y="4187952"/>
             <a:ext cx="73152" cy="73152"/>
           </a:xfrm>
           <a:prstGeom prst="rect">
@@ -23855,13 +24003,13 @@
       </p:sp>
       <p:sp>
         <p:nvSpPr>
-          <p:cNvPr id="43" name="TextBox 42"/>
-          <p:cNvSpPr txBox="1"/>
-          <p:nvPr/>
-        </p:nvSpPr>
-        <p:spPr>
-          <a:xfrm>
-            <a:off x="667512" y="3858768"/>
+          <p:cNvPr id="47" name="TextBox 46"/>
+          <p:cNvSpPr txBox="1"/>
+          <p:nvPr/>
+        </p:nvSpPr>
+        <p:spPr>
+          <a:xfrm>
+            <a:off x="667512" y="4123944"/>
             <a:ext cx="4224528" cy="237744"/>
           </a:xfrm>
           <a:prstGeom prst="rect">
@@ -23883,20 +24031,20 @@
                 </a:solidFill>
                 <a:latin typeface="Calibri"/>
               </a:rPr>
-              <a:t>Normalize to non-zero TDP weeks — eliminate false troughs from shelf-presence gaps</a:t>
-            </a:r>
-          </a:p>
-        </p:txBody>
-      </p:sp>
-      <p:sp>
-        <p:nvSpPr>
-          <p:cNvPr id="44" name="Rectangle 43"/>
+              <a:t>Calculate promo lift ratio: incremental units ÷ base units, per SKU × account × event</a:t>
+            </a:r>
+          </a:p>
+        </p:txBody>
+      </p:sp>
+      <p:sp>
+        <p:nvSpPr>
+          <p:cNvPr id="48" name="Rectangle 47"/>
           <p:cNvSpPr/>
           <p:nvPr/>
         </p:nvSpPr>
         <p:spPr>
           <a:xfrm>
-            <a:off x="502920" y="4169664"/>
+            <a:off x="502920" y="4434840"/>
             <a:ext cx="73152" cy="73152"/>
           </a:xfrm>
           <a:prstGeom prst="rect">
@@ -23933,13 +24081,13 @@
       </p:sp>
       <p:sp>
         <p:nvSpPr>
-          <p:cNvPr id="45" name="TextBox 44"/>
-          <p:cNvSpPr txBox="1"/>
-          <p:nvPr/>
-        </p:nvSpPr>
-        <p:spPr>
-          <a:xfrm>
-            <a:off x="667512" y="4105656"/>
+          <p:cNvPr id="49" name="TextBox 48"/>
+          <p:cNvSpPr txBox="1"/>
+          <p:nvPr/>
+        </p:nvSpPr>
+        <p:spPr>
+          <a:xfrm>
+            <a:off x="667512" y="4370831"/>
             <a:ext cx="4224528" cy="237744"/>
           </a:xfrm>
           <a:prstGeom prst="rect">
@@ -23961,20 +24109,20 @@
                 </a:solidFill>
                 <a:latin typeface="Calibri"/>
               </a:rPr>
-              <a:t>Compute rolling averages (4-week, 13-week) to smooth noise while preserving trend</a:t>
-            </a:r>
-          </a:p>
-        </p:txBody>
-      </p:sp>
-      <p:sp>
-        <p:nvSpPr>
-          <p:cNvPr id="46" name="Rectangle 45"/>
+              <a:t>Group events into discount depth buckets (0–10%, 10–20%, 20–30%, 30%+)</a:t>
+            </a:r>
+          </a:p>
+        </p:txBody>
+      </p:sp>
+      <p:sp>
+        <p:nvSpPr>
+          <p:cNvPr id="50" name="Rectangle 49"/>
           <p:cNvSpPr/>
           <p:nvPr/>
         </p:nvSpPr>
         <p:spPr>
           <a:xfrm>
-            <a:off x="502920" y="4416552"/>
+            <a:off x="502920" y="4681727"/>
             <a:ext cx="73152" cy="73152"/>
           </a:xfrm>
           <a:prstGeom prst="rect">
@@ -24011,13 +24159,13 @@
       </p:sp>
       <p:sp>
         <p:nvSpPr>
-          <p:cNvPr id="47" name="TextBox 46"/>
-          <p:cNvSpPr txBox="1"/>
-          <p:nvPr/>
-        </p:nvSpPr>
-        <p:spPr>
-          <a:xfrm>
-            <a:off x="667512" y="4352544"/>
+          <p:cNvPr id="51" name="TextBox 50"/>
+          <p:cNvSpPr txBox="1"/>
+          <p:nvPr/>
+        </p:nvSpPr>
+        <p:spPr>
+          <a:xfrm>
+            <a:off x="667512" y="4617719"/>
             <a:ext cx="4224528" cy="237744"/>
           </a:xfrm>
           <a:prstGeom prst="rect">
@@ -24039,20 +24187,20 @@
                 </a:solidFill>
                 <a:latin typeface="Calibri"/>
               </a:rPr>
-              <a:t>Build 12-month seasonality index from category raw monthly averages</a:t>
-            </a:r>
-          </a:p>
-        </p:txBody>
-      </p:sp>
-      <p:sp>
-        <p:nvSpPr>
-          <p:cNvPr id="48" name="Rectangle 47"/>
+              <a:t>Separate response curves by channel — grocery and c-store show distinct lift profiles</a:t>
+            </a:r>
+          </a:p>
+        </p:txBody>
+      </p:sp>
+      <p:sp>
+        <p:nvSpPr>
+          <p:cNvPr id="52" name="Rectangle 51"/>
           <p:cNvSpPr/>
           <p:nvPr/>
         </p:nvSpPr>
         <p:spPr>
           <a:xfrm>
-            <a:off x="502920" y="4663440"/>
+            <a:off x="502920" y="4928615"/>
             <a:ext cx="73152" cy="73152"/>
           </a:xfrm>
           <a:prstGeom prst="rect">
@@ -24089,13 +24237,13 @@
       </p:sp>
       <p:sp>
         <p:nvSpPr>
-          <p:cNvPr id="49" name="TextBox 48"/>
-          <p:cNvSpPr txBox="1"/>
-          <p:nvPr/>
-        </p:nvSpPr>
-        <p:spPr>
-          <a:xfrm>
-            <a:off x="667512" y="4599431"/>
+          <p:cNvPr id="53" name="TextBox 52"/>
+          <p:cNvSpPr txBox="1"/>
+          <p:nvPr/>
+        </p:nvSpPr>
+        <p:spPr>
+          <a:xfrm>
+            <a:off x="667512" y="4864607"/>
             <a:ext cx="4224528" cy="237744"/>
           </a:xfrm>
           <a:prstGeom prst="rect">
@@ -24117,20 +24265,20 @@
                 </a:solidFill>
                 <a:latin typeface="Calibri"/>
               </a:rPr>
-              <a:t>Flag promo weeks so model learns baseline vs. promo-lifted demand separately</a:t>
-            </a:r>
-          </a:p>
-        </p:txBody>
-      </p:sp>
-      <p:sp>
-        <p:nvSpPr>
-          <p:cNvPr id="50" name="Rectangle 49"/>
+              <a:t>Separate response curves by pack size — 12-packs show a 30%+ discount cliff</a:t>
+            </a:r>
+          </a:p>
+        </p:txBody>
+      </p:sp>
+      <p:sp>
+        <p:nvSpPr>
+          <p:cNvPr id="54" name="Rectangle 53"/>
           <p:cNvSpPr/>
           <p:nvPr/>
         </p:nvSpPr>
         <p:spPr>
           <a:xfrm>
-            <a:off x="502920" y="4910327"/>
+            <a:off x="502920" y="5175503"/>
             <a:ext cx="73152" cy="73152"/>
           </a:xfrm>
           <a:prstGeom prst="rect">
@@ -24167,13 +24315,13 @@
       </p:sp>
       <p:sp>
         <p:nvSpPr>
-          <p:cNvPr id="51" name="TextBox 50"/>
-          <p:cNvSpPr txBox="1"/>
-          <p:nvPr/>
-        </p:nvSpPr>
-        <p:spPr>
-          <a:xfrm>
-            <a:off x="667512" y="4846319"/>
+          <p:cNvPr id="55" name="TextBox 54"/>
+          <p:cNvSpPr txBox="1"/>
+          <p:nvPr/>
+        </p:nvSpPr>
+        <p:spPr>
+          <a:xfrm>
+            <a:off x="667512" y="5111495"/>
             <a:ext cx="4224528" cy="237744"/>
           </a:xfrm>
           <a:prstGeom prst="rect">
@@ -24195,92 +24343,14 @@
                 </a:solidFill>
                 <a:latin typeface="Calibri"/>
               </a:rPr>
-              <a:t>Train separate forecast per SKU × retailer — Kroger velocity ≠ Target velocity</a:t>
-            </a:r>
-          </a:p>
-        </p:txBody>
-      </p:sp>
-      <p:sp>
-        <p:nvSpPr>
-          <p:cNvPr id="52" name="Rectangle 51"/>
-          <p:cNvSpPr/>
-          <p:nvPr/>
-        </p:nvSpPr>
-        <p:spPr>
-          <a:xfrm>
-            <a:off x="502920" y="5157215"/>
-            <a:ext cx="73152" cy="73152"/>
-          </a:xfrm>
-          <a:prstGeom prst="rect">
-            <a:avLst/>
-          </a:prstGeom>
-          <a:solidFill>
-            <a:srgbClr val="4078D0"/>
-          </a:solidFill>
-          <a:ln>
-            <a:noFill/>
-          </a:ln>
-        </p:spPr>
-        <p:style>
-          <a:lnRef idx="1">
-            <a:schemeClr val="accent1"/>
-          </a:lnRef>
-          <a:fillRef idx="3">
-            <a:schemeClr val="accent1"/>
-          </a:fillRef>
-          <a:effectRef idx="2">
-            <a:schemeClr val="accent1"/>
-          </a:effectRef>
-          <a:fontRef idx="minor">
-            <a:schemeClr val="lt1"/>
-          </a:fontRef>
-        </p:style>
-        <p:txBody>
-          <a:bodyPr rtlCol="0" anchor="ctr"/>
-          <a:lstStyle/>
-          <a:p>
-            <a:pPr algn="ctr"/>
-          </a:p>
-        </p:txBody>
-      </p:sp>
-      <p:sp>
-        <p:nvSpPr>
-          <p:cNvPr id="53" name="TextBox 52"/>
-          <p:cNvSpPr txBox="1"/>
-          <p:nvPr/>
-        </p:nvSpPr>
-        <p:spPr>
-          <a:xfrm>
-            <a:off x="667512" y="5093207"/>
-            <a:ext cx="4224528" cy="237744"/>
-          </a:xfrm>
-          <a:prstGeom prst="rect">
-            <a:avLst/>
-          </a:prstGeom>
-          <a:noFill/>
-        </p:spPr>
-        <p:txBody>
-          <a:bodyPr wrap="square">
-            <a:spAutoFit/>
-          </a:bodyPr>
-          <a:lstStyle/>
-          <a:p>
-            <a:pPr algn="l"/>
-            <a:r>
-              <a:rPr sz="850" b="0" i="0">
-                <a:solidFill>
-                  <a:srgbClr val="111827"/>
-                </a:solidFill>
-                <a:latin typeface="Calibri"/>
-              </a:rPr>
-              <a:t>Fall back to exponential smoothing (ETS) for SKUs with &lt;8 weeks of history</a:t>
-            </a:r>
-          </a:p>
-        </p:txBody>
-      </p:sp>
-      <p:sp>
-        <p:nvSpPr>
-          <p:cNvPr id="54" name="Rectangle 53"/>
+              <a:t>Identify the depth where marginal lift no longer justifies additional margin give-up</a:t>
+            </a:r>
+          </a:p>
+        </p:txBody>
+      </p:sp>
+      <p:sp>
+        <p:nvSpPr>
+          <p:cNvPr id="56" name="Rectangle 55"/>
           <p:cNvSpPr/>
           <p:nvPr/>
         </p:nvSpPr>
@@ -24323,7 +24393,7 @@
       </p:sp>
       <p:sp>
         <p:nvSpPr>
-          <p:cNvPr id="55" name="TextBox 54"/>
+          <p:cNvPr id="57" name="TextBox 56"/>
           <p:cNvSpPr txBox="1"/>
           <p:nvPr/>
         </p:nvSpPr>
@@ -24358,14 +24428,14 @@
       </p:sp>
       <p:sp>
         <p:nvSpPr>
-          <p:cNvPr id="56" name="Rectangle 55"/>
+          <p:cNvPr id="58" name="Rectangle 57"/>
           <p:cNvSpPr/>
           <p:nvPr/>
         </p:nvSpPr>
         <p:spPr>
           <a:xfrm>
             <a:off x="5349240" y="1691640"/>
-            <a:ext cx="6492240" cy="1371600"/>
+            <a:ext cx="6492240" cy="1051560"/>
           </a:xfrm>
           <a:prstGeom prst="rect">
             <a:avLst/>
@@ -24403,7 +24473,7 @@
       </p:sp>
       <p:sp>
         <p:nvSpPr>
-          <p:cNvPr id="57" name="TextBox 56"/>
+          <p:cNvPr id="59" name="TextBox 58"/>
           <p:cNvSpPr txBox="1"/>
           <p:nvPr/>
         </p:nvSpPr>
@@ -24431,14 +24501,14 @@
                 </a:solidFill>
                 <a:latin typeface="Calibri"/>
               </a:rPr>
-              <a:t>›  13-week demand forecast per SKU × retailer account</a:t>
-            </a:r>
-          </a:p>
-        </p:txBody>
-      </p:sp>
-      <p:sp>
-        <p:nvSpPr>
-          <p:cNvPr id="58" name="TextBox 57"/>
+              <a:t>›  Expected lift % at each discount depth for this SKU × channel × pack size</a:t>
+            </a:r>
+          </a:p>
+        </p:txBody>
+      </p:sp>
+      <p:sp>
+        <p:nvSpPr>
+          <p:cNvPr id="60" name="TextBox 59"/>
           <p:cNvSpPr txBox="1"/>
           <p:nvPr/>
         </p:nvSpPr>
@@ -24466,14 +24536,14 @@
                 </a:solidFill>
                 <a:latin typeface="Calibri"/>
               </a:rPr>
-              <a:t>›  Confidence bands (low / base / high scenario)</a:t>
-            </a:r>
-          </a:p>
-        </p:txBody>
-      </p:sp>
-      <p:sp>
-        <p:nvSpPr>
-          <p:cNvPr id="59" name="TextBox 58"/>
+              <a:t>›  Optimal discount depth recommendation — where lift peaks before the cliff</a:t>
+            </a:r>
+          </a:p>
+        </p:txBody>
+      </p:sp>
+      <p:sp>
+        <p:nvSpPr>
+          <p:cNvPr id="61" name="TextBox 60"/>
           <p:cNvSpPr txBox="1"/>
           <p:nvPr/>
         </p:nvSpPr>
@@ -24501,55 +24571,20 @@
                 </a:solidFill>
                 <a:latin typeface="Calibri"/>
               </a:rPr>
-              <a:t>›  Promo-uplift scenario — demand if a promotion is planned in the forecast window</a:t>
-            </a:r>
-          </a:p>
-        </p:txBody>
-      </p:sp>
-      <p:sp>
-        <p:nvSpPr>
-          <p:cNvPr id="60" name="TextBox 59"/>
-          <p:cNvSpPr txBox="1"/>
-          <p:nvPr/>
-        </p:nvSpPr>
-        <p:spPr>
-          <a:xfrm>
-            <a:off x="5623559" y="2715768"/>
-            <a:ext cx="6126479" cy="256032"/>
-          </a:xfrm>
-          <a:prstGeom prst="rect">
-            <a:avLst/>
-          </a:prstGeom>
-          <a:noFill/>
-        </p:spPr>
-        <p:txBody>
-          <a:bodyPr wrap="square">
-            <a:spAutoFit/>
-          </a:bodyPr>
-          <a:lstStyle/>
-          <a:p>
-            <a:pPr algn="l"/>
-            <a:r>
-              <a:rPr sz="950" b="0" i="0">
-                <a:solidFill>
-                  <a:srgbClr val="0E5E38"/>
-                </a:solidFill>
-                <a:latin typeface="Calibri"/>
-              </a:rPr>
-              <a:t>›  Forecast accuracy benchmark: 4% wMAPE vs. 7–10% industry baseline</a:t>
-            </a:r>
-          </a:p>
-        </p:txBody>
-      </p:sp>
-      <p:sp>
-        <p:nvSpPr>
-          <p:cNvPr id="61" name="Rectangle 60"/>
+              <a:t>›  Incremental vs. cannibalized demand breakdown at each discount level</a:t>
+            </a:r>
+          </a:p>
+        </p:txBody>
+      </p:sp>
+      <p:sp>
+        <p:nvSpPr>
+          <p:cNvPr id="62" name="Rectangle 61"/>
           <p:cNvSpPr/>
           <p:nvPr/>
         </p:nvSpPr>
         <p:spPr>
           <a:xfrm>
-            <a:off x="5349240" y="3172968"/>
+            <a:off x="5349240" y="2852928"/>
             <a:ext cx="6492240" cy="274320"/>
           </a:xfrm>
           <a:prstGeom prst="rect">
@@ -24586,13 +24621,13 @@
       </p:sp>
       <p:sp>
         <p:nvSpPr>
-          <p:cNvPr id="62" name="TextBox 61"/>
-          <p:cNvSpPr txBox="1"/>
-          <p:nvPr/>
-        </p:nvSpPr>
-        <p:spPr>
-          <a:xfrm>
-            <a:off x="5458968" y="3218688"/>
+          <p:cNvPr id="63" name="TextBox 62"/>
+          <p:cNvSpPr txBox="1"/>
+          <p:nvPr/>
+        </p:nvSpPr>
+        <p:spPr>
+          <a:xfrm>
+            <a:off x="5458968" y="2898648"/>
             <a:ext cx="6492240" cy="201168"/>
           </a:xfrm>
           <a:prstGeom prst="rect">
@@ -24621,13 +24656,13 @@
       </p:sp>
       <p:sp>
         <p:nvSpPr>
-          <p:cNvPr id="63" name="Rectangle 62"/>
+          <p:cNvPr id="64" name="Rectangle 63"/>
           <p:cNvSpPr/>
           <p:nvPr/>
         </p:nvSpPr>
         <p:spPr>
           <a:xfrm>
-            <a:off x="5349240" y="3447288"/>
+            <a:off x="5349240" y="3127248"/>
             <a:ext cx="6492240" cy="1371600"/>
           </a:xfrm>
           <a:prstGeom prst="rect">
@@ -24666,7 +24701,42 @@
       </p:sp>
       <p:sp>
         <p:nvSpPr>
-          <p:cNvPr id="64" name="TextBox 63"/>
+          <p:cNvPr id="65" name="TextBox 64"/>
+          <p:cNvSpPr txBox="1"/>
+          <p:nvPr/>
+        </p:nvSpPr>
+        <p:spPr>
+          <a:xfrm>
+            <a:off x="5623559" y="3191256"/>
+            <a:ext cx="6126479" cy="256032"/>
+          </a:xfrm>
+          <a:prstGeom prst="rect">
+            <a:avLst/>
+          </a:prstGeom>
+          <a:noFill/>
+        </p:spPr>
+        <p:txBody>
+          <a:bodyPr wrap="square">
+            <a:spAutoFit/>
+          </a:bodyPr>
+          <a:lstStyle/>
+          <a:p>
+            <a:pPr algn="l"/>
+            <a:r>
+              <a:rPr sz="950" b="0" i="0">
+                <a:solidFill>
+                  <a:srgbClr val="8A4800"/>
+                </a:solidFill>
+                <a:latin typeface="Calibri"/>
+              </a:rPr>
+              <a:t>›  Historical promo events — discount depth, timing, and observed lift per event</a:t>
+            </a:r>
+          </a:p>
+        </p:txBody>
+      </p:sp>
+      <p:sp>
+        <p:nvSpPr>
+          <p:cNvPr id="66" name="TextBox 65"/>
           <p:cNvSpPr txBox="1"/>
           <p:nvPr/>
         </p:nvSpPr>
@@ -24694,14 +24764,14 @@
                 </a:solidFill>
                 <a:latin typeface="Calibri"/>
               </a:rPr>
-              <a:t>›  52-week actual demand trend by SKU and retailer account</a:t>
-            </a:r>
-          </a:p>
-        </p:txBody>
-      </p:sp>
-      <p:sp>
-        <p:nvSpPr>
-          <p:cNvPr id="65" name="TextBox 64"/>
+              <a:t>›  Lift trend by event type — TPR vs. display vs. feature support</a:t>
+            </a:r>
+          </a:p>
+        </p:txBody>
+      </p:sp>
+      <p:sp>
+        <p:nvSpPr>
+          <p:cNvPr id="67" name="TextBox 66"/>
           <p:cNvSpPr txBox="1"/>
           <p:nvPr/>
         </p:nvSpPr>
@@ -24729,14 +24799,14 @@
                 </a:solidFill>
                 <a:latin typeface="Calibri"/>
               </a:rPr>
-              <a:t>›  Distribution (stores stocking) trend over the same period</a:t>
-            </a:r>
-          </a:p>
-        </p:txBody>
-      </p:sp>
-      <p:sp>
-        <p:nvSpPr>
-          <p:cNvPr id="66" name="TextBox 65"/>
+              <a:t>›  % weeks on promo trend — is this SKU becoming promo-dependent?</a:t>
+            </a:r>
+          </a:p>
+        </p:txBody>
+      </p:sp>
+      <p:sp>
+        <p:nvSpPr>
+          <p:cNvPr id="68" name="TextBox 67"/>
           <p:cNvSpPr txBox="1"/>
           <p:nvPr/>
         </p:nvSpPr>
@@ -24764,49 +24834,14 @@
                 </a:solidFill>
                 <a:latin typeface="Calibri"/>
               </a:rPr>
-              <a:t>›  Category average velocity — how this SKU compares to 13-week category norm</a:t>
-            </a:r>
-          </a:p>
-        </p:txBody>
-      </p:sp>
-      <p:sp>
-        <p:nvSpPr>
-          <p:cNvPr id="67" name="TextBox 66"/>
-          <p:cNvSpPr txBox="1"/>
-          <p:nvPr/>
-        </p:nvSpPr>
-        <p:spPr>
-          <a:xfrm>
-            <a:off x="5623559" y="4471416"/>
-            <a:ext cx="6126479" cy="256032"/>
-          </a:xfrm>
-          <a:prstGeom prst="rect">
-            <a:avLst/>
-          </a:prstGeom>
-          <a:noFill/>
-        </p:spPr>
-        <p:txBody>
-          <a:bodyPr wrap="square">
-            <a:spAutoFit/>
-          </a:bodyPr>
-          <a:lstStyle/>
-          <a:p>
-            <a:pPr algn="l"/>
-            <a:r>
-              <a:rPr sz="950" b="0" i="0">
-                <a:solidFill>
-                  <a:srgbClr val="8A4800"/>
-                </a:solidFill>
-                <a:latin typeface="Calibri"/>
-              </a:rPr>
-              <a:t>›  Seasonal index overlay — expected lift or drag on the forecast period</a:t>
-            </a:r>
-          </a:p>
-        </p:txBody>
-      </p:sp>
-      <p:sp>
-        <p:nvSpPr>
-          <p:cNvPr id="68" name="Rectangle 67"/>
+              <a:t>›  Channel comparison — lift curve across grocery / mass / c-store for this SKU</a:t>
+            </a:r>
+          </a:p>
+        </p:txBody>
+      </p:sp>
+      <p:sp>
+        <p:nvSpPr>
+          <p:cNvPr id="69" name="Rectangle 68"/>
           <p:cNvSpPr/>
           <p:nvPr/>
         </p:nvSpPr>
@@ -24849,7 +24884,7 @@
       </p:sp>
       <p:sp>
         <p:nvSpPr>
-          <p:cNvPr id="69" name="TextBox 68"/>
+          <p:cNvPr id="70" name="TextBox 69"/>
           <p:cNvSpPr txBox="1"/>
           <p:nvPr/>
         </p:nvSpPr>
@@ -24884,7 +24919,7 @@
       </p:sp>
       <p:sp>
         <p:nvSpPr>
-          <p:cNvPr id="70" name="Rectangle 69"/>
+          <p:cNvPr id="71" name="Rectangle 70"/>
           <p:cNvSpPr/>
           <p:nvPr/>
         </p:nvSpPr>
@@ -24929,7 +24964,7 @@
       </p:sp>
       <p:sp>
         <p:nvSpPr>
-          <p:cNvPr id="71" name="TextBox 70"/>
+          <p:cNvPr id="72" name="TextBox 71"/>
           <p:cNvSpPr txBox="1"/>
           <p:nvPr/>
         </p:nvSpPr>
@@ -24957,14 +24992,14 @@
                 </a:solidFill>
                 <a:latin typeface="Calibri"/>
               </a:rPr>
-              <a:t>Seasonality index · Forecast model training · ETS fallback · Confidence bands · Publish 13-week projections to Mo UI</a:t>
-            </a:r>
-          </a:p>
-        </p:txBody>
-      </p:sp>
-      <p:sp>
-        <p:nvSpPr>
-          <p:cNvPr id="72" name="Rectangle 71"/>
+              <a:t>Lift curve modeling · Depth optimization scoring · Channel × pack separation · Publish to Mo UI</a:t>
+            </a:r>
+          </a:p>
+        </p:txBody>
+      </p:sp>
+      <p:sp>
+        <p:nvSpPr>
+          <p:cNvPr id="73" name="Rectangle 72"/>
           <p:cNvSpPr/>
           <p:nvPr/>
         </p:nvSpPr>
@@ -25007,7 +25042,7 @@
       </p:sp>
       <p:sp>
         <p:nvSpPr>
-          <p:cNvPr id="73" name="TextBox 72"/>
+          <p:cNvPr id="74" name="TextBox 73"/>
           <p:cNvSpPr txBox="1"/>
           <p:nvPr/>
         </p:nvSpPr>
@@ -25042,7 +25077,7 @@
       </p:sp>
       <p:sp>
         <p:nvSpPr>
-          <p:cNvPr id="74" name="Rectangle 73"/>
+          <p:cNvPr id="75" name="Rectangle 74"/>
           <p:cNvSpPr/>
           <p:nvPr/>
         </p:nvSpPr>
@@ -25087,7 +25122,7 @@
       </p:sp>
       <p:sp>
         <p:nvSpPr>
-          <p:cNvPr id="75" name="TextBox 74"/>
+          <p:cNvPr id="76" name="TextBox 75"/>
           <p:cNvSpPr txBox="1"/>
           <p:nvPr/>
         </p:nvSpPr>
@@ -25115,14 +25150,14 @@
                 </a:solidFill>
                 <a:latin typeface="Calibri"/>
               </a:rPr>
-              <a:t>SPINS export deposit · Connor validates 13-week forecasts against FP&amp;A actuals · Share actuals data for backtesting and accuracy measurement</a:t>
-            </a:r>
-          </a:p>
-        </p:txBody>
-      </p:sp>
-      <p:sp>
-        <p:nvSpPr>
-          <p:cNvPr id="76" name="TextBox 75"/>
+              <a:t>SPINS export deposit (including promo flags) · Review lift projections · Confirm discount depth guidance with trade marketing team</a:t>
+            </a:r>
+          </a:p>
+        </p:txBody>
+      </p:sp>
+      <p:sp>
+        <p:nvSpPr>
+          <p:cNvPr id="77" name="TextBox 76"/>
           <p:cNvSpPr txBox="1"/>
           <p:nvPr/>
         </p:nvSpPr>

</xml_diff>

<commit_message>
Add BUILT launch checklist; update Slide 11 and artifact navigator
New: mockups/built_launch_checklist.html — interactive punch-list for
Phase 1 go-live (environment setup, SSO/auth, open questions, Week 1-2
commitments). State persists in localStorage.

Slide 11: Phase 1 model list updated to include demand forecast;
companion document callout added at slide bottom.

Navigator: checklist added to Customer-Facing category; kickoff deck
description updated to reflect new module ordering.

Co-Authored-By: Claude Sonnet 4.6 <noreply@anthropic.com>
</commit_message>
<xml_diff>
--- a/mockups/mo_data_ops_kickoff.pptx
+++ b/mockups/mo_data_ops_kickoff.pptx
@@ -8320,7 +8320,7 @@
                 </a:solidFill>
                 <a:latin typeface="Calibri"/>
               </a:rPr>
-              <a:t>Aevah runs Phase 1 models (cannibalization risk + price elasticity) — no BUILT action needed</a:t>
+              <a:t>Aevah trains Phase 1 models: demand forecast, cannibalization risk, price elasticity — no BUILT action needed</a:t>
             </a:r>
           </a:p>
         </p:txBody>
@@ -8468,7 +8468,7 @@
                 </a:solidFill>
                 <a:latin typeface="Calibri"/>
               </a:rPr>
-              <a:t>Aevah hosts Mo walkthrough with Brian + Connor; projection validation session</a:t>
+              <a:t>Aevah hosts Mo walkthrough with Brian — demand forecast review + FOOD-channel account walkthrough</a:t>
             </a:r>
           </a:p>
         </p:txBody>
@@ -8616,14 +8616,92 @@
                 </a:solidFill>
                 <a:latin typeface="Calibri"/>
               </a:rPr>
-              <a:t>Connor's team reviews findings; UI adjustments made; Phase 2 scoping begins</a:t>
-            </a:r>
-          </a:p>
-        </p:txBody>
-      </p:sp>
-      <p:sp>
-        <p:nvSpPr>
-          <p:cNvPr id="53" name="TextBox 52"/>
+              <a:t>Brian + team validate projections; UI adjustments made; Phase 2 scoping begins</a:t>
+            </a:r>
+          </a:p>
+        </p:txBody>
+      </p:sp>
+      <p:sp>
+        <p:nvSpPr>
+          <p:cNvPr id="53" name="Rectangle 52"/>
+          <p:cNvSpPr/>
+          <p:nvPr/>
+        </p:nvSpPr>
+        <p:spPr>
+          <a:xfrm>
+            <a:off x="457200" y="6080760"/>
+            <a:ext cx="11338560" cy="274320"/>
+          </a:xfrm>
+          <a:prstGeom prst="rect">
+            <a:avLst/>
+          </a:prstGeom>
+          <a:solidFill>
+            <a:srgbClr val="142850"/>
+          </a:solidFill>
+          <a:ln>
+            <a:noFill/>
+          </a:ln>
+        </p:spPr>
+        <p:style>
+          <a:lnRef idx="1">
+            <a:schemeClr val="accent1"/>
+          </a:lnRef>
+          <a:fillRef idx="3">
+            <a:schemeClr val="accent1"/>
+          </a:fillRef>
+          <a:effectRef idx="2">
+            <a:schemeClr val="accent1"/>
+          </a:effectRef>
+          <a:fontRef idx="minor">
+            <a:schemeClr val="lt1"/>
+          </a:fontRef>
+        </p:style>
+        <p:txBody>
+          <a:bodyPr rtlCol="0" anchor="ctr"/>
+          <a:lstStyle/>
+          <a:p>
+            <a:pPr algn="ctr"/>
+          </a:p>
+        </p:txBody>
+      </p:sp>
+      <p:sp>
+        <p:nvSpPr>
+          <p:cNvPr id="54" name="TextBox 53"/>
+          <p:cNvSpPr txBox="1"/>
+          <p:nvPr/>
+        </p:nvSpPr>
+        <p:spPr>
+          <a:xfrm>
+            <a:off x="585216" y="6099048"/>
+            <a:ext cx="8686800" cy="237744"/>
+          </a:xfrm>
+          <a:prstGeom prst="rect">
+            <a:avLst/>
+          </a:prstGeom>
+          <a:noFill/>
+        </p:spPr>
+        <p:txBody>
+          <a:bodyPr wrap="square">
+            <a:spAutoFit/>
+          </a:bodyPr>
+          <a:lstStyle/>
+          <a:p>
+            <a:pPr algn="l"/>
+            <a:r>
+              <a:rPr sz="800" b="0" i="0">
+                <a:solidFill>
+                  <a:srgbClr val="A0C0F0"/>
+                </a:solidFill>
+                <a:latin typeface="Calibri"/>
+              </a:rPr>
+              <a:t>Companion document:  BUILT × Aevah Launch Checklist  ·  Environment setup · SSO &amp; access · Open questions · Week 1–2 commitments</a:t>
+            </a:r>
+          </a:p>
+        </p:txBody>
+      </p:sp>
+      <p:sp>
+        <p:nvSpPr>
+          <p:cNvPr id="55" name="TextBox 54"/>
           <p:cNvSpPr txBox="1"/>
           <p:nvPr/>
         </p:nvSpPr>

</xml_diff>